<commit_message>
Add Gen5.4 GLM replay diagnostic
</commit_message>
<xml_diff>
--- a/presentations/gen5_4_ml_decision_engine_incremental_build.pptx
+++ b/presentations/gen5_4_ml_decision_engine_incremental_build.pptx
@@ -2,22 +2,29 @@
 <file path=ppt/presentation.xml><?xml version="1.0" encoding="utf-8"?>
 <p:presentation xmlns:p="http://schemas.openxmlformats.org/presentationml/2006/main">
   <p:sldMasterIdLst>
-    <p:sldMasterId xmlns:r="http://schemas.openxmlformats.org/officeDocument/2006/relationships" id="2147483648" r:id="R887a5165dec64549"/>
+    <p:sldMasterId xmlns:r="http://schemas.openxmlformats.org/officeDocument/2006/relationships" id="2147483648" r:id="Rb707c0c617c44f5f"/>
   </p:sldMasterIdLst>
   <p:notesMasterIdLst>
-    <p:notesMasterId xmlns:r="http://schemas.openxmlformats.org/officeDocument/2006/relationships" r:id="Rdc700c6eed724d83"/>
+    <p:notesMasterId xmlns:r="http://schemas.openxmlformats.org/officeDocument/2006/relationships" r:id="R27608b05f04c46d9"/>
   </p:notesMasterIdLst>
   <p:sldIdLst>
-    <p:sldId xmlns:r="http://schemas.openxmlformats.org/officeDocument/2006/relationships" id="256" r:id="R1813de4d8fd14741"/>
-    <p:sldId xmlns:r="http://schemas.openxmlformats.org/officeDocument/2006/relationships" id="257" r:id="R4f631ccd5b854966"/>
-    <p:sldId xmlns:r="http://schemas.openxmlformats.org/officeDocument/2006/relationships" id="258" r:id="R5a607c52bd5341b1"/>
-    <p:sldId xmlns:r="http://schemas.openxmlformats.org/officeDocument/2006/relationships" id="259" r:id="R43fb36539e7e4467"/>
-    <p:sldId xmlns:r="http://schemas.openxmlformats.org/officeDocument/2006/relationships" id="260" r:id="Rd971c8a94ff94f15"/>
-    <p:sldId xmlns:r="http://schemas.openxmlformats.org/officeDocument/2006/relationships" id="261" r:id="R13e0b814fead4bb1"/>
-    <p:sldId xmlns:r="http://schemas.openxmlformats.org/officeDocument/2006/relationships" id="262" r:id="R13e2ad61cc104483"/>
-    <p:sldId xmlns:r="http://schemas.openxmlformats.org/officeDocument/2006/relationships" id="263" r:id="R3bc4374851964d35"/>
-    <p:sldId xmlns:r="http://schemas.openxmlformats.org/officeDocument/2006/relationships" id="264" r:id="R5f26bc39a55a48e5"/>
-    <p:sldId xmlns:r="http://schemas.openxmlformats.org/officeDocument/2006/relationships" id="265" r:id="Rb25315040c9a409a"/>
+    <p:sldId xmlns:r="http://schemas.openxmlformats.org/officeDocument/2006/relationships" id="256" r:id="R2aff7e8acff749d7"/>
+    <p:sldId xmlns:r="http://schemas.openxmlformats.org/officeDocument/2006/relationships" id="257" r:id="Rb7c27742628d4312"/>
+    <p:sldId xmlns:r="http://schemas.openxmlformats.org/officeDocument/2006/relationships" id="258" r:id="R6e05c5979eb048b1"/>
+    <p:sldId xmlns:r="http://schemas.openxmlformats.org/officeDocument/2006/relationships" id="259" r:id="Rc17acef321df40c8"/>
+    <p:sldId xmlns:r="http://schemas.openxmlformats.org/officeDocument/2006/relationships" id="260" r:id="R2139a1163d4946e5"/>
+    <p:sldId xmlns:r="http://schemas.openxmlformats.org/officeDocument/2006/relationships" id="261" r:id="Rcc36a9fba9514e54"/>
+    <p:sldId xmlns:r="http://schemas.openxmlformats.org/officeDocument/2006/relationships" id="262" r:id="R52e81f1b7cce450f"/>
+    <p:sldId xmlns:r="http://schemas.openxmlformats.org/officeDocument/2006/relationships" id="263" r:id="R4e9745ced60e4c5d"/>
+    <p:sldId xmlns:r="http://schemas.openxmlformats.org/officeDocument/2006/relationships" id="264" r:id="R66d61afad71b43a2"/>
+    <p:sldId xmlns:r="http://schemas.openxmlformats.org/officeDocument/2006/relationships" id="265" r:id="Rc06a3a9b543144b2"/>
+    <p:sldId xmlns:r="http://schemas.openxmlformats.org/officeDocument/2006/relationships" id="266" r:id="Rd78829dd075f4fcf"/>
+    <p:sldId xmlns:r="http://schemas.openxmlformats.org/officeDocument/2006/relationships" id="267" r:id="R296052f1e7984a01"/>
+    <p:sldId xmlns:r="http://schemas.openxmlformats.org/officeDocument/2006/relationships" id="268" r:id="R594f24f54e8f42b7"/>
+    <p:sldId xmlns:r="http://schemas.openxmlformats.org/officeDocument/2006/relationships" id="269" r:id="Rc52d03f33f0e40eb"/>
+    <p:sldId xmlns:r="http://schemas.openxmlformats.org/officeDocument/2006/relationships" id="270" r:id="R31adc33a12ac4ab6"/>
+    <p:sldId xmlns:r="http://schemas.openxmlformats.org/officeDocument/2006/relationships" id="271" r:id="R9839342601494d6d"/>
+    <p:sldId xmlns:r="http://schemas.openxmlformats.org/officeDocument/2006/relationships" id="272" r:id="Rac05c9d3386a4f5e"/>
   </p:sldIdLst>
   <p:sldSz cx="12192000" cy="6858000"/>
   <p:notesSz cx="6858000" cy="9144000"/>
@@ -638,6 +645,468 @@
 </p:notes>
 </file>
 
+<file path=ppt/notesSlides/notesSlide11.xml><?xml version="1.0" encoding="utf-8"?>
+<p:notes xmlns:p="http://schemas.openxmlformats.org/presentationml/2006/main">
+  <p:cSld>
+    <p:spTree>
+      <p:nvGrpSpPr>
+        <p:cNvPr id="1" name=""/>
+        <p:cNvGrpSpPr/>
+        <p:nvPr/>
+      </p:nvGrpSpPr>
+      <p:grpSpPr>
+        <a:xfrm xmlns:a="http://schemas.openxmlformats.org/drawingml/2006/main"/>
+      </p:grpSpPr>
+      <p:sp>
+        <p:nvSpPr>
+          <p:cNvPr id="2" name="Slide Image Placeholder 1"/>
+          <p:cNvSpPr>
+            <a:spLocks xmlns:a="http://schemas.openxmlformats.org/drawingml/2006/main" noGrp="1"/>
+          </p:cNvSpPr>
+          <p:nvPr>
+            <p:ph type="sldImg" idx="0"/>
+          </p:nvPr>
+        </p:nvSpPr>
+        <p:spPr/>
+      </p:sp>
+      <p:sp>
+        <p:nvSpPr>
+          <p:cNvPr id="3" name="Notes Placeholder 2"/>
+          <p:cNvSpPr>
+            <a:spLocks xmlns:a="http://schemas.openxmlformats.org/drawingml/2006/main" noGrp="1"/>
+          </p:cNvSpPr>
+          <p:nvPr>
+            <p:ph type="body" idx="1"/>
+          </p:nvPr>
+        </p:nvSpPr>
+        <p:spPr/>
+        <p:txBody>
+          <a:bodyPr xmlns:a="http://schemas.openxmlformats.org/drawingml/2006/main"/>
+          <a:lstStyle xmlns:a="http://schemas.openxmlformats.org/drawingml/2006/main"/>
+          <a:p xmlns:a="http://schemas.openxmlformats.org/drawingml/2006/main"/>
+        </p:txBody>
+      </p:sp>
+      <p:sp>
+        <p:nvSpPr>
+          <p:cNvPr id="4" name="Slide Number Placeholder 3"/>
+          <p:cNvSpPr>
+            <a:spLocks xmlns:a="http://schemas.openxmlformats.org/drawingml/2006/main" noGrp="1"/>
+          </p:cNvSpPr>
+          <p:nvPr>
+            <p:ph type="sldNum" idx="5"/>
+          </p:nvPr>
+        </p:nvSpPr>
+        <p:spPr/>
+        <p:txBody>
+          <a:bodyPr xmlns:a="http://schemas.openxmlformats.org/drawingml/2006/main"/>
+          <a:lstStyle xmlns:a="http://schemas.openxmlformats.org/drawingml/2006/main"/>
+          <a:p xmlns:a="http://schemas.openxmlformats.org/drawingml/2006/main"/>
+        </p:txBody>
+      </p:sp>
+    </p:spTree>
+  </p:cSld>
+  <p:clrMapOvr>
+    <a:masterClrMapping xmlns:a="http://schemas.openxmlformats.org/drawingml/2006/main"/>
+  </p:clrMapOvr>
+</p:notes>
+</file>
+
+<file path=ppt/notesSlides/notesSlide12.xml><?xml version="1.0" encoding="utf-8"?>
+<p:notes xmlns:p="http://schemas.openxmlformats.org/presentationml/2006/main">
+  <p:cSld>
+    <p:spTree>
+      <p:nvGrpSpPr>
+        <p:cNvPr id="1" name=""/>
+        <p:cNvGrpSpPr/>
+        <p:nvPr/>
+      </p:nvGrpSpPr>
+      <p:grpSpPr>
+        <a:xfrm xmlns:a="http://schemas.openxmlformats.org/drawingml/2006/main"/>
+      </p:grpSpPr>
+      <p:sp>
+        <p:nvSpPr>
+          <p:cNvPr id="2" name="Slide Image Placeholder 1"/>
+          <p:cNvSpPr>
+            <a:spLocks xmlns:a="http://schemas.openxmlformats.org/drawingml/2006/main" noGrp="1"/>
+          </p:cNvSpPr>
+          <p:nvPr>
+            <p:ph type="sldImg" idx="0"/>
+          </p:nvPr>
+        </p:nvSpPr>
+        <p:spPr/>
+      </p:sp>
+      <p:sp>
+        <p:nvSpPr>
+          <p:cNvPr id="3" name="Notes Placeholder 2"/>
+          <p:cNvSpPr>
+            <a:spLocks xmlns:a="http://schemas.openxmlformats.org/drawingml/2006/main" noGrp="1"/>
+          </p:cNvSpPr>
+          <p:nvPr>
+            <p:ph type="body" idx="1"/>
+          </p:nvPr>
+        </p:nvSpPr>
+        <p:spPr/>
+        <p:txBody>
+          <a:bodyPr xmlns:a="http://schemas.openxmlformats.org/drawingml/2006/main"/>
+          <a:lstStyle xmlns:a="http://schemas.openxmlformats.org/drawingml/2006/main"/>
+          <a:p xmlns:a="http://schemas.openxmlformats.org/drawingml/2006/main"/>
+        </p:txBody>
+      </p:sp>
+      <p:sp>
+        <p:nvSpPr>
+          <p:cNvPr id="4" name="Slide Number Placeholder 3"/>
+          <p:cNvSpPr>
+            <a:spLocks xmlns:a="http://schemas.openxmlformats.org/drawingml/2006/main" noGrp="1"/>
+          </p:cNvSpPr>
+          <p:nvPr>
+            <p:ph type="sldNum" idx="5"/>
+          </p:nvPr>
+        </p:nvSpPr>
+        <p:spPr/>
+        <p:txBody>
+          <a:bodyPr xmlns:a="http://schemas.openxmlformats.org/drawingml/2006/main"/>
+          <a:lstStyle xmlns:a="http://schemas.openxmlformats.org/drawingml/2006/main"/>
+          <a:p xmlns:a="http://schemas.openxmlformats.org/drawingml/2006/main"/>
+        </p:txBody>
+      </p:sp>
+    </p:spTree>
+  </p:cSld>
+  <p:clrMapOvr>
+    <a:masterClrMapping xmlns:a="http://schemas.openxmlformats.org/drawingml/2006/main"/>
+  </p:clrMapOvr>
+</p:notes>
+</file>
+
+<file path=ppt/notesSlides/notesSlide13.xml><?xml version="1.0" encoding="utf-8"?>
+<p:notes xmlns:p="http://schemas.openxmlformats.org/presentationml/2006/main">
+  <p:cSld>
+    <p:spTree>
+      <p:nvGrpSpPr>
+        <p:cNvPr id="1" name=""/>
+        <p:cNvGrpSpPr/>
+        <p:nvPr/>
+      </p:nvGrpSpPr>
+      <p:grpSpPr>
+        <a:xfrm xmlns:a="http://schemas.openxmlformats.org/drawingml/2006/main"/>
+      </p:grpSpPr>
+      <p:sp>
+        <p:nvSpPr>
+          <p:cNvPr id="2" name="Slide Image Placeholder 1"/>
+          <p:cNvSpPr>
+            <a:spLocks xmlns:a="http://schemas.openxmlformats.org/drawingml/2006/main" noGrp="1"/>
+          </p:cNvSpPr>
+          <p:nvPr>
+            <p:ph type="sldImg" idx="0"/>
+          </p:nvPr>
+        </p:nvSpPr>
+        <p:spPr/>
+      </p:sp>
+      <p:sp>
+        <p:nvSpPr>
+          <p:cNvPr id="3" name="Notes Placeholder 2"/>
+          <p:cNvSpPr>
+            <a:spLocks xmlns:a="http://schemas.openxmlformats.org/drawingml/2006/main" noGrp="1"/>
+          </p:cNvSpPr>
+          <p:nvPr>
+            <p:ph type="body" idx="1"/>
+          </p:nvPr>
+        </p:nvSpPr>
+        <p:spPr/>
+        <p:txBody>
+          <a:bodyPr xmlns:a="http://schemas.openxmlformats.org/drawingml/2006/main"/>
+          <a:lstStyle xmlns:a="http://schemas.openxmlformats.org/drawingml/2006/main"/>
+          <a:p xmlns:a="http://schemas.openxmlformats.org/drawingml/2006/main"/>
+        </p:txBody>
+      </p:sp>
+      <p:sp>
+        <p:nvSpPr>
+          <p:cNvPr id="4" name="Slide Number Placeholder 3"/>
+          <p:cNvSpPr>
+            <a:spLocks xmlns:a="http://schemas.openxmlformats.org/drawingml/2006/main" noGrp="1"/>
+          </p:cNvSpPr>
+          <p:nvPr>
+            <p:ph type="sldNum" idx="5"/>
+          </p:nvPr>
+        </p:nvSpPr>
+        <p:spPr/>
+        <p:txBody>
+          <a:bodyPr xmlns:a="http://schemas.openxmlformats.org/drawingml/2006/main"/>
+          <a:lstStyle xmlns:a="http://schemas.openxmlformats.org/drawingml/2006/main"/>
+          <a:p xmlns:a="http://schemas.openxmlformats.org/drawingml/2006/main"/>
+        </p:txBody>
+      </p:sp>
+    </p:spTree>
+  </p:cSld>
+  <p:clrMapOvr>
+    <a:masterClrMapping xmlns:a="http://schemas.openxmlformats.org/drawingml/2006/main"/>
+  </p:clrMapOvr>
+</p:notes>
+</file>
+
+<file path=ppt/notesSlides/notesSlide14.xml><?xml version="1.0" encoding="utf-8"?>
+<p:notes xmlns:p="http://schemas.openxmlformats.org/presentationml/2006/main">
+  <p:cSld>
+    <p:spTree>
+      <p:nvGrpSpPr>
+        <p:cNvPr id="1" name=""/>
+        <p:cNvGrpSpPr/>
+        <p:nvPr/>
+      </p:nvGrpSpPr>
+      <p:grpSpPr>
+        <a:xfrm xmlns:a="http://schemas.openxmlformats.org/drawingml/2006/main"/>
+      </p:grpSpPr>
+      <p:sp>
+        <p:nvSpPr>
+          <p:cNvPr id="2" name="Slide Image Placeholder 1"/>
+          <p:cNvSpPr>
+            <a:spLocks xmlns:a="http://schemas.openxmlformats.org/drawingml/2006/main" noGrp="1"/>
+          </p:cNvSpPr>
+          <p:nvPr>
+            <p:ph type="sldImg" idx="0"/>
+          </p:nvPr>
+        </p:nvSpPr>
+        <p:spPr/>
+      </p:sp>
+      <p:sp>
+        <p:nvSpPr>
+          <p:cNvPr id="3" name="Notes Placeholder 2"/>
+          <p:cNvSpPr>
+            <a:spLocks xmlns:a="http://schemas.openxmlformats.org/drawingml/2006/main" noGrp="1"/>
+          </p:cNvSpPr>
+          <p:nvPr>
+            <p:ph type="body" idx="1"/>
+          </p:nvPr>
+        </p:nvSpPr>
+        <p:spPr/>
+        <p:txBody>
+          <a:bodyPr xmlns:a="http://schemas.openxmlformats.org/drawingml/2006/main"/>
+          <a:lstStyle xmlns:a="http://schemas.openxmlformats.org/drawingml/2006/main"/>
+          <a:p xmlns:a="http://schemas.openxmlformats.org/drawingml/2006/main"/>
+        </p:txBody>
+      </p:sp>
+      <p:sp>
+        <p:nvSpPr>
+          <p:cNvPr id="4" name="Slide Number Placeholder 3"/>
+          <p:cNvSpPr>
+            <a:spLocks xmlns:a="http://schemas.openxmlformats.org/drawingml/2006/main" noGrp="1"/>
+          </p:cNvSpPr>
+          <p:nvPr>
+            <p:ph type="sldNum" idx="5"/>
+          </p:nvPr>
+        </p:nvSpPr>
+        <p:spPr/>
+        <p:txBody>
+          <a:bodyPr xmlns:a="http://schemas.openxmlformats.org/drawingml/2006/main"/>
+          <a:lstStyle xmlns:a="http://schemas.openxmlformats.org/drawingml/2006/main"/>
+          <a:p xmlns:a="http://schemas.openxmlformats.org/drawingml/2006/main"/>
+        </p:txBody>
+      </p:sp>
+    </p:spTree>
+  </p:cSld>
+  <p:clrMapOvr>
+    <a:masterClrMapping xmlns:a="http://schemas.openxmlformats.org/drawingml/2006/main"/>
+  </p:clrMapOvr>
+</p:notes>
+</file>
+
+<file path=ppt/notesSlides/notesSlide15.xml><?xml version="1.0" encoding="utf-8"?>
+<p:notes xmlns:p="http://schemas.openxmlformats.org/presentationml/2006/main">
+  <p:cSld>
+    <p:spTree>
+      <p:nvGrpSpPr>
+        <p:cNvPr id="1" name=""/>
+        <p:cNvGrpSpPr/>
+        <p:nvPr/>
+      </p:nvGrpSpPr>
+      <p:grpSpPr>
+        <a:xfrm xmlns:a="http://schemas.openxmlformats.org/drawingml/2006/main"/>
+      </p:grpSpPr>
+      <p:sp>
+        <p:nvSpPr>
+          <p:cNvPr id="2" name="Slide Image Placeholder 1"/>
+          <p:cNvSpPr>
+            <a:spLocks xmlns:a="http://schemas.openxmlformats.org/drawingml/2006/main" noGrp="1"/>
+          </p:cNvSpPr>
+          <p:nvPr>
+            <p:ph type="sldImg" idx="0"/>
+          </p:nvPr>
+        </p:nvSpPr>
+        <p:spPr/>
+      </p:sp>
+      <p:sp>
+        <p:nvSpPr>
+          <p:cNvPr id="3" name="Notes Placeholder 2"/>
+          <p:cNvSpPr>
+            <a:spLocks xmlns:a="http://schemas.openxmlformats.org/drawingml/2006/main" noGrp="1"/>
+          </p:cNvSpPr>
+          <p:nvPr>
+            <p:ph type="body" idx="1"/>
+          </p:nvPr>
+        </p:nvSpPr>
+        <p:spPr/>
+        <p:txBody>
+          <a:bodyPr xmlns:a="http://schemas.openxmlformats.org/drawingml/2006/main"/>
+          <a:lstStyle xmlns:a="http://schemas.openxmlformats.org/drawingml/2006/main"/>
+          <a:p xmlns:a="http://schemas.openxmlformats.org/drawingml/2006/main"/>
+        </p:txBody>
+      </p:sp>
+      <p:sp>
+        <p:nvSpPr>
+          <p:cNvPr id="4" name="Slide Number Placeholder 3"/>
+          <p:cNvSpPr>
+            <a:spLocks xmlns:a="http://schemas.openxmlformats.org/drawingml/2006/main" noGrp="1"/>
+          </p:cNvSpPr>
+          <p:nvPr>
+            <p:ph type="sldNum" idx="5"/>
+          </p:nvPr>
+        </p:nvSpPr>
+        <p:spPr/>
+        <p:txBody>
+          <a:bodyPr xmlns:a="http://schemas.openxmlformats.org/drawingml/2006/main"/>
+          <a:lstStyle xmlns:a="http://schemas.openxmlformats.org/drawingml/2006/main"/>
+          <a:p xmlns:a="http://schemas.openxmlformats.org/drawingml/2006/main"/>
+        </p:txBody>
+      </p:sp>
+    </p:spTree>
+  </p:cSld>
+  <p:clrMapOvr>
+    <a:masterClrMapping xmlns:a="http://schemas.openxmlformats.org/drawingml/2006/main"/>
+  </p:clrMapOvr>
+</p:notes>
+</file>
+
+<file path=ppt/notesSlides/notesSlide16.xml><?xml version="1.0" encoding="utf-8"?>
+<p:notes xmlns:p="http://schemas.openxmlformats.org/presentationml/2006/main">
+  <p:cSld>
+    <p:spTree>
+      <p:nvGrpSpPr>
+        <p:cNvPr id="1" name=""/>
+        <p:cNvGrpSpPr/>
+        <p:nvPr/>
+      </p:nvGrpSpPr>
+      <p:grpSpPr>
+        <a:xfrm xmlns:a="http://schemas.openxmlformats.org/drawingml/2006/main"/>
+      </p:grpSpPr>
+      <p:sp>
+        <p:nvSpPr>
+          <p:cNvPr id="2" name="Slide Image Placeholder 1"/>
+          <p:cNvSpPr>
+            <a:spLocks xmlns:a="http://schemas.openxmlformats.org/drawingml/2006/main" noGrp="1"/>
+          </p:cNvSpPr>
+          <p:nvPr>
+            <p:ph type="sldImg" idx="0"/>
+          </p:nvPr>
+        </p:nvSpPr>
+        <p:spPr/>
+      </p:sp>
+      <p:sp>
+        <p:nvSpPr>
+          <p:cNvPr id="3" name="Notes Placeholder 2"/>
+          <p:cNvSpPr>
+            <a:spLocks xmlns:a="http://schemas.openxmlformats.org/drawingml/2006/main" noGrp="1"/>
+          </p:cNvSpPr>
+          <p:nvPr>
+            <p:ph type="body" idx="1"/>
+          </p:nvPr>
+        </p:nvSpPr>
+        <p:spPr/>
+        <p:txBody>
+          <a:bodyPr xmlns:a="http://schemas.openxmlformats.org/drawingml/2006/main"/>
+          <a:lstStyle xmlns:a="http://schemas.openxmlformats.org/drawingml/2006/main"/>
+          <a:p xmlns:a="http://schemas.openxmlformats.org/drawingml/2006/main"/>
+        </p:txBody>
+      </p:sp>
+      <p:sp>
+        <p:nvSpPr>
+          <p:cNvPr id="4" name="Slide Number Placeholder 3"/>
+          <p:cNvSpPr>
+            <a:spLocks xmlns:a="http://schemas.openxmlformats.org/drawingml/2006/main" noGrp="1"/>
+          </p:cNvSpPr>
+          <p:nvPr>
+            <p:ph type="sldNum" idx="5"/>
+          </p:nvPr>
+        </p:nvSpPr>
+        <p:spPr/>
+        <p:txBody>
+          <a:bodyPr xmlns:a="http://schemas.openxmlformats.org/drawingml/2006/main"/>
+          <a:lstStyle xmlns:a="http://schemas.openxmlformats.org/drawingml/2006/main"/>
+          <a:p xmlns:a="http://schemas.openxmlformats.org/drawingml/2006/main"/>
+        </p:txBody>
+      </p:sp>
+    </p:spTree>
+  </p:cSld>
+  <p:clrMapOvr>
+    <a:masterClrMapping xmlns:a="http://schemas.openxmlformats.org/drawingml/2006/main"/>
+  </p:clrMapOvr>
+</p:notes>
+</file>
+
+<file path=ppt/notesSlides/notesSlide17.xml><?xml version="1.0" encoding="utf-8"?>
+<p:notes xmlns:p="http://schemas.openxmlformats.org/presentationml/2006/main">
+  <p:cSld>
+    <p:spTree>
+      <p:nvGrpSpPr>
+        <p:cNvPr id="1" name=""/>
+        <p:cNvGrpSpPr/>
+        <p:nvPr/>
+      </p:nvGrpSpPr>
+      <p:grpSpPr>
+        <a:xfrm xmlns:a="http://schemas.openxmlformats.org/drawingml/2006/main"/>
+      </p:grpSpPr>
+      <p:sp>
+        <p:nvSpPr>
+          <p:cNvPr id="2" name="Slide Image Placeholder 1"/>
+          <p:cNvSpPr>
+            <a:spLocks xmlns:a="http://schemas.openxmlformats.org/drawingml/2006/main" noGrp="1"/>
+          </p:cNvSpPr>
+          <p:nvPr>
+            <p:ph type="sldImg" idx="0"/>
+          </p:nvPr>
+        </p:nvSpPr>
+        <p:spPr/>
+      </p:sp>
+      <p:sp>
+        <p:nvSpPr>
+          <p:cNvPr id="3" name="Notes Placeholder 2"/>
+          <p:cNvSpPr>
+            <a:spLocks xmlns:a="http://schemas.openxmlformats.org/drawingml/2006/main" noGrp="1"/>
+          </p:cNvSpPr>
+          <p:nvPr>
+            <p:ph type="body" idx="1"/>
+          </p:nvPr>
+        </p:nvSpPr>
+        <p:spPr/>
+        <p:txBody>
+          <a:bodyPr xmlns:a="http://schemas.openxmlformats.org/drawingml/2006/main"/>
+          <a:lstStyle xmlns:a="http://schemas.openxmlformats.org/drawingml/2006/main"/>
+          <a:p xmlns:a="http://schemas.openxmlformats.org/drawingml/2006/main"/>
+        </p:txBody>
+      </p:sp>
+      <p:sp>
+        <p:nvSpPr>
+          <p:cNvPr id="4" name="Slide Number Placeholder 3"/>
+          <p:cNvSpPr>
+            <a:spLocks xmlns:a="http://schemas.openxmlformats.org/drawingml/2006/main" noGrp="1"/>
+          </p:cNvSpPr>
+          <p:nvPr>
+            <p:ph type="sldNum" idx="5"/>
+          </p:nvPr>
+        </p:nvSpPr>
+        <p:spPr/>
+        <p:txBody>
+          <a:bodyPr xmlns:a="http://schemas.openxmlformats.org/drawingml/2006/main"/>
+          <a:lstStyle xmlns:a="http://schemas.openxmlformats.org/drawingml/2006/main"/>
+          <a:p xmlns:a="http://schemas.openxmlformats.org/drawingml/2006/main"/>
+        </p:txBody>
+      </p:sp>
+    </p:spTree>
+  </p:cSld>
+  <p:clrMapOvr>
+    <a:masterClrMapping xmlns:a="http://schemas.openxmlformats.org/drawingml/2006/main"/>
+  </p:clrMapOvr>
+</p:notes>
+</file>
+
 <file path=ppt/notesSlides/notesSlide2.xml><?xml version="1.0" encoding="utf-8"?>
 <p:notes xmlns:p="http://schemas.openxmlformats.org/presentationml/2006/main">
   <p:cSld>
@@ -1204,7 +1673,7 @@
   </p:cSld>
   <p:clrMap bg1="lt1" tx1="dk1" bg2="lt2" tx2="dk2" accent1="accent1" accent2="accent2" accent3="accent3" accent4="accent4" accent5="accent5" accent6="accent6" hlink="hlink" folHlink="folHlink"/>
   <p:sldLayoutIdLst>
-    <p:sldLayoutId xmlns:r="http://schemas.openxmlformats.org/officeDocument/2006/relationships" id="2147483649" r:id="Rbc6dd20e172740a4"/>
+    <p:sldLayoutId xmlns:r="http://schemas.openxmlformats.org/officeDocument/2006/relationships" id="2147483649" r:id="R48674be5d3da4449"/>
   </p:sldLayoutIdLst>
   <p:txStyles>
     <p:titleStyle>
@@ -1755,7 +2224,7 @@
           <p:cNvPr id="1" name="">
             <a:extLst xmlns:a="http://schemas.openxmlformats.org/drawingml/2006/main">
               <a:ext uri="{FF2B5EF4-FFF2-40B4-BE49-F238E27FC236}">
-                <a16:creationId xmlns:a16="http://schemas.microsoft.com/office/drawing/2014/main" id="{51297AF3-4788-49AC-81FC-42CBA6E3E527}"/>
+                <a16:creationId xmlns:a16="http://schemas.microsoft.com/office/drawing/2014/main" id="{22DD9EAA-DED7-4A68-9ED9-7E1AFAEFB75B}"/>
               </a:ext>
             </a:extLst>
           </p:cNvPr>
@@ -1805,7 +2274,7 @@
           <p:cNvPr id="2" name="">
             <a:extLst xmlns:a="http://schemas.openxmlformats.org/drawingml/2006/main">
               <a:ext uri="{FF2B5EF4-FFF2-40B4-BE49-F238E27FC236}">
-                <a16:creationId xmlns:a16="http://schemas.microsoft.com/office/drawing/2014/main" id="{2955C1F2-35D9-405B-8D70-D86FC5782625}"/>
+                <a16:creationId xmlns:a16="http://schemas.microsoft.com/office/drawing/2014/main" id="{74D4798E-90B8-4E56-8BD3-53ED7F5EFF2A}"/>
               </a:ext>
             </a:extLst>
           </p:cNvPr>
@@ -1855,7 +2324,7 @@
           <p:cNvPr id="3" name="">
             <a:extLst xmlns:a="http://schemas.openxmlformats.org/drawingml/2006/main">
               <a:ext uri="{FF2B5EF4-FFF2-40B4-BE49-F238E27FC236}">
-                <a16:creationId xmlns:a16="http://schemas.microsoft.com/office/drawing/2014/main" id="{AA54D87C-EE50-4303-949B-2431E4CA9A12}"/>
+                <a16:creationId xmlns:a16="http://schemas.microsoft.com/office/drawing/2014/main" id="{2108B7D8-3993-4710-855B-A725AED2FBA4}"/>
               </a:ext>
             </a:extLst>
           </p:cNvPr>
@@ -1905,7 +2374,7 @@
           <p:cNvPr id="4" name="">
             <a:extLst xmlns:a="http://schemas.openxmlformats.org/drawingml/2006/main">
               <a:ext uri="{FF2B5EF4-FFF2-40B4-BE49-F238E27FC236}">
-                <a16:creationId xmlns:a16="http://schemas.microsoft.com/office/drawing/2014/main" id="{DD4AB86C-5DEA-4A31-89EE-4FF9AFD4B29B}"/>
+                <a16:creationId xmlns:a16="http://schemas.microsoft.com/office/drawing/2014/main" id="{168EF6BD-500C-47C0-9193-1F14C389A897}"/>
               </a:ext>
             </a:extLst>
           </p:cNvPr>
@@ -1936,7 +2405,7 @@
           <p:cNvPr id="5" name="">
             <a:extLst xmlns:a="http://schemas.openxmlformats.org/drawingml/2006/main">
               <a:ext uri="{FF2B5EF4-FFF2-40B4-BE49-F238E27FC236}">
-                <a16:creationId xmlns:a16="http://schemas.microsoft.com/office/drawing/2014/main" id="{7104F541-4A14-4531-BB1D-BC88603E81D0}"/>
+                <a16:creationId xmlns:a16="http://schemas.microsoft.com/office/drawing/2014/main" id="{EB2A158B-2493-48D7-B6A6-AF7D1575D2C8}"/>
               </a:ext>
             </a:extLst>
           </p:cNvPr>
@@ -1986,7 +2455,7 @@
           <p:cNvPr id="6" name="">
             <a:extLst xmlns:a="http://schemas.openxmlformats.org/drawingml/2006/main">
               <a:ext uri="{FF2B5EF4-FFF2-40B4-BE49-F238E27FC236}">
-                <a16:creationId xmlns:a16="http://schemas.microsoft.com/office/drawing/2014/main" id="{3E039810-6BCB-468C-8F60-89E07A661E8E}"/>
+                <a16:creationId xmlns:a16="http://schemas.microsoft.com/office/drawing/2014/main" id="{531B1FE1-037C-4E09-93FF-0967BE4B99BB}"/>
               </a:ext>
             </a:extLst>
           </p:cNvPr>
@@ -2017,7 +2486,7 @@
           <p:cNvPr id="7" name="">
             <a:extLst xmlns:a="http://schemas.openxmlformats.org/drawingml/2006/main">
               <a:ext uri="{FF2B5EF4-FFF2-40B4-BE49-F238E27FC236}">
-                <a16:creationId xmlns:a16="http://schemas.microsoft.com/office/drawing/2014/main" id="{2C29CA01-AA0E-405B-9745-767757C8F0A4}"/>
+                <a16:creationId xmlns:a16="http://schemas.microsoft.com/office/drawing/2014/main" id="{0645951D-59D7-481A-94F5-A566A74D08CD}"/>
               </a:ext>
             </a:extLst>
           </p:cNvPr>
@@ -2067,7 +2536,7 @@
           <p:cNvPr id="8" name="">
             <a:extLst xmlns:a="http://schemas.openxmlformats.org/drawingml/2006/main">
               <a:ext uri="{FF2B5EF4-FFF2-40B4-BE49-F238E27FC236}">
-                <a16:creationId xmlns:a16="http://schemas.microsoft.com/office/drawing/2014/main" id="{A8A24AD7-0527-42A0-AD31-3328871738B6}"/>
+                <a16:creationId xmlns:a16="http://schemas.microsoft.com/office/drawing/2014/main" id="{B5F49E97-235D-43EA-BFA4-2AA41194BC17}"/>
               </a:ext>
             </a:extLst>
           </p:cNvPr>
@@ -2149,7 +2618,7 @@
     </p:spTree>
     <p:extLst>
       <p:ext uri="{BB962C8B-B14F-4D97-AF65-F5344CB8AC3E}">
-        <p14:creationId xmlns:p14="http://schemas.microsoft.com/office/powerpoint/2010/main" val="1867606813"/>
+        <p14:creationId xmlns:p14="http://schemas.microsoft.com/office/powerpoint/2010/main" val="1741620921"/>
       </p:ext>
     </p:extLst>
   </p:cSld>
@@ -2180,7 +2649,7 @@
           <p:cNvPr id="1" name="">
             <a:extLst xmlns:a="http://schemas.openxmlformats.org/drawingml/2006/main">
               <a:ext uri="{FF2B5EF4-FFF2-40B4-BE49-F238E27FC236}">
-                <a16:creationId xmlns:a16="http://schemas.microsoft.com/office/drawing/2014/main" id="{8D67CF19-7628-457B-B841-EDBBD8D77AEE}"/>
+                <a16:creationId xmlns:a16="http://schemas.microsoft.com/office/drawing/2014/main" id="{E9433120-54E9-48E7-B64D-7D58861E3762}"/>
               </a:ext>
             </a:extLst>
           </p:cNvPr>
@@ -2230,7 +2699,7 @@
           <p:cNvPr id="2" name="">
             <a:extLst xmlns:a="http://schemas.openxmlformats.org/drawingml/2006/main">
               <a:ext uri="{FF2B5EF4-FFF2-40B4-BE49-F238E27FC236}">
-                <a16:creationId xmlns:a16="http://schemas.microsoft.com/office/drawing/2014/main" id="{6A6A8FF4-4A23-4BAB-B392-77054275CDA1}"/>
+                <a16:creationId xmlns:a16="http://schemas.microsoft.com/office/drawing/2014/main" id="{377AAB0A-234E-4BF8-8749-607462636B49}"/>
               </a:ext>
             </a:extLst>
           </p:cNvPr>
@@ -2270,7 +2739,7 @@
                   <a:srgbClr val="000000"/>
                 </a:solidFill>
               </a:rPr>
-              <a:t>The next build can fit a deliberately simple model</a:t>
+              <a:t>The next build tests a deliberately simple model</a:t>
             </a:r>
           </a:p>
         </p:txBody>
@@ -2280,7 +2749,7 @@
           <p:cNvPr id="3" name="">
             <a:extLst xmlns:a="http://schemas.openxmlformats.org/drawingml/2006/main">
               <a:ext uri="{FF2B5EF4-FFF2-40B4-BE49-F238E27FC236}">
-                <a16:creationId xmlns:a16="http://schemas.microsoft.com/office/drawing/2014/main" id="{1E40FCCE-56DD-4315-831C-11B8AAA952AA}"/>
+                <a16:creationId xmlns:a16="http://schemas.microsoft.com/office/drawing/2014/main" id="{A123B74E-EBC7-47F6-BDF4-4275072C5F00}"/>
               </a:ext>
             </a:extLst>
           </p:cNvPr>
@@ -2311,7 +2780,7 @@
           <p:cNvPr id="4" name="">
             <a:extLst xmlns:a="http://schemas.openxmlformats.org/drawingml/2006/main">
               <a:ext uri="{FF2B5EF4-FFF2-40B4-BE49-F238E27FC236}">
-                <a16:creationId xmlns:a16="http://schemas.microsoft.com/office/drawing/2014/main" id="{2DB4936B-3630-41ED-8BA2-E6CDE49480D8}"/>
+                <a16:creationId xmlns:a16="http://schemas.microsoft.com/office/drawing/2014/main" id="{22888014-DF4E-4741-A439-49705E9F56CC}"/>
               </a:ext>
             </a:extLst>
           </p:cNvPr>
@@ -2323,7 +2792,7 @@
         <p:spPr>
           <a:xfrm xmlns:a="http://schemas.openxmlformats.org/drawingml/2006/main">
             <a:off x="876300" y="2152650"/>
-            <a:ext cx="7239000" cy="685800"/>
+            <a:ext cx="7429500" cy="819150"/>
           </a:xfrm>
           <a:prstGeom xmlns:a="http://schemas.openxmlformats.org/drawingml/2006/main" prst="rect">
             <a:avLst/>
@@ -2351,7 +2820,7 @@
                   <a:srgbClr val="000000"/>
                 </a:solidFill>
               </a:rPr>
-              <a:t>ML-P0 passed the table-quality gate. The next useful slice is ML-P1: GLM logistic replay.</a:t>
+              <a:t>ML-P0 passed the table-quality gate. ML-P1 asks whether a plain GLM can turn that table into coherent daily long/flat behavior.</a:t>
             </a:r>
           </a:p>
         </p:txBody>
@@ -2361,18 +2830,18 @@
           <p:cNvPr id="5" name="">
             <a:extLst xmlns:a="http://schemas.openxmlformats.org/drawingml/2006/main">
               <a:ext uri="{FF2B5EF4-FFF2-40B4-BE49-F238E27FC236}">
-                <a16:creationId xmlns:a16="http://schemas.microsoft.com/office/drawing/2014/main" id="{7C409D97-D7E2-4345-9469-AF38C2938144}"/>
-              </a:ext>
-            </a:extLst>
-          </p:cNvPr>
-          <p:cNvSpPr>
-            <a:spLocks xmlns:a="http://schemas.openxmlformats.org/drawingml/2006/main" noGrp="1"/>
-          </p:cNvSpPr>
-          <p:nvPr/>
-        </p:nvSpPr>
-        <p:spPr>
-          <a:xfrm xmlns:a="http://schemas.openxmlformats.org/drawingml/2006/main">
-            <a:off x="1181100" y="3343275"/>
+                <a16:creationId xmlns:a16="http://schemas.microsoft.com/office/drawing/2014/main" id="{E2CB7C25-C316-4C07-B795-201F3C558FFC}"/>
+              </a:ext>
+            </a:extLst>
+          </p:cNvPr>
+          <p:cNvSpPr>
+            <a:spLocks xmlns:a="http://schemas.openxmlformats.org/drawingml/2006/main" noGrp="1"/>
+          </p:cNvSpPr>
+          <p:nvPr/>
+        </p:nvSpPr>
+        <p:spPr>
+          <a:xfrm xmlns:a="http://schemas.openxmlformats.org/drawingml/2006/main">
+            <a:off x="1181100" y="3438525"/>
             <a:ext cx="190500" cy="247650"/>
           </a:xfrm>
           <a:prstGeom xmlns:a="http://schemas.openxmlformats.org/drawingml/2006/main" prst="rect">
@@ -2411,18 +2880,18 @@
           <p:cNvPr id="6" name="">
             <a:extLst xmlns:a="http://schemas.openxmlformats.org/drawingml/2006/main">
               <a:ext uri="{FF2B5EF4-FFF2-40B4-BE49-F238E27FC236}">
-                <a16:creationId xmlns:a16="http://schemas.microsoft.com/office/drawing/2014/main" id="{A35D1A28-0127-4504-9302-3C11723FD722}"/>
-              </a:ext>
-            </a:extLst>
-          </p:cNvPr>
-          <p:cNvSpPr>
-            <a:spLocks xmlns:a="http://schemas.openxmlformats.org/drawingml/2006/main" noGrp="1"/>
-          </p:cNvSpPr>
-          <p:nvPr/>
-        </p:nvSpPr>
-        <p:spPr>
-          <a:xfrm xmlns:a="http://schemas.openxmlformats.org/drawingml/2006/main">
-            <a:off x="1447800" y="3333750"/>
+                <a16:creationId xmlns:a16="http://schemas.microsoft.com/office/drawing/2014/main" id="{008E636A-20FC-473C-8E32-BC1D34EEC805}"/>
+              </a:ext>
+            </a:extLst>
+          </p:cNvPr>
+          <p:cNvSpPr>
+            <a:spLocks xmlns:a="http://schemas.openxmlformats.org/drawingml/2006/main" noGrp="1"/>
+          </p:cNvSpPr>
+          <p:nvPr/>
+        </p:nvSpPr>
+        <p:spPr>
+          <a:xfrm xmlns:a="http://schemas.openxmlformats.org/drawingml/2006/main">
+            <a:off x="1447800" y="3429000"/>
             <a:ext cx="4686300" cy="514350"/>
           </a:xfrm>
           <a:prstGeom xmlns:a="http://schemas.openxmlformats.org/drawingml/2006/main" prst="rect">
@@ -2461,18 +2930,18 @@
           <p:cNvPr id="7" name="">
             <a:extLst xmlns:a="http://schemas.openxmlformats.org/drawingml/2006/main">
               <a:ext uri="{FF2B5EF4-FFF2-40B4-BE49-F238E27FC236}">
-                <a16:creationId xmlns:a16="http://schemas.microsoft.com/office/drawing/2014/main" id="{77C338E9-7181-49B6-8180-8D24FE131A7E}"/>
-              </a:ext>
-            </a:extLst>
-          </p:cNvPr>
-          <p:cNvSpPr>
-            <a:spLocks xmlns:a="http://schemas.openxmlformats.org/drawingml/2006/main" noGrp="1"/>
-          </p:cNvSpPr>
-          <p:nvPr/>
-        </p:nvSpPr>
-        <p:spPr>
-          <a:xfrm xmlns:a="http://schemas.openxmlformats.org/drawingml/2006/main">
-            <a:off x="1181100" y="4010025"/>
+                <a16:creationId xmlns:a16="http://schemas.microsoft.com/office/drawing/2014/main" id="{81C1E11A-DA31-4027-AF79-CB2768896CC9}"/>
+              </a:ext>
+            </a:extLst>
+          </p:cNvPr>
+          <p:cNvSpPr>
+            <a:spLocks xmlns:a="http://schemas.openxmlformats.org/drawingml/2006/main" noGrp="1"/>
+          </p:cNvSpPr>
+          <p:nvPr/>
+        </p:nvSpPr>
+        <p:spPr>
+          <a:xfrm xmlns:a="http://schemas.openxmlformats.org/drawingml/2006/main">
+            <a:off x="1181100" y="4105275"/>
             <a:ext cx="190500" cy="247650"/>
           </a:xfrm>
           <a:prstGeom xmlns:a="http://schemas.openxmlformats.org/drawingml/2006/main" prst="rect">
@@ -2511,18 +2980,18 @@
           <p:cNvPr id="8" name="">
             <a:extLst xmlns:a="http://schemas.openxmlformats.org/drawingml/2006/main">
               <a:ext uri="{FF2B5EF4-FFF2-40B4-BE49-F238E27FC236}">
-                <a16:creationId xmlns:a16="http://schemas.microsoft.com/office/drawing/2014/main" id="{0CEAB92E-BB1F-420B-8C5D-F5CC9ED498C9}"/>
-              </a:ext>
-            </a:extLst>
-          </p:cNvPr>
-          <p:cNvSpPr>
-            <a:spLocks xmlns:a="http://schemas.openxmlformats.org/drawingml/2006/main" noGrp="1"/>
-          </p:cNvSpPr>
-          <p:nvPr/>
-        </p:nvSpPr>
-        <p:spPr>
-          <a:xfrm xmlns:a="http://schemas.openxmlformats.org/drawingml/2006/main">
-            <a:off x="1447800" y="4000500"/>
+                <a16:creationId xmlns:a16="http://schemas.microsoft.com/office/drawing/2014/main" id="{070DD0C6-3850-41AD-AF31-5242E3D0E32E}"/>
+              </a:ext>
+            </a:extLst>
+          </p:cNvPr>
+          <p:cNvSpPr>
+            <a:spLocks xmlns:a="http://schemas.openxmlformats.org/drawingml/2006/main" noGrp="1"/>
+          </p:cNvSpPr>
+          <p:nvPr/>
+        </p:nvSpPr>
+        <p:spPr>
+          <a:xfrm xmlns:a="http://schemas.openxmlformats.org/drawingml/2006/main">
+            <a:off x="1447800" y="4095750"/>
             <a:ext cx="4686300" cy="514350"/>
           </a:xfrm>
           <a:prstGeom xmlns:a="http://schemas.openxmlformats.org/drawingml/2006/main" prst="rect">
@@ -2561,18 +3030,18 @@
           <p:cNvPr id="9" name="">
             <a:extLst xmlns:a="http://schemas.openxmlformats.org/drawingml/2006/main">
               <a:ext uri="{FF2B5EF4-FFF2-40B4-BE49-F238E27FC236}">
-                <a16:creationId xmlns:a16="http://schemas.microsoft.com/office/drawing/2014/main" id="{CFC93CAE-013D-4A66-BA20-4D662C5C5E1E}"/>
-              </a:ext>
-            </a:extLst>
-          </p:cNvPr>
-          <p:cNvSpPr>
-            <a:spLocks xmlns:a="http://schemas.openxmlformats.org/drawingml/2006/main" noGrp="1"/>
-          </p:cNvSpPr>
-          <p:nvPr/>
-        </p:nvSpPr>
-        <p:spPr>
-          <a:xfrm xmlns:a="http://schemas.openxmlformats.org/drawingml/2006/main">
-            <a:off x="1181100" y="4676775"/>
+                <a16:creationId xmlns:a16="http://schemas.microsoft.com/office/drawing/2014/main" id="{F2DE1AD5-1493-4952-A325-9A0E993FF858}"/>
+              </a:ext>
+            </a:extLst>
+          </p:cNvPr>
+          <p:cNvSpPr>
+            <a:spLocks xmlns:a="http://schemas.openxmlformats.org/drawingml/2006/main" noGrp="1"/>
+          </p:cNvSpPr>
+          <p:nvPr/>
+        </p:nvSpPr>
+        <p:spPr>
+          <a:xfrm xmlns:a="http://schemas.openxmlformats.org/drawingml/2006/main">
+            <a:off x="1181100" y="4772025"/>
             <a:ext cx="190500" cy="247650"/>
           </a:xfrm>
           <a:prstGeom xmlns:a="http://schemas.openxmlformats.org/drawingml/2006/main" prst="rect">
@@ -2611,18 +3080,18 @@
           <p:cNvPr id="10" name="">
             <a:extLst xmlns:a="http://schemas.openxmlformats.org/drawingml/2006/main">
               <a:ext uri="{FF2B5EF4-FFF2-40B4-BE49-F238E27FC236}">
-                <a16:creationId xmlns:a16="http://schemas.microsoft.com/office/drawing/2014/main" id="{366CA9CA-D27F-4297-8F8C-27E36F5324B1}"/>
-              </a:ext>
-            </a:extLst>
-          </p:cNvPr>
-          <p:cNvSpPr>
-            <a:spLocks xmlns:a="http://schemas.openxmlformats.org/drawingml/2006/main" noGrp="1"/>
-          </p:cNvSpPr>
-          <p:nvPr/>
-        </p:nvSpPr>
-        <p:spPr>
-          <a:xfrm xmlns:a="http://schemas.openxmlformats.org/drawingml/2006/main">
-            <a:off x="1447800" y="4667250"/>
+                <a16:creationId xmlns:a16="http://schemas.microsoft.com/office/drawing/2014/main" id="{90C25DD9-2476-4EAF-9760-8A4E9803B1D9}"/>
+              </a:ext>
+            </a:extLst>
+          </p:cNvPr>
+          <p:cNvSpPr>
+            <a:spLocks xmlns:a="http://schemas.openxmlformats.org/drawingml/2006/main" noGrp="1"/>
+          </p:cNvSpPr>
+          <p:nvPr/>
+        </p:nvSpPr>
+        <p:spPr>
+          <a:xfrm xmlns:a="http://schemas.openxmlformats.org/drawingml/2006/main">
+            <a:off x="1447800" y="4762500"/>
             <a:ext cx="4686300" cy="514350"/>
           </a:xfrm>
           <a:prstGeom xmlns:a="http://schemas.openxmlformats.org/drawingml/2006/main" prst="rect">
@@ -2651,7 +3120,7 @@
                   <a:srgbClr val="222222"/>
                 </a:solidFill>
               </a:rPr>
-              <a:t>Replay long/flat decisions with fixed or TRAIN-selected thresholds.</a:t>
+              <a:t>Replay long/flat decisions with fixed thresholds.</a:t>
             </a:r>
           </a:p>
         </p:txBody>
@@ -2661,18 +3130,18 @@
           <p:cNvPr id="11" name="">
             <a:extLst xmlns:a="http://schemas.openxmlformats.org/drawingml/2006/main">
               <a:ext uri="{FF2B5EF4-FFF2-40B4-BE49-F238E27FC236}">
-                <a16:creationId xmlns:a16="http://schemas.microsoft.com/office/drawing/2014/main" id="{E8BB212A-CE16-4EDD-9CD9-52091AC60BCF}"/>
-              </a:ext>
-            </a:extLst>
-          </p:cNvPr>
-          <p:cNvSpPr>
-            <a:spLocks xmlns:a="http://schemas.openxmlformats.org/drawingml/2006/main" noGrp="1"/>
-          </p:cNvSpPr>
-          <p:nvPr/>
-        </p:nvSpPr>
-        <p:spPr>
-          <a:xfrm xmlns:a="http://schemas.openxmlformats.org/drawingml/2006/main">
-            <a:off x="1181100" y="5343525"/>
+                <a16:creationId xmlns:a16="http://schemas.microsoft.com/office/drawing/2014/main" id="{E00CDFB8-B9C2-4BDF-90EE-82123BA8E721}"/>
+              </a:ext>
+            </a:extLst>
+          </p:cNvPr>
+          <p:cNvSpPr>
+            <a:spLocks xmlns:a="http://schemas.openxmlformats.org/drawingml/2006/main" noGrp="1"/>
+          </p:cNvSpPr>
+          <p:nvPr/>
+        </p:nvSpPr>
+        <p:spPr>
+          <a:xfrm xmlns:a="http://schemas.openxmlformats.org/drawingml/2006/main">
+            <a:off x="1181100" y="5438775"/>
             <a:ext cx="190500" cy="247650"/>
           </a:xfrm>
           <a:prstGeom xmlns:a="http://schemas.openxmlformats.org/drawingml/2006/main" prst="rect">
@@ -2711,18 +3180,18 @@
           <p:cNvPr id="12" name="">
             <a:extLst xmlns:a="http://schemas.openxmlformats.org/drawingml/2006/main">
               <a:ext uri="{FF2B5EF4-FFF2-40B4-BE49-F238E27FC236}">
-                <a16:creationId xmlns:a16="http://schemas.microsoft.com/office/drawing/2014/main" id="{6872B35B-2496-4B17-A15B-683D4A5D7491}"/>
-              </a:ext>
-            </a:extLst>
-          </p:cNvPr>
-          <p:cNvSpPr>
-            <a:spLocks xmlns:a="http://schemas.openxmlformats.org/drawingml/2006/main" noGrp="1"/>
-          </p:cNvSpPr>
-          <p:nvPr/>
-        </p:nvSpPr>
-        <p:spPr>
-          <a:xfrm xmlns:a="http://schemas.openxmlformats.org/drawingml/2006/main">
-            <a:off x="1447800" y="5334000"/>
+                <a16:creationId xmlns:a16="http://schemas.microsoft.com/office/drawing/2014/main" id="{306A68B5-1FF9-4F48-AE3D-99B240DFE1F9}"/>
+              </a:ext>
+            </a:extLst>
+          </p:cNvPr>
+          <p:cNvSpPr>
+            <a:spLocks xmlns:a="http://schemas.openxmlformats.org/drawingml/2006/main" noGrp="1"/>
+          </p:cNvSpPr>
+          <p:nvPr/>
+        </p:nvSpPr>
+        <p:spPr>
+          <a:xfrm xmlns:a="http://schemas.openxmlformats.org/drawingml/2006/main">
+            <a:off x="1447800" y="5429250"/>
             <a:ext cx="4686300" cy="514350"/>
           </a:xfrm>
           <a:prstGeom xmlns:a="http://schemas.openxmlformats.org/drawingml/2006/main" prst="rect">
@@ -2761,7 +3230,7 @@
           <p:cNvPr id="13" name="">
             <a:extLst xmlns:a="http://schemas.openxmlformats.org/drawingml/2006/main">
               <a:ext uri="{FF2B5EF4-FFF2-40B4-BE49-F238E27FC236}">
-                <a16:creationId xmlns:a16="http://schemas.microsoft.com/office/drawing/2014/main" id="{8D618258-06D8-4D21-A199-B57F7CCDBF5D}"/>
+                <a16:creationId xmlns:a16="http://schemas.microsoft.com/office/drawing/2014/main" id="{D83FF65D-7C2F-4140-9656-9C9B5B92AC23}"/>
               </a:ext>
             </a:extLst>
           </p:cNvPr>
@@ -2794,7 +3263,7 @@
           <p:cNvPr id="14" name="">
             <a:extLst xmlns:a="http://schemas.openxmlformats.org/drawingml/2006/main">
               <a:ext uri="{FF2B5EF4-FFF2-40B4-BE49-F238E27FC236}">
-                <a16:creationId xmlns:a16="http://schemas.microsoft.com/office/drawing/2014/main" id="{AA740C19-6DCC-4105-82ED-8F674763E324}"/>
+                <a16:creationId xmlns:a16="http://schemas.microsoft.com/office/drawing/2014/main" id="{CC4D7CB7-6EF8-420F-B5C5-171871E04535}"/>
               </a:ext>
             </a:extLst>
           </p:cNvPr>
@@ -2844,7 +3313,7 @@
           <p:cNvPr id="15" name="">
             <a:extLst xmlns:a="http://schemas.openxmlformats.org/drawingml/2006/main">
               <a:ext uri="{FF2B5EF4-FFF2-40B4-BE49-F238E27FC236}">
-                <a16:creationId xmlns:a16="http://schemas.microsoft.com/office/drawing/2014/main" id="{A9455E30-7B3A-4AAF-8B19-0A521AF89CB5}"/>
+                <a16:creationId xmlns:a16="http://schemas.microsoft.com/office/drawing/2014/main" id="{3109ADDB-48A8-4412-B2E4-8CAFD94E7DA1}"/>
               </a:ext>
             </a:extLst>
           </p:cNvPr>
@@ -2892,7 +3361,3000 @@
     </p:spTree>
     <p:extLst>
       <p:ext uri="{BB962C8B-B14F-4D97-AF65-F5344CB8AC3E}">
-        <p14:creationId xmlns:p14="http://schemas.microsoft.com/office/powerpoint/2010/main" val="264138324"/>
+        <p14:creationId xmlns:p14="http://schemas.microsoft.com/office/powerpoint/2010/main" val="2059781940"/>
+      </p:ext>
+    </p:extLst>
+  </p:cSld>
+</p:sld>
+</file>
+
+<file path=ppt/slides/slide11.xml><?xml version="1.0" encoding="utf-8"?>
+<p:sld xmlns:p="http://schemas.openxmlformats.org/presentationml/2006/main">
+  <p:cSld>
+    <p:bg>
+      <p:bgPr>
+        <a:solidFill xmlns:a="http://schemas.openxmlformats.org/drawingml/2006/main">
+          <a:srgbClr val="FFFFFF"/>
+        </a:solidFill>
+      </p:bgPr>
+    </p:bg>
+    <p:spTree>
+      <p:nvGrpSpPr>
+        <p:cNvPr id="1" name=""/>
+        <p:cNvGrpSpPr/>
+        <p:nvPr/>
+      </p:nvGrpSpPr>
+      <p:grpSpPr>
+        <a:xfrm xmlns:a="http://schemas.openxmlformats.org/drawingml/2006/main"/>
+      </p:grpSpPr>
+      <p:sp>
+        <p:nvSpPr>
+          <p:cNvPr id="1" name="">
+            <a:extLst xmlns:a="http://schemas.openxmlformats.org/drawingml/2006/main">
+              <a:ext uri="{FF2B5EF4-FFF2-40B4-BE49-F238E27FC236}">
+                <a16:creationId xmlns:a16="http://schemas.microsoft.com/office/drawing/2014/main" id="{BAB78496-6B8D-498C-9F6D-D0A8682DA063}"/>
+              </a:ext>
+            </a:extLst>
+          </p:cNvPr>
+          <p:cNvSpPr>
+            <a:spLocks xmlns:a="http://schemas.openxmlformats.org/drawingml/2006/main" noGrp="1"/>
+          </p:cNvSpPr>
+          <p:nvPr/>
+        </p:nvSpPr>
+        <p:spPr>
+          <a:xfrm xmlns:a="http://schemas.openxmlformats.org/drawingml/2006/main">
+            <a:off x="685800" y="495300"/>
+            <a:ext cx="4762500" cy="419100"/>
+          </a:xfrm>
+          <a:prstGeom xmlns:a="http://schemas.openxmlformats.org/drawingml/2006/main" prst="rect">
+            <a:avLst/>
+          </a:prstGeom>
+          <a:noFill xmlns:a="http://schemas.openxmlformats.org/drawingml/2006/main"/>
+          <a:ln xmlns:a="http://schemas.openxmlformats.org/drawingml/2006/main" w="0">
+            <a:noFill/>
+            <a:prstDash val="solid"/>
+          </a:ln>
+        </p:spPr>
+        <p:txBody>
+          <a:bodyPr xmlns:a="http://schemas.openxmlformats.org/drawingml/2006/main"/>
+          <a:lstStyle xmlns:a="http://schemas.openxmlformats.org/drawingml/2006/main"/>
+          <a:p xmlns:a="http://schemas.openxmlformats.org/drawingml/2006/main">
+            <a:pPr algn="l">
+              <a:defRPr sz="2400" b="1" i="0">
+                <a:solidFill>
+                  <a:srgbClr val="555555"/>
+                </a:solidFill>
+              </a:defRPr>
+            </a:pPr>
+            <a:r>
+              <a:rPr sz="2400" b="1" i="0">
+                <a:solidFill>
+                  <a:srgbClr val="555555"/>
+                </a:solidFill>
+              </a:rPr>
+              <a:t>Transition</a:t>
+            </a:r>
+          </a:p>
+        </p:txBody>
+      </p:sp>
+      <p:sp>
+        <p:nvSpPr>
+          <p:cNvPr id="2" name="">
+            <a:extLst xmlns:a="http://schemas.openxmlformats.org/drawingml/2006/main">
+              <a:ext uri="{FF2B5EF4-FFF2-40B4-BE49-F238E27FC236}">
+                <a16:creationId xmlns:a16="http://schemas.microsoft.com/office/drawing/2014/main" id="{C43701A2-ED47-4AFC-8CA8-F9E9209F1255}"/>
+              </a:ext>
+            </a:extLst>
+          </p:cNvPr>
+          <p:cNvSpPr>
+            <a:spLocks xmlns:a="http://schemas.openxmlformats.org/drawingml/2006/main" noGrp="1"/>
+          </p:cNvSpPr>
+          <p:nvPr/>
+        </p:nvSpPr>
+        <p:spPr>
+          <a:xfrm xmlns:a="http://schemas.openxmlformats.org/drawingml/2006/main">
+            <a:off x="685800" y="1600200"/>
+            <a:ext cx="8572500" cy="876300"/>
+          </a:xfrm>
+          <a:prstGeom xmlns:a="http://schemas.openxmlformats.org/drawingml/2006/main" prst="rect">
+            <a:avLst/>
+          </a:prstGeom>
+          <a:noFill xmlns:a="http://schemas.openxmlformats.org/drawingml/2006/main"/>
+          <a:ln xmlns:a="http://schemas.openxmlformats.org/drawingml/2006/main" w="0">
+            <a:noFill/>
+            <a:prstDash val="solid"/>
+          </a:ln>
+        </p:spPr>
+        <p:txBody>
+          <a:bodyPr xmlns:a="http://schemas.openxmlformats.org/drawingml/2006/main"/>
+          <a:lstStyle xmlns:a="http://schemas.openxmlformats.org/drawingml/2006/main"/>
+          <a:p xmlns:a="http://schemas.openxmlformats.org/drawingml/2006/main">
+            <a:pPr algn="l">
+              <a:defRPr sz="3900" b="1" i="0">
+                <a:solidFill>
+                  <a:srgbClr val="000000"/>
+                </a:solidFill>
+              </a:defRPr>
+            </a:pPr>
+            <a:r>
+              <a:rPr sz="3900" b="1" i="0">
+                <a:solidFill>
+                  <a:srgbClr val="000000"/>
+                </a:solidFill>
+              </a:rPr>
+              <a:t>The deck now moves from table safety to model behavior</a:t>
+            </a:r>
+          </a:p>
+        </p:txBody>
+      </p:sp>
+      <p:sp>
+        <p:nvSpPr>
+          <p:cNvPr id="3" name="">
+            <a:extLst xmlns:a="http://schemas.openxmlformats.org/drawingml/2006/main">
+              <a:ext uri="{FF2B5EF4-FFF2-40B4-BE49-F238E27FC236}">
+                <a16:creationId xmlns:a16="http://schemas.microsoft.com/office/drawing/2014/main" id="{9EBA40C5-3BC3-4CD0-BCE0-4A052156F139}"/>
+              </a:ext>
+            </a:extLst>
+          </p:cNvPr>
+          <p:cNvSpPr>
+            <a:spLocks xmlns:a="http://schemas.openxmlformats.org/drawingml/2006/main" noGrp="1"/>
+          </p:cNvSpPr>
+          <p:nvPr/>
+        </p:nvSpPr>
+        <p:spPr>
+          <a:xfrm xmlns:a="http://schemas.openxmlformats.org/drawingml/2006/main">
+            <a:off x="723900" y="3105150"/>
+            <a:ext cx="5715000" cy="19050"/>
+          </a:xfrm>
+          <a:prstGeom xmlns:a="http://schemas.openxmlformats.org/drawingml/2006/main" prst="rect">
+            <a:avLst/>
+          </a:prstGeom>
+          <a:solidFill xmlns:a="http://schemas.openxmlformats.org/drawingml/2006/main">
+            <a:srgbClr val="B8BCC4"/>
+          </a:solidFill>
+          <a:ln xmlns:a="http://schemas.openxmlformats.org/drawingml/2006/main" w="0">
+            <a:noFill/>
+            <a:prstDash val="solid"/>
+          </a:ln>
+        </p:spPr>
+      </p:sp>
+      <p:sp>
+        <p:nvSpPr>
+          <p:cNvPr id="4" name="">
+            <a:extLst xmlns:a="http://schemas.openxmlformats.org/drawingml/2006/main">
+              <a:ext uri="{FF2B5EF4-FFF2-40B4-BE49-F238E27FC236}">
+                <a16:creationId xmlns:a16="http://schemas.microsoft.com/office/drawing/2014/main" id="{1BF0108E-FFFE-4644-A73C-AB2EBF4AD59B}"/>
+              </a:ext>
+            </a:extLst>
+          </p:cNvPr>
+          <p:cNvSpPr>
+            <a:spLocks xmlns:a="http://schemas.openxmlformats.org/drawingml/2006/main" noGrp="1"/>
+          </p:cNvSpPr>
+          <p:nvPr/>
+        </p:nvSpPr>
+        <p:spPr>
+          <a:xfrm xmlns:a="http://schemas.openxmlformats.org/drawingml/2006/main">
+            <a:off x="723900" y="3467100"/>
+            <a:ext cx="7334250" cy="1066800"/>
+          </a:xfrm>
+          <a:prstGeom xmlns:a="http://schemas.openxmlformats.org/drawingml/2006/main" prst="rect">
+            <a:avLst/>
+          </a:prstGeom>
+          <a:noFill xmlns:a="http://schemas.openxmlformats.org/drawingml/2006/main"/>
+          <a:ln xmlns:a="http://schemas.openxmlformats.org/drawingml/2006/main" w="0">
+            <a:noFill/>
+            <a:prstDash val="solid"/>
+          </a:ln>
+        </p:spPr>
+        <p:txBody>
+          <a:bodyPr xmlns:a="http://schemas.openxmlformats.org/drawingml/2006/main"/>
+          <a:lstStyle xmlns:a="http://schemas.openxmlformats.org/drawingml/2006/main"/>
+          <a:p xmlns:a="http://schemas.openxmlformats.org/drawingml/2006/main">
+            <a:pPr algn="l">
+              <a:defRPr sz="1800" b="0" i="0">
+                <a:solidFill>
+                  <a:srgbClr val="222222"/>
+                </a:solidFill>
+              </a:defRPr>
+            </a:pPr>
+            <a:r>
+              <a:rPr sz="1800" b="0" i="0">
+                <a:solidFill>
+                  <a:srgbClr val="222222"/>
+                </a:solidFill>
+              </a:rPr>
+              <a:t>ML-P1 fits a GLM on TRAIN rows, freezes the model, predicts OOS h3 probability, and replays fixed-threshold long/flat decisions. This is a diagnostic model, not an allocation claim.</a:t>
+            </a:r>
+          </a:p>
+        </p:txBody>
+      </p:sp>
+      <p:sp>
+        <p:nvSpPr>
+          <p:cNvPr id="5" name="">
+            <a:extLst xmlns:a="http://schemas.openxmlformats.org/drawingml/2006/main">
+              <a:ext uri="{FF2B5EF4-FFF2-40B4-BE49-F238E27FC236}">
+                <a16:creationId xmlns:a16="http://schemas.microsoft.com/office/drawing/2014/main" id="{18F2328B-BF2F-4628-9415-1077679B85A7}"/>
+              </a:ext>
+            </a:extLst>
+          </p:cNvPr>
+          <p:cNvSpPr>
+            <a:spLocks xmlns:a="http://schemas.openxmlformats.org/drawingml/2006/main" noGrp="1"/>
+          </p:cNvSpPr>
+          <p:nvPr/>
+        </p:nvSpPr>
+        <p:spPr>
+          <a:xfrm xmlns:a="http://schemas.openxmlformats.org/drawingml/2006/main">
+            <a:off x="8801100" y="0"/>
+            <a:ext cx="3390900" cy="6858000"/>
+          </a:xfrm>
+          <a:prstGeom xmlns:a="http://schemas.openxmlformats.org/drawingml/2006/main" prst="rect">
+            <a:avLst/>
+          </a:prstGeom>
+          <a:solidFill xmlns:a="http://schemas.openxmlformats.org/drawingml/2006/main">
+            <a:srgbClr val="EDEDED"/>
+          </a:solidFill>
+          <a:ln xmlns:a="http://schemas.openxmlformats.org/drawingml/2006/main" w="0">
+            <a:noFill/>
+            <a:prstDash val="solid"/>
+          </a:ln>
+        </p:spPr>
+      </p:sp>
+      <p:sp>
+        <p:nvSpPr>
+          <p:cNvPr id="6" name="">
+            <a:extLst xmlns:a="http://schemas.openxmlformats.org/drawingml/2006/main">
+              <a:ext uri="{FF2B5EF4-FFF2-40B4-BE49-F238E27FC236}">
+                <a16:creationId xmlns:a16="http://schemas.microsoft.com/office/drawing/2014/main" id="{E59E8A10-FBF2-4ECA-B4FE-A57A7E3946D2}"/>
+              </a:ext>
+            </a:extLst>
+          </p:cNvPr>
+          <p:cNvSpPr>
+            <a:spLocks xmlns:a="http://schemas.openxmlformats.org/drawingml/2006/main" noGrp="1"/>
+          </p:cNvSpPr>
+          <p:nvPr/>
+        </p:nvSpPr>
+        <p:spPr>
+          <a:xfrm xmlns:a="http://schemas.openxmlformats.org/drawingml/2006/main">
+            <a:off x="9353550" y="2343150"/>
+            <a:ext cx="2190750" cy="438150"/>
+          </a:xfrm>
+          <a:prstGeom xmlns:a="http://schemas.openxmlformats.org/drawingml/2006/main" prst="rect">
+            <a:avLst/>
+          </a:prstGeom>
+          <a:noFill xmlns:a="http://schemas.openxmlformats.org/drawingml/2006/main"/>
+          <a:ln xmlns:a="http://schemas.openxmlformats.org/drawingml/2006/main" w="0">
+            <a:noFill/>
+            <a:prstDash val="solid"/>
+          </a:ln>
+        </p:spPr>
+        <p:txBody>
+          <a:bodyPr xmlns:a="http://schemas.openxmlformats.org/drawingml/2006/main"/>
+          <a:lstStyle xmlns:a="http://schemas.openxmlformats.org/drawingml/2006/main"/>
+          <a:p xmlns:a="http://schemas.openxmlformats.org/drawingml/2006/main">
+            <a:pPr algn="ctr">
+              <a:defRPr sz="3150" b="1" i="0">
+                <a:solidFill>
+                  <a:srgbClr val="000000"/>
+                </a:solidFill>
+              </a:defRPr>
+            </a:pPr>
+            <a:r>
+              <a:rPr sz="3150" b="1" i="0">
+                <a:solidFill>
+                  <a:srgbClr val="000000"/>
+                </a:solidFill>
+              </a:rPr>
+              <a:t>ML-P1</a:t>
+            </a:r>
+          </a:p>
+        </p:txBody>
+      </p:sp>
+      <p:sp>
+        <p:nvSpPr>
+          <p:cNvPr id="7" name="">
+            <a:extLst xmlns:a="http://schemas.openxmlformats.org/drawingml/2006/main">
+              <a:ext uri="{FF2B5EF4-FFF2-40B4-BE49-F238E27FC236}">
+                <a16:creationId xmlns:a16="http://schemas.microsoft.com/office/drawing/2014/main" id="{C1D56FAB-09FB-44F2-AA9F-6FFCDBC2433C}"/>
+              </a:ext>
+            </a:extLst>
+          </p:cNvPr>
+          <p:cNvSpPr>
+            <a:spLocks xmlns:a="http://schemas.openxmlformats.org/drawingml/2006/main" noGrp="1"/>
+          </p:cNvSpPr>
+          <p:nvPr/>
+        </p:nvSpPr>
+        <p:spPr>
+          <a:xfrm xmlns:a="http://schemas.openxmlformats.org/drawingml/2006/main">
+            <a:off x="9353550" y="3067050"/>
+            <a:ext cx="2190750" cy="342900"/>
+          </a:xfrm>
+          <a:prstGeom xmlns:a="http://schemas.openxmlformats.org/drawingml/2006/main" prst="rect">
+            <a:avLst/>
+          </a:prstGeom>
+          <a:noFill xmlns:a="http://schemas.openxmlformats.org/drawingml/2006/main"/>
+          <a:ln xmlns:a="http://schemas.openxmlformats.org/drawingml/2006/main" w="0">
+            <a:noFill/>
+            <a:prstDash val="solid"/>
+          </a:ln>
+        </p:spPr>
+        <p:txBody>
+          <a:bodyPr xmlns:a="http://schemas.openxmlformats.org/drawingml/2006/main"/>
+          <a:lstStyle xmlns:a="http://schemas.openxmlformats.org/drawingml/2006/main"/>
+          <a:p xmlns:a="http://schemas.openxmlformats.org/drawingml/2006/main">
+            <a:pPr algn="ctr">
+              <a:defRPr sz="1950" b="0" i="0">
+                <a:solidFill>
+                  <a:srgbClr val="222222"/>
+                </a:solidFill>
+              </a:defRPr>
+            </a:pPr>
+            <a:r>
+              <a:rPr sz="1950" b="0" i="0">
+                <a:solidFill>
+                  <a:srgbClr val="222222"/>
+                </a:solidFill>
+              </a:rPr>
+              <a:t>GLM replay</a:t>
+            </a:r>
+          </a:p>
+        </p:txBody>
+      </p:sp>
+    </p:spTree>
+    <p:extLst>
+      <p:ext uri="{BB962C8B-B14F-4D97-AF65-F5344CB8AC3E}">
+        <p14:creationId xmlns:p14="http://schemas.microsoft.com/office/powerpoint/2010/main" val="1272524852"/>
+      </p:ext>
+    </p:extLst>
+  </p:cSld>
+</p:sld>
+</file>
+
+<file path=ppt/slides/slide12.xml><?xml version="1.0" encoding="utf-8"?>
+<p:sld xmlns:p="http://schemas.openxmlformats.org/presentationml/2006/main">
+  <p:cSld>
+    <p:bg>
+      <p:bgPr>
+        <a:solidFill xmlns:a="http://schemas.openxmlformats.org/drawingml/2006/main">
+          <a:srgbClr val="FFFFFF"/>
+        </a:solidFill>
+      </p:bgPr>
+    </p:bg>
+    <p:spTree>
+      <p:nvGrpSpPr>
+        <p:cNvPr id="1" name=""/>
+        <p:cNvGrpSpPr/>
+        <p:nvPr/>
+      </p:nvGrpSpPr>
+      <p:grpSpPr>
+        <a:xfrm xmlns:a="http://schemas.openxmlformats.org/drawingml/2006/main"/>
+      </p:grpSpPr>
+      <p:sp>
+        <p:nvSpPr>
+          <p:cNvPr id="1" name="">
+            <a:extLst xmlns:a="http://schemas.openxmlformats.org/drawingml/2006/main">
+              <a:ext uri="{FF2B5EF4-FFF2-40B4-BE49-F238E27FC236}">
+                <a16:creationId xmlns:a16="http://schemas.microsoft.com/office/drawing/2014/main" id="{D94409FE-8D27-47EB-A7EF-5446947686A8}"/>
+              </a:ext>
+            </a:extLst>
+          </p:cNvPr>
+          <p:cNvSpPr>
+            <a:spLocks xmlns:a="http://schemas.openxmlformats.org/drawingml/2006/main" noGrp="1"/>
+          </p:cNvSpPr>
+          <p:nvPr/>
+        </p:nvSpPr>
+        <p:spPr>
+          <a:xfrm xmlns:a="http://schemas.openxmlformats.org/drawingml/2006/main">
+            <a:off x="685800" y="400050"/>
+            <a:ext cx="8572500" cy="247650"/>
+          </a:xfrm>
+          <a:prstGeom xmlns:a="http://schemas.openxmlformats.org/drawingml/2006/main" prst="rect">
+            <a:avLst/>
+          </a:prstGeom>
+          <a:noFill xmlns:a="http://schemas.openxmlformats.org/drawingml/2006/main"/>
+          <a:ln xmlns:a="http://schemas.openxmlformats.org/drawingml/2006/main" w="0">
+            <a:noFill/>
+            <a:prstDash val="solid"/>
+          </a:ln>
+        </p:spPr>
+        <p:txBody>
+          <a:bodyPr xmlns:a="http://schemas.openxmlformats.org/drawingml/2006/main"/>
+          <a:lstStyle xmlns:a="http://schemas.openxmlformats.org/drawingml/2006/main"/>
+          <a:p xmlns:a="http://schemas.openxmlformats.org/drawingml/2006/main">
+            <a:pPr algn="l">
+              <a:defRPr sz="975" b="1" i="0">
+                <a:solidFill>
+                  <a:srgbClr val="555555"/>
+                </a:solidFill>
+              </a:defRPr>
+            </a:pPr>
+            <a:r>
+              <a:rPr sz="975" b="1" i="0">
+                <a:solidFill>
+                  <a:srgbClr val="555555"/>
+                </a:solidFill>
+              </a:rPr>
+              <a:t>GEN5.4 ML DECISION ENGINE</a:t>
+            </a:r>
+          </a:p>
+        </p:txBody>
+      </p:sp>
+      <p:sp>
+        <p:nvSpPr>
+          <p:cNvPr id="2" name="">
+            <a:extLst xmlns:a="http://schemas.openxmlformats.org/drawingml/2006/main">
+              <a:ext uri="{FF2B5EF4-FFF2-40B4-BE49-F238E27FC236}">
+                <a16:creationId xmlns:a16="http://schemas.microsoft.com/office/drawing/2014/main" id="{DC3CC4F6-EEC9-4F98-AB06-2111D81B603C}"/>
+              </a:ext>
+            </a:extLst>
+          </p:cNvPr>
+          <p:cNvSpPr>
+            <a:spLocks xmlns:a="http://schemas.openxmlformats.org/drawingml/2006/main" noGrp="1"/>
+          </p:cNvSpPr>
+          <p:nvPr/>
+        </p:nvSpPr>
+        <p:spPr>
+          <a:xfrm xmlns:a="http://schemas.openxmlformats.org/drawingml/2006/main">
+            <a:off x="685800" y="723900"/>
+            <a:ext cx="10287000" cy="876300"/>
+          </a:xfrm>
+          <a:prstGeom xmlns:a="http://schemas.openxmlformats.org/drawingml/2006/main" prst="rect">
+            <a:avLst/>
+          </a:prstGeom>
+          <a:noFill xmlns:a="http://schemas.openxmlformats.org/drawingml/2006/main"/>
+          <a:ln xmlns:a="http://schemas.openxmlformats.org/drawingml/2006/main" w="0">
+            <a:noFill/>
+            <a:prstDash val="solid"/>
+          </a:ln>
+        </p:spPr>
+        <p:txBody>
+          <a:bodyPr xmlns:a="http://schemas.openxmlformats.org/drawingml/2006/main"/>
+          <a:lstStyle xmlns:a="http://schemas.openxmlformats.org/drawingml/2006/main"/>
+          <a:p xmlns:a="http://schemas.openxmlformats.org/drawingml/2006/main">
+            <a:pPr algn="l">
+              <a:defRPr sz="2850" b="1" i="0">
+                <a:solidFill>
+                  <a:srgbClr val="000000"/>
+                </a:solidFill>
+              </a:defRPr>
+            </a:pPr>
+            <a:r>
+              <a:rPr sz="2850" b="1" i="0">
+                <a:solidFill>
+                  <a:srgbClr val="000000"/>
+                </a:solidFill>
+              </a:rPr>
+              <a:t>The GLM baseline became defensive, not participatory</a:t>
+            </a:r>
+          </a:p>
+        </p:txBody>
+      </p:sp>
+      <p:sp>
+        <p:nvSpPr>
+          <p:cNvPr id="3" name="">
+            <a:extLst xmlns:a="http://schemas.openxmlformats.org/drawingml/2006/main">
+              <a:ext uri="{FF2B5EF4-FFF2-40B4-BE49-F238E27FC236}">
+                <a16:creationId xmlns:a16="http://schemas.microsoft.com/office/drawing/2014/main" id="{F6D9BC46-D8E9-4DA8-A754-002431DE46D0}"/>
+              </a:ext>
+            </a:extLst>
+          </p:cNvPr>
+          <p:cNvSpPr>
+            <a:spLocks xmlns:a="http://schemas.openxmlformats.org/drawingml/2006/main" noGrp="1"/>
+          </p:cNvSpPr>
+          <p:nvPr/>
+        </p:nvSpPr>
+        <p:spPr>
+          <a:xfrm xmlns:a="http://schemas.openxmlformats.org/drawingml/2006/main">
+            <a:off x="685800" y="1657350"/>
+            <a:ext cx="10820400" cy="19050"/>
+          </a:xfrm>
+          <a:prstGeom xmlns:a="http://schemas.openxmlformats.org/drawingml/2006/main" prst="rect">
+            <a:avLst/>
+          </a:prstGeom>
+          <a:solidFill xmlns:a="http://schemas.openxmlformats.org/drawingml/2006/main">
+            <a:srgbClr val="B8BCC4"/>
+          </a:solidFill>
+          <a:ln xmlns:a="http://schemas.openxmlformats.org/drawingml/2006/main" w="0">
+            <a:noFill/>
+            <a:prstDash val="solid"/>
+          </a:ln>
+        </p:spPr>
+      </p:sp>
+      <p:sp>
+        <p:nvSpPr>
+          <p:cNvPr id="4" name="">
+            <a:extLst xmlns:a="http://schemas.openxmlformats.org/drawingml/2006/main">
+              <a:ext uri="{FF2B5EF4-FFF2-40B4-BE49-F238E27FC236}">
+                <a16:creationId xmlns:a16="http://schemas.microsoft.com/office/drawing/2014/main" id="{9381AF91-F9B8-44CB-A9EC-936FBCE3D1AD}"/>
+              </a:ext>
+            </a:extLst>
+          </p:cNvPr>
+          <p:cNvSpPr>
+            <a:spLocks xmlns:a="http://schemas.openxmlformats.org/drawingml/2006/main" noGrp="1"/>
+          </p:cNvSpPr>
+          <p:nvPr/>
+        </p:nvSpPr>
+        <p:spPr>
+          <a:xfrm xmlns:a="http://schemas.openxmlformats.org/drawingml/2006/main">
+            <a:off x="819150" y="2152650"/>
+            <a:ext cx="2333625" cy="1200150"/>
+          </a:xfrm>
+          <a:prstGeom xmlns:a="http://schemas.openxmlformats.org/drawingml/2006/main" prst="rect">
+            <a:avLst/>
+          </a:prstGeom>
+          <a:solidFill xmlns:a="http://schemas.openxmlformats.org/drawingml/2006/main">
+            <a:srgbClr val="EDEDED"/>
+          </a:solidFill>
+          <a:ln xmlns:a="http://schemas.openxmlformats.org/drawingml/2006/main" w="9525">
+            <a:solidFill>
+              <a:srgbClr val="B8BCC4"/>
+            </a:solidFill>
+            <a:prstDash val="solid"/>
+          </a:ln>
+        </p:spPr>
+      </p:sp>
+      <p:sp>
+        <p:nvSpPr>
+          <p:cNvPr id="5" name="">
+            <a:extLst xmlns:a="http://schemas.openxmlformats.org/drawingml/2006/main">
+              <a:ext uri="{FF2B5EF4-FFF2-40B4-BE49-F238E27FC236}">
+                <a16:creationId xmlns:a16="http://schemas.microsoft.com/office/drawing/2014/main" id="{926E6486-5646-4AD0-8731-963A520563D3}"/>
+              </a:ext>
+            </a:extLst>
+          </p:cNvPr>
+          <p:cNvSpPr>
+            <a:spLocks xmlns:a="http://schemas.openxmlformats.org/drawingml/2006/main" noGrp="1"/>
+          </p:cNvSpPr>
+          <p:nvPr/>
+        </p:nvSpPr>
+        <p:spPr>
+          <a:xfrm xmlns:a="http://schemas.openxmlformats.org/drawingml/2006/main">
+            <a:off x="990600" y="2305050"/>
+            <a:ext cx="1990725" cy="171450"/>
+          </a:xfrm>
+          <a:prstGeom xmlns:a="http://schemas.openxmlformats.org/drawingml/2006/main" prst="rect">
+            <a:avLst/>
+          </a:prstGeom>
+          <a:noFill xmlns:a="http://schemas.openxmlformats.org/drawingml/2006/main"/>
+          <a:ln xmlns:a="http://schemas.openxmlformats.org/drawingml/2006/main" w="0">
+            <a:noFill/>
+            <a:prstDash val="solid"/>
+          </a:ln>
+        </p:spPr>
+        <p:txBody>
+          <a:bodyPr xmlns:a="http://schemas.openxmlformats.org/drawingml/2006/main"/>
+          <a:lstStyle xmlns:a="http://schemas.openxmlformats.org/drawingml/2006/main"/>
+          <a:p xmlns:a="http://schemas.openxmlformats.org/drawingml/2006/main">
+            <a:pPr algn="l">
+              <a:defRPr sz="900" b="1" i="0">
+                <a:solidFill>
+                  <a:srgbClr val="555555"/>
+                </a:solidFill>
+              </a:defRPr>
+            </a:pPr>
+            <a:r>
+              <a:rPr sz="900" b="1" i="0">
+                <a:solidFill>
+                  <a:srgbClr val="555555"/>
+                </a:solidFill>
+              </a:rPr>
+              <a:t>2020 ACTIVE</a:t>
+            </a:r>
+          </a:p>
+        </p:txBody>
+      </p:sp>
+      <p:sp>
+        <p:nvSpPr>
+          <p:cNvPr id="6" name="">
+            <a:extLst xmlns:a="http://schemas.openxmlformats.org/drawingml/2006/main">
+              <a:ext uri="{FF2B5EF4-FFF2-40B4-BE49-F238E27FC236}">
+                <a16:creationId xmlns:a16="http://schemas.microsoft.com/office/drawing/2014/main" id="{AC448AA7-7C54-4C6B-BBF9-7D72856BCFFE}"/>
+              </a:ext>
+            </a:extLst>
+          </p:cNvPr>
+          <p:cNvSpPr>
+            <a:spLocks xmlns:a="http://schemas.openxmlformats.org/drawingml/2006/main" noGrp="1"/>
+          </p:cNvSpPr>
+          <p:nvPr/>
+        </p:nvSpPr>
+        <p:spPr>
+          <a:xfrm xmlns:a="http://schemas.openxmlformats.org/drawingml/2006/main">
+            <a:off x="990600" y="2552700"/>
+            <a:ext cx="1990725" cy="361950"/>
+          </a:xfrm>
+          <a:prstGeom xmlns:a="http://schemas.openxmlformats.org/drawingml/2006/main" prst="rect">
+            <a:avLst/>
+          </a:prstGeom>
+          <a:noFill xmlns:a="http://schemas.openxmlformats.org/drawingml/2006/main"/>
+          <a:ln xmlns:a="http://schemas.openxmlformats.org/drawingml/2006/main" w="0">
+            <a:noFill/>
+            <a:prstDash val="solid"/>
+          </a:ln>
+        </p:spPr>
+        <p:txBody>
+          <a:bodyPr xmlns:a="http://schemas.openxmlformats.org/drawingml/2006/main"/>
+          <a:lstStyle xmlns:a="http://schemas.openxmlformats.org/drawingml/2006/main"/>
+          <a:p xmlns:a="http://schemas.openxmlformats.org/drawingml/2006/main">
+            <a:pPr algn="l">
+              <a:defRPr sz="2250" b="1" i="0">
+                <a:solidFill>
+                  <a:srgbClr val="000000"/>
+                </a:solidFill>
+              </a:defRPr>
+            </a:pPr>
+            <a:r>
+              <a:rPr sz="2250" b="1" i="0">
+                <a:solidFill>
+                  <a:srgbClr val="000000"/>
+                </a:solidFill>
+              </a:rPr>
+              <a:t>8.0%</a:t>
+            </a:r>
+          </a:p>
+        </p:txBody>
+      </p:sp>
+      <p:sp>
+        <p:nvSpPr>
+          <p:cNvPr id="7" name="">
+            <a:extLst xmlns:a="http://schemas.openxmlformats.org/drawingml/2006/main">
+              <a:ext uri="{FF2B5EF4-FFF2-40B4-BE49-F238E27FC236}">
+                <a16:creationId xmlns:a16="http://schemas.microsoft.com/office/drawing/2014/main" id="{07B95273-76CF-47FF-9E93-68188C85FA69}"/>
+              </a:ext>
+            </a:extLst>
+          </p:cNvPr>
+          <p:cNvSpPr>
+            <a:spLocks xmlns:a="http://schemas.openxmlformats.org/drawingml/2006/main" noGrp="1"/>
+          </p:cNvSpPr>
+          <p:nvPr/>
+        </p:nvSpPr>
+        <p:spPr>
+          <a:xfrm xmlns:a="http://schemas.openxmlformats.org/drawingml/2006/main">
+            <a:off x="990600" y="2971800"/>
+            <a:ext cx="1990725" cy="323850"/>
+          </a:xfrm>
+          <a:prstGeom xmlns:a="http://schemas.openxmlformats.org/drawingml/2006/main" prst="rect">
+            <a:avLst/>
+          </a:prstGeom>
+          <a:noFill xmlns:a="http://schemas.openxmlformats.org/drawingml/2006/main"/>
+          <a:ln xmlns:a="http://schemas.openxmlformats.org/drawingml/2006/main" w="0">
+            <a:noFill/>
+            <a:prstDash val="solid"/>
+          </a:ln>
+        </p:spPr>
+        <p:txBody>
+          <a:bodyPr xmlns:a="http://schemas.openxmlformats.org/drawingml/2006/main"/>
+          <a:lstStyle xmlns:a="http://schemas.openxmlformats.org/drawingml/2006/main"/>
+          <a:p xmlns:a="http://schemas.openxmlformats.org/drawingml/2006/main">
+            <a:pPr algn="l">
+              <a:defRPr sz="1125" b="0" i="0">
+                <a:solidFill>
+                  <a:srgbClr val="555555"/>
+                </a:solidFill>
+              </a:defRPr>
+            </a:pPr>
+            <a:r>
+              <a:rPr sz="1125" b="0" i="0">
+                <a:solidFill>
+                  <a:srgbClr val="555555"/>
+                </a:solidFill>
+              </a:rPr>
+              <a:t>Basket hold 214.0%</a:t>
+            </a:r>
+          </a:p>
+        </p:txBody>
+      </p:sp>
+      <p:sp>
+        <p:nvSpPr>
+          <p:cNvPr id="8" name="">
+            <a:extLst xmlns:a="http://schemas.openxmlformats.org/drawingml/2006/main">
+              <a:ext uri="{FF2B5EF4-FFF2-40B4-BE49-F238E27FC236}">
+                <a16:creationId xmlns:a16="http://schemas.microsoft.com/office/drawing/2014/main" id="{0A43E010-8C1E-4D1E-A966-1FE0651E28DD}"/>
+              </a:ext>
+            </a:extLst>
+          </p:cNvPr>
+          <p:cNvSpPr>
+            <a:spLocks xmlns:a="http://schemas.openxmlformats.org/drawingml/2006/main" noGrp="1"/>
+          </p:cNvSpPr>
+          <p:nvPr/>
+        </p:nvSpPr>
+        <p:spPr>
+          <a:xfrm xmlns:a="http://schemas.openxmlformats.org/drawingml/2006/main">
+            <a:off x="3524250" y="2152650"/>
+            <a:ext cx="2333625" cy="1200150"/>
+          </a:xfrm>
+          <a:prstGeom xmlns:a="http://schemas.openxmlformats.org/drawingml/2006/main" prst="rect">
+            <a:avLst/>
+          </a:prstGeom>
+          <a:solidFill xmlns:a="http://schemas.openxmlformats.org/drawingml/2006/main">
+            <a:srgbClr val="EDEDED"/>
+          </a:solidFill>
+          <a:ln xmlns:a="http://schemas.openxmlformats.org/drawingml/2006/main" w="9525">
+            <a:solidFill>
+              <a:srgbClr val="B8BCC4"/>
+            </a:solidFill>
+            <a:prstDash val="solid"/>
+          </a:ln>
+        </p:spPr>
+      </p:sp>
+      <p:sp>
+        <p:nvSpPr>
+          <p:cNvPr id="9" name="">
+            <a:extLst xmlns:a="http://schemas.openxmlformats.org/drawingml/2006/main">
+              <a:ext uri="{FF2B5EF4-FFF2-40B4-BE49-F238E27FC236}">
+                <a16:creationId xmlns:a16="http://schemas.microsoft.com/office/drawing/2014/main" id="{7941A2AA-93C8-475B-ABFA-82B856044C8E}"/>
+              </a:ext>
+            </a:extLst>
+          </p:cNvPr>
+          <p:cNvSpPr>
+            <a:spLocks xmlns:a="http://schemas.openxmlformats.org/drawingml/2006/main" noGrp="1"/>
+          </p:cNvSpPr>
+          <p:nvPr/>
+        </p:nvSpPr>
+        <p:spPr>
+          <a:xfrm xmlns:a="http://schemas.openxmlformats.org/drawingml/2006/main">
+            <a:off x="3695700" y="2305050"/>
+            <a:ext cx="1990725" cy="171450"/>
+          </a:xfrm>
+          <a:prstGeom xmlns:a="http://schemas.openxmlformats.org/drawingml/2006/main" prst="rect">
+            <a:avLst/>
+          </a:prstGeom>
+          <a:noFill xmlns:a="http://schemas.openxmlformats.org/drawingml/2006/main"/>
+          <a:ln xmlns:a="http://schemas.openxmlformats.org/drawingml/2006/main" w="0">
+            <a:noFill/>
+            <a:prstDash val="solid"/>
+          </a:ln>
+        </p:spPr>
+        <p:txBody>
+          <a:bodyPr xmlns:a="http://schemas.openxmlformats.org/drawingml/2006/main"/>
+          <a:lstStyle xmlns:a="http://schemas.openxmlformats.org/drawingml/2006/main"/>
+          <a:p xmlns:a="http://schemas.openxmlformats.org/drawingml/2006/main">
+            <a:pPr algn="l">
+              <a:defRPr sz="900" b="1" i="0">
+                <a:solidFill>
+                  <a:srgbClr val="555555"/>
+                </a:solidFill>
+              </a:defRPr>
+            </a:pPr>
+            <a:r>
+              <a:rPr sz="900" b="1" i="0">
+                <a:solidFill>
+                  <a:srgbClr val="555555"/>
+                </a:solidFill>
+              </a:rPr>
+              <a:t>2020 EXPOSURE</a:t>
+            </a:r>
+          </a:p>
+        </p:txBody>
+      </p:sp>
+      <p:sp>
+        <p:nvSpPr>
+          <p:cNvPr id="10" name="">
+            <a:extLst xmlns:a="http://schemas.openxmlformats.org/drawingml/2006/main">
+              <a:ext uri="{FF2B5EF4-FFF2-40B4-BE49-F238E27FC236}">
+                <a16:creationId xmlns:a16="http://schemas.microsoft.com/office/drawing/2014/main" id="{D289D85E-767F-4440-920B-3D49876A70F1}"/>
+              </a:ext>
+            </a:extLst>
+          </p:cNvPr>
+          <p:cNvSpPr>
+            <a:spLocks xmlns:a="http://schemas.openxmlformats.org/drawingml/2006/main" noGrp="1"/>
+          </p:cNvSpPr>
+          <p:nvPr/>
+        </p:nvSpPr>
+        <p:spPr>
+          <a:xfrm xmlns:a="http://schemas.openxmlformats.org/drawingml/2006/main">
+            <a:off x="3695700" y="2552700"/>
+            <a:ext cx="1990725" cy="361950"/>
+          </a:xfrm>
+          <a:prstGeom xmlns:a="http://schemas.openxmlformats.org/drawingml/2006/main" prst="rect">
+            <a:avLst/>
+          </a:prstGeom>
+          <a:noFill xmlns:a="http://schemas.openxmlformats.org/drawingml/2006/main"/>
+          <a:ln xmlns:a="http://schemas.openxmlformats.org/drawingml/2006/main" w="0">
+            <a:noFill/>
+            <a:prstDash val="solid"/>
+          </a:ln>
+        </p:spPr>
+        <p:txBody>
+          <a:bodyPr xmlns:a="http://schemas.openxmlformats.org/drawingml/2006/main"/>
+          <a:lstStyle xmlns:a="http://schemas.openxmlformats.org/drawingml/2006/main"/>
+          <a:p xmlns:a="http://schemas.openxmlformats.org/drawingml/2006/main">
+            <a:pPr algn="l">
+              <a:defRPr sz="2250" b="1" i="0">
+                <a:solidFill>
+                  <a:srgbClr val="000000"/>
+                </a:solidFill>
+              </a:defRPr>
+            </a:pPr>
+            <a:r>
+              <a:rPr sz="2250" b="1" i="0">
+                <a:solidFill>
+                  <a:srgbClr val="000000"/>
+                </a:solidFill>
+              </a:rPr>
+              <a:t>27.6%</a:t>
+            </a:r>
+          </a:p>
+        </p:txBody>
+      </p:sp>
+      <p:sp>
+        <p:nvSpPr>
+          <p:cNvPr id="11" name="">
+            <a:extLst xmlns:a="http://schemas.openxmlformats.org/drawingml/2006/main">
+              <a:ext uri="{FF2B5EF4-FFF2-40B4-BE49-F238E27FC236}">
+                <a16:creationId xmlns:a16="http://schemas.microsoft.com/office/drawing/2014/main" id="{C9914161-045C-4C05-9CC9-2ACB7023B031}"/>
+              </a:ext>
+            </a:extLst>
+          </p:cNvPr>
+          <p:cNvSpPr>
+            <a:spLocks xmlns:a="http://schemas.openxmlformats.org/drawingml/2006/main" noGrp="1"/>
+          </p:cNvSpPr>
+          <p:nvPr/>
+        </p:nvSpPr>
+        <p:spPr>
+          <a:xfrm xmlns:a="http://schemas.openxmlformats.org/drawingml/2006/main">
+            <a:off x="3695700" y="2971800"/>
+            <a:ext cx="1990725" cy="323850"/>
+          </a:xfrm>
+          <a:prstGeom xmlns:a="http://schemas.openxmlformats.org/drawingml/2006/main" prst="rect">
+            <a:avLst/>
+          </a:prstGeom>
+          <a:noFill xmlns:a="http://schemas.openxmlformats.org/drawingml/2006/main"/>
+          <a:ln xmlns:a="http://schemas.openxmlformats.org/drawingml/2006/main" w="0">
+            <a:noFill/>
+            <a:prstDash val="solid"/>
+          </a:ln>
+        </p:spPr>
+        <p:txBody>
+          <a:bodyPr xmlns:a="http://schemas.openxmlformats.org/drawingml/2006/main"/>
+          <a:lstStyle xmlns:a="http://schemas.openxmlformats.org/drawingml/2006/main"/>
+          <a:p xmlns:a="http://schemas.openxmlformats.org/drawingml/2006/main">
+            <a:pPr algn="l">
+              <a:defRPr sz="1125" b="0" i="0">
+                <a:solidFill>
+                  <a:srgbClr val="555555"/>
+                </a:solidFill>
+              </a:defRPr>
+            </a:pPr>
+            <a:r>
+              <a:rPr sz="1125" b="0" i="0">
+                <a:solidFill>
+                  <a:srgbClr val="555555"/>
+                </a:solidFill>
+              </a:rPr>
+              <a:t>Stayed flat 68.3% of decision rows.</a:t>
+            </a:r>
+          </a:p>
+        </p:txBody>
+      </p:sp>
+      <p:sp>
+        <p:nvSpPr>
+          <p:cNvPr id="12" name="">
+            <a:extLst xmlns:a="http://schemas.openxmlformats.org/drawingml/2006/main">
+              <a:ext uri="{FF2B5EF4-FFF2-40B4-BE49-F238E27FC236}">
+                <a16:creationId xmlns:a16="http://schemas.microsoft.com/office/drawing/2014/main" id="{C168FAA0-81EA-40C7-B5C5-576807DE6921}"/>
+              </a:ext>
+            </a:extLst>
+          </p:cNvPr>
+          <p:cNvSpPr>
+            <a:spLocks xmlns:a="http://schemas.openxmlformats.org/drawingml/2006/main" noGrp="1"/>
+          </p:cNvSpPr>
+          <p:nvPr/>
+        </p:nvSpPr>
+        <p:spPr>
+          <a:xfrm xmlns:a="http://schemas.openxmlformats.org/drawingml/2006/main">
+            <a:off x="6229350" y="2152650"/>
+            <a:ext cx="2333625" cy="1200150"/>
+          </a:xfrm>
+          <a:prstGeom xmlns:a="http://schemas.openxmlformats.org/drawingml/2006/main" prst="rect">
+            <a:avLst/>
+          </a:prstGeom>
+          <a:solidFill xmlns:a="http://schemas.openxmlformats.org/drawingml/2006/main">
+            <a:srgbClr val="EDEDED"/>
+          </a:solidFill>
+          <a:ln xmlns:a="http://schemas.openxmlformats.org/drawingml/2006/main" w="9525">
+            <a:solidFill>
+              <a:srgbClr val="B8BCC4"/>
+            </a:solidFill>
+            <a:prstDash val="solid"/>
+          </a:ln>
+        </p:spPr>
+      </p:sp>
+      <p:sp>
+        <p:nvSpPr>
+          <p:cNvPr id="13" name="">
+            <a:extLst xmlns:a="http://schemas.openxmlformats.org/drawingml/2006/main">
+              <a:ext uri="{FF2B5EF4-FFF2-40B4-BE49-F238E27FC236}">
+                <a16:creationId xmlns:a16="http://schemas.microsoft.com/office/drawing/2014/main" id="{4246C54F-C939-44CB-B12F-E777AF3F485F}"/>
+              </a:ext>
+            </a:extLst>
+          </p:cNvPr>
+          <p:cNvSpPr>
+            <a:spLocks xmlns:a="http://schemas.openxmlformats.org/drawingml/2006/main" noGrp="1"/>
+          </p:cNvSpPr>
+          <p:nvPr/>
+        </p:nvSpPr>
+        <p:spPr>
+          <a:xfrm xmlns:a="http://schemas.openxmlformats.org/drawingml/2006/main">
+            <a:off x="6400800" y="2305050"/>
+            <a:ext cx="1990725" cy="171450"/>
+          </a:xfrm>
+          <a:prstGeom xmlns:a="http://schemas.openxmlformats.org/drawingml/2006/main" prst="rect">
+            <a:avLst/>
+          </a:prstGeom>
+          <a:noFill xmlns:a="http://schemas.openxmlformats.org/drawingml/2006/main"/>
+          <a:ln xmlns:a="http://schemas.openxmlformats.org/drawingml/2006/main" w="0">
+            <a:noFill/>
+            <a:prstDash val="solid"/>
+          </a:ln>
+        </p:spPr>
+        <p:txBody>
+          <a:bodyPr xmlns:a="http://schemas.openxmlformats.org/drawingml/2006/main"/>
+          <a:lstStyle xmlns:a="http://schemas.openxmlformats.org/drawingml/2006/main"/>
+          <a:p xmlns:a="http://schemas.openxmlformats.org/drawingml/2006/main">
+            <a:pPr algn="l">
+              <a:defRPr sz="900" b="1" i="0">
+                <a:solidFill>
+                  <a:srgbClr val="555555"/>
+                </a:solidFill>
+              </a:defRPr>
+            </a:pPr>
+            <a:r>
+              <a:rPr sz="900" b="1" i="0">
+                <a:solidFill>
+                  <a:srgbClr val="555555"/>
+                </a:solidFill>
+              </a:rPr>
+              <a:t>2022 ACTIVE</a:t>
+            </a:r>
+          </a:p>
+        </p:txBody>
+      </p:sp>
+      <p:sp>
+        <p:nvSpPr>
+          <p:cNvPr id="14" name="">
+            <a:extLst xmlns:a="http://schemas.openxmlformats.org/drawingml/2006/main">
+              <a:ext uri="{FF2B5EF4-FFF2-40B4-BE49-F238E27FC236}">
+                <a16:creationId xmlns:a16="http://schemas.microsoft.com/office/drawing/2014/main" id="{534BA515-B339-4C53-B80A-21E57E283A49}"/>
+              </a:ext>
+            </a:extLst>
+          </p:cNvPr>
+          <p:cNvSpPr>
+            <a:spLocks xmlns:a="http://schemas.openxmlformats.org/drawingml/2006/main" noGrp="1"/>
+          </p:cNvSpPr>
+          <p:nvPr/>
+        </p:nvSpPr>
+        <p:spPr>
+          <a:xfrm xmlns:a="http://schemas.openxmlformats.org/drawingml/2006/main">
+            <a:off x="6400800" y="2552700"/>
+            <a:ext cx="1990725" cy="361950"/>
+          </a:xfrm>
+          <a:prstGeom xmlns:a="http://schemas.openxmlformats.org/drawingml/2006/main" prst="rect">
+            <a:avLst/>
+          </a:prstGeom>
+          <a:noFill xmlns:a="http://schemas.openxmlformats.org/drawingml/2006/main"/>
+          <a:ln xmlns:a="http://schemas.openxmlformats.org/drawingml/2006/main" w="0">
+            <a:noFill/>
+            <a:prstDash val="solid"/>
+          </a:ln>
+        </p:spPr>
+        <p:txBody>
+          <a:bodyPr xmlns:a="http://schemas.openxmlformats.org/drawingml/2006/main"/>
+          <a:lstStyle xmlns:a="http://schemas.openxmlformats.org/drawingml/2006/main"/>
+          <a:p xmlns:a="http://schemas.openxmlformats.org/drawingml/2006/main">
+            <a:pPr algn="l">
+              <a:defRPr sz="2250" b="1" i="0">
+                <a:solidFill>
+                  <a:srgbClr val="000000"/>
+                </a:solidFill>
+              </a:defRPr>
+            </a:pPr>
+            <a:r>
+              <a:rPr sz="2250" b="1" i="0">
+                <a:solidFill>
+                  <a:srgbClr val="000000"/>
+                </a:solidFill>
+              </a:rPr>
+              <a:t>-42.4%</a:t>
+            </a:r>
+          </a:p>
+        </p:txBody>
+      </p:sp>
+      <p:sp>
+        <p:nvSpPr>
+          <p:cNvPr id="15" name="">
+            <a:extLst xmlns:a="http://schemas.openxmlformats.org/drawingml/2006/main">
+              <a:ext uri="{FF2B5EF4-FFF2-40B4-BE49-F238E27FC236}">
+                <a16:creationId xmlns:a16="http://schemas.microsoft.com/office/drawing/2014/main" id="{3B2A0946-494D-478C-AABB-650D08EABCEE}"/>
+              </a:ext>
+            </a:extLst>
+          </p:cNvPr>
+          <p:cNvSpPr>
+            <a:spLocks xmlns:a="http://schemas.openxmlformats.org/drawingml/2006/main" noGrp="1"/>
+          </p:cNvSpPr>
+          <p:nvPr/>
+        </p:nvSpPr>
+        <p:spPr>
+          <a:xfrm xmlns:a="http://schemas.openxmlformats.org/drawingml/2006/main">
+            <a:off x="6400800" y="2971800"/>
+            <a:ext cx="1990725" cy="323850"/>
+          </a:xfrm>
+          <a:prstGeom xmlns:a="http://schemas.openxmlformats.org/drawingml/2006/main" prst="rect">
+            <a:avLst/>
+          </a:prstGeom>
+          <a:noFill xmlns:a="http://schemas.openxmlformats.org/drawingml/2006/main"/>
+          <a:ln xmlns:a="http://schemas.openxmlformats.org/drawingml/2006/main" w="0">
+            <a:noFill/>
+            <a:prstDash val="solid"/>
+          </a:ln>
+        </p:spPr>
+        <p:txBody>
+          <a:bodyPr xmlns:a="http://schemas.openxmlformats.org/drawingml/2006/main"/>
+          <a:lstStyle xmlns:a="http://schemas.openxmlformats.org/drawingml/2006/main"/>
+          <a:p xmlns:a="http://schemas.openxmlformats.org/drawingml/2006/main">
+            <a:pPr algn="l">
+              <a:defRPr sz="1125" b="0" i="0">
+                <a:solidFill>
+                  <a:srgbClr val="555555"/>
+                </a:solidFill>
+              </a:defRPr>
+            </a:pPr>
+            <a:r>
+              <a:rPr sz="1125" b="0" i="0">
+                <a:solidFill>
+                  <a:srgbClr val="555555"/>
+                </a:solidFill>
+              </a:rPr>
+              <a:t>Basket hold -54.2%</a:t>
+            </a:r>
+          </a:p>
+        </p:txBody>
+      </p:sp>
+      <p:sp>
+        <p:nvSpPr>
+          <p:cNvPr id="16" name="">
+            <a:extLst xmlns:a="http://schemas.openxmlformats.org/drawingml/2006/main">
+              <a:ext uri="{FF2B5EF4-FFF2-40B4-BE49-F238E27FC236}">
+                <a16:creationId xmlns:a16="http://schemas.microsoft.com/office/drawing/2014/main" id="{2C301819-07BA-4164-87F1-05CAF99C69F3}"/>
+              </a:ext>
+            </a:extLst>
+          </p:cNvPr>
+          <p:cNvSpPr>
+            <a:spLocks xmlns:a="http://schemas.openxmlformats.org/drawingml/2006/main" noGrp="1"/>
+          </p:cNvSpPr>
+          <p:nvPr/>
+        </p:nvSpPr>
+        <p:spPr>
+          <a:xfrm xmlns:a="http://schemas.openxmlformats.org/drawingml/2006/main">
+            <a:off x="8934450" y="2152650"/>
+            <a:ext cx="2333625" cy="1200150"/>
+          </a:xfrm>
+          <a:prstGeom xmlns:a="http://schemas.openxmlformats.org/drawingml/2006/main" prst="rect">
+            <a:avLst/>
+          </a:prstGeom>
+          <a:solidFill xmlns:a="http://schemas.openxmlformats.org/drawingml/2006/main">
+            <a:srgbClr val="EDEDED"/>
+          </a:solidFill>
+          <a:ln xmlns:a="http://schemas.openxmlformats.org/drawingml/2006/main" w="9525">
+            <a:solidFill>
+              <a:srgbClr val="B8BCC4"/>
+            </a:solidFill>
+            <a:prstDash val="solid"/>
+          </a:ln>
+        </p:spPr>
+      </p:sp>
+      <p:sp>
+        <p:nvSpPr>
+          <p:cNvPr id="17" name="">
+            <a:extLst xmlns:a="http://schemas.openxmlformats.org/drawingml/2006/main">
+              <a:ext uri="{FF2B5EF4-FFF2-40B4-BE49-F238E27FC236}">
+                <a16:creationId xmlns:a16="http://schemas.microsoft.com/office/drawing/2014/main" id="{8CC08740-0A01-4C0C-9D92-27EDDA824070}"/>
+              </a:ext>
+            </a:extLst>
+          </p:cNvPr>
+          <p:cNvSpPr>
+            <a:spLocks xmlns:a="http://schemas.openxmlformats.org/drawingml/2006/main" noGrp="1"/>
+          </p:cNvSpPr>
+          <p:nvPr/>
+        </p:nvSpPr>
+        <p:spPr>
+          <a:xfrm xmlns:a="http://schemas.openxmlformats.org/drawingml/2006/main">
+            <a:off x="9105900" y="2305050"/>
+            <a:ext cx="1990725" cy="171450"/>
+          </a:xfrm>
+          <a:prstGeom xmlns:a="http://schemas.openxmlformats.org/drawingml/2006/main" prst="rect">
+            <a:avLst/>
+          </a:prstGeom>
+          <a:noFill xmlns:a="http://schemas.openxmlformats.org/drawingml/2006/main"/>
+          <a:ln xmlns:a="http://schemas.openxmlformats.org/drawingml/2006/main" w="0">
+            <a:noFill/>
+            <a:prstDash val="solid"/>
+          </a:ln>
+        </p:spPr>
+        <p:txBody>
+          <a:bodyPr xmlns:a="http://schemas.openxmlformats.org/drawingml/2006/main"/>
+          <a:lstStyle xmlns:a="http://schemas.openxmlformats.org/drawingml/2006/main"/>
+          <a:p xmlns:a="http://schemas.openxmlformats.org/drawingml/2006/main">
+            <a:pPr algn="l">
+              <a:defRPr sz="900" b="1" i="0">
+                <a:solidFill>
+                  <a:srgbClr val="555555"/>
+                </a:solidFill>
+              </a:defRPr>
+            </a:pPr>
+            <a:r>
+              <a:rPr sz="900" b="1" i="0">
+                <a:solidFill>
+                  <a:srgbClr val="555555"/>
+                </a:solidFill>
+              </a:rPr>
+              <a:t>LEAKAGE AUDIT</a:t>
+            </a:r>
+          </a:p>
+        </p:txBody>
+      </p:sp>
+      <p:sp>
+        <p:nvSpPr>
+          <p:cNvPr id="18" name="">
+            <a:extLst xmlns:a="http://schemas.openxmlformats.org/drawingml/2006/main">
+              <a:ext uri="{FF2B5EF4-FFF2-40B4-BE49-F238E27FC236}">
+                <a16:creationId xmlns:a16="http://schemas.microsoft.com/office/drawing/2014/main" id="{E8FBA8DF-C648-4BC9-A4F5-5D8A119013C1}"/>
+              </a:ext>
+            </a:extLst>
+          </p:cNvPr>
+          <p:cNvSpPr>
+            <a:spLocks xmlns:a="http://schemas.openxmlformats.org/drawingml/2006/main" noGrp="1"/>
+          </p:cNvSpPr>
+          <p:nvPr/>
+        </p:nvSpPr>
+        <p:spPr>
+          <a:xfrm xmlns:a="http://schemas.openxmlformats.org/drawingml/2006/main">
+            <a:off x="9105900" y="2552700"/>
+            <a:ext cx="1990725" cy="361950"/>
+          </a:xfrm>
+          <a:prstGeom xmlns:a="http://schemas.openxmlformats.org/drawingml/2006/main" prst="rect">
+            <a:avLst/>
+          </a:prstGeom>
+          <a:noFill xmlns:a="http://schemas.openxmlformats.org/drawingml/2006/main"/>
+          <a:ln xmlns:a="http://schemas.openxmlformats.org/drawingml/2006/main" w="0">
+            <a:noFill/>
+            <a:prstDash val="solid"/>
+          </a:ln>
+        </p:spPr>
+        <p:txBody>
+          <a:bodyPr xmlns:a="http://schemas.openxmlformats.org/drawingml/2006/main"/>
+          <a:lstStyle xmlns:a="http://schemas.openxmlformats.org/drawingml/2006/main"/>
+          <a:p xmlns:a="http://schemas.openxmlformats.org/drawingml/2006/main">
+            <a:pPr algn="l">
+              <a:defRPr sz="2250" b="1" i="0">
+                <a:solidFill>
+                  <a:srgbClr val="000000"/>
+                </a:solidFill>
+              </a:defRPr>
+            </a:pPr>
+            <a:r>
+              <a:rPr sz="2250" b="1" i="0">
+                <a:solidFill>
+                  <a:srgbClr val="000000"/>
+                </a:solidFill>
+              </a:rPr>
+              <a:t>All PASS</a:t>
+            </a:r>
+          </a:p>
+        </p:txBody>
+      </p:sp>
+      <p:sp>
+        <p:nvSpPr>
+          <p:cNvPr id="19" name="">
+            <a:extLst xmlns:a="http://schemas.openxmlformats.org/drawingml/2006/main">
+              <a:ext uri="{FF2B5EF4-FFF2-40B4-BE49-F238E27FC236}">
+                <a16:creationId xmlns:a16="http://schemas.microsoft.com/office/drawing/2014/main" id="{3E482B9E-055E-4018-A6F8-7335BAFBE52B}"/>
+              </a:ext>
+            </a:extLst>
+          </p:cNvPr>
+          <p:cNvSpPr>
+            <a:spLocks xmlns:a="http://schemas.openxmlformats.org/drawingml/2006/main" noGrp="1"/>
+          </p:cNvSpPr>
+          <p:nvPr/>
+        </p:nvSpPr>
+        <p:spPr>
+          <a:xfrm xmlns:a="http://schemas.openxmlformats.org/drawingml/2006/main">
+            <a:off x="9105900" y="2971800"/>
+            <a:ext cx="1990725" cy="323850"/>
+          </a:xfrm>
+          <a:prstGeom xmlns:a="http://schemas.openxmlformats.org/drawingml/2006/main" prst="rect">
+            <a:avLst/>
+          </a:prstGeom>
+          <a:noFill xmlns:a="http://schemas.openxmlformats.org/drawingml/2006/main"/>
+          <a:ln xmlns:a="http://schemas.openxmlformats.org/drawingml/2006/main" w="0">
+            <a:noFill/>
+            <a:prstDash val="solid"/>
+          </a:ln>
+        </p:spPr>
+        <p:txBody>
+          <a:bodyPr xmlns:a="http://schemas.openxmlformats.org/drawingml/2006/main"/>
+          <a:lstStyle xmlns:a="http://schemas.openxmlformats.org/drawingml/2006/main"/>
+          <a:p xmlns:a="http://schemas.openxmlformats.org/drawingml/2006/main">
+            <a:pPr algn="l">
+              <a:defRPr sz="1125" b="0" i="0">
+                <a:solidFill>
+                  <a:srgbClr val="555555"/>
+                </a:solidFill>
+              </a:defRPr>
+            </a:pPr>
+            <a:r>
+              <a:rPr sz="1125" b="0" i="0">
+                <a:solidFill>
+                  <a:srgbClr val="555555"/>
+                </a:solidFill>
+              </a:rPr>
+              <a:t>TRAIN fit only; OOS prediction only.</a:t>
+            </a:r>
+          </a:p>
+        </p:txBody>
+      </p:sp>
+      <p:sp>
+        <p:nvSpPr>
+          <p:cNvPr id="20" name="">
+            <a:extLst xmlns:a="http://schemas.openxmlformats.org/drawingml/2006/main">
+              <a:ext uri="{FF2B5EF4-FFF2-40B4-BE49-F238E27FC236}">
+                <a16:creationId xmlns:a16="http://schemas.microsoft.com/office/drawing/2014/main" id="{577B79E9-1BB6-4C1E-A96D-1790E0B2EE54}"/>
+              </a:ext>
+            </a:extLst>
+          </p:cNvPr>
+          <p:cNvSpPr>
+            <a:spLocks xmlns:a="http://schemas.openxmlformats.org/drawingml/2006/main" noGrp="1"/>
+          </p:cNvSpPr>
+          <p:nvPr/>
+        </p:nvSpPr>
+        <p:spPr>
+          <a:xfrm xmlns:a="http://schemas.openxmlformats.org/drawingml/2006/main">
+            <a:off x="1066800" y="4095750"/>
+            <a:ext cx="9334500" cy="800100"/>
+          </a:xfrm>
+          <a:prstGeom xmlns:a="http://schemas.openxmlformats.org/drawingml/2006/main" prst="rect">
+            <a:avLst/>
+          </a:prstGeom>
+          <a:noFill xmlns:a="http://schemas.openxmlformats.org/drawingml/2006/main"/>
+          <a:ln xmlns:a="http://schemas.openxmlformats.org/drawingml/2006/main" w="0">
+            <a:noFill/>
+            <a:prstDash val="solid"/>
+          </a:ln>
+        </p:spPr>
+        <p:txBody>
+          <a:bodyPr xmlns:a="http://schemas.openxmlformats.org/drawingml/2006/main"/>
+          <a:lstStyle xmlns:a="http://schemas.openxmlformats.org/drawingml/2006/main"/>
+          <a:p xmlns:a="http://schemas.openxmlformats.org/drawingml/2006/main">
+            <a:pPr algn="ctr">
+              <a:defRPr sz="2100" b="1" i="0">
+                <a:solidFill>
+                  <a:srgbClr val="000000"/>
+                </a:solidFill>
+              </a:defRPr>
+            </a:pPr>
+            <a:r>
+              <a:rPr sz="2100" b="1" i="0">
+                <a:solidFill>
+                  <a:srgbClr val="000000"/>
+                </a:solidFill>
+              </a:rPr>
+              <a:t>The first GLM replay proves the mechanics, but not the alpha thesis. It missed most of the 2020 rally and was useful mainly as partial 2022 defense.</a:t>
+            </a:r>
+          </a:p>
+        </p:txBody>
+      </p:sp>
+    </p:spTree>
+    <p:extLst>
+      <p:ext uri="{BB962C8B-B14F-4D97-AF65-F5344CB8AC3E}">
+        <p14:creationId xmlns:p14="http://schemas.microsoft.com/office/powerpoint/2010/main" val="1722505646"/>
+      </p:ext>
+    </p:extLst>
+  </p:cSld>
+</p:sld>
+</file>
+
+<file path=ppt/slides/slide13.xml><?xml version="1.0" encoding="utf-8"?>
+<p:sld xmlns:p="http://schemas.openxmlformats.org/presentationml/2006/main">
+  <p:cSld>
+    <p:bg>
+      <p:bgPr>
+        <a:solidFill xmlns:a="http://schemas.openxmlformats.org/drawingml/2006/main">
+          <a:srgbClr val="FFFFFF"/>
+        </a:solidFill>
+      </p:bgPr>
+    </p:bg>
+    <p:spTree>
+      <p:nvGrpSpPr>
+        <p:cNvPr id="1" name=""/>
+        <p:cNvGrpSpPr/>
+        <p:nvPr/>
+      </p:nvGrpSpPr>
+      <p:grpSpPr>
+        <a:xfrm xmlns:a="http://schemas.openxmlformats.org/drawingml/2006/main"/>
+      </p:grpSpPr>
+      <p:sp>
+        <p:nvSpPr>
+          <p:cNvPr id="1" name="">
+            <a:extLst xmlns:a="http://schemas.openxmlformats.org/drawingml/2006/main">
+              <a:ext uri="{FF2B5EF4-FFF2-40B4-BE49-F238E27FC236}">
+                <a16:creationId xmlns:a16="http://schemas.microsoft.com/office/drawing/2014/main" id="{223799F1-D6BF-4BC1-93A5-BD6951CEC742}"/>
+              </a:ext>
+            </a:extLst>
+          </p:cNvPr>
+          <p:cNvSpPr>
+            <a:spLocks xmlns:a="http://schemas.openxmlformats.org/drawingml/2006/main" noGrp="1"/>
+          </p:cNvSpPr>
+          <p:nvPr/>
+        </p:nvSpPr>
+        <p:spPr>
+          <a:xfrm xmlns:a="http://schemas.openxmlformats.org/drawingml/2006/main">
+            <a:off x="685800" y="400050"/>
+            <a:ext cx="8572500" cy="247650"/>
+          </a:xfrm>
+          <a:prstGeom xmlns:a="http://schemas.openxmlformats.org/drawingml/2006/main" prst="rect">
+            <a:avLst/>
+          </a:prstGeom>
+          <a:noFill xmlns:a="http://schemas.openxmlformats.org/drawingml/2006/main"/>
+          <a:ln xmlns:a="http://schemas.openxmlformats.org/drawingml/2006/main" w="0">
+            <a:noFill/>
+            <a:prstDash val="solid"/>
+          </a:ln>
+        </p:spPr>
+        <p:txBody>
+          <a:bodyPr xmlns:a="http://schemas.openxmlformats.org/drawingml/2006/main"/>
+          <a:lstStyle xmlns:a="http://schemas.openxmlformats.org/drawingml/2006/main"/>
+          <a:p xmlns:a="http://schemas.openxmlformats.org/drawingml/2006/main">
+            <a:pPr algn="l">
+              <a:defRPr sz="975" b="1" i="0">
+                <a:solidFill>
+                  <a:srgbClr val="555555"/>
+                </a:solidFill>
+              </a:defRPr>
+            </a:pPr>
+            <a:r>
+              <a:rPr sz="975" b="1" i="0">
+                <a:solidFill>
+                  <a:srgbClr val="555555"/>
+                </a:solidFill>
+              </a:rPr>
+              <a:t>GEN5.4 ML DECISION ENGINE</a:t>
+            </a:r>
+          </a:p>
+        </p:txBody>
+      </p:sp>
+      <p:sp>
+        <p:nvSpPr>
+          <p:cNvPr id="2" name="">
+            <a:extLst xmlns:a="http://schemas.openxmlformats.org/drawingml/2006/main">
+              <a:ext uri="{FF2B5EF4-FFF2-40B4-BE49-F238E27FC236}">
+                <a16:creationId xmlns:a16="http://schemas.microsoft.com/office/drawing/2014/main" id="{6A34D0D8-8461-41CD-BD0B-0E16C6C85D76}"/>
+              </a:ext>
+            </a:extLst>
+          </p:cNvPr>
+          <p:cNvSpPr>
+            <a:spLocks xmlns:a="http://schemas.openxmlformats.org/drawingml/2006/main" noGrp="1"/>
+          </p:cNvSpPr>
+          <p:nvPr/>
+        </p:nvSpPr>
+        <p:spPr>
+          <a:xfrm xmlns:a="http://schemas.openxmlformats.org/drawingml/2006/main">
+            <a:off x="685800" y="723900"/>
+            <a:ext cx="10287000" cy="876300"/>
+          </a:xfrm>
+          <a:prstGeom xmlns:a="http://schemas.openxmlformats.org/drawingml/2006/main" prst="rect">
+            <a:avLst/>
+          </a:prstGeom>
+          <a:noFill xmlns:a="http://schemas.openxmlformats.org/drawingml/2006/main"/>
+          <a:ln xmlns:a="http://schemas.openxmlformats.org/drawingml/2006/main" w="0">
+            <a:noFill/>
+            <a:prstDash val="solid"/>
+          </a:ln>
+        </p:spPr>
+        <p:txBody>
+          <a:bodyPr xmlns:a="http://schemas.openxmlformats.org/drawingml/2006/main"/>
+          <a:lstStyle xmlns:a="http://schemas.openxmlformats.org/drawingml/2006/main"/>
+          <a:p xmlns:a="http://schemas.openxmlformats.org/drawingml/2006/main">
+            <a:pPr algn="l">
+              <a:defRPr sz="2850" b="1" i="0">
+                <a:solidFill>
+                  <a:srgbClr val="000000"/>
+                </a:solidFill>
+              </a:defRPr>
+            </a:pPr>
+            <a:r>
+              <a:rPr sz="2850" b="1" i="0">
+                <a:solidFill>
+                  <a:srgbClr val="000000"/>
+                </a:solidFill>
+              </a:rPr>
+              <a:t>The equity curve shows the same participation problem we have been chasing</a:t>
+            </a:r>
+          </a:p>
+        </p:txBody>
+      </p:sp>
+      <p:sp>
+        <p:nvSpPr>
+          <p:cNvPr id="3" name="">
+            <a:extLst xmlns:a="http://schemas.openxmlformats.org/drawingml/2006/main">
+              <a:ext uri="{FF2B5EF4-FFF2-40B4-BE49-F238E27FC236}">
+                <a16:creationId xmlns:a16="http://schemas.microsoft.com/office/drawing/2014/main" id="{25761B01-669B-41B5-8EC0-D8DEC8317240}"/>
+              </a:ext>
+            </a:extLst>
+          </p:cNvPr>
+          <p:cNvSpPr>
+            <a:spLocks xmlns:a="http://schemas.openxmlformats.org/drawingml/2006/main" noGrp="1"/>
+          </p:cNvSpPr>
+          <p:nvPr/>
+        </p:nvSpPr>
+        <p:spPr>
+          <a:xfrm xmlns:a="http://schemas.openxmlformats.org/drawingml/2006/main">
+            <a:off x="685800" y="1657350"/>
+            <a:ext cx="10820400" cy="19050"/>
+          </a:xfrm>
+          <a:prstGeom xmlns:a="http://schemas.openxmlformats.org/drawingml/2006/main" prst="rect">
+            <a:avLst/>
+          </a:prstGeom>
+          <a:solidFill xmlns:a="http://schemas.openxmlformats.org/drawingml/2006/main">
+            <a:srgbClr val="B8BCC4"/>
+          </a:solidFill>
+          <a:ln xmlns:a="http://schemas.openxmlformats.org/drawingml/2006/main" w="0">
+            <a:noFill/>
+            <a:prstDash val="solid"/>
+          </a:ln>
+        </p:spPr>
+      </p:sp>
+      <p:pic>
+        <p:nvPicPr>
+          <p:cNvPr id="10" name=""/>
+          <p:cNvPicPr>
+            <a:picLocks xmlns:a="http://schemas.openxmlformats.org/drawingml/2006/main" noChangeAspect="1"/>
+          </p:cNvPicPr>
+          <p:nvPr/>
+        </p:nvPicPr>
+        <p:blipFill>
+          <a:blip xmlns:r="http://schemas.openxmlformats.org/officeDocument/2006/relationships" xmlns:a="http://schemas.openxmlformats.org/drawingml/2006/main" r:embed="Rdb4ccd48a1ef407b"/>
+          <a:stretch xmlns:a="http://schemas.openxmlformats.org/drawingml/2006/main"/>
+        </p:blipFill>
+        <p:spPr>
+          <a:xfrm xmlns:a="http://schemas.openxmlformats.org/drawingml/2006/main">
+            <a:off x="868680" y="2000250"/>
+            <a:ext cx="6835140" cy="3943350"/>
+          </a:xfrm>
+          <a:prstGeom xmlns:a="http://schemas.openxmlformats.org/drawingml/2006/main" prst="rect">
+            <a:avLst/>
+          </a:prstGeom>
+        </p:spPr>
+      </p:pic>
+      <p:sp>
+        <p:nvSpPr>
+          <p:cNvPr id="5" name="">
+            <a:extLst xmlns:a="http://schemas.openxmlformats.org/drawingml/2006/main">
+              <a:ext uri="{FF2B5EF4-FFF2-40B4-BE49-F238E27FC236}">
+                <a16:creationId xmlns:a16="http://schemas.microsoft.com/office/drawing/2014/main" id="{D31C325D-BE86-44D5-8410-932A9DB6227A}"/>
+              </a:ext>
+            </a:extLst>
+          </p:cNvPr>
+          <p:cNvSpPr>
+            <a:spLocks xmlns:a="http://schemas.openxmlformats.org/drawingml/2006/main" noGrp="1"/>
+          </p:cNvSpPr>
+          <p:nvPr/>
+        </p:nvSpPr>
+        <p:spPr>
+          <a:xfrm xmlns:a="http://schemas.openxmlformats.org/drawingml/2006/main">
+            <a:off x="8477250" y="2133600"/>
+            <a:ext cx="2476500" cy="304800"/>
+          </a:xfrm>
+          <a:prstGeom xmlns:a="http://schemas.openxmlformats.org/drawingml/2006/main" prst="rect">
+            <a:avLst/>
+          </a:prstGeom>
+          <a:noFill xmlns:a="http://schemas.openxmlformats.org/drawingml/2006/main"/>
+          <a:ln xmlns:a="http://schemas.openxmlformats.org/drawingml/2006/main" w="0">
+            <a:noFill/>
+            <a:prstDash val="solid"/>
+          </a:ln>
+        </p:spPr>
+        <p:txBody>
+          <a:bodyPr xmlns:a="http://schemas.openxmlformats.org/drawingml/2006/main"/>
+          <a:lstStyle xmlns:a="http://schemas.openxmlformats.org/drawingml/2006/main"/>
+          <a:p xmlns:a="http://schemas.openxmlformats.org/drawingml/2006/main">
+            <a:pPr algn="l">
+              <a:defRPr sz="1950" b="1" i="0">
+                <a:solidFill>
+                  <a:srgbClr val="222222"/>
+                </a:solidFill>
+              </a:defRPr>
+            </a:pPr>
+            <a:r>
+              <a:rPr sz="1950" b="1" i="0">
+                <a:solidFill>
+                  <a:srgbClr val="222222"/>
+                </a:solidFill>
+              </a:rPr>
+              <a:t>Interpretation</a:t>
+            </a:r>
+          </a:p>
+        </p:txBody>
+      </p:sp>
+      <p:sp>
+        <p:nvSpPr>
+          <p:cNvPr id="6" name="">
+            <a:extLst xmlns:a="http://schemas.openxmlformats.org/drawingml/2006/main">
+              <a:ext uri="{FF2B5EF4-FFF2-40B4-BE49-F238E27FC236}">
+                <a16:creationId xmlns:a16="http://schemas.microsoft.com/office/drawing/2014/main" id="{56E8C882-7CB3-42D9-80C2-5A28F72CFBC6}"/>
+              </a:ext>
+            </a:extLst>
+          </p:cNvPr>
+          <p:cNvSpPr>
+            <a:spLocks xmlns:a="http://schemas.openxmlformats.org/drawingml/2006/main" noGrp="1"/>
+          </p:cNvSpPr>
+          <p:nvPr/>
+        </p:nvSpPr>
+        <p:spPr>
+          <a:xfrm xmlns:a="http://schemas.openxmlformats.org/drawingml/2006/main">
+            <a:off x="8477250" y="2686050"/>
+            <a:ext cx="2571750" cy="2095500"/>
+          </a:xfrm>
+          <a:prstGeom xmlns:a="http://schemas.openxmlformats.org/drawingml/2006/main" prst="rect">
+            <a:avLst/>
+          </a:prstGeom>
+          <a:noFill xmlns:a="http://schemas.openxmlformats.org/drawingml/2006/main"/>
+          <a:ln xmlns:a="http://schemas.openxmlformats.org/drawingml/2006/main" w="0">
+            <a:noFill/>
+            <a:prstDash val="solid"/>
+          </a:ln>
+        </p:spPr>
+        <p:txBody>
+          <a:bodyPr xmlns:a="http://schemas.openxmlformats.org/drawingml/2006/main"/>
+          <a:lstStyle xmlns:a="http://schemas.openxmlformats.org/drawingml/2006/main"/>
+          <a:p xmlns:a="http://schemas.openxmlformats.org/drawingml/2006/main">
+            <a:pPr algn="l">
+              <a:defRPr sz="1650" b="0" i="0">
+                <a:solidFill>
+                  <a:srgbClr val="222222"/>
+                </a:solidFill>
+              </a:defRPr>
+            </a:pPr>
+            <a:r>
+              <a:rPr sz="1650" b="0" i="0">
+                <a:solidFill>
+                  <a:srgbClr val="222222"/>
+                </a:solidFill>
+              </a:rPr>
+              <a:t>In 2020, the model stayed too cautious while the basket compounded aggressively. In 2022, the model preserved capital relative to the falling basket, but it was still not cleanly risk-off.</a:t>
+            </a:r>
+          </a:p>
+        </p:txBody>
+      </p:sp>
+    </p:spTree>
+    <p:extLst>
+      <p:ext uri="{BB962C8B-B14F-4D97-AF65-F5344CB8AC3E}">
+        <p14:creationId xmlns:p14="http://schemas.microsoft.com/office/powerpoint/2010/main" val="1009614114"/>
+      </p:ext>
+    </p:extLst>
+  </p:cSld>
+</p:sld>
+</file>
+
+<file path=ppt/slides/slide14.xml><?xml version="1.0" encoding="utf-8"?>
+<p:sld xmlns:p="http://schemas.openxmlformats.org/presentationml/2006/main">
+  <p:cSld>
+    <p:bg>
+      <p:bgPr>
+        <a:solidFill xmlns:a="http://schemas.openxmlformats.org/drawingml/2006/main">
+          <a:srgbClr val="FFFFFF"/>
+        </a:solidFill>
+      </p:bgPr>
+    </p:bg>
+    <p:spTree>
+      <p:nvGrpSpPr>
+        <p:cNvPr id="1" name=""/>
+        <p:cNvGrpSpPr/>
+        <p:nvPr/>
+      </p:nvGrpSpPr>
+      <p:grpSpPr>
+        <a:xfrm xmlns:a="http://schemas.openxmlformats.org/drawingml/2006/main"/>
+      </p:grpSpPr>
+      <p:sp>
+        <p:nvSpPr>
+          <p:cNvPr id="1" name="">
+            <a:extLst xmlns:a="http://schemas.openxmlformats.org/drawingml/2006/main">
+              <a:ext uri="{FF2B5EF4-FFF2-40B4-BE49-F238E27FC236}">
+                <a16:creationId xmlns:a16="http://schemas.microsoft.com/office/drawing/2014/main" id="{6C634AD6-EF0A-4918-AEA4-BBF8C9881F9F}"/>
+              </a:ext>
+            </a:extLst>
+          </p:cNvPr>
+          <p:cNvSpPr>
+            <a:spLocks xmlns:a="http://schemas.openxmlformats.org/drawingml/2006/main" noGrp="1"/>
+          </p:cNvSpPr>
+          <p:nvPr/>
+        </p:nvSpPr>
+        <p:spPr>
+          <a:xfrm xmlns:a="http://schemas.openxmlformats.org/drawingml/2006/main">
+            <a:off x="685800" y="400050"/>
+            <a:ext cx="8572500" cy="247650"/>
+          </a:xfrm>
+          <a:prstGeom xmlns:a="http://schemas.openxmlformats.org/drawingml/2006/main" prst="rect">
+            <a:avLst/>
+          </a:prstGeom>
+          <a:noFill xmlns:a="http://schemas.openxmlformats.org/drawingml/2006/main"/>
+          <a:ln xmlns:a="http://schemas.openxmlformats.org/drawingml/2006/main" w="0">
+            <a:noFill/>
+            <a:prstDash val="solid"/>
+          </a:ln>
+        </p:spPr>
+        <p:txBody>
+          <a:bodyPr xmlns:a="http://schemas.openxmlformats.org/drawingml/2006/main"/>
+          <a:lstStyle xmlns:a="http://schemas.openxmlformats.org/drawingml/2006/main"/>
+          <a:p xmlns:a="http://schemas.openxmlformats.org/drawingml/2006/main">
+            <a:pPr algn="l">
+              <a:defRPr sz="975" b="1" i="0">
+                <a:solidFill>
+                  <a:srgbClr val="555555"/>
+                </a:solidFill>
+              </a:defRPr>
+            </a:pPr>
+            <a:r>
+              <a:rPr sz="975" b="1" i="0">
+                <a:solidFill>
+                  <a:srgbClr val="555555"/>
+                </a:solidFill>
+              </a:rPr>
+              <a:t>GEN5.4 ML DECISION ENGINE</a:t>
+            </a:r>
+          </a:p>
+        </p:txBody>
+      </p:sp>
+      <p:sp>
+        <p:nvSpPr>
+          <p:cNvPr id="2" name="">
+            <a:extLst xmlns:a="http://schemas.openxmlformats.org/drawingml/2006/main">
+              <a:ext uri="{FF2B5EF4-FFF2-40B4-BE49-F238E27FC236}">
+                <a16:creationId xmlns:a16="http://schemas.microsoft.com/office/drawing/2014/main" id="{4589C4A9-22E5-4BA8-8646-7ECB09F8273D}"/>
+              </a:ext>
+            </a:extLst>
+          </p:cNvPr>
+          <p:cNvSpPr>
+            <a:spLocks xmlns:a="http://schemas.openxmlformats.org/drawingml/2006/main" noGrp="1"/>
+          </p:cNvSpPr>
+          <p:nvPr/>
+        </p:nvSpPr>
+        <p:spPr>
+          <a:xfrm xmlns:a="http://schemas.openxmlformats.org/drawingml/2006/main">
+            <a:off x="685800" y="723900"/>
+            <a:ext cx="10287000" cy="876300"/>
+          </a:xfrm>
+          <a:prstGeom xmlns:a="http://schemas.openxmlformats.org/drawingml/2006/main" prst="rect">
+            <a:avLst/>
+          </a:prstGeom>
+          <a:noFill xmlns:a="http://schemas.openxmlformats.org/drawingml/2006/main"/>
+          <a:ln xmlns:a="http://schemas.openxmlformats.org/drawingml/2006/main" w="0">
+            <a:noFill/>
+            <a:prstDash val="solid"/>
+          </a:ln>
+        </p:spPr>
+        <p:txBody>
+          <a:bodyPr xmlns:a="http://schemas.openxmlformats.org/drawingml/2006/main"/>
+          <a:lstStyle xmlns:a="http://schemas.openxmlformats.org/drawingml/2006/main"/>
+          <a:p xmlns:a="http://schemas.openxmlformats.org/drawingml/2006/main">
+            <a:pPr algn="l">
+              <a:defRPr sz="2850" b="1" i="0">
+                <a:solidFill>
+                  <a:srgbClr val="000000"/>
+                </a:solidFill>
+              </a:defRPr>
+            </a:pPr>
+            <a:r>
+              <a:rPr sz="2850" b="1" i="0">
+                <a:solidFill>
+                  <a:srgbClr val="000000"/>
+                </a:solidFill>
+              </a:rPr>
+              <a:t>Probability trade tapes show what the policy actually did</a:t>
+            </a:r>
+          </a:p>
+        </p:txBody>
+      </p:sp>
+      <p:sp>
+        <p:nvSpPr>
+          <p:cNvPr id="3" name="">
+            <a:extLst xmlns:a="http://schemas.openxmlformats.org/drawingml/2006/main">
+              <a:ext uri="{FF2B5EF4-FFF2-40B4-BE49-F238E27FC236}">
+                <a16:creationId xmlns:a16="http://schemas.microsoft.com/office/drawing/2014/main" id="{05D8BBAD-784A-4C55-AD4C-530DA7210E76}"/>
+              </a:ext>
+            </a:extLst>
+          </p:cNvPr>
+          <p:cNvSpPr>
+            <a:spLocks xmlns:a="http://schemas.openxmlformats.org/drawingml/2006/main" noGrp="1"/>
+          </p:cNvSpPr>
+          <p:nvPr/>
+        </p:nvSpPr>
+        <p:spPr>
+          <a:xfrm xmlns:a="http://schemas.openxmlformats.org/drawingml/2006/main">
+            <a:off x="685800" y="1657350"/>
+            <a:ext cx="10820400" cy="19050"/>
+          </a:xfrm>
+          <a:prstGeom xmlns:a="http://schemas.openxmlformats.org/drawingml/2006/main" prst="rect">
+            <a:avLst/>
+          </a:prstGeom>
+          <a:solidFill xmlns:a="http://schemas.openxmlformats.org/drawingml/2006/main">
+            <a:srgbClr val="B8BCC4"/>
+          </a:solidFill>
+          <a:ln xmlns:a="http://schemas.openxmlformats.org/drawingml/2006/main" w="0">
+            <a:noFill/>
+            <a:prstDash val="solid"/>
+          </a:ln>
+        </p:spPr>
+      </p:sp>
+      <p:pic>
+        <p:nvPicPr>
+          <p:cNvPr id="10" name=""/>
+          <p:cNvPicPr>
+            <a:picLocks xmlns:a="http://schemas.openxmlformats.org/drawingml/2006/main" noChangeAspect="1"/>
+          </p:cNvPicPr>
+          <p:nvPr/>
+        </p:nvPicPr>
+        <p:blipFill>
+          <a:blip xmlns:r="http://schemas.openxmlformats.org/officeDocument/2006/relationships" xmlns:a="http://schemas.openxmlformats.org/drawingml/2006/main" r:embed="R3d44d20a57bd4082"/>
+          <a:stretch xmlns:a="http://schemas.openxmlformats.org/drawingml/2006/main"/>
+        </p:blipFill>
+        <p:spPr>
+          <a:xfrm xmlns:a="http://schemas.openxmlformats.org/drawingml/2006/main">
+            <a:off x="1038785" y="2000250"/>
+            <a:ext cx="6494929" cy="3943350"/>
+          </a:xfrm>
+          <a:prstGeom xmlns:a="http://schemas.openxmlformats.org/drawingml/2006/main" prst="rect">
+            <a:avLst/>
+          </a:prstGeom>
+        </p:spPr>
+      </p:pic>
+      <p:sp>
+        <p:nvSpPr>
+          <p:cNvPr id="5" name="">
+            <a:extLst xmlns:a="http://schemas.openxmlformats.org/drawingml/2006/main">
+              <a:ext uri="{FF2B5EF4-FFF2-40B4-BE49-F238E27FC236}">
+                <a16:creationId xmlns:a16="http://schemas.microsoft.com/office/drawing/2014/main" id="{73DA46D4-0353-4A50-9CB7-4EDB70E56449}"/>
+              </a:ext>
+            </a:extLst>
+          </p:cNvPr>
+          <p:cNvSpPr>
+            <a:spLocks xmlns:a="http://schemas.openxmlformats.org/drawingml/2006/main" noGrp="1"/>
+          </p:cNvSpPr>
+          <p:nvPr/>
+        </p:nvSpPr>
+        <p:spPr>
+          <a:xfrm xmlns:a="http://schemas.openxmlformats.org/drawingml/2006/main">
+            <a:off x="8477250" y="2133600"/>
+            <a:ext cx="2571750" cy="304800"/>
+          </a:xfrm>
+          <a:prstGeom xmlns:a="http://schemas.openxmlformats.org/drawingml/2006/main" prst="rect">
+            <a:avLst/>
+          </a:prstGeom>
+          <a:noFill xmlns:a="http://schemas.openxmlformats.org/drawingml/2006/main"/>
+          <a:ln xmlns:a="http://schemas.openxmlformats.org/drawingml/2006/main" w="0">
+            <a:noFill/>
+            <a:prstDash val="solid"/>
+          </a:ln>
+        </p:spPr>
+        <p:txBody>
+          <a:bodyPr xmlns:a="http://schemas.openxmlformats.org/drawingml/2006/main"/>
+          <a:lstStyle xmlns:a="http://schemas.openxmlformats.org/drawingml/2006/main"/>
+          <a:p xmlns:a="http://schemas.openxmlformats.org/drawingml/2006/main">
+            <a:pPr algn="l">
+              <a:defRPr sz="1950" b="1" i="0">
+                <a:solidFill>
+                  <a:srgbClr val="222222"/>
+                </a:solidFill>
+              </a:defRPr>
+            </a:pPr>
+            <a:r>
+              <a:rPr sz="1950" b="1" i="0">
+                <a:solidFill>
+                  <a:srgbClr val="222222"/>
+                </a:solidFill>
+              </a:rPr>
+              <a:t>What this reveals</a:t>
+            </a:r>
+          </a:p>
+        </p:txBody>
+      </p:sp>
+      <p:sp>
+        <p:nvSpPr>
+          <p:cNvPr id="6" name="">
+            <a:extLst xmlns:a="http://schemas.openxmlformats.org/drawingml/2006/main">
+              <a:ext uri="{FF2B5EF4-FFF2-40B4-BE49-F238E27FC236}">
+                <a16:creationId xmlns:a16="http://schemas.microsoft.com/office/drawing/2014/main" id="{885340DF-2D6C-47CE-8A1A-E075562DF56A}"/>
+              </a:ext>
+            </a:extLst>
+          </p:cNvPr>
+          <p:cNvSpPr>
+            <a:spLocks xmlns:a="http://schemas.openxmlformats.org/drawingml/2006/main" noGrp="1"/>
+          </p:cNvSpPr>
+          <p:nvPr/>
+        </p:nvSpPr>
+        <p:spPr>
+          <a:xfrm xmlns:a="http://schemas.openxmlformats.org/drawingml/2006/main">
+            <a:off x="8477250" y="2705100"/>
+            <a:ext cx="2571750" cy="2095500"/>
+          </a:xfrm>
+          <a:prstGeom xmlns:a="http://schemas.openxmlformats.org/drawingml/2006/main" prst="rect">
+            <a:avLst/>
+          </a:prstGeom>
+          <a:noFill xmlns:a="http://schemas.openxmlformats.org/drawingml/2006/main"/>
+          <a:ln xmlns:a="http://schemas.openxmlformats.org/drawingml/2006/main" w="0">
+            <a:noFill/>
+            <a:prstDash val="solid"/>
+          </a:ln>
+        </p:spPr>
+        <p:txBody>
+          <a:bodyPr xmlns:a="http://schemas.openxmlformats.org/drawingml/2006/main"/>
+          <a:lstStyle xmlns:a="http://schemas.openxmlformats.org/drawingml/2006/main"/>
+          <a:p xmlns:a="http://schemas.openxmlformats.org/drawingml/2006/main">
+            <a:pPr algn="l">
+              <a:defRPr sz="1650" b="0" i="0">
+                <a:solidFill>
+                  <a:srgbClr val="222222"/>
+                </a:solidFill>
+              </a:defRPr>
+            </a:pPr>
+            <a:r>
+              <a:rPr sz="1650" b="0" i="0">
+                <a:solidFill>
+                  <a:srgbClr val="222222"/>
+                </a:solidFill>
+              </a:rPr>
+              <a:t>The probability trace is now an inspectable decision surface. We can see whether missed upside comes from low predicted probabilities, high thresholds, or replay mechanics.</a:t>
+            </a:r>
+          </a:p>
+        </p:txBody>
+      </p:sp>
+    </p:spTree>
+    <p:extLst>
+      <p:ext uri="{BB962C8B-B14F-4D97-AF65-F5344CB8AC3E}">
+        <p14:creationId xmlns:p14="http://schemas.microsoft.com/office/powerpoint/2010/main" val="1178976824"/>
+      </p:ext>
+    </p:extLst>
+  </p:cSld>
+</p:sld>
+</file>
+
+<file path=ppt/slides/slide15.xml><?xml version="1.0" encoding="utf-8"?>
+<p:sld xmlns:p="http://schemas.openxmlformats.org/presentationml/2006/main">
+  <p:cSld>
+    <p:bg>
+      <p:bgPr>
+        <a:solidFill xmlns:a="http://schemas.openxmlformats.org/drawingml/2006/main">
+          <a:srgbClr val="FFFFFF"/>
+        </a:solidFill>
+      </p:bgPr>
+    </p:bg>
+    <p:spTree>
+      <p:nvGrpSpPr>
+        <p:cNvPr id="1" name=""/>
+        <p:cNvGrpSpPr/>
+        <p:nvPr/>
+      </p:nvGrpSpPr>
+      <p:grpSpPr>
+        <a:xfrm xmlns:a="http://schemas.openxmlformats.org/drawingml/2006/main"/>
+      </p:grpSpPr>
+      <p:sp>
+        <p:nvSpPr>
+          <p:cNvPr id="1" name="">
+            <a:extLst xmlns:a="http://schemas.openxmlformats.org/drawingml/2006/main">
+              <a:ext uri="{FF2B5EF4-FFF2-40B4-BE49-F238E27FC236}">
+                <a16:creationId xmlns:a16="http://schemas.microsoft.com/office/drawing/2014/main" id="{267BF6E0-143E-42B9-8D8A-A902B14E8C20}"/>
+              </a:ext>
+            </a:extLst>
+          </p:cNvPr>
+          <p:cNvSpPr>
+            <a:spLocks xmlns:a="http://schemas.openxmlformats.org/drawingml/2006/main" noGrp="1"/>
+          </p:cNvSpPr>
+          <p:nvPr/>
+        </p:nvSpPr>
+        <p:spPr>
+          <a:xfrm xmlns:a="http://schemas.openxmlformats.org/drawingml/2006/main">
+            <a:off x="685800" y="400050"/>
+            <a:ext cx="8572500" cy="247650"/>
+          </a:xfrm>
+          <a:prstGeom xmlns:a="http://schemas.openxmlformats.org/drawingml/2006/main" prst="rect">
+            <a:avLst/>
+          </a:prstGeom>
+          <a:noFill xmlns:a="http://schemas.openxmlformats.org/drawingml/2006/main"/>
+          <a:ln xmlns:a="http://schemas.openxmlformats.org/drawingml/2006/main" w="0">
+            <a:noFill/>
+            <a:prstDash val="solid"/>
+          </a:ln>
+        </p:spPr>
+        <p:txBody>
+          <a:bodyPr xmlns:a="http://schemas.openxmlformats.org/drawingml/2006/main"/>
+          <a:lstStyle xmlns:a="http://schemas.openxmlformats.org/drawingml/2006/main"/>
+          <a:p xmlns:a="http://schemas.openxmlformats.org/drawingml/2006/main">
+            <a:pPr algn="l">
+              <a:defRPr sz="975" b="1" i="0">
+                <a:solidFill>
+                  <a:srgbClr val="555555"/>
+                </a:solidFill>
+              </a:defRPr>
+            </a:pPr>
+            <a:r>
+              <a:rPr sz="975" b="1" i="0">
+                <a:solidFill>
+                  <a:srgbClr val="555555"/>
+                </a:solidFill>
+              </a:rPr>
+              <a:t>GEN5.4 ML DECISION ENGINE</a:t>
+            </a:r>
+          </a:p>
+        </p:txBody>
+      </p:sp>
+      <p:sp>
+        <p:nvSpPr>
+          <p:cNvPr id="2" name="">
+            <a:extLst xmlns:a="http://schemas.openxmlformats.org/drawingml/2006/main">
+              <a:ext uri="{FF2B5EF4-FFF2-40B4-BE49-F238E27FC236}">
+                <a16:creationId xmlns:a16="http://schemas.microsoft.com/office/drawing/2014/main" id="{27DF5611-408C-4B57-AF5B-15B7B5F2B405}"/>
+              </a:ext>
+            </a:extLst>
+          </p:cNvPr>
+          <p:cNvSpPr>
+            <a:spLocks xmlns:a="http://schemas.openxmlformats.org/drawingml/2006/main" noGrp="1"/>
+          </p:cNvSpPr>
+          <p:nvPr/>
+        </p:nvSpPr>
+        <p:spPr>
+          <a:xfrm xmlns:a="http://schemas.openxmlformats.org/drawingml/2006/main">
+            <a:off x="685800" y="723900"/>
+            <a:ext cx="10287000" cy="876300"/>
+          </a:xfrm>
+          <a:prstGeom xmlns:a="http://schemas.openxmlformats.org/drawingml/2006/main" prst="rect">
+            <a:avLst/>
+          </a:prstGeom>
+          <a:noFill xmlns:a="http://schemas.openxmlformats.org/drawingml/2006/main"/>
+          <a:ln xmlns:a="http://schemas.openxmlformats.org/drawingml/2006/main" w="0">
+            <a:noFill/>
+            <a:prstDash val="solid"/>
+          </a:ln>
+        </p:spPr>
+        <p:txBody>
+          <a:bodyPr xmlns:a="http://schemas.openxmlformats.org/drawingml/2006/main"/>
+          <a:lstStyle xmlns:a="http://schemas.openxmlformats.org/drawingml/2006/main"/>
+          <a:p xmlns:a="http://schemas.openxmlformats.org/drawingml/2006/main">
+            <a:pPr algn="l">
+              <a:defRPr sz="2850" b="1" i="0">
+                <a:solidFill>
+                  <a:srgbClr val="000000"/>
+                </a:solidFill>
+              </a:defRPr>
+            </a:pPr>
+            <a:r>
+              <a:rPr sz="2850" b="1" i="0">
+                <a:solidFill>
+                  <a:srgbClr val="000000"/>
+                </a:solidFill>
+              </a:rPr>
+              <a:t>The diagnostics point to threshold and calibration questions</a:t>
+            </a:r>
+          </a:p>
+        </p:txBody>
+      </p:sp>
+      <p:sp>
+        <p:nvSpPr>
+          <p:cNvPr id="3" name="">
+            <a:extLst xmlns:a="http://schemas.openxmlformats.org/drawingml/2006/main">
+              <a:ext uri="{FF2B5EF4-FFF2-40B4-BE49-F238E27FC236}">
+                <a16:creationId xmlns:a16="http://schemas.microsoft.com/office/drawing/2014/main" id="{467C111F-3567-4A5A-829D-0E25ACC75EDA}"/>
+              </a:ext>
+            </a:extLst>
+          </p:cNvPr>
+          <p:cNvSpPr>
+            <a:spLocks xmlns:a="http://schemas.openxmlformats.org/drawingml/2006/main" noGrp="1"/>
+          </p:cNvSpPr>
+          <p:nvPr/>
+        </p:nvSpPr>
+        <p:spPr>
+          <a:xfrm xmlns:a="http://schemas.openxmlformats.org/drawingml/2006/main">
+            <a:off x="685800" y="1657350"/>
+            <a:ext cx="10820400" cy="19050"/>
+          </a:xfrm>
+          <a:prstGeom xmlns:a="http://schemas.openxmlformats.org/drawingml/2006/main" prst="rect">
+            <a:avLst/>
+          </a:prstGeom>
+          <a:solidFill xmlns:a="http://schemas.openxmlformats.org/drawingml/2006/main">
+            <a:srgbClr val="B8BCC4"/>
+          </a:solidFill>
+          <a:ln xmlns:a="http://schemas.openxmlformats.org/drawingml/2006/main" w="0">
+            <a:noFill/>
+            <a:prstDash val="solid"/>
+          </a:ln>
+        </p:spPr>
+      </p:sp>
+      <p:pic>
+        <p:nvPicPr>
+          <p:cNvPr id="10" name=""/>
+          <p:cNvPicPr>
+            <a:picLocks xmlns:a="http://schemas.openxmlformats.org/drawingml/2006/main" noChangeAspect="1"/>
+          </p:cNvPicPr>
+          <p:nvPr/>
+        </p:nvPicPr>
+        <p:blipFill>
+          <a:blip xmlns:r="http://schemas.openxmlformats.org/officeDocument/2006/relationships" xmlns:a="http://schemas.openxmlformats.org/drawingml/2006/main" r:embed="R3bb354eaefd94b65"/>
+          <a:stretch xmlns:a="http://schemas.openxmlformats.org/drawingml/2006/main"/>
+        </p:blipFill>
+        <p:spPr>
+          <a:xfrm xmlns:a="http://schemas.openxmlformats.org/drawingml/2006/main">
+            <a:off x="704850" y="2415381"/>
+            <a:ext cx="4762500" cy="2579688"/>
+          </a:xfrm>
+          <a:prstGeom xmlns:a="http://schemas.openxmlformats.org/drawingml/2006/main" prst="rect">
+            <a:avLst/>
+          </a:prstGeom>
+        </p:spPr>
+      </p:pic>
+      <p:pic>
+        <p:nvPicPr>
+          <p:cNvPr id="11" name=""/>
+          <p:cNvPicPr>
+            <a:picLocks xmlns:a="http://schemas.openxmlformats.org/drawingml/2006/main" noChangeAspect="1"/>
+          </p:cNvPicPr>
+          <p:nvPr/>
+        </p:nvPicPr>
+        <p:blipFill>
+          <a:blip xmlns:r="http://schemas.openxmlformats.org/officeDocument/2006/relationships" xmlns:a="http://schemas.openxmlformats.org/drawingml/2006/main" r:embed="R7c7901c779094e86"/>
+          <a:stretch xmlns:a="http://schemas.openxmlformats.org/drawingml/2006/main"/>
+        </p:blipFill>
+        <p:spPr>
+          <a:xfrm xmlns:a="http://schemas.openxmlformats.org/drawingml/2006/main">
+            <a:off x="5962650" y="2415381"/>
+            <a:ext cx="4762500" cy="2579688"/>
+          </a:xfrm>
+          <a:prstGeom xmlns:a="http://schemas.openxmlformats.org/drawingml/2006/main" prst="rect">
+            <a:avLst/>
+          </a:prstGeom>
+        </p:spPr>
+      </p:pic>
+      <p:sp>
+        <p:nvSpPr>
+          <p:cNvPr id="6" name="">
+            <a:extLst xmlns:a="http://schemas.openxmlformats.org/drawingml/2006/main">
+              <a:ext uri="{FF2B5EF4-FFF2-40B4-BE49-F238E27FC236}">
+                <a16:creationId xmlns:a16="http://schemas.microsoft.com/office/drawing/2014/main" id="{32515E30-2D23-42CE-A7B4-559F846E6F2D}"/>
+              </a:ext>
+            </a:extLst>
+          </p:cNvPr>
+          <p:cNvSpPr>
+            <a:spLocks xmlns:a="http://schemas.openxmlformats.org/drawingml/2006/main" noGrp="1"/>
+          </p:cNvSpPr>
+          <p:nvPr/>
+        </p:nvSpPr>
+        <p:spPr>
+          <a:xfrm xmlns:a="http://schemas.openxmlformats.org/drawingml/2006/main">
+            <a:off x="1104900" y="5753100"/>
+            <a:ext cx="9334500" cy="400050"/>
+          </a:xfrm>
+          <a:prstGeom xmlns:a="http://schemas.openxmlformats.org/drawingml/2006/main" prst="rect">
+            <a:avLst/>
+          </a:prstGeom>
+          <a:noFill xmlns:a="http://schemas.openxmlformats.org/drawingml/2006/main"/>
+          <a:ln xmlns:a="http://schemas.openxmlformats.org/drawingml/2006/main" w="0">
+            <a:noFill/>
+            <a:prstDash val="solid"/>
+          </a:ln>
+        </p:spPr>
+        <p:txBody>
+          <a:bodyPr xmlns:a="http://schemas.openxmlformats.org/drawingml/2006/main"/>
+          <a:lstStyle xmlns:a="http://schemas.openxmlformats.org/drawingml/2006/main"/>
+          <a:p xmlns:a="http://schemas.openxmlformats.org/drawingml/2006/main">
+            <a:pPr algn="ctr">
+              <a:defRPr sz="1500" b="0" i="0">
+                <a:solidFill>
+                  <a:srgbClr val="555555"/>
+                </a:solidFill>
+              </a:defRPr>
+            </a:pPr>
+            <a:r>
+              <a:rPr sz="1500" b="0" i="0">
+                <a:solidFill>
+                  <a:srgbClr val="555555"/>
+                </a:solidFill>
+              </a:rPr>
+              <a:t>Fixed thresholds are intentionally crude. The next improvement should be TRAIN-only threshold selection and probability calibration, not a rush to a more complex model.</a:t>
+            </a:r>
+          </a:p>
+        </p:txBody>
+      </p:sp>
+    </p:spTree>
+    <p:extLst>
+      <p:ext uri="{BB962C8B-B14F-4D97-AF65-F5344CB8AC3E}">
+        <p14:creationId xmlns:p14="http://schemas.microsoft.com/office/powerpoint/2010/main" val="1806072866"/>
+      </p:ext>
+    </p:extLst>
+  </p:cSld>
+</p:sld>
+</file>
+
+<file path=ppt/slides/slide16.xml><?xml version="1.0" encoding="utf-8"?>
+<p:sld xmlns:p="http://schemas.openxmlformats.org/presentationml/2006/main">
+  <p:cSld>
+    <p:bg>
+      <p:bgPr>
+        <a:solidFill xmlns:a="http://schemas.openxmlformats.org/drawingml/2006/main">
+          <a:srgbClr val="FFFFFF"/>
+        </a:solidFill>
+      </p:bgPr>
+    </p:bg>
+    <p:spTree>
+      <p:nvGrpSpPr>
+        <p:cNvPr id="1" name=""/>
+        <p:cNvGrpSpPr/>
+        <p:nvPr/>
+      </p:nvGrpSpPr>
+      <p:grpSpPr>
+        <a:xfrm xmlns:a="http://schemas.openxmlformats.org/drawingml/2006/main"/>
+      </p:grpSpPr>
+      <p:sp>
+        <p:nvSpPr>
+          <p:cNvPr id="1" name="">
+            <a:extLst xmlns:a="http://schemas.openxmlformats.org/drawingml/2006/main">
+              <a:ext uri="{FF2B5EF4-FFF2-40B4-BE49-F238E27FC236}">
+                <a16:creationId xmlns:a16="http://schemas.microsoft.com/office/drawing/2014/main" id="{642CA9DE-E36F-4458-B86D-7DBD6C3E34C9}"/>
+              </a:ext>
+            </a:extLst>
+          </p:cNvPr>
+          <p:cNvSpPr>
+            <a:spLocks xmlns:a="http://schemas.openxmlformats.org/drawingml/2006/main" noGrp="1"/>
+          </p:cNvSpPr>
+          <p:nvPr/>
+        </p:nvSpPr>
+        <p:spPr>
+          <a:xfrm xmlns:a="http://schemas.openxmlformats.org/drawingml/2006/main">
+            <a:off x="685800" y="400050"/>
+            <a:ext cx="8572500" cy="247650"/>
+          </a:xfrm>
+          <a:prstGeom xmlns:a="http://schemas.openxmlformats.org/drawingml/2006/main" prst="rect">
+            <a:avLst/>
+          </a:prstGeom>
+          <a:noFill xmlns:a="http://schemas.openxmlformats.org/drawingml/2006/main"/>
+          <a:ln xmlns:a="http://schemas.openxmlformats.org/drawingml/2006/main" w="0">
+            <a:noFill/>
+            <a:prstDash val="solid"/>
+          </a:ln>
+        </p:spPr>
+        <p:txBody>
+          <a:bodyPr xmlns:a="http://schemas.openxmlformats.org/drawingml/2006/main"/>
+          <a:lstStyle xmlns:a="http://schemas.openxmlformats.org/drawingml/2006/main"/>
+          <a:p xmlns:a="http://schemas.openxmlformats.org/drawingml/2006/main">
+            <a:pPr algn="l">
+              <a:defRPr sz="975" b="1" i="0">
+                <a:solidFill>
+                  <a:srgbClr val="555555"/>
+                </a:solidFill>
+              </a:defRPr>
+            </a:pPr>
+            <a:r>
+              <a:rPr sz="975" b="1" i="0">
+                <a:solidFill>
+                  <a:srgbClr val="555555"/>
+                </a:solidFill>
+              </a:rPr>
+              <a:t>GEN5.4 ML DECISION ENGINE</a:t>
+            </a:r>
+          </a:p>
+        </p:txBody>
+      </p:sp>
+      <p:sp>
+        <p:nvSpPr>
+          <p:cNvPr id="2" name="">
+            <a:extLst xmlns:a="http://schemas.openxmlformats.org/drawingml/2006/main">
+              <a:ext uri="{FF2B5EF4-FFF2-40B4-BE49-F238E27FC236}">
+                <a16:creationId xmlns:a16="http://schemas.microsoft.com/office/drawing/2014/main" id="{FAB409D2-306A-4801-BA1E-2B9398E43528}"/>
+              </a:ext>
+            </a:extLst>
+          </p:cNvPr>
+          <p:cNvSpPr>
+            <a:spLocks xmlns:a="http://schemas.openxmlformats.org/drawingml/2006/main" noGrp="1"/>
+          </p:cNvSpPr>
+          <p:nvPr/>
+        </p:nvSpPr>
+        <p:spPr>
+          <a:xfrm xmlns:a="http://schemas.openxmlformats.org/drawingml/2006/main">
+            <a:off x="685800" y="723900"/>
+            <a:ext cx="10287000" cy="876300"/>
+          </a:xfrm>
+          <a:prstGeom xmlns:a="http://schemas.openxmlformats.org/drawingml/2006/main" prst="rect">
+            <a:avLst/>
+          </a:prstGeom>
+          <a:noFill xmlns:a="http://schemas.openxmlformats.org/drawingml/2006/main"/>
+          <a:ln xmlns:a="http://schemas.openxmlformats.org/drawingml/2006/main" w="0">
+            <a:noFill/>
+            <a:prstDash val="solid"/>
+          </a:ln>
+        </p:spPr>
+        <p:txBody>
+          <a:bodyPr xmlns:a="http://schemas.openxmlformats.org/drawingml/2006/main"/>
+          <a:lstStyle xmlns:a="http://schemas.openxmlformats.org/drawingml/2006/main"/>
+          <a:p xmlns:a="http://schemas.openxmlformats.org/drawingml/2006/main">
+            <a:pPr algn="l">
+              <a:defRPr sz="2850" b="1" i="0">
+                <a:solidFill>
+                  <a:srgbClr val="000000"/>
+                </a:solidFill>
+              </a:defRPr>
+            </a:pPr>
+            <a:r>
+              <a:rPr sz="2850" b="1" i="0">
+                <a:solidFill>
+                  <a:srgbClr val="000000"/>
+                </a:solidFill>
+              </a:rPr>
+              <a:t>The coefficient audit keeps the simple model explainable</a:t>
+            </a:r>
+          </a:p>
+        </p:txBody>
+      </p:sp>
+      <p:sp>
+        <p:nvSpPr>
+          <p:cNvPr id="3" name="">
+            <a:extLst xmlns:a="http://schemas.openxmlformats.org/drawingml/2006/main">
+              <a:ext uri="{FF2B5EF4-FFF2-40B4-BE49-F238E27FC236}">
+                <a16:creationId xmlns:a16="http://schemas.microsoft.com/office/drawing/2014/main" id="{5AEF41AD-3F7C-44BF-BA72-34B85539F54E}"/>
+              </a:ext>
+            </a:extLst>
+          </p:cNvPr>
+          <p:cNvSpPr>
+            <a:spLocks xmlns:a="http://schemas.openxmlformats.org/drawingml/2006/main" noGrp="1"/>
+          </p:cNvSpPr>
+          <p:nvPr/>
+        </p:nvSpPr>
+        <p:spPr>
+          <a:xfrm xmlns:a="http://schemas.openxmlformats.org/drawingml/2006/main">
+            <a:off x="685800" y="1657350"/>
+            <a:ext cx="10820400" cy="19050"/>
+          </a:xfrm>
+          <a:prstGeom xmlns:a="http://schemas.openxmlformats.org/drawingml/2006/main" prst="rect">
+            <a:avLst/>
+          </a:prstGeom>
+          <a:solidFill xmlns:a="http://schemas.openxmlformats.org/drawingml/2006/main">
+            <a:srgbClr val="B8BCC4"/>
+          </a:solidFill>
+          <a:ln xmlns:a="http://schemas.openxmlformats.org/drawingml/2006/main" w="0">
+            <a:noFill/>
+            <a:prstDash val="solid"/>
+          </a:ln>
+        </p:spPr>
+      </p:sp>
+      <p:pic>
+        <p:nvPicPr>
+          <p:cNvPr id="10" name=""/>
+          <p:cNvPicPr>
+            <a:picLocks xmlns:a="http://schemas.openxmlformats.org/drawingml/2006/main" noChangeAspect="1"/>
+          </p:cNvPicPr>
+          <p:nvPr/>
+        </p:nvPicPr>
+        <p:blipFill>
+          <a:blip xmlns:r="http://schemas.openxmlformats.org/officeDocument/2006/relationships" xmlns:a="http://schemas.openxmlformats.org/drawingml/2006/main" r:embed="R56ce0e7682184027"/>
+          <a:stretch xmlns:a="http://schemas.openxmlformats.org/drawingml/2006/main"/>
+        </p:blipFill>
+        <p:spPr>
+          <a:xfrm xmlns:a="http://schemas.openxmlformats.org/drawingml/2006/main">
+            <a:off x="1371600" y="2038350"/>
+            <a:ext cx="5448300" cy="3714750"/>
+          </a:xfrm>
+          <a:prstGeom xmlns:a="http://schemas.openxmlformats.org/drawingml/2006/main" prst="rect">
+            <a:avLst/>
+          </a:prstGeom>
+        </p:spPr>
+      </p:pic>
+      <p:sp>
+        <p:nvSpPr>
+          <p:cNvPr id="5" name="">
+            <a:extLst xmlns:a="http://schemas.openxmlformats.org/drawingml/2006/main">
+              <a:ext uri="{FF2B5EF4-FFF2-40B4-BE49-F238E27FC236}">
+                <a16:creationId xmlns:a16="http://schemas.microsoft.com/office/drawing/2014/main" id="{16F48DE2-BBCC-4DA0-99D7-98119485A152}"/>
+              </a:ext>
+            </a:extLst>
+          </p:cNvPr>
+          <p:cNvSpPr>
+            <a:spLocks xmlns:a="http://schemas.openxmlformats.org/drawingml/2006/main" noGrp="1"/>
+          </p:cNvSpPr>
+          <p:nvPr/>
+        </p:nvSpPr>
+        <p:spPr>
+          <a:xfrm xmlns:a="http://schemas.openxmlformats.org/drawingml/2006/main">
+            <a:off x="8096250" y="2133600"/>
+            <a:ext cx="2857500" cy="323850"/>
+          </a:xfrm>
+          <a:prstGeom xmlns:a="http://schemas.openxmlformats.org/drawingml/2006/main" prst="rect">
+            <a:avLst/>
+          </a:prstGeom>
+          <a:noFill xmlns:a="http://schemas.openxmlformats.org/drawingml/2006/main"/>
+          <a:ln xmlns:a="http://schemas.openxmlformats.org/drawingml/2006/main" w="0">
+            <a:noFill/>
+            <a:prstDash val="solid"/>
+          </a:ln>
+        </p:spPr>
+        <p:txBody>
+          <a:bodyPr xmlns:a="http://schemas.openxmlformats.org/drawingml/2006/main"/>
+          <a:lstStyle xmlns:a="http://schemas.openxmlformats.org/drawingml/2006/main"/>
+          <a:p xmlns:a="http://schemas.openxmlformats.org/drawingml/2006/main">
+            <a:pPr algn="l">
+              <a:defRPr sz="1950" b="1" i="0">
+                <a:solidFill>
+                  <a:srgbClr val="222222"/>
+                </a:solidFill>
+              </a:defRPr>
+            </a:pPr>
+            <a:r>
+              <a:rPr sz="1950" b="1" i="0">
+                <a:solidFill>
+                  <a:srgbClr val="222222"/>
+                </a:solidFill>
+              </a:rPr>
+              <a:t>Why GLM still earns its keep</a:t>
+            </a:r>
+          </a:p>
+        </p:txBody>
+      </p:sp>
+      <p:sp>
+        <p:nvSpPr>
+          <p:cNvPr id="6" name="">
+            <a:extLst xmlns:a="http://schemas.openxmlformats.org/drawingml/2006/main">
+              <a:ext uri="{FF2B5EF4-FFF2-40B4-BE49-F238E27FC236}">
+                <a16:creationId xmlns:a16="http://schemas.microsoft.com/office/drawing/2014/main" id="{33D6C3B4-8EB8-4551-840A-454ECA07CC94}"/>
+              </a:ext>
+            </a:extLst>
+          </p:cNvPr>
+          <p:cNvSpPr>
+            <a:spLocks xmlns:a="http://schemas.openxmlformats.org/drawingml/2006/main" noGrp="1"/>
+          </p:cNvSpPr>
+          <p:nvPr/>
+        </p:nvSpPr>
+        <p:spPr>
+          <a:xfrm xmlns:a="http://schemas.openxmlformats.org/drawingml/2006/main">
+            <a:off x="8096250" y="2743200"/>
+            <a:ext cx="2724150" cy="2000250"/>
+          </a:xfrm>
+          <a:prstGeom xmlns:a="http://schemas.openxmlformats.org/drawingml/2006/main" prst="rect">
+            <a:avLst/>
+          </a:prstGeom>
+          <a:noFill xmlns:a="http://schemas.openxmlformats.org/drawingml/2006/main"/>
+          <a:ln xmlns:a="http://schemas.openxmlformats.org/drawingml/2006/main" w="0">
+            <a:noFill/>
+            <a:prstDash val="solid"/>
+          </a:ln>
+        </p:spPr>
+        <p:txBody>
+          <a:bodyPr xmlns:a="http://schemas.openxmlformats.org/drawingml/2006/main"/>
+          <a:lstStyle xmlns:a="http://schemas.openxmlformats.org/drawingml/2006/main"/>
+          <a:p xmlns:a="http://schemas.openxmlformats.org/drawingml/2006/main">
+            <a:pPr algn="l">
+              <a:defRPr sz="1650" b="0" i="0">
+                <a:solidFill>
+                  <a:srgbClr val="222222"/>
+                </a:solidFill>
+              </a:defRPr>
+            </a:pPr>
+            <a:r>
+              <a:rPr sz="1650" b="0" i="0">
+                <a:solidFill>
+                  <a:srgbClr val="222222"/>
+                </a:solidFill>
+              </a:rPr>
+              <a:t>Even when performance is underwhelming, coefficients expose what the model is leaning on. That makes GLM a useful diagnostic bridge before XGBoost.</a:t>
+            </a:r>
+          </a:p>
+        </p:txBody>
+      </p:sp>
+    </p:spTree>
+    <p:extLst>
+      <p:ext uri="{BB962C8B-B14F-4D97-AF65-F5344CB8AC3E}">
+        <p14:creationId xmlns:p14="http://schemas.microsoft.com/office/powerpoint/2010/main" val="1372516781"/>
+      </p:ext>
+    </p:extLst>
+  </p:cSld>
+</p:sld>
+</file>
+
+<file path=ppt/slides/slide17.xml><?xml version="1.0" encoding="utf-8"?>
+<p:sld xmlns:p="http://schemas.openxmlformats.org/presentationml/2006/main">
+  <p:cSld>
+    <p:bg>
+      <p:bgPr>
+        <a:solidFill xmlns:a="http://schemas.openxmlformats.org/drawingml/2006/main">
+          <a:srgbClr val="FFFFFF"/>
+        </a:solidFill>
+      </p:bgPr>
+    </p:bg>
+    <p:spTree>
+      <p:nvGrpSpPr>
+        <p:cNvPr id="1" name=""/>
+        <p:cNvGrpSpPr/>
+        <p:nvPr/>
+      </p:nvGrpSpPr>
+      <p:grpSpPr>
+        <a:xfrm xmlns:a="http://schemas.openxmlformats.org/drawingml/2006/main"/>
+      </p:grpSpPr>
+      <p:sp>
+        <p:nvSpPr>
+          <p:cNvPr id="1" name="">
+            <a:extLst xmlns:a="http://schemas.openxmlformats.org/drawingml/2006/main">
+              <a:ext uri="{FF2B5EF4-FFF2-40B4-BE49-F238E27FC236}">
+                <a16:creationId xmlns:a16="http://schemas.microsoft.com/office/drawing/2014/main" id="{B70F0E02-B4B5-495B-9E85-6D703003DEED}"/>
+              </a:ext>
+            </a:extLst>
+          </p:cNvPr>
+          <p:cNvSpPr>
+            <a:spLocks xmlns:a="http://schemas.openxmlformats.org/drawingml/2006/main" noGrp="1"/>
+          </p:cNvSpPr>
+          <p:nvPr/>
+        </p:nvSpPr>
+        <p:spPr>
+          <a:xfrm xmlns:a="http://schemas.openxmlformats.org/drawingml/2006/main">
+            <a:off x="685800" y="400050"/>
+            <a:ext cx="8572500" cy="247650"/>
+          </a:xfrm>
+          <a:prstGeom xmlns:a="http://schemas.openxmlformats.org/drawingml/2006/main" prst="rect">
+            <a:avLst/>
+          </a:prstGeom>
+          <a:noFill xmlns:a="http://schemas.openxmlformats.org/drawingml/2006/main"/>
+          <a:ln xmlns:a="http://schemas.openxmlformats.org/drawingml/2006/main" w="0">
+            <a:noFill/>
+            <a:prstDash val="solid"/>
+          </a:ln>
+        </p:spPr>
+        <p:txBody>
+          <a:bodyPr xmlns:a="http://schemas.openxmlformats.org/drawingml/2006/main"/>
+          <a:lstStyle xmlns:a="http://schemas.openxmlformats.org/drawingml/2006/main"/>
+          <a:p xmlns:a="http://schemas.openxmlformats.org/drawingml/2006/main">
+            <a:pPr algn="l">
+              <a:defRPr sz="975" b="1" i="0">
+                <a:solidFill>
+                  <a:srgbClr val="555555"/>
+                </a:solidFill>
+              </a:defRPr>
+            </a:pPr>
+            <a:r>
+              <a:rPr sz="975" b="1" i="0">
+                <a:solidFill>
+                  <a:srgbClr val="555555"/>
+                </a:solidFill>
+              </a:rPr>
+              <a:t>GEN5.4 ML DECISION ENGINE</a:t>
+            </a:r>
+          </a:p>
+        </p:txBody>
+      </p:sp>
+      <p:sp>
+        <p:nvSpPr>
+          <p:cNvPr id="2" name="">
+            <a:extLst xmlns:a="http://schemas.openxmlformats.org/drawingml/2006/main">
+              <a:ext uri="{FF2B5EF4-FFF2-40B4-BE49-F238E27FC236}">
+                <a16:creationId xmlns:a16="http://schemas.microsoft.com/office/drawing/2014/main" id="{CF831CC8-E204-4CDB-B3A3-A5BD45E5E571}"/>
+              </a:ext>
+            </a:extLst>
+          </p:cNvPr>
+          <p:cNvSpPr>
+            <a:spLocks xmlns:a="http://schemas.openxmlformats.org/drawingml/2006/main" noGrp="1"/>
+          </p:cNvSpPr>
+          <p:nvPr/>
+        </p:nvSpPr>
+        <p:spPr>
+          <a:xfrm xmlns:a="http://schemas.openxmlformats.org/drawingml/2006/main">
+            <a:off x="685800" y="723900"/>
+            <a:ext cx="10287000" cy="876300"/>
+          </a:xfrm>
+          <a:prstGeom xmlns:a="http://schemas.openxmlformats.org/drawingml/2006/main" prst="rect">
+            <a:avLst/>
+          </a:prstGeom>
+          <a:noFill xmlns:a="http://schemas.openxmlformats.org/drawingml/2006/main"/>
+          <a:ln xmlns:a="http://schemas.openxmlformats.org/drawingml/2006/main" w="0">
+            <a:noFill/>
+            <a:prstDash val="solid"/>
+          </a:ln>
+        </p:spPr>
+        <p:txBody>
+          <a:bodyPr xmlns:a="http://schemas.openxmlformats.org/drawingml/2006/main"/>
+          <a:lstStyle xmlns:a="http://schemas.openxmlformats.org/drawingml/2006/main"/>
+          <a:p xmlns:a="http://schemas.openxmlformats.org/drawingml/2006/main">
+            <a:pPr algn="l">
+              <a:defRPr sz="2850" b="1" i="0">
+                <a:solidFill>
+                  <a:srgbClr val="000000"/>
+                </a:solidFill>
+              </a:defRPr>
+            </a:pPr>
+            <a:r>
+              <a:rPr sz="2850" b="1" i="0">
+                <a:solidFill>
+                  <a:srgbClr val="000000"/>
+                </a:solidFill>
+              </a:rPr>
+              <a:t>The next slice should improve the decision policy before model complexity</a:t>
+            </a:r>
+          </a:p>
+        </p:txBody>
+      </p:sp>
+      <p:sp>
+        <p:nvSpPr>
+          <p:cNvPr id="3" name="">
+            <a:extLst xmlns:a="http://schemas.openxmlformats.org/drawingml/2006/main">
+              <a:ext uri="{FF2B5EF4-FFF2-40B4-BE49-F238E27FC236}">
+                <a16:creationId xmlns:a16="http://schemas.microsoft.com/office/drawing/2014/main" id="{69B448A7-543C-46F8-BF47-33BDCEE7D56E}"/>
+              </a:ext>
+            </a:extLst>
+          </p:cNvPr>
+          <p:cNvSpPr>
+            <a:spLocks xmlns:a="http://schemas.openxmlformats.org/drawingml/2006/main" noGrp="1"/>
+          </p:cNvSpPr>
+          <p:nvPr/>
+        </p:nvSpPr>
+        <p:spPr>
+          <a:xfrm xmlns:a="http://schemas.openxmlformats.org/drawingml/2006/main">
+            <a:off x="685800" y="1657350"/>
+            <a:ext cx="10820400" cy="19050"/>
+          </a:xfrm>
+          <a:prstGeom xmlns:a="http://schemas.openxmlformats.org/drawingml/2006/main" prst="rect">
+            <a:avLst/>
+          </a:prstGeom>
+          <a:solidFill xmlns:a="http://schemas.openxmlformats.org/drawingml/2006/main">
+            <a:srgbClr val="B8BCC4"/>
+          </a:solidFill>
+          <a:ln xmlns:a="http://schemas.openxmlformats.org/drawingml/2006/main" w="0">
+            <a:noFill/>
+            <a:prstDash val="solid"/>
+          </a:ln>
+        </p:spPr>
+      </p:sp>
+      <p:sp>
+        <p:nvSpPr>
+          <p:cNvPr id="4" name="">
+            <a:extLst xmlns:a="http://schemas.openxmlformats.org/drawingml/2006/main">
+              <a:ext uri="{FF2B5EF4-FFF2-40B4-BE49-F238E27FC236}">
+                <a16:creationId xmlns:a16="http://schemas.microsoft.com/office/drawing/2014/main" id="{5C1A2757-358E-4795-AF5B-FD84C9FD8433}"/>
+              </a:ext>
+            </a:extLst>
+          </p:cNvPr>
+          <p:cNvSpPr>
+            <a:spLocks xmlns:a="http://schemas.openxmlformats.org/drawingml/2006/main" noGrp="1"/>
+          </p:cNvSpPr>
+          <p:nvPr/>
+        </p:nvSpPr>
+        <p:spPr>
+          <a:xfrm xmlns:a="http://schemas.openxmlformats.org/drawingml/2006/main">
+            <a:off x="876300" y="2133600"/>
+            <a:ext cx="8953500" cy="819150"/>
+          </a:xfrm>
+          <a:prstGeom xmlns:a="http://schemas.openxmlformats.org/drawingml/2006/main" prst="rect">
+            <a:avLst/>
+          </a:prstGeom>
+          <a:noFill xmlns:a="http://schemas.openxmlformats.org/drawingml/2006/main"/>
+          <a:ln xmlns:a="http://schemas.openxmlformats.org/drawingml/2006/main" w="0">
+            <a:noFill/>
+            <a:prstDash val="solid"/>
+          </a:ln>
+        </p:spPr>
+        <p:txBody>
+          <a:bodyPr xmlns:a="http://schemas.openxmlformats.org/drawingml/2006/main"/>
+          <a:lstStyle xmlns:a="http://schemas.openxmlformats.org/drawingml/2006/main"/>
+          <a:p xmlns:a="http://schemas.openxmlformats.org/drawingml/2006/main">
+            <a:pPr algn="l">
+              <a:defRPr sz="2250" b="1" i="0">
+                <a:solidFill>
+                  <a:srgbClr val="000000"/>
+                </a:solidFill>
+              </a:defRPr>
+            </a:pPr>
+            <a:r>
+              <a:rPr sz="2250" b="1" i="0">
+                <a:solidFill>
+                  <a:srgbClr val="000000"/>
+                </a:solidFill>
+              </a:rPr>
+              <a:t>ML-P1 worked mechanically and exposed a familiar failure mode: too little upside participation in 2020, partial defense in 2022.</a:t>
+            </a:r>
+          </a:p>
+        </p:txBody>
+      </p:sp>
+      <p:sp>
+        <p:nvSpPr>
+          <p:cNvPr id="5" name="">
+            <a:extLst xmlns:a="http://schemas.openxmlformats.org/drawingml/2006/main">
+              <a:ext uri="{FF2B5EF4-FFF2-40B4-BE49-F238E27FC236}">
+                <a16:creationId xmlns:a16="http://schemas.microsoft.com/office/drawing/2014/main" id="{84E21A71-3346-4484-B58D-C43DDED0DAE6}"/>
+              </a:ext>
+            </a:extLst>
+          </p:cNvPr>
+          <p:cNvSpPr>
+            <a:spLocks xmlns:a="http://schemas.openxmlformats.org/drawingml/2006/main" noGrp="1"/>
+          </p:cNvSpPr>
+          <p:nvPr/>
+        </p:nvSpPr>
+        <p:spPr>
+          <a:xfrm xmlns:a="http://schemas.openxmlformats.org/drawingml/2006/main">
+            <a:off x="1219200" y="3457575"/>
+            <a:ext cx="190500" cy="247650"/>
+          </a:xfrm>
+          <a:prstGeom xmlns:a="http://schemas.openxmlformats.org/drawingml/2006/main" prst="rect">
+            <a:avLst/>
+          </a:prstGeom>
+          <a:noFill xmlns:a="http://schemas.openxmlformats.org/drawingml/2006/main"/>
+          <a:ln xmlns:a="http://schemas.openxmlformats.org/drawingml/2006/main" w="0">
+            <a:noFill/>
+            <a:prstDash val="solid"/>
+          </a:ln>
+        </p:spPr>
+        <p:txBody>
+          <a:bodyPr xmlns:a="http://schemas.openxmlformats.org/drawingml/2006/main"/>
+          <a:lstStyle xmlns:a="http://schemas.openxmlformats.org/drawingml/2006/main"/>
+          <a:p xmlns:a="http://schemas.openxmlformats.org/drawingml/2006/main">
+            <a:pPr algn="l">
+              <a:defRPr sz="1575" b="1" i="0">
+                <a:solidFill>
+                  <a:srgbClr val="FF6B35"/>
+                </a:solidFill>
+              </a:defRPr>
+            </a:pPr>
+            <a:r>
+              <a:rPr sz="1575" b="1" i="0">
+                <a:solidFill>
+                  <a:srgbClr val="FF6B35"/>
+                </a:solidFill>
+              </a:rPr>
+              <a:t>-</a:t>
+            </a:r>
+          </a:p>
+        </p:txBody>
+      </p:sp>
+      <p:sp>
+        <p:nvSpPr>
+          <p:cNvPr id="6" name="">
+            <a:extLst xmlns:a="http://schemas.openxmlformats.org/drawingml/2006/main">
+              <a:ext uri="{FF2B5EF4-FFF2-40B4-BE49-F238E27FC236}">
+                <a16:creationId xmlns:a16="http://schemas.microsoft.com/office/drawing/2014/main" id="{017FD423-A7FB-4B1D-94AF-B8F783EEA01E}"/>
+              </a:ext>
+            </a:extLst>
+          </p:cNvPr>
+          <p:cNvSpPr>
+            <a:spLocks xmlns:a="http://schemas.openxmlformats.org/drawingml/2006/main" noGrp="1"/>
+          </p:cNvSpPr>
+          <p:nvPr/>
+        </p:nvSpPr>
+        <p:spPr>
+          <a:xfrm xmlns:a="http://schemas.openxmlformats.org/drawingml/2006/main">
+            <a:off x="1485900" y="3448050"/>
+            <a:ext cx="6591300" cy="514350"/>
+          </a:xfrm>
+          <a:prstGeom xmlns:a="http://schemas.openxmlformats.org/drawingml/2006/main" prst="rect">
+            <a:avLst/>
+          </a:prstGeom>
+          <a:noFill xmlns:a="http://schemas.openxmlformats.org/drawingml/2006/main"/>
+          <a:ln xmlns:a="http://schemas.openxmlformats.org/drawingml/2006/main" w="0">
+            <a:noFill/>
+            <a:prstDash val="solid"/>
+          </a:ln>
+        </p:spPr>
+        <p:txBody>
+          <a:bodyPr xmlns:a="http://schemas.openxmlformats.org/drawingml/2006/main"/>
+          <a:lstStyle xmlns:a="http://schemas.openxmlformats.org/drawingml/2006/main"/>
+          <a:p xmlns:a="http://schemas.openxmlformats.org/drawingml/2006/main">
+            <a:pPr algn="l">
+              <a:defRPr sz="1575" b="0" i="0">
+                <a:solidFill>
+                  <a:srgbClr val="222222"/>
+                </a:solidFill>
+              </a:defRPr>
+            </a:pPr>
+            <a:r>
+              <a:rPr sz="1575" b="0" i="0">
+                <a:solidFill>
+                  <a:srgbClr val="222222"/>
+                </a:solidFill>
+              </a:rPr>
+              <a:t>Add TRAIN-only threshold selection or calibration before XGBoost.</a:t>
+            </a:r>
+          </a:p>
+        </p:txBody>
+      </p:sp>
+      <p:sp>
+        <p:nvSpPr>
+          <p:cNvPr id="7" name="">
+            <a:extLst xmlns:a="http://schemas.openxmlformats.org/drawingml/2006/main">
+              <a:ext uri="{FF2B5EF4-FFF2-40B4-BE49-F238E27FC236}">
+                <a16:creationId xmlns:a16="http://schemas.microsoft.com/office/drawing/2014/main" id="{355CCE95-6906-441B-AB28-8A5100E63196}"/>
+              </a:ext>
+            </a:extLst>
+          </p:cNvPr>
+          <p:cNvSpPr>
+            <a:spLocks xmlns:a="http://schemas.openxmlformats.org/drawingml/2006/main" noGrp="1"/>
+          </p:cNvSpPr>
+          <p:nvPr/>
+        </p:nvSpPr>
+        <p:spPr>
+          <a:xfrm xmlns:a="http://schemas.openxmlformats.org/drawingml/2006/main">
+            <a:off x="1219200" y="4124325"/>
+            <a:ext cx="190500" cy="247650"/>
+          </a:xfrm>
+          <a:prstGeom xmlns:a="http://schemas.openxmlformats.org/drawingml/2006/main" prst="rect">
+            <a:avLst/>
+          </a:prstGeom>
+          <a:noFill xmlns:a="http://schemas.openxmlformats.org/drawingml/2006/main"/>
+          <a:ln xmlns:a="http://schemas.openxmlformats.org/drawingml/2006/main" w="0">
+            <a:noFill/>
+            <a:prstDash val="solid"/>
+          </a:ln>
+        </p:spPr>
+        <p:txBody>
+          <a:bodyPr xmlns:a="http://schemas.openxmlformats.org/drawingml/2006/main"/>
+          <a:lstStyle xmlns:a="http://schemas.openxmlformats.org/drawingml/2006/main"/>
+          <a:p xmlns:a="http://schemas.openxmlformats.org/drawingml/2006/main">
+            <a:pPr algn="l">
+              <a:defRPr sz="1575" b="1" i="0">
+                <a:solidFill>
+                  <a:srgbClr val="FF6B35"/>
+                </a:solidFill>
+              </a:defRPr>
+            </a:pPr>
+            <a:r>
+              <a:rPr sz="1575" b="1" i="0">
+                <a:solidFill>
+                  <a:srgbClr val="FF6B35"/>
+                </a:solidFill>
+              </a:rPr>
+              <a:t>-</a:t>
+            </a:r>
+          </a:p>
+        </p:txBody>
+      </p:sp>
+      <p:sp>
+        <p:nvSpPr>
+          <p:cNvPr id="8" name="">
+            <a:extLst xmlns:a="http://schemas.openxmlformats.org/drawingml/2006/main">
+              <a:ext uri="{FF2B5EF4-FFF2-40B4-BE49-F238E27FC236}">
+                <a16:creationId xmlns:a16="http://schemas.microsoft.com/office/drawing/2014/main" id="{6EE7B62B-1697-47D3-A422-CCD27A606808}"/>
+              </a:ext>
+            </a:extLst>
+          </p:cNvPr>
+          <p:cNvSpPr>
+            <a:spLocks xmlns:a="http://schemas.openxmlformats.org/drawingml/2006/main" noGrp="1"/>
+          </p:cNvSpPr>
+          <p:nvPr/>
+        </p:nvSpPr>
+        <p:spPr>
+          <a:xfrm xmlns:a="http://schemas.openxmlformats.org/drawingml/2006/main">
+            <a:off x="1485900" y="4114800"/>
+            <a:ext cx="6591300" cy="514350"/>
+          </a:xfrm>
+          <a:prstGeom xmlns:a="http://schemas.openxmlformats.org/drawingml/2006/main" prst="rect">
+            <a:avLst/>
+          </a:prstGeom>
+          <a:noFill xmlns:a="http://schemas.openxmlformats.org/drawingml/2006/main"/>
+          <a:ln xmlns:a="http://schemas.openxmlformats.org/drawingml/2006/main" w="0">
+            <a:noFill/>
+            <a:prstDash val="solid"/>
+          </a:ln>
+        </p:spPr>
+        <p:txBody>
+          <a:bodyPr xmlns:a="http://schemas.openxmlformats.org/drawingml/2006/main"/>
+          <a:lstStyle xmlns:a="http://schemas.openxmlformats.org/drawingml/2006/main"/>
+          <a:p xmlns:a="http://schemas.openxmlformats.org/drawingml/2006/main">
+            <a:pPr algn="l">
+              <a:defRPr sz="1575" b="0" i="0">
+                <a:solidFill>
+                  <a:srgbClr val="222222"/>
+                </a:solidFill>
+              </a:defRPr>
+            </a:pPr>
+            <a:r>
+              <a:rPr sz="1575" b="0" i="0">
+                <a:solidFill>
+                  <a:srgbClr val="222222"/>
+                </a:solidFill>
+              </a:rPr>
+              <a:t>Compare fixed thresholds against a more permissive participation policy.</a:t>
+            </a:r>
+          </a:p>
+        </p:txBody>
+      </p:sp>
+      <p:sp>
+        <p:nvSpPr>
+          <p:cNvPr id="9" name="">
+            <a:extLst xmlns:a="http://schemas.openxmlformats.org/drawingml/2006/main">
+              <a:ext uri="{FF2B5EF4-FFF2-40B4-BE49-F238E27FC236}">
+                <a16:creationId xmlns:a16="http://schemas.microsoft.com/office/drawing/2014/main" id="{CE139752-EEE6-475C-AF2B-BD0455694AED}"/>
+              </a:ext>
+            </a:extLst>
+          </p:cNvPr>
+          <p:cNvSpPr>
+            <a:spLocks xmlns:a="http://schemas.openxmlformats.org/drawingml/2006/main" noGrp="1"/>
+          </p:cNvSpPr>
+          <p:nvPr/>
+        </p:nvSpPr>
+        <p:spPr>
+          <a:xfrm xmlns:a="http://schemas.openxmlformats.org/drawingml/2006/main">
+            <a:off x="1219200" y="4791075"/>
+            <a:ext cx="190500" cy="247650"/>
+          </a:xfrm>
+          <a:prstGeom xmlns:a="http://schemas.openxmlformats.org/drawingml/2006/main" prst="rect">
+            <a:avLst/>
+          </a:prstGeom>
+          <a:noFill xmlns:a="http://schemas.openxmlformats.org/drawingml/2006/main"/>
+          <a:ln xmlns:a="http://schemas.openxmlformats.org/drawingml/2006/main" w="0">
+            <a:noFill/>
+            <a:prstDash val="solid"/>
+          </a:ln>
+        </p:spPr>
+        <p:txBody>
+          <a:bodyPr xmlns:a="http://schemas.openxmlformats.org/drawingml/2006/main"/>
+          <a:lstStyle xmlns:a="http://schemas.openxmlformats.org/drawingml/2006/main"/>
+          <a:p xmlns:a="http://schemas.openxmlformats.org/drawingml/2006/main">
+            <a:pPr algn="l">
+              <a:defRPr sz="1575" b="1" i="0">
+                <a:solidFill>
+                  <a:srgbClr val="FF6B35"/>
+                </a:solidFill>
+              </a:defRPr>
+            </a:pPr>
+            <a:r>
+              <a:rPr sz="1575" b="1" i="0">
+                <a:solidFill>
+                  <a:srgbClr val="FF6B35"/>
+                </a:solidFill>
+              </a:rPr>
+              <a:t>-</a:t>
+            </a:r>
+          </a:p>
+        </p:txBody>
+      </p:sp>
+      <p:sp>
+        <p:nvSpPr>
+          <p:cNvPr id="10" name="">
+            <a:extLst xmlns:a="http://schemas.openxmlformats.org/drawingml/2006/main">
+              <a:ext uri="{FF2B5EF4-FFF2-40B4-BE49-F238E27FC236}">
+                <a16:creationId xmlns:a16="http://schemas.microsoft.com/office/drawing/2014/main" id="{36265261-C1F9-4417-93DE-B3199706EB62}"/>
+              </a:ext>
+            </a:extLst>
+          </p:cNvPr>
+          <p:cNvSpPr>
+            <a:spLocks xmlns:a="http://schemas.openxmlformats.org/drawingml/2006/main" noGrp="1"/>
+          </p:cNvSpPr>
+          <p:nvPr/>
+        </p:nvSpPr>
+        <p:spPr>
+          <a:xfrm xmlns:a="http://schemas.openxmlformats.org/drawingml/2006/main">
+            <a:off x="1485900" y="4781550"/>
+            <a:ext cx="6591300" cy="514350"/>
+          </a:xfrm>
+          <a:prstGeom xmlns:a="http://schemas.openxmlformats.org/drawingml/2006/main" prst="rect">
+            <a:avLst/>
+          </a:prstGeom>
+          <a:noFill xmlns:a="http://schemas.openxmlformats.org/drawingml/2006/main"/>
+          <a:ln xmlns:a="http://schemas.openxmlformats.org/drawingml/2006/main" w="0">
+            <a:noFill/>
+            <a:prstDash val="solid"/>
+          </a:ln>
+        </p:spPr>
+        <p:txBody>
+          <a:bodyPr xmlns:a="http://schemas.openxmlformats.org/drawingml/2006/main"/>
+          <a:lstStyle xmlns:a="http://schemas.openxmlformats.org/drawingml/2006/main"/>
+          <a:p xmlns:a="http://schemas.openxmlformats.org/drawingml/2006/main">
+            <a:pPr algn="l">
+              <a:defRPr sz="1575" b="0" i="0">
+                <a:solidFill>
+                  <a:srgbClr val="222222"/>
+                </a:solidFill>
+              </a:defRPr>
+            </a:pPr>
+            <a:r>
+              <a:rPr sz="1575" b="0" i="0">
+                <a:solidFill>
+                  <a:srgbClr val="222222"/>
+                </a:solidFill>
+              </a:rPr>
+              <a:t>Keep probability trade tapes as the required visual audit for every ML replay.</a:t>
+            </a:r>
+          </a:p>
+        </p:txBody>
+      </p:sp>
+      <p:sp>
+        <p:nvSpPr>
+          <p:cNvPr id="11" name="">
+            <a:extLst xmlns:a="http://schemas.openxmlformats.org/drawingml/2006/main">
+              <a:ext uri="{FF2B5EF4-FFF2-40B4-BE49-F238E27FC236}">
+                <a16:creationId xmlns:a16="http://schemas.microsoft.com/office/drawing/2014/main" id="{7725340E-E51E-4B3E-84C3-015B5152A235}"/>
+              </a:ext>
+            </a:extLst>
+          </p:cNvPr>
+          <p:cNvSpPr>
+            <a:spLocks xmlns:a="http://schemas.openxmlformats.org/drawingml/2006/main" noGrp="1"/>
+          </p:cNvSpPr>
+          <p:nvPr/>
+        </p:nvSpPr>
+        <p:spPr>
+          <a:xfrm xmlns:a="http://schemas.openxmlformats.org/drawingml/2006/main">
+            <a:off x="1219200" y="5457825"/>
+            <a:ext cx="190500" cy="247650"/>
+          </a:xfrm>
+          <a:prstGeom xmlns:a="http://schemas.openxmlformats.org/drawingml/2006/main" prst="rect">
+            <a:avLst/>
+          </a:prstGeom>
+          <a:noFill xmlns:a="http://schemas.openxmlformats.org/drawingml/2006/main"/>
+          <a:ln xmlns:a="http://schemas.openxmlformats.org/drawingml/2006/main" w="0">
+            <a:noFill/>
+            <a:prstDash val="solid"/>
+          </a:ln>
+        </p:spPr>
+        <p:txBody>
+          <a:bodyPr xmlns:a="http://schemas.openxmlformats.org/drawingml/2006/main"/>
+          <a:lstStyle xmlns:a="http://schemas.openxmlformats.org/drawingml/2006/main"/>
+          <a:p xmlns:a="http://schemas.openxmlformats.org/drawingml/2006/main">
+            <a:pPr algn="l">
+              <a:defRPr sz="1575" b="1" i="0">
+                <a:solidFill>
+                  <a:srgbClr val="FF6B35"/>
+                </a:solidFill>
+              </a:defRPr>
+            </a:pPr>
+            <a:r>
+              <a:rPr sz="1575" b="1" i="0">
+                <a:solidFill>
+                  <a:srgbClr val="FF6B35"/>
+                </a:solidFill>
+              </a:rPr>
+              <a:t>-</a:t>
+            </a:r>
+          </a:p>
+        </p:txBody>
+      </p:sp>
+      <p:sp>
+        <p:nvSpPr>
+          <p:cNvPr id="12" name="">
+            <a:extLst xmlns:a="http://schemas.openxmlformats.org/drawingml/2006/main">
+              <a:ext uri="{FF2B5EF4-FFF2-40B4-BE49-F238E27FC236}">
+                <a16:creationId xmlns:a16="http://schemas.microsoft.com/office/drawing/2014/main" id="{53AFDD3D-0A17-4F21-9F6D-0A16A249F7A1}"/>
+              </a:ext>
+            </a:extLst>
+          </p:cNvPr>
+          <p:cNvSpPr>
+            <a:spLocks xmlns:a="http://schemas.openxmlformats.org/drawingml/2006/main" noGrp="1"/>
+          </p:cNvSpPr>
+          <p:nvPr/>
+        </p:nvSpPr>
+        <p:spPr>
+          <a:xfrm xmlns:a="http://schemas.openxmlformats.org/drawingml/2006/main">
+            <a:off x="1485900" y="5448300"/>
+            <a:ext cx="6591300" cy="514350"/>
+          </a:xfrm>
+          <a:prstGeom xmlns:a="http://schemas.openxmlformats.org/drawingml/2006/main" prst="rect">
+            <a:avLst/>
+          </a:prstGeom>
+          <a:noFill xmlns:a="http://schemas.openxmlformats.org/drawingml/2006/main"/>
+          <a:ln xmlns:a="http://schemas.openxmlformats.org/drawingml/2006/main" w="0">
+            <a:noFill/>
+            <a:prstDash val="solid"/>
+          </a:ln>
+        </p:spPr>
+        <p:txBody>
+          <a:bodyPr xmlns:a="http://schemas.openxmlformats.org/drawingml/2006/main"/>
+          <a:lstStyle xmlns:a="http://schemas.openxmlformats.org/drawingml/2006/main"/>
+          <a:p xmlns:a="http://schemas.openxmlformats.org/drawingml/2006/main">
+            <a:pPr algn="l">
+              <a:defRPr sz="1575" b="0" i="0">
+                <a:solidFill>
+                  <a:srgbClr val="222222"/>
+                </a:solidFill>
+              </a:defRPr>
+            </a:pPr>
+            <a:r>
+              <a:rPr sz="1575" b="0" i="0">
+                <a:solidFill>
+                  <a:srgbClr val="222222"/>
+                </a:solidFill>
+              </a:rPr>
+              <a:t>Only then add XGBoost as a nonlinear challenger.</a:t>
+            </a:r>
+          </a:p>
+        </p:txBody>
+      </p:sp>
+    </p:spTree>
+    <p:extLst>
+      <p:ext uri="{BB962C8B-B14F-4D97-AF65-F5344CB8AC3E}">
+        <p14:creationId xmlns:p14="http://schemas.microsoft.com/office/powerpoint/2010/main" val="1600121359"/>
       </p:ext>
     </p:extLst>
   </p:cSld>
@@ -2923,7 +6385,7 @@
           <p:cNvPr id="1" name="">
             <a:extLst xmlns:a="http://schemas.openxmlformats.org/drawingml/2006/main">
               <a:ext uri="{FF2B5EF4-FFF2-40B4-BE49-F238E27FC236}">
-                <a16:creationId xmlns:a16="http://schemas.microsoft.com/office/drawing/2014/main" id="{2D3D3116-F229-4A30-A630-8DE89C6E88C7}"/>
+                <a16:creationId xmlns:a16="http://schemas.microsoft.com/office/drawing/2014/main" id="{E36542FA-F233-4D13-B547-F790B39EB006}"/>
               </a:ext>
             </a:extLst>
           </p:cNvPr>
@@ -2973,7 +6435,7 @@
           <p:cNvPr id="2" name="">
             <a:extLst xmlns:a="http://schemas.openxmlformats.org/drawingml/2006/main">
               <a:ext uri="{FF2B5EF4-FFF2-40B4-BE49-F238E27FC236}">
-                <a16:creationId xmlns:a16="http://schemas.microsoft.com/office/drawing/2014/main" id="{38628281-9CC2-4DD8-88EB-A0468660007F}"/>
+                <a16:creationId xmlns:a16="http://schemas.microsoft.com/office/drawing/2014/main" id="{98AA86FC-52B0-4F43-B0A0-88CB7483313E}"/>
               </a:ext>
             </a:extLst>
           </p:cNvPr>
@@ -3023,7 +6485,7 @@
           <p:cNvPr id="3" name="">
             <a:extLst xmlns:a="http://schemas.openxmlformats.org/drawingml/2006/main">
               <a:ext uri="{FF2B5EF4-FFF2-40B4-BE49-F238E27FC236}">
-                <a16:creationId xmlns:a16="http://schemas.microsoft.com/office/drawing/2014/main" id="{881A57B8-713A-447B-844F-D95492082D65}"/>
+                <a16:creationId xmlns:a16="http://schemas.microsoft.com/office/drawing/2014/main" id="{E2D7AF07-2065-454F-B243-B3F7F8DD9F31}"/>
               </a:ext>
             </a:extLst>
           </p:cNvPr>
@@ -3054,7 +6516,7 @@
           <p:cNvPr id="4" name="">
             <a:extLst xmlns:a="http://schemas.openxmlformats.org/drawingml/2006/main">
               <a:ext uri="{FF2B5EF4-FFF2-40B4-BE49-F238E27FC236}">
-                <a16:creationId xmlns:a16="http://schemas.microsoft.com/office/drawing/2014/main" id="{D87F8008-CB0D-44DE-B7C5-E272E8F17BCF}"/>
+                <a16:creationId xmlns:a16="http://schemas.microsoft.com/office/drawing/2014/main" id="{75839C31-D04D-41CE-96C0-64F2392A2050}"/>
               </a:ext>
             </a:extLst>
           </p:cNvPr>
@@ -3104,7 +6566,7 @@
           <p:cNvPr id="5" name="">
             <a:extLst xmlns:a="http://schemas.openxmlformats.org/drawingml/2006/main">
               <a:ext uri="{FF2B5EF4-FFF2-40B4-BE49-F238E27FC236}">
-                <a16:creationId xmlns:a16="http://schemas.microsoft.com/office/drawing/2014/main" id="{BEE8D60B-C168-4ABC-9A87-9132EF04188D}"/>
+                <a16:creationId xmlns:a16="http://schemas.microsoft.com/office/drawing/2014/main" id="{B250E0EF-7F93-4459-A211-4CFE69A12981}"/>
               </a:ext>
             </a:extLst>
           </p:cNvPr>
@@ -3154,7 +6616,7 @@
           <p:cNvPr id="6" name="">
             <a:extLst xmlns:a="http://schemas.openxmlformats.org/drawingml/2006/main">
               <a:ext uri="{FF2B5EF4-FFF2-40B4-BE49-F238E27FC236}">
-                <a16:creationId xmlns:a16="http://schemas.microsoft.com/office/drawing/2014/main" id="{FB8B5DF2-70F6-4276-BE2A-ABE57AF99C17}"/>
+                <a16:creationId xmlns:a16="http://schemas.microsoft.com/office/drawing/2014/main" id="{5BCB7FBC-677F-437E-93EB-CD384D83AF80}"/>
               </a:ext>
             </a:extLst>
           </p:cNvPr>
@@ -3204,7 +6666,7 @@
           <p:cNvPr id="7" name="">
             <a:extLst xmlns:a="http://schemas.openxmlformats.org/drawingml/2006/main">
               <a:ext uri="{FF2B5EF4-FFF2-40B4-BE49-F238E27FC236}">
-                <a16:creationId xmlns:a16="http://schemas.microsoft.com/office/drawing/2014/main" id="{824033C1-8FE9-492D-A4F6-BE644C5B53DC}"/>
+                <a16:creationId xmlns:a16="http://schemas.microsoft.com/office/drawing/2014/main" id="{9DEDB69F-E2E1-418B-AD5A-A33102B57D37}"/>
               </a:ext>
             </a:extLst>
           </p:cNvPr>
@@ -3254,7 +6716,7 @@
           <p:cNvPr id="8" name="">
             <a:extLst xmlns:a="http://schemas.openxmlformats.org/drawingml/2006/main">
               <a:ext uri="{FF2B5EF4-FFF2-40B4-BE49-F238E27FC236}">
-                <a16:creationId xmlns:a16="http://schemas.microsoft.com/office/drawing/2014/main" id="{697EEC48-24A1-4BBD-BE40-9C9727D73362}"/>
+                <a16:creationId xmlns:a16="http://schemas.microsoft.com/office/drawing/2014/main" id="{1C7143CA-8817-4B70-967B-FC3C5C42BC77}"/>
               </a:ext>
             </a:extLst>
           </p:cNvPr>
@@ -3304,7 +6766,7 @@
           <p:cNvPr id="9" name="">
             <a:extLst xmlns:a="http://schemas.openxmlformats.org/drawingml/2006/main">
               <a:ext uri="{FF2B5EF4-FFF2-40B4-BE49-F238E27FC236}">
-                <a16:creationId xmlns:a16="http://schemas.microsoft.com/office/drawing/2014/main" id="{748FEEF0-8819-44ED-AE3F-EDC6C5BD7233}"/>
+                <a16:creationId xmlns:a16="http://schemas.microsoft.com/office/drawing/2014/main" id="{6E9353EA-877B-42E2-8D32-A03D4691FE17}"/>
               </a:ext>
             </a:extLst>
           </p:cNvPr>
@@ -3354,7 +6816,7 @@
           <p:cNvPr id="10" name="">
             <a:extLst xmlns:a="http://schemas.openxmlformats.org/drawingml/2006/main">
               <a:ext uri="{FF2B5EF4-FFF2-40B4-BE49-F238E27FC236}">
-                <a16:creationId xmlns:a16="http://schemas.microsoft.com/office/drawing/2014/main" id="{E31CB908-B65D-4A08-B161-783952FE4D61}"/>
+                <a16:creationId xmlns:a16="http://schemas.microsoft.com/office/drawing/2014/main" id="{E828698A-FED4-4922-8C52-91F54AB4E579}"/>
               </a:ext>
             </a:extLst>
           </p:cNvPr>
@@ -3387,7 +6849,7 @@
           <p:cNvPr id="11" name="">
             <a:extLst xmlns:a="http://schemas.openxmlformats.org/drawingml/2006/main">
               <a:ext uri="{FF2B5EF4-FFF2-40B4-BE49-F238E27FC236}">
-                <a16:creationId xmlns:a16="http://schemas.microsoft.com/office/drawing/2014/main" id="{D4D48257-C940-4336-9DD6-B157190440B2}"/>
+                <a16:creationId xmlns:a16="http://schemas.microsoft.com/office/drawing/2014/main" id="{87E6B38D-58F5-400D-B2B6-B077881A3ABD}"/>
               </a:ext>
             </a:extLst>
           </p:cNvPr>
@@ -3420,7 +6882,7 @@
           <p:cNvPr id="12" name="">
             <a:extLst xmlns:a="http://schemas.openxmlformats.org/drawingml/2006/main">
               <a:ext uri="{FF2B5EF4-FFF2-40B4-BE49-F238E27FC236}">
-                <a16:creationId xmlns:a16="http://schemas.microsoft.com/office/drawing/2014/main" id="{205071EB-FF8A-4211-9A7D-4642F5AE1158}"/>
+                <a16:creationId xmlns:a16="http://schemas.microsoft.com/office/drawing/2014/main" id="{30D3DFC3-3A91-4721-A77F-628DA1591DED}"/>
               </a:ext>
             </a:extLst>
           </p:cNvPr>
@@ -3453,7 +6915,7 @@
           <p:cNvPr id="13" name="">
             <a:extLst xmlns:a="http://schemas.openxmlformats.org/drawingml/2006/main">
               <a:ext uri="{FF2B5EF4-FFF2-40B4-BE49-F238E27FC236}">
-                <a16:creationId xmlns:a16="http://schemas.microsoft.com/office/drawing/2014/main" id="{2A037570-6BAF-48A2-999B-56E72FF6111A}"/>
+                <a16:creationId xmlns:a16="http://schemas.microsoft.com/office/drawing/2014/main" id="{E7E9F800-B400-4D11-8EC7-C9616CED9795}"/>
               </a:ext>
             </a:extLst>
           </p:cNvPr>
@@ -3503,7 +6965,7 @@
           <p:cNvPr id="14" name="">
             <a:extLst xmlns:a="http://schemas.openxmlformats.org/drawingml/2006/main">
               <a:ext uri="{FF2B5EF4-FFF2-40B4-BE49-F238E27FC236}">
-                <a16:creationId xmlns:a16="http://schemas.microsoft.com/office/drawing/2014/main" id="{D97737ED-1952-41D4-838F-561B42464F8F}"/>
+                <a16:creationId xmlns:a16="http://schemas.microsoft.com/office/drawing/2014/main" id="{79948B6A-BADE-4BF8-B8DF-BB211E818ABF}"/>
               </a:ext>
             </a:extLst>
           </p:cNvPr>
@@ -3553,7 +7015,7 @@
           <p:cNvPr id="15" name="">
             <a:extLst xmlns:a="http://schemas.openxmlformats.org/drawingml/2006/main">
               <a:ext uri="{FF2B5EF4-FFF2-40B4-BE49-F238E27FC236}">
-                <a16:creationId xmlns:a16="http://schemas.microsoft.com/office/drawing/2014/main" id="{8B2C933E-6213-4D53-8316-EF34CCA7B498}"/>
+                <a16:creationId xmlns:a16="http://schemas.microsoft.com/office/drawing/2014/main" id="{C162CA3C-445E-4EAA-9B6D-A672FAD83D07}"/>
               </a:ext>
             </a:extLst>
           </p:cNvPr>
@@ -3603,7 +7065,7 @@
           <p:cNvPr id="16" name="">
             <a:extLst xmlns:a="http://schemas.openxmlformats.org/drawingml/2006/main">
               <a:ext uri="{FF2B5EF4-FFF2-40B4-BE49-F238E27FC236}">
-                <a16:creationId xmlns:a16="http://schemas.microsoft.com/office/drawing/2014/main" id="{BC2BAF09-C017-47F6-90E1-7CA1E5715175}"/>
+                <a16:creationId xmlns:a16="http://schemas.microsoft.com/office/drawing/2014/main" id="{9D1B2354-CB80-4D3A-AAA4-253B5F40F867}"/>
               </a:ext>
             </a:extLst>
           </p:cNvPr>
@@ -3651,7 +7113,7 @@
     </p:spTree>
     <p:extLst>
       <p:ext uri="{BB962C8B-B14F-4D97-AF65-F5344CB8AC3E}">
-        <p14:creationId xmlns:p14="http://schemas.microsoft.com/office/powerpoint/2010/main" val="1175299945"/>
+        <p14:creationId xmlns:p14="http://schemas.microsoft.com/office/powerpoint/2010/main" val="1145742833"/>
       </p:ext>
     </p:extLst>
   </p:cSld>
@@ -3682,7 +7144,7 @@
           <p:cNvPr id="1" name="">
             <a:extLst xmlns:a="http://schemas.openxmlformats.org/drawingml/2006/main">
               <a:ext uri="{FF2B5EF4-FFF2-40B4-BE49-F238E27FC236}">
-                <a16:creationId xmlns:a16="http://schemas.microsoft.com/office/drawing/2014/main" id="{2FB1C057-855C-4AA3-A837-951ED1A3D2B2}"/>
+                <a16:creationId xmlns:a16="http://schemas.microsoft.com/office/drawing/2014/main" id="{3C11B574-C1F3-44C2-BFDD-F21961BF1C3E}"/>
               </a:ext>
             </a:extLst>
           </p:cNvPr>
@@ -3732,7 +7194,7 @@
           <p:cNvPr id="2" name="">
             <a:extLst xmlns:a="http://schemas.openxmlformats.org/drawingml/2006/main">
               <a:ext uri="{FF2B5EF4-FFF2-40B4-BE49-F238E27FC236}">
-                <a16:creationId xmlns:a16="http://schemas.microsoft.com/office/drawing/2014/main" id="{D5AB3119-8A38-4DA0-97D7-B300655E78CA}"/>
+                <a16:creationId xmlns:a16="http://schemas.microsoft.com/office/drawing/2014/main" id="{A7CB5D9B-0291-4EE9-82E6-2642158D5577}"/>
               </a:ext>
             </a:extLst>
           </p:cNvPr>
@@ -3782,7 +7244,7 @@
           <p:cNvPr id="3" name="">
             <a:extLst xmlns:a="http://schemas.openxmlformats.org/drawingml/2006/main">
               <a:ext uri="{FF2B5EF4-FFF2-40B4-BE49-F238E27FC236}">
-                <a16:creationId xmlns:a16="http://schemas.microsoft.com/office/drawing/2014/main" id="{F5D82727-81A2-4CE3-AE7A-4DE953BEE4F1}"/>
+                <a16:creationId xmlns:a16="http://schemas.microsoft.com/office/drawing/2014/main" id="{1D87F613-3AF1-4682-AD3A-060509D7BF5D}"/>
               </a:ext>
             </a:extLst>
           </p:cNvPr>
@@ -3813,7 +7275,7 @@
           <p:cNvPr id="4" name="">
             <a:extLst xmlns:a="http://schemas.openxmlformats.org/drawingml/2006/main">
               <a:ext uri="{FF2B5EF4-FFF2-40B4-BE49-F238E27FC236}">
-                <a16:creationId xmlns:a16="http://schemas.microsoft.com/office/drawing/2014/main" id="{5D8F4142-FAA8-48C0-83DE-56CCE8E60E4C}"/>
+                <a16:creationId xmlns:a16="http://schemas.microsoft.com/office/drawing/2014/main" id="{F6616A57-8C91-4C73-A3BB-E60F55BB43D8}"/>
               </a:ext>
             </a:extLst>
           </p:cNvPr>
@@ -3846,7 +7308,7 @@
           <p:cNvPr id="5" name="">
             <a:extLst xmlns:a="http://schemas.openxmlformats.org/drawingml/2006/main">
               <a:ext uri="{FF2B5EF4-FFF2-40B4-BE49-F238E27FC236}">
-                <a16:creationId xmlns:a16="http://schemas.microsoft.com/office/drawing/2014/main" id="{24A87B9D-2B67-4B84-9702-94936EC10420}"/>
+                <a16:creationId xmlns:a16="http://schemas.microsoft.com/office/drawing/2014/main" id="{6D9D3AF4-5757-43E5-A418-F71F569A0FBD}"/>
               </a:ext>
             </a:extLst>
           </p:cNvPr>
@@ -3896,7 +7358,7 @@
           <p:cNvPr id="6" name="">
             <a:extLst xmlns:a="http://schemas.openxmlformats.org/drawingml/2006/main">
               <a:ext uri="{FF2B5EF4-FFF2-40B4-BE49-F238E27FC236}">
-                <a16:creationId xmlns:a16="http://schemas.microsoft.com/office/drawing/2014/main" id="{D5D5DF54-0268-4F3E-8558-62D14DC4554B}"/>
+                <a16:creationId xmlns:a16="http://schemas.microsoft.com/office/drawing/2014/main" id="{C6A3C248-60D4-4990-9D39-DBB1829C406B}"/>
               </a:ext>
             </a:extLst>
           </p:cNvPr>
@@ -3946,7 +7408,7 @@
           <p:cNvPr id="7" name="">
             <a:extLst xmlns:a="http://schemas.openxmlformats.org/drawingml/2006/main">
               <a:ext uri="{FF2B5EF4-FFF2-40B4-BE49-F238E27FC236}">
-                <a16:creationId xmlns:a16="http://schemas.microsoft.com/office/drawing/2014/main" id="{889D5642-9F6A-499B-B025-4BB4A70D6491}"/>
+                <a16:creationId xmlns:a16="http://schemas.microsoft.com/office/drawing/2014/main" id="{7ACC55DD-3E8C-4F28-B518-55C3AC04973A}"/>
               </a:ext>
             </a:extLst>
           </p:cNvPr>
@@ -3996,7 +7458,7 @@
           <p:cNvPr id="8" name="">
             <a:extLst xmlns:a="http://schemas.openxmlformats.org/drawingml/2006/main">
               <a:ext uri="{FF2B5EF4-FFF2-40B4-BE49-F238E27FC236}">
-                <a16:creationId xmlns:a16="http://schemas.microsoft.com/office/drawing/2014/main" id="{9FDF4B8C-70E6-454A-8DF1-0D91AB2E417F}"/>
+                <a16:creationId xmlns:a16="http://schemas.microsoft.com/office/drawing/2014/main" id="{9F403F99-7F34-4602-829A-03CB9FF6A0CE}"/>
               </a:ext>
             </a:extLst>
           </p:cNvPr>
@@ -4029,7 +7491,7 @@
           <p:cNvPr id="9" name="">
             <a:extLst xmlns:a="http://schemas.openxmlformats.org/drawingml/2006/main">
               <a:ext uri="{FF2B5EF4-FFF2-40B4-BE49-F238E27FC236}">
-                <a16:creationId xmlns:a16="http://schemas.microsoft.com/office/drawing/2014/main" id="{057C8727-2616-44EB-868D-4417E3F123D9}"/>
+                <a16:creationId xmlns:a16="http://schemas.microsoft.com/office/drawing/2014/main" id="{874F63C7-771C-454F-9587-47CCD93648EA}"/>
               </a:ext>
             </a:extLst>
           </p:cNvPr>
@@ -4079,7 +7541,7 @@
           <p:cNvPr id="10" name="">
             <a:extLst xmlns:a="http://schemas.openxmlformats.org/drawingml/2006/main">
               <a:ext uri="{FF2B5EF4-FFF2-40B4-BE49-F238E27FC236}">
-                <a16:creationId xmlns:a16="http://schemas.microsoft.com/office/drawing/2014/main" id="{70E1E100-0E42-4645-8826-CEFA30C36687}"/>
+                <a16:creationId xmlns:a16="http://schemas.microsoft.com/office/drawing/2014/main" id="{10B9D2F1-223D-4225-8DC0-EC935AB32A6B}"/>
               </a:ext>
             </a:extLst>
           </p:cNvPr>
@@ -4129,7 +7591,7 @@
           <p:cNvPr id="11" name="">
             <a:extLst xmlns:a="http://schemas.openxmlformats.org/drawingml/2006/main">
               <a:ext uri="{FF2B5EF4-FFF2-40B4-BE49-F238E27FC236}">
-                <a16:creationId xmlns:a16="http://schemas.microsoft.com/office/drawing/2014/main" id="{92F541B4-8A66-408C-AC62-69CC4536833E}"/>
+                <a16:creationId xmlns:a16="http://schemas.microsoft.com/office/drawing/2014/main" id="{E10288E7-C5CD-42FB-8ED6-33039496AEDD}"/>
               </a:ext>
             </a:extLst>
           </p:cNvPr>
@@ -4179,7 +7641,7 @@
           <p:cNvPr id="12" name="">
             <a:extLst xmlns:a="http://schemas.openxmlformats.org/drawingml/2006/main">
               <a:ext uri="{FF2B5EF4-FFF2-40B4-BE49-F238E27FC236}">
-                <a16:creationId xmlns:a16="http://schemas.microsoft.com/office/drawing/2014/main" id="{F541CC6A-1171-4B27-877A-69F96E55AEF2}"/>
+                <a16:creationId xmlns:a16="http://schemas.microsoft.com/office/drawing/2014/main" id="{800C4630-44AC-4DA9-B90B-B460F1B27BB6}"/>
               </a:ext>
             </a:extLst>
           </p:cNvPr>
@@ -4212,7 +7674,7 @@
           <p:cNvPr id="13" name="">
             <a:extLst xmlns:a="http://schemas.openxmlformats.org/drawingml/2006/main">
               <a:ext uri="{FF2B5EF4-FFF2-40B4-BE49-F238E27FC236}">
-                <a16:creationId xmlns:a16="http://schemas.microsoft.com/office/drawing/2014/main" id="{1C1BCFF0-CD06-4266-B3A5-D8C62C4883AE}"/>
+                <a16:creationId xmlns:a16="http://schemas.microsoft.com/office/drawing/2014/main" id="{10C2F5D8-D422-41F7-BF1F-01D5C340A4CB}"/>
               </a:ext>
             </a:extLst>
           </p:cNvPr>
@@ -4262,7 +7724,7 @@
           <p:cNvPr id="14" name="">
             <a:extLst xmlns:a="http://schemas.openxmlformats.org/drawingml/2006/main">
               <a:ext uri="{FF2B5EF4-FFF2-40B4-BE49-F238E27FC236}">
-                <a16:creationId xmlns:a16="http://schemas.microsoft.com/office/drawing/2014/main" id="{65E65122-5FDA-4CC4-8196-23017A4E794A}"/>
+                <a16:creationId xmlns:a16="http://schemas.microsoft.com/office/drawing/2014/main" id="{30B92D43-FD4C-450D-9C1F-7DF0B33ADF71}"/>
               </a:ext>
             </a:extLst>
           </p:cNvPr>
@@ -4312,7 +7774,7 @@
           <p:cNvPr id="15" name="">
             <a:extLst xmlns:a="http://schemas.openxmlformats.org/drawingml/2006/main">
               <a:ext uri="{FF2B5EF4-FFF2-40B4-BE49-F238E27FC236}">
-                <a16:creationId xmlns:a16="http://schemas.microsoft.com/office/drawing/2014/main" id="{2E8A504E-E2AA-41D0-85E4-EDB7E3B0B7F2}"/>
+                <a16:creationId xmlns:a16="http://schemas.microsoft.com/office/drawing/2014/main" id="{C2CA55F2-5160-42FD-8A8F-D749DCEFA3CD}"/>
               </a:ext>
             </a:extLst>
           </p:cNvPr>
@@ -4362,7 +7824,7 @@
           <p:cNvPr id="16" name="">
             <a:extLst xmlns:a="http://schemas.openxmlformats.org/drawingml/2006/main">
               <a:ext uri="{FF2B5EF4-FFF2-40B4-BE49-F238E27FC236}">
-                <a16:creationId xmlns:a16="http://schemas.microsoft.com/office/drawing/2014/main" id="{038C03F5-1FAE-43F1-94EE-3D88C153612D}"/>
+                <a16:creationId xmlns:a16="http://schemas.microsoft.com/office/drawing/2014/main" id="{1EDC3B2B-7968-4B81-BE81-0B1A266EE0E0}"/>
               </a:ext>
             </a:extLst>
           </p:cNvPr>
@@ -4412,7 +7874,7 @@
           <p:cNvPr id="17" name="">
             <a:extLst xmlns:a="http://schemas.openxmlformats.org/drawingml/2006/main">
               <a:ext uri="{FF2B5EF4-FFF2-40B4-BE49-F238E27FC236}">
-                <a16:creationId xmlns:a16="http://schemas.microsoft.com/office/drawing/2014/main" id="{87191720-EB7D-4509-B923-874D74BF6AD1}"/>
+                <a16:creationId xmlns:a16="http://schemas.microsoft.com/office/drawing/2014/main" id="{8A129D36-D038-419E-93E2-BA40532DB466}"/>
               </a:ext>
             </a:extLst>
           </p:cNvPr>
@@ -4462,7 +7924,7 @@
           <p:cNvPr id="18" name="">
             <a:extLst xmlns:a="http://schemas.openxmlformats.org/drawingml/2006/main">
               <a:ext uri="{FF2B5EF4-FFF2-40B4-BE49-F238E27FC236}">
-                <a16:creationId xmlns:a16="http://schemas.microsoft.com/office/drawing/2014/main" id="{5C37FC3D-D5C2-4743-907B-40CF51418EDC}"/>
+                <a16:creationId xmlns:a16="http://schemas.microsoft.com/office/drawing/2014/main" id="{3AD45CF1-64AB-42E1-A81F-87A2D5FD29C3}"/>
               </a:ext>
             </a:extLst>
           </p:cNvPr>
@@ -4512,7 +7974,7 @@
           <p:cNvPr id="19" name="">
             <a:extLst xmlns:a="http://schemas.openxmlformats.org/drawingml/2006/main">
               <a:ext uri="{FF2B5EF4-FFF2-40B4-BE49-F238E27FC236}">
-                <a16:creationId xmlns:a16="http://schemas.microsoft.com/office/drawing/2014/main" id="{633F3DAB-A622-4F49-BB4F-2AF38191A1CE}"/>
+                <a16:creationId xmlns:a16="http://schemas.microsoft.com/office/drawing/2014/main" id="{F3986E6B-B807-48ED-91F4-46CD332D4E09}"/>
               </a:ext>
             </a:extLst>
           </p:cNvPr>
@@ -4562,7 +8024,7 @@
           <p:cNvPr id="20" name="">
             <a:extLst xmlns:a="http://schemas.openxmlformats.org/drawingml/2006/main">
               <a:ext uri="{FF2B5EF4-FFF2-40B4-BE49-F238E27FC236}">
-                <a16:creationId xmlns:a16="http://schemas.microsoft.com/office/drawing/2014/main" id="{DB79FEE1-EC1E-4DF5-ABC4-ABFBF8F48921}"/>
+                <a16:creationId xmlns:a16="http://schemas.microsoft.com/office/drawing/2014/main" id="{B32FF8A3-725A-4BBF-89EE-F53E78CC35A3}"/>
               </a:ext>
             </a:extLst>
           </p:cNvPr>
@@ -4612,7 +8074,7 @@
           <p:cNvPr id="21" name="">
             <a:extLst xmlns:a="http://schemas.openxmlformats.org/drawingml/2006/main">
               <a:ext uri="{FF2B5EF4-FFF2-40B4-BE49-F238E27FC236}">
-                <a16:creationId xmlns:a16="http://schemas.microsoft.com/office/drawing/2014/main" id="{B3D204E1-BC7C-4AEF-AF68-1B6B2625D9E8}"/>
+                <a16:creationId xmlns:a16="http://schemas.microsoft.com/office/drawing/2014/main" id="{0876B1BC-A436-4FB1-BB4D-A2CBFF9B3948}"/>
               </a:ext>
             </a:extLst>
           </p:cNvPr>
@@ -4662,7 +8124,7 @@
           <p:cNvPr id="22" name="">
             <a:extLst xmlns:a="http://schemas.openxmlformats.org/drawingml/2006/main">
               <a:ext uri="{FF2B5EF4-FFF2-40B4-BE49-F238E27FC236}">
-                <a16:creationId xmlns:a16="http://schemas.microsoft.com/office/drawing/2014/main" id="{5BA2E5E4-F386-46ED-8182-9999E6D2725C}"/>
+                <a16:creationId xmlns:a16="http://schemas.microsoft.com/office/drawing/2014/main" id="{2BFF81E5-AC0C-4CFA-9B6E-21F1F303FB3A}"/>
               </a:ext>
             </a:extLst>
           </p:cNvPr>
@@ -4712,7 +8174,7 @@
           <p:cNvPr id="23" name="">
             <a:extLst xmlns:a="http://schemas.openxmlformats.org/drawingml/2006/main">
               <a:ext uri="{FF2B5EF4-FFF2-40B4-BE49-F238E27FC236}">
-                <a16:creationId xmlns:a16="http://schemas.microsoft.com/office/drawing/2014/main" id="{467D0BE3-ADB4-466A-9057-3622303F631A}"/>
+                <a16:creationId xmlns:a16="http://schemas.microsoft.com/office/drawing/2014/main" id="{BEF7CF42-7C61-43D1-85B3-239D6AD0007D}"/>
               </a:ext>
             </a:extLst>
           </p:cNvPr>
@@ -4760,7 +8222,7 @@
     </p:spTree>
     <p:extLst>
       <p:ext uri="{BB962C8B-B14F-4D97-AF65-F5344CB8AC3E}">
-        <p14:creationId xmlns:p14="http://schemas.microsoft.com/office/powerpoint/2010/main" val="1208145346"/>
+        <p14:creationId xmlns:p14="http://schemas.microsoft.com/office/powerpoint/2010/main" val="283073382"/>
       </p:ext>
     </p:extLst>
   </p:cSld>
@@ -4791,7 +8253,7 @@
           <p:cNvPr id="1" name="">
             <a:extLst xmlns:a="http://schemas.openxmlformats.org/drawingml/2006/main">
               <a:ext uri="{FF2B5EF4-FFF2-40B4-BE49-F238E27FC236}">
-                <a16:creationId xmlns:a16="http://schemas.microsoft.com/office/drawing/2014/main" id="{BE4CEDAC-272D-4918-9A3B-598010D83738}"/>
+                <a16:creationId xmlns:a16="http://schemas.microsoft.com/office/drawing/2014/main" id="{67558621-DBF2-4D73-917B-D15E0817111A}"/>
               </a:ext>
             </a:extLst>
           </p:cNvPr>
@@ -4841,7 +8303,7 @@
           <p:cNvPr id="2" name="">
             <a:extLst xmlns:a="http://schemas.openxmlformats.org/drawingml/2006/main">
               <a:ext uri="{FF2B5EF4-FFF2-40B4-BE49-F238E27FC236}">
-                <a16:creationId xmlns:a16="http://schemas.microsoft.com/office/drawing/2014/main" id="{7787CB41-355A-492E-B96C-0D7A7067087F}"/>
+                <a16:creationId xmlns:a16="http://schemas.microsoft.com/office/drawing/2014/main" id="{E5E9B7F3-496E-4356-BC9E-958257962B04}"/>
               </a:ext>
             </a:extLst>
           </p:cNvPr>
@@ -4891,7 +8353,7 @@
           <p:cNvPr id="3" name="">
             <a:extLst xmlns:a="http://schemas.openxmlformats.org/drawingml/2006/main">
               <a:ext uri="{FF2B5EF4-FFF2-40B4-BE49-F238E27FC236}">
-                <a16:creationId xmlns:a16="http://schemas.microsoft.com/office/drawing/2014/main" id="{1D3B2DB3-2C45-456E-B31A-F641157D2FB7}"/>
+                <a16:creationId xmlns:a16="http://schemas.microsoft.com/office/drawing/2014/main" id="{95C6FBB8-BA3D-4842-AE40-2D270782464A}"/>
               </a:ext>
             </a:extLst>
           </p:cNvPr>
@@ -4926,7 +8388,7 @@
           <p:nvPr/>
         </p:nvPicPr>
         <p:blipFill>
-          <a:blip xmlns:r="http://schemas.openxmlformats.org/officeDocument/2006/relationships" xmlns:a="http://schemas.openxmlformats.org/drawingml/2006/main" r:embed="R45b38e8f8a94467d"/>
+          <a:blip xmlns:r="http://schemas.openxmlformats.org/officeDocument/2006/relationships" xmlns:a="http://schemas.openxmlformats.org/drawingml/2006/main" r:embed="Rb2781d92ac6f4ae2"/>
           <a:stretch xmlns:a="http://schemas.openxmlformats.org/drawingml/2006/main"/>
         </p:blipFill>
         <p:spPr>
@@ -4944,7 +8406,7 @@
           <p:cNvPr id="5" name="">
             <a:extLst xmlns:a="http://schemas.openxmlformats.org/drawingml/2006/main">
               <a:ext uri="{FF2B5EF4-FFF2-40B4-BE49-F238E27FC236}">
-                <a16:creationId xmlns:a16="http://schemas.microsoft.com/office/drawing/2014/main" id="{26DAA6D3-43DF-466A-BF8D-FF709AFE0D6F}"/>
+                <a16:creationId xmlns:a16="http://schemas.microsoft.com/office/drawing/2014/main" id="{D683C9EE-2243-4DB7-AF8F-03EDED947A7F}"/>
               </a:ext>
             </a:extLst>
           </p:cNvPr>
@@ -4994,7 +8456,7 @@
           <p:cNvPr id="6" name="">
             <a:extLst xmlns:a="http://schemas.openxmlformats.org/drawingml/2006/main">
               <a:ext uri="{FF2B5EF4-FFF2-40B4-BE49-F238E27FC236}">
-                <a16:creationId xmlns:a16="http://schemas.microsoft.com/office/drawing/2014/main" id="{420D03E2-44BA-45E4-8F2A-952FD3EDDD69}"/>
+                <a16:creationId xmlns:a16="http://schemas.microsoft.com/office/drawing/2014/main" id="{21EBB7B0-9EA4-45D5-87A9-5EACBA1F6FB5}"/>
               </a:ext>
             </a:extLst>
           </p:cNvPr>
@@ -5042,7 +8504,7 @@
     </p:spTree>
     <p:extLst>
       <p:ext uri="{BB962C8B-B14F-4D97-AF65-F5344CB8AC3E}">
-        <p14:creationId xmlns:p14="http://schemas.microsoft.com/office/powerpoint/2010/main" val="2131488481"/>
+        <p14:creationId xmlns:p14="http://schemas.microsoft.com/office/powerpoint/2010/main" val="1359632138"/>
       </p:ext>
     </p:extLst>
   </p:cSld>
@@ -5073,7 +8535,7 @@
           <p:cNvPr id="1" name="">
             <a:extLst xmlns:a="http://schemas.openxmlformats.org/drawingml/2006/main">
               <a:ext uri="{FF2B5EF4-FFF2-40B4-BE49-F238E27FC236}">
-                <a16:creationId xmlns:a16="http://schemas.microsoft.com/office/drawing/2014/main" id="{D627DB27-E8B8-4530-9E0A-4535BB65A4AA}"/>
+                <a16:creationId xmlns:a16="http://schemas.microsoft.com/office/drawing/2014/main" id="{2062BF1D-E943-43D1-BC96-A2D9D66CCD13}"/>
               </a:ext>
             </a:extLst>
           </p:cNvPr>
@@ -5123,7 +8585,7 @@
           <p:cNvPr id="2" name="">
             <a:extLst xmlns:a="http://schemas.openxmlformats.org/drawingml/2006/main">
               <a:ext uri="{FF2B5EF4-FFF2-40B4-BE49-F238E27FC236}">
-                <a16:creationId xmlns:a16="http://schemas.microsoft.com/office/drawing/2014/main" id="{59CDD211-29E8-45F1-9BB7-EE9F7D34F629}"/>
+                <a16:creationId xmlns:a16="http://schemas.microsoft.com/office/drawing/2014/main" id="{0FA8E4B3-59D8-42EA-9528-0D837A5E61DC}"/>
               </a:ext>
             </a:extLst>
           </p:cNvPr>
@@ -5173,7 +8635,7 @@
           <p:cNvPr id="3" name="">
             <a:extLst xmlns:a="http://schemas.openxmlformats.org/drawingml/2006/main">
               <a:ext uri="{FF2B5EF4-FFF2-40B4-BE49-F238E27FC236}">
-                <a16:creationId xmlns:a16="http://schemas.microsoft.com/office/drawing/2014/main" id="{E10D44A4-D104-4DCB-80B2-A0379AA05490}"/>
+                <a16:creationId xmlns:a16="http://schemas.microsoft.com/office/drawing/2014/main" id="{1752EB5F-2B85-4D80-9E43-BC85AE4AB711}"/>
               </a:ext>
             </a:extLst>
           </p:cNvPr>
@@ -5208,7 +8670,7 @@
           <p:nvPr/>
         </p:nvPicPr>
         <p:blipFill>
-          <a:blip xmlns:r="http://schemas.openxmlformats.org/officeDocument/2006/relationships" xmlns:a="http://schemas.openxmlformats.org/drawingml/2006/main" r:embed="Rafbb8db577794480"/>
+          <a:blip xmlns:r="http://schemas.openxmlformats.org/officeDocument/2006/relationships" xmlns:a="http://schemas.openxmlformats.org/drawingml/2006/main" r:embed="Rd48cbabb66624634"/>
           <a:stretch xmlns:a="http://schemas.openxmlformats.org/drawingml/2006/main"/>
         </p:blipFill>
         <p:spPr>
@@ -5226,7 +8688,7 @@
           <p:cNvPr id="5" name="">
             <a:extLst xmlns:a="http://schemas.openxmlformats.org/drawingml/2006/main">
               <a:ext uri="{FF2B5EF4-FFF2-40B4-BE49-F238E27FC236}">
-                <a16:creationId xmlns:a16="http://schemas.microsoft.com/office/drawing/2014/main" id="{47DE1D6A-B564-48CF-9CA9-B6691F4D5673}"/>
+                <a16:creationId xmlns:a16="http://schemas.microsoft.com/office/drawing/2014/main" id="{7FFBB2C4-59DB-43F1-9B43-0D588CDABB3A}"/>
               </a:ext>
             </a:extLst>
           </p:cNvPr>
@@ -5276,7 +8738,7 @@
           <p:cNvPr id="6" name="">
             <a:extLst xmlns:a="http://schemas.openxmlformats.org/drawingml/2006/main">
               <a:ext uri="{FF2B5EF4-FFF2-40B4-BE49-F238E27FC236}">
-                <a16:creationId xmlns:a16="http://schemas.microsoft.com/office/drawing/2014/main" id="{F49A6A01-F2A1-43B8-93FE-912D601EC899}"/>
+                <a16:creationId xmlns:a16="http://schemas.microsoft.com/office/drawing/2014/main" id="{B128D558-C29B-4E43-B0D5-442ABEF7773D}"/>
               </a:ext>
             </a:extLst>
           </p:cNvPr>
@@ -5326,7 +8788,7 @@
           <p:cNvPr id="7" name="">
             <a:extLst xmlns:a="http://schemas.openxmlformats.org/drawingml/2006/main">
               <a:ext uri="{FF2B5EF4-FFF2-40B4-BE49-F238E27FC236}">
-                <a16:creationId xmlns:a16="http://schemas.microsoft.com/office/drawing/2014/main" id="{1DED3548-4465-4395-B498-8D17B85467E8}"/>
+                <a16:creationId xmlns:a16="http://schemas.microsoft.com/office/drawing/2014/main" id="{FE87E29F-E4A5-4C99-AC38-3EBB0379A1E2}"/>
               </a:ext>
             </a:extLst>
           </p:cNvPr>
@@ -5376,7 +8838,7 @@
           <p:cNvPr id="8" name="">
             <a:extLst xmlns:a="http://schemas.openxmlformats.org/drawingml/2006/main">
               <a:ext uri="{FF2B5EF4-FFF2-40B4-BE49-F238E27FC236}">
-                <a16:creationId xmlns:a16="http://schemas.microsoft.com/office/drawing/2014/main" id="{0A2E44DB-D737-4312-B79F-51C24DC960D2}"/>
+                <a16:creationId xmlns:a16="http://schemas.microsoft.com/office/drawing/2014/main" id="{1407C223-C106-4223-BADA-30C50F3AB022}"/>
               </a:ext>
             </a:extLst>
           </p:cNvPr>
@@ -5426,7 +8888,7 @@
           <p:cNvPr id="9" name="">
             <a:extLst xmlns:a="http://schemas.openxmlformats.org/drawingml/2006/main">
               <a:ext uri="{FF2B5EF4-FFF2-40B4-BE49-F238E27FC236}">
-                <a16:creationId xmlns:a16="http://schemas.microsoft.com/office/drawing/2014/main" id="{F966C680-EE38-44DA-BD50-274D1ABA055F}"/>
+                <a16:creationId xmlns:a16="http://schemas.microsoft.com/office/drawing/2014/main" id="{CF15DBFE-3B24-4233-8645-1D7BCCC33DD9}"/>
               </a:ext>
             </a:extLst>
           </p:cNvPr>
@@ -5474,7 +8936,7 @@
     </p:spTree>
     <p:extLst>
       <p:ext uri="{BB962C8B-B14F-4D97-AF65-F5344CB8AC3E}">
-        <p14:creationId xmlns:p14="http://schemas.microsoft.com/office/powerpoint/2010/main" val="1397441991"/>
+        <p14:creationId xmlns:p14="http://schemas.microsoft.com/office/powerpoint/2010/main" val="84248713"/>
       </p:ext>
     </p:extLst>
   </p:cSld>
@@ -5505,7 +8967,7 @@
           <p:cNvPr id="1" name="">
             <a:extLst xmlns:a="http://schemas.openxmlformats.org/drawingml/2006/main">
               <a:ext uri="{FF2B5EF4-FFF2-40B4-BE49-F238E27FC236}">
-                <a16:creationId xmlns:a16="http://schemas.microsoft.com/office/drawing/2014/main" id="{BD8CE286-173C-4059-8D60-6C213853AC9A}"/>
+                <a16:creationId xmlns:a16="http://schemas.microsoft.com/office/drawing/2014/main" id="{47A552C9-2C95-4129-8038-484434E3CA8B}"/>
               </a:ext>
             </a:extLst>
           </p:cNvPr>
@@ -5555,7 +9017,7 @@
           <p:cNvPr id="2" name="">
             <a:extLst xmlns:a="http://schemas.openxmlformats.org/drawingml/2006/main">
               <a:ext uri="{FF2B5EF4-FFF2-40B4-BE49-F238E27FC236}">
-                <a16:creationId xmlns:a16="http://schemas.microsoft.com/office/drawing/2014/main" id="{8C57CF57-E1B3-442B-87BF-2E31AC3EB1F5}"/>
+                <a16:creationId xmlns:a16="http://schemas.microsoft.com/office/drawing/2014/main" id="{E0314130-4464-482D-9300-51DDD1A85025}"/>
               </a:ext>
             </a:extLst>
           </p:cNvPr>
@@ -5605,7 +9067,7 @@
           <p:cNvPr id="3" name="">
             <a:extLst xmlns:a="http://schemas.openxmlformats.org/drawingml/2006/main">
               <a:ext uri="{FF2B5EF4-FFF2-40B4-BE49-F238E27FC236}">
-                <a16:creationId xmlns:a16="http://schemas.microsoft.com/office/drawing/2014/main" id="{470EDB80-C3C6-4922-8830-C14D9F411F2D}"/>
+                <a16:creationId xmlns:a16="http://schemas.microsoft.com/office/drawing/2014/main" id="{985557C4-1100-4616-8AB3-5AF8BD78D17F}"/>
               </a:ext>
             </a:extLst>
           </p:cNvPr>
@@ -5640,7 +9102,7 @@
           <p:nvPr/>
         </p:nvPicPr>
         <p:blipFill>
-          <a:blip xmlns:r="http://schemas.openxmlformats.org/officeDocument/2006/relationships" xmlns:a="http://schemas.openxmlformats.org/drawingml/2006/main" r:embed="R8caca0b3c8a349d6"/>
+          <a:blip xmlns:r="http://schemas.openxmlformats.org/officeDocument/2006/relationships" xmlns:a="http://schemas.openxmlformats.org/drawingml/2006/main" r:embed="R2e63199a85354e8a"/>
           <a:stretch xmlns:a="http://schemas.openxmlformats.org/drawingml/2006/main"/>
         </p:blipFill>
         <p:spPr>
@@ -5662,7 +9124,7 @@
           <p:nvPr/>
         </p:nvPicPr>
         <p:blipFill>
-          <a:blip xmlns:r="http://schemas.openxmlformats.org/officeDocument/2006/relationships" xmlns:a="http://schemas.openxmlformats.org/drawingml/2006/main" r:embed="R7e8ffa8ceb7c4a83"/>
+          <a:blip xmlns:r="http://schemas.openxmlformats.org/officeDocument/2006/relationships" xmlns:a="http://schemas.openxmlformats.org/drawingml/2006/main" r:embed="R285caf0581ef4807"/>
           <a:stretch xmlns:a="http://schemas.openxmlformats.org/drawingml/2006/main"/>
         </p:blipFill>
         <p:spPr>
@@ -5680,7 +9142,7 @@
           <p:cNvPr id="6" name="">
             <a:extLst xmlns:a="http://schemas.openxmlformats.org/drawingml/2006/main">
               <a:ext uri="{FF2B5EF4-FFF2-40B4-BE49-F238E27FC236}">
-                <a16:creationId xmlns:a16="http://schemas.microsoft.com/office/drawing/2014/main" id="{FDD40F44-47E4-48C7-A68D-1951F8334E5A}"/>
+                <a16:creationId xmlns:a16="http://schemas.microsoft.com/office/drawing/2014/main" id="{6892F3D6-E61A-4ABD-A16F-EA7D39989BC4}"/>
               </a:ext>
             </a:extLst>
           </p:cNvPr>
@@ -5728,7 +9190,7 @@
     </p:spTree>
     <p:extLst>
       <p:ext uri="{BB962C8B-B14F-4D97-AF65-F5344CB8AC3E}">
-        <p14:creationId xmlns:p14="http://schemas.microsoft.com/office/powerpoint/2010/main" val="703810571"/>
+        <p14:creationId xmlns:p14="http://schemas.microsoft.com/office/powerpoint/2010/main" val="2145780310"/>
       </p:ext>
     </p:extLst>
   </p:cSld>
@@ -5759,7 +9221,7 @@
           <p:cNvPr id="1" name="">
             <a:extLst xmlns:a="http://schemas.openxmlformats.org/drawingml/2006/main">
               <a:ext uri="{FF2B5EF4-FFF2-40B4-BE49-F238E27FC236}">
-                <a16:creationId xmlns:a16="http://schemas.microsoft.com/office/drawing/2014/main" id="{6A92B035-1A71-4186-93CA-F6F18439A633}"/>
+                <a16:creationId xmlns:a16="http://schemas.microsoft.com/office/drawing/2014/main" id="{FF945AB4-9652-4D23-B473-9DC19589EF78}"/>
               </a:ext>
             </a:extLst>
           </p:cNvPr>
@@ -5809,7 +9271,7 @@
           <p:cNvPr id="2" name="">
             <a:extLst xmlns:a="http://schemas.openxmlformats.org/drawingml/2006/main">
               <a:ext uri="{FF2B5EF4-FFF2-40B4-BE49-F238E27FC236}">
-                <a16:creationId xmlns:a16="http://schemas.microsoft.com/office/drawing/2014/main" id="{C8E16806-76CC-4B15-9CE0-0919F96D026C}"/>
+                <a16:creationId xmlns:a16="http://schemas.microsoft.com/office/drawing/2014/main" id="{E0643663-21DD-4992-93E4-F4ECA1DEF43D}"/>
               </a:ext>
             </a:extLst>
           </p:cNvPr>
@@ -5859,7 +9321,7 @@
           <p:cNvPr id="3" name="">
             <a:extLst xmlns:a="http://schemas.openxmlformats.org/drawingml/2006/main">
               <a:ext uri="{FF2B5EF4-FFF2-40B4-BE49-F238E27FC236}">
-                <a16:creationId xmlns:a16="http://schemas.microsoft.com/office/drawing/2014/main" id="{ED37A337-A36D-4D36-9DFA-872AFB70213C}"/>
+                <a16:creationId xmlns:a16="http://schemas.microsoft.com/office/drawing/2014/main" id="{3796EC5E-F207-42E4-8C75-9D007C512A3B}"/>
               </a:ext>
             </a:extLst>
           </p:cNvPr>
@@ -5894,7 +9356,7 @@
           <p:nvPr/>
         </p:nvPicPr>
         <p:blipFill>
-          <a:blip xmlns:r="http://schemas.openxmlformats.org/officeDocument/2006/relationships" xmlns:a="http://schemas.openxmlformats.org/drawingml/2006/main" r:embed="R35aaee48819d4a2d"/>
+          <a:blip xmlns:r="http://schemas.openxmlformats.org/officeDocument/2006/relationships" xmlns:a="http://schemas.openxmlformats.org/drawingml/2006/main" r:embed="R041723920c6f4a3a"/>
           <a:stretch xmlns:a="http://schemas.openxmlformats.org/drawingml/2006/main"/>
         </p:blipFill>
         <p:spPr>
@@ -5912,7 +9374,7 @@
           <p:cNvPr id="5" name="">
             <a:extLst xmlns:a="http://schemas.openxmlformats.org/drawingml/2006/main">
               <a:ext uri="{FF2B5EF4-FFF2-40B4-BE49-F238E27FC236}">
-                <a16:creationId xmlns:a16="http://schemas.microsoft.com/office/drawing/2014/main" id="{4BDB4D6B-982A-4F72-AABA-1AF0E0F0AB5C}"/>
+                <a16:creationId xmlns:a16="http://schemas.microsoft.com/office/drawing/2014/main" id="{8057A7B9-6179-41BD-8DF5-D5FC8CF1C6A8}"/>
               </a:ext>
             </a:extLst>
           </p:cNvPr>
@@ -5962,7 +9424,7 @@
           <p:cNvPr id="6" name="">
             <a:extLst xmlns:a="http://schemas.openxmlformats.org/drawingml/2006/main">
               <a:ext uri="{FF2B5EF4-FFF2-40B4-BE49-F238E27FC236}">
-                <a16:creationId xmlns:a16="http://schemas.microsoft.com/office/drawing/2014/main" id="{3F2849C3-107B-4900-8659-3662692153F8}"/>
+                <a16:creationId xmlns:a16="http://schemas.microsoft.com/office/drawing/2014/main" id="{416B2653-493C-4521-BB8D-9C36593577C7}"/>
               </a:ext>
             </a:extLst>
           </p:cNvPr>
@@ -6010,7 +9472,7 @@
     </p:spTree>
     <p:extLst>
       <p:ext uri="{BB962C8B-B14F-4D97-AF65-F5344CB8AC3E}">
-        <p14:creationId xmlns:p14="http://schemas.microsoft.com/office/powerpoint/2010/main" val="1937255442"/>
+        <p14:creationId xmlns:p14="http://schemas.microsoft.com/office/powerpoint/2010/main" val="1764599846"/>
       </p:ext>
     </p:extLst>
   </p:cSld>
@@ -6041,7 +9503,7 @@
           <p:cNvPr id="1" name="">
             <a:extLst xmlns:a="http://schemas.openxmlformats.org/drawingml/2006/main">
               <a:ext uri="{FF2B5EF4-FFF2-40B4-BE49-F238E27FC236}">
-                <a16:creationId xmlns:a16="http://schemas.microsoft.com/office/drawing/2014/main" id="{967F1554-FA34-4C4B-A449-AC4A1C75E0A5}"/>
+                <a16:creationId xmlns:a16="http://schemas.microsoft.com/office/drawing/2014/main" id="{21763562-DC6A-49B1-88D0-B48B6A453911}"/>
               </a:ext>
             </a:extLst>
           </p:cNvPr>
@@ -6091,7 +9553,7 @@
           <p:cNvPr id="2" name="">
             <a:extLst xmlns:a="http://schemas.openxmlformats.org/drawingml/2006/main">
               <a:ext uri="{FF2B5EF4-FFF2-40B4-BE49-F238E27FC236}">
-                <a16:creationId xmlns:a16="http://schemas.microsoft.com/office/drawing/2014/main" id="{7308F579-54F9-4D9A-81CC-1DB1EB3BF8A5}"/>
+                <a16:creationId xmlns:a16="http://schemas.microsoft.com/office/drawing/2014/main" id="{A6089CB9-54DF-4506-A248-93C6CFF38369}"/>
               </a:ext>
             </a:extLst>
           </p:cNvPr>
@@ -6141,7 +9603,7 @@
           <p:cNvPr id="3" name="">
             <a:extLst xmlns:a="http://schemas.openxmlformats.org/drawingml/2006/main">
               <a:ext uri="{FF2B5EF4-FFF2-40B4-BE49-F238E27FC236}">
-                <a16:creationId xmlns:a16="http://schemas.microsoft.com/office/drawing/2014/main" id="{4C9FB5D5-574C-4658-A21A-C426B2DBD9D0}"/>
+                <a16:creationId xmlns:a16="http://schemas.microsoft.com/office/drawing/2014/main" id="{123AC082-A088-4B4E-AF3A-D1446AC0B734}"/>
               </a:ext>
             </a:extLst>
           </p:cNvPr>
@@ -6176,7 +9638,7 @@
           <p:nvPr/>
         </p:nvPicPr>
         <p:blipFill>
-          <a:blip xmlns:r="http://schemas.openxmlformats.org/officeDocument/2006/relationships" xmlns:a="http://schemas.openxmlformats.org/drawingml/2006/main" r:embed="R54715c4ed7054f56"/>
+          <a:blip xmlns:r="http://schemas.openxmlformats.org/officeDocument/2006/relationships" xmlns:a="http://schemas.openxmlformats.org/drawingml/2006/main" r:embed="Rb6097a288f9e44d8"/>
           <a:stretch xmlns:a="http://schemas.openxmlformats.org/drawingml/2006/main"/>
         </p:blipFill>
         <p:spPr>
@@ -6194,7 +9656,7 @@
           <p:cNvPr id="5" name="">
             <a:extLst xmlns:a="http://schemas.openxmlformats.org/drawingml/2006/main">
               <a:ext uri="{FF2B5EF4-FFF2-40B4-BE49-F238E27FC236}">
-                <a16:creationId xmlns:a16="http://schemas.microsoft.com/office/drawing/2014/main" id="{231B6546-058C-4FBE-ACC2-ACD9FDDC9AB6}"/>
+                <a16:creationId xmlns:a16="http://schemas.microsoft.com/office/drawing/2014/main" id="{1BA55CEB-AA0D-4A33-A502-E96C60FDE8FA}"/>
               </a:ext>
             </a:extLst>
           </p:cNvPr>
@@ -6244,7 +9706,7 @@
           <p:cNvPr id="6" name="">
             <a:extLst xmlns:a="http://schemas.openxmlformats.org/drawingml/2006/main">
               <a:ext uri="{FF2B5EF4-FFF2-40B4-BE49-F238E27FC236}">
-                <a16:creationId xmlns:a16="http://schemas.microsoft.com/office/drawing/2014/main" id="{A9CF3C8D-3616-4904-978B-FEA70047DC7B}"/>
+                <a16:creationId xmlns:a16="http://schemas.microsoft.com/office/drawing/2014/main" id="{9D1095F9-DE1D-453D-A8CE-B48598375D70}"/>
               </a:ext>
             </a:extLst>
           </p:cNvPr>
@@ -6292,7 +9754,7 @@
     </p:spTree>
     <p:extLst>
       <p:ext uri="{BB962C8B-B14F-4D97-AF65-F5344CB8AC3E}">
-        <p14:creationId xmlns:p14="http://schemas.microsoft.com/office/powerpoint/2010/main" val="1092751670"/>
+        <p14:creationId xmlns:p14="http://schemas.microsoft.com/office/powerpoint/2010/main" val="1271054265"/>
       </p:ext>
     </p:extLst>
   </p:cSld>
@@ -6323,7 +9785,7 @@
           <p:cNvPr id="1" name="">
             <a:extLst xmlns:a="http://schemas.openxmlformats.org/drawingml/2006/main">
               <a:ext uri="{FF2B5EF4-FFF2-40B4-BE49-F238E27FC236}">
-                <a16:creationId xmlns:a16="http://schemas.microsoft.com/office/drawing/2014/main" id="{68446D6A-ACBF-4580-B1FB-D02C4651160F}"/>
+                <a16:creationId xmlns:a16="http://schemas.microsoft.com/office/drawing/2014/main" id="{65C7D25F-8534-4CA8-8A63-1D7FAFB2C164}"/>
               </a:ext>
             </a:extLst>
           </p:cNvPr>
@@ -6373,7 +9835,7 @@
           <p:cNvPr id="2" name="">
             <a:extLst xmlns:a="http://schemas.openxmlformats.org/drawingml/2006/main">
               <a:ext uri="{FF2B5EF4-FFF2-40B4-BE49-F238E27FC236}">
-                <a16:creationId xmlns:a16="http://schemas.microsoft.com/office/drawing/2014/main" id="{3E6EA4A1-90DA-4AA9-91A1-BA7CB639C7E4}"/>
+                <a16:creationId xmlns:a16="http://schemas.microsoft.com/office/drawing/2014/main" id="{4A87B3F8-240C-4A58-8289-31D2FF30681F}"/>
               </a:ext>
             </a:extLst>
           </p:cNvPr>
@@ -6423,7 +9885,7 @@
           <p:cNvPr id="3" name="">
             <a:extLst xmlns:a="http://schemas.openxmlformats.org/drawingml/2006/main">
               <a:ext uri="{FF2B5EF4-FFF2-40B4-BE49-F238E27FC236}">
-                <a16:creationId xmlns:a16="http://schemas.microsoft.com/office/drawing/2014/main" id="{B9599219-FB0F-4265-83C0-2D4BDAD21A10}"/>
+                <a16:creationId xmlns:a16="http://schemas.microsoft.com/office/drawing/2014/main" id="{0BBC8194-93C2-40C1-9E80-0C8231F063D1}"/>
               </a:ext>
             </a:extLst>
           </p:cNvPr>
@@ -6458,7 +9920,7 @@
           <p:nvPr/>
         </p:nvPicPr>
         <p:blipFill>
-          <a:blip xmlns:r="http://schemas.openxmlformats.org/officeDocument/2006/relationships" xmlns:a="http://schemas.openxmlformats.org/drawingml/2006/main" r:embed="Rd01ec63977b44f35"/>
+          <a:blip xmlns:r="http://schemas.openxmlformats.org/officeDocument/2006/relationships" xmlns:a="http://schemas.openxmlformats.org/drawingml/2006/main" r:embed="R143e6562c1864d33"/>
           <a:stretch xmlns:a="http://schemas.openxmlformats.org/drawingml/2006/main"/>
         </p:blipFill>
         <p:spPr>
@@ -6476,7 +9938,7 @@
           <p:cNvPr id="5" name="">
             <a:extLst xmlns:a="http://schemas.openxmlformats.org/drawingml/2006/main">
               <a:ext uri="{FF2B5EF4-FFF2-40B4-BE49-F238E27FC236}">
-                <a16:creationId xmlns:a16="http://schemas.microsoft.com/office/drawing/2014/main" id="{BCA550AA-9150-409F-8EA6-8BE7C4B0208C}"/>
+                <a16:creationId xmlns:a16="http://schemas.microsoft.com/office/drawing/2014/main" id="{8048E2A4-C1B1-4F8D-B887-50AA7EECD31F}"/>
               </a:ext>
             </a:extLst>
           </p:cNvPr>
@@ -6526,7 +9988,7 @@
           <p:cNvPr id="6" name="">
             <a:extLst xmlns:a="http://schemas.openxmlformats.org/drawingml/2006/main">
               <a:ext uri="{FF2B5EF4-FFF2-40B4-BE49-F238E27FC236}">
-                <a16:creationId xmlns:a16="http://schemas.microsoft.com/office/drawing/2014/main" id="{F3AF0545-61FA-4730-B052-E238AE8F40BC}"/>
+                <a16:creationId xmlns:a16="http://schemas.microsoft.com/office/drawing/2014/main" id="{ADAE09F9-ECE6-4A98-A3CA-328753551038}"/>
               </a:ext>
             </a:extLst>
           </p:cNvPr>
@@ -6574,7 +10036,7 @@
     </p:spTree>
     <p:extLst>
       <p:ext uri="{BB962C8B-B14F-4D97-AF65-F5344CB8AC3E}">
-        <p14:creationId xmlns:p14="http://schemas.microsoft.com/office/powerpoint/2010/main" val="1687094444"/>
+        <p14:creationId xmlns:p14="http://schemas.microsoft.com/office/powerpoint/2010/main" val="730828306"/>
       </p:ext>
     </p:extLst>
   </p:cSld>

</xml_diff>

<commit_message>
Add Gen5.4 GLM threshold diagnostic
</commit_message>
<xml_diff>
--- a/presentations/gen5_4_ml_decision_engine_incremental_build.pptx
+++ b/presentations/gen5_4_ml_decision_engine_incremental_build.pptx
@@ -2,29 +2,35 @@
 <file path=ppt/presentation.xml><?xml version="1.0" encoding="utf-8"?>
 <p:presentation xmlns:p="http://schemas.openxmlformats.org/presentationml/2006/main">
   <p:sldMasterIdLst>
-    <p:sldMasterId xmlns:r="http://schemas.openxmlformats.org/officeDocument/2006/relationships" id="2147483648" r:id="Rb707c0c617c44f5f"/>
+    <p:sldMasterId xmlns:r="http://schemas.openxmlformats.org/officeDocument/2006/relationships" id="2147483648" r:id="R6d41729f27f342ac"/>
   </p:sldMasterIdLst>
   <p:notesMasterIdLst>
-    <p:notesMasterId xmlns:r="http://schemas.openxmlformats.org/officeDocument/2006/relationships" r:id="R27608b05f04c46d9"/>
+    <p:notesMasterId xmlns:r="http://schemas.openxmlformats.org/officeDocument/2006/relationships" r:id="R043d61efd29a47bc"/>
   </p:notesMasterIdLst>
   <p:sldIdLst>
-    <p:sldId xmlns:r="http://schemas.openxmlformats.org/officeDocument/2006/relationships" id="256" r:id="R2aff7e8acff749d7"/>
-    <p:sldId xmlns:r="http://schemas.openxmlformats.org/officeDocument/2006/relationships" id="257" r:id="Rb7c27742628d4312"/>
-    <p:sldId xmlns:r="http://schemas.openxmlformats.org/officeDocument/2006/relationships" id="258" r:id="R6e05c5979eb048b1"/>
-    <p:sldId xmlns:r="http://schemas.openxmlformats.org/officeDocument/2006/relationships" id="259" r:id="Rc17acef321df40c8"/>
-    <p:sldId xmlns:r="http://schemas.openxmlformats.org/officeDocument/2006/relationships" id="260" r:id="R2139a1163d4946e5"/>
-    <p:sldId xmlns:r="http://schemas.openxmlformats.org/officeDocument/2006/relationships" id="261" r:id="Rcc36a9fba9514e54"/>
-    <p:sldId xmlns:r="http://schemas.openxmlformats.org/officeDocument/2006/relationships" id="262" r:id="R52e81f1b7cce450f"/>
-    <p:sldId xmlns:r="http://schemas.openxmlformats.org/officeDocument/2006/relationships" id="263" r:id="R4e9745ced60e4c5d"/>
-    <p:sldId xmlns:r="http://schemas.openxmlformats.org/officeDocument/2006/relationships" id="264" r:id="R66d61afad71b43a2"/>
-    <p:sldId xmlns:r="http://schemas.openxmlformats.org/officeDocument/2006/relationships" id="265" r:id="Rc06a3a9b543144b2"/>
-    <p:sldId xmlns:r="http://schemas.openxmlformats.org/officeDocument/2006/relationships" id="266" r:id="Rd78829dd075f4fcf"/>
-    <p:sldId xmlns:r="http://schemas.openxmlformats.org/officeDocument/2006/relationships" id="267" r:id="R296052f1e7984a01"/>
-    <p:sldId xmlns:r="http://schemas.openxmlformats.org/officeDocument/2006/relationships" id="268" r:id="R594f24f54e8f42b7"/>
-    <p:sldId xmlns:r="http://schemas.openxmlformats.org/officeDocument/2006/relationships" id="269" r:id="Rc52d03f33f0e40eb"/>
-    <p:sldId xmlns:r="http://schemas.openxmlformats.org/officeDocument/2006/relationships" id="270" r:id="R31adc33a12ac4ab6"/>
-    <p:sldId xmlns:r="http://schemas.openxmlformats.org/officeDocument/2006/relationships" id="271" r:id="R9839342601494d6d"/>
-    <p:sldId xmlns:r="http://schemas.openxmlformats.org/officeDocument/2006/relationships" id="272" r:id="Rac05c9d3386a4f5e"/>
+    <p:sldId xmlns:r="http://schemas.openxmlformats.org/officeDocument/2006/relationships" id="256" r:id="R4eba74f325d04d1c"/>
+    <p:sldId xmlns:r="http://schemas.openxmlformats.org/officeDocument/2006/relationships" id="257" r:id="R193a6581455145c3"/>
+    <p:sldId xmlns:r="http://schemas.openxmlformats.org/officeDocument/2006/relationships" id="258" r:id="R0a3df4233f5b43a8"/>
+    <p:sldId xmlns:r="http://schemas.openxmlformats.org/officeDocument/2006/relationships" id="259" r:id="R5dc8012d94534b84"/>
+    <p:sldId xmlns:r="http://schemas.openxmlformats.org/officeDocument/2006/relationships" id="260" r:id="Rde70e23c898f4b5e"/>
+    <p:sldId xmlns:r="http://schemas.openxmlformats.org/officeDocument/2006/relationships" id="261" r:id="R35e9d67dbdf847d2"/>
+    <p:sldId xmlns:r="http://schemas.openxmlformats.org/officeDocument/2006/relationships" id="262" r:id="Rb9fb15f0a42646c7"/>
+    <p:sldId xmlns:r="http://schemas.openxmlformats.org/officeDocument/2006/relationships" id="263" r:id="R8aa8334d5d864572"/>
+    <p:sldId xmlns:r="http://schemas.openxmlformats.org/officeDocument/2006/relationships" id="264" r:id="R7b7c552059f64007"/>
+    <p:sldId xmlns:r="http://schemas.openxmlformats.org/officeDocument/2006/relationships" id="265" r:id="Re12480b505c24f72"/>
+    <p:sldId xmlns:r="http://schemas.openxmlformats.org/officeDocument/2006/relationships" id="266" r:id="R8aac13fd05be4331"/>
+    <p:sldId xmlns:r="http://schemas.openxmlformats.org/officeDocument/2006/relationships" id="267" r:id="Rde8455fe5f814c61"/>
+    <p:sldId xmlns:r="http://schemas.openxmlformats.org/officeDocument/2006/relationships" id="268" r:id="R67711544fc154a50"/>
+    <p:sldId xmlns:r="http://schemas.openxmlformats.org/officeDocument/2006/relationships" id="269" r:id="Rfb6450fbba1d4c2a"/>
+    <p:sldId xmlns:r="http://schemas.openxmlformats.org/officeDocument/2006/relationships" id="270" r:id="R41d0f0615e6b4fa7"/>
+    <p:sldId xmlns:r="http://schemas.openxmlformats.org/officeDocument/2006/relationships" id="271" r:id="Rf775f735c7034712"/>
+    <p:sldId xmlns:r="http://schemas.openxmlformats.org/officeDocument/2006/relationships" id="272" r:id="R8151a4f4f3ca4fed"/>
+    <p:sldId xmlns:r="http://schemas.openxmlformats.org/officeDocument/2006/relationships" id="273" r:id="R51fed3a7319642f5"/>
+    <p:sldId xmlns:r="http://schemas.openxmlformats.org/officeDocument/2006/relationships" id="274" r:id="Ra6d2a73654a548a4"/>
+    <p:sldId xmlns:r="http://schemas.openxmlformats.org/officeDocument/2006/relationships" id="275" r:id="Ra394ba65e9304e85"/>
+    <p:sldId xmlns:r="http://schemas.openxmlformats.org/officeDocument/2006/relationships" id="276" r:id="R962fbe9229794304"/>
+    <p:sldId xmlns:r="http://schemas.openxmlformats.org/officeDocument/2006/relationships" id="277" r:id="R51aa217391e64253"/>
+    <p:sldId xmlns:r="http://schemas.openxmlformats.org/officeDocument/2006/relationships" id="278" r:id="R53630d97e41e4f27"/>
   </p:sldIdLst>
   <p:sldSz cx="12192000" cy="6858000"/>
   <p:notesSz cx="6858000" cy="9144000"/>
@@ -1107,7 +1113,403 @@
 </p:notes>
 </file>
 
+<file path=ppt/notesSlides/notesSlide18.xml><?xml version="1.0" encoding="utf-8"?>
+<p:notes xmlns:p="http://schemas.openxmlformats.org/presentationml/2006/main">
+  <p:cSld>
+    <p:spTree>
+      <p:nvGrpSpPr>
+        <p:cNvPr id="1" name=""/>
+        <p:cNvGrpSpPr/>
+        <p:nvPr/>
+      </p:nvGrpSpPr>
+      <p:grpSpPr>
+        <a:xfrm xmlns:a="http://schemas.openxmlformats.org/drawingml/2006/main"/>
+      </p:grpSpPr>
+      <p:sp>
+        <p:nvSpPr>
+          <p:cNvPr id="2" name="Slide Image Placeholder 1"/>
+          <p:cNvSpPr>
+            <a:spLocks xmlns:a="http://schemas.openxmlformats.org/drawingml/2006/main" noGrp="1"/>
+          </p:cNvSpPr>
+          <p:nvPr>
+            <p:ph type="sldImg" idx="0"/>
+          </p:nvPr>
+        </p:nvSpPr>
+        <p:spPr/>
+      </p:sp>
+      <p:sp>
+        <p:nvSpPr>
+          <p:cNvPr id="3" name="Notes Placeholder 2"/>
+          <p:cNvSpPr>
+            <a:spLocks xmlns:a="http://schemas.openxmlformats.org/drawingml/2006/main" noGrp="1"/>
+          </p:cNvSpPr>
+          <p:nvPr>
+            <p:ph type="body" idx="1"/>
+          </p:nvPr>
+        </p:nvSpPr>
+        <p:spPr/>
+        <p:txBody>
+          <a:bodyPr xmlns:a="http://schemas.openxmlformats.org/drawingml/2006/main"/>
+          <a:lstStyle xmlns:a="http://schemas.openxmlformats.org/drawingml/2006/main"/>
+          <a:p xmlns:a="http://schemas.openxmlformats.org/drawingml/2006/main"/>
+        </p:txBody>
+      </p:sp>
+      <p:sp>
+        <p:nvSpPr>
+          <p:cNvPr id="4" name="Slide Number Placeholder 3"/>
+          <p:cNvSpPr>
+            <a:spLocks xmlns:a="http://schemas.openxmlformats.org/drawingml/2006/main" noGrp="1"/>
+          </p:cNvSpPr>
+          <p:nvPr>
+            <p:ph type="sldNum" idx="5"/>
+          </p:nvPr>
+        </p:nvSpPr>
+        <p:spPr/>
+        <p:txBody>
+          <a:bodyPr xmlns:a="http://schemas.openxmlformats.org/drawingml/2006/main"/>
+          <a:lstStyle xmlns:a="http://schemas.openxmlformats.org/drawingml/2006/main"/>
+          <a:p xmlns:a="http://schemas.openxmlformats.org/drawingml/2006/main"/>
+        </p:txBody>
+      </p:sp>
+    </p:spTree>
+  </p:cSld>
+  <p:clrMapOvr>
+    <a:masterClrMapping xmlns:a="http://schemas.openxmlformats.org/drawingml/2006/main"/>
+  </p:clrMapOvr>
+</p:notes>
+</file>
+
+<file path=ppt/notesSlides/notesSlide19.xml><?xml version="1.0" encoding="utf-8"?>
+<p:notes xmlns:p="http://schemas.openxmlformats.org/presentationml/2006/main">
+  <p:cSld>
+    <p:spTree>
+      <p:nvGrpSpPr>
+        <p:cNvPr id="1" name=""/>
+        <p:cNvGrpSpPr/>
+        <p:nvPr/>
+      </p:nvGrpSpPr>
+      <p:grpSpPr>
+        <a:xfrm xmlns:a="http://schemas.openxmlformats.org/drawingml/2006/main"/>
+      </p:grpSpPr>
+      <p:sp>
+        <p:nvSpPr>
+          <p:cNvPr id="2" name="Slide Image Placeholder 1"/>
+          <p:cNvSpPr>
+            <a:spLocks xmlns:a="http://schemas.openxmlformats.org/drawingml/2006/main" noGrp="1"/>
+          </p:cNvSpPr>
+          <p:nvPr>
+            <p:ph type="sldImg" idx="0"/>
+          </p:nvPr>
+        </p:nvSpPr>
+        <p:spPr/>
+      </p:sp>
+      <p:sp>
+        <p:nvSpPr>
+          <p:cNvPr id="3" name="Notes Placeholder 2"/>
+          <p:cNvSpPr>
+            <a:spLocks xmlns:a="http://schemas.openxmlformats.org/drawingml/2006/main" noGrp="1"/>
+          </p:cNvSpPr>
+          <p:nvPr>
+            <p:ph type="body" idx="1"/>
+          </p:nvPr>
+        </p:nvSpPr>
+        <p:spPr/>
+        <p:txBody>
+          <a:bodyPr xmlns:a="http://schemas.openxmlformats.org/drawingml/2006/main"/>
+          <a:lstStyle xmlns:a="http://schemas.openxmlformats.org/drawingml/2006/main"/>
+          <a:p xmlns:a="http://schemas.openxmlformats.org/drawingml/2006/main"/>
+        </p:txBody>
+      </p:sp>
+      <p:sp>
+        <p:nvSpPr>
+          <p:cNvPr id="4" name="Slide Number Placeholder 3"/>
+          <p:cNvSpPr>
+            <a:spLocks xmlns:a="http://schemas.openxmlformats.org/drawingml/2006/main" noGrp="1"/>
+          </p:cNvSpPr>
+          <p:nvPr>
+            <p:ph type="sldNum" idx="5"/>
+          </p:nvPr>
+        </p:nvSpPr>
+        <p:spPr/>
+        <p:txBody>
+          <a:bodyPr xmlns:a="http://schemas.openxmlformats.org/drawingml/2006/main"/>
+          <a:lstStyle xmlns:a="http://schemas.openxmlformats.org/drawingml/2006/main"/>
+          <a:p xmlns:a="http://schemas.openxmlformats.org/drawingml/2006/main"/>
+        </p:txBody>
+      </p:sp>
+    </p:spTree>
+  </p:cSld>
+  <p:clrMapOvr>
+    <a:masterClrMapping xmlns:a="http://schemas.openxmlformats.org/drawingml/2006/main"/>
+  </p:clrMapOvr>
+</p:notes>
+</file>
+
 <file path=ppt/notesSlides/notesSlide2.xml><?xml version="1.0" encoding="utf-8"?>
+<p:notes xmlns:p="http://schemas.openxmlformats.org/presentationml/2006/main">
+  <p:cSld>
+    <p:spTree>
+      <p:nvGrpSpPr>
+        <p:cNvPr id="1" name=""/>
+        <p:cNvGrpSpPr/>
+        <p:nvPr/>
+      </p:nvGrpSpPr>
+      <p:grpSpPr>
+        <a:xfrm xmlns:a="http://schemas.openxmlformats.org/drawingml/2006/main"/>
+      </p:grpSpPr>
+      <p:sp>
+        <p:nvSpPr>
+          <p:cNvPr id="2" name="Slide Image Placeholder 1"/>
+          <p:cNvSpPr>
+            <a:spLocks xmlns:a="http://schemas.openxmlformats.org/drawingml/2006/main" noGrp="1"/>
+          </p:cNvSpPr>
+          <p:nvPr>
+            <p:ph type="sldImg" idx="0"/>
+          </p:nvPr>
+        </p:nvSpPr>
+        <p:spPr/>
+      </p:sp>
+      <p:sp>
+        <p:nvSpPr>
+          <p:cNvPr id="3" name="Notes Placeholder 2"/>
+          <p:cNvSpPr>
+            <a:spLocks xmlns:a="http://schemas.openxmlformats.org/drawingml/2006/main" noGrp="1"/>
+          </p:cNvSpPr>
+          <p:nvPr>
+            <p:ph type="body" idx="1"/>
+          </p:nvPr>
+        </p:nvSpPr>
+        <p:spPr/>
+        <p:txBody>
+          <a:bodyPr xmlns:a="http://schemas.openxmlformats.org/drawingml/2006/main"/>
+          <a:lstStyle xmlns:a="http://schemas.openxmlformats.org/drawingml/2006/main"/>
+          <a:p xmlns:a="http://schemas.openxmlformats.org/drawingml/2006/main"/>
+        </p:txBody>
+      </p:sp>
+      <p:sp>
+        <p:nvSpPr>
+          <p:cNvPr id="4" name="Slide Number Placeholder 3"/>
+          <p:cNvSpPr>
+            <a:spLocks xmlns:a="http://schemas.openxmlformats.org/drawingml/2006/main" noGrp="1"/>
+          </p:cNvSpPr>
+          <p:nvPr>
+            <p:ph type="sldNum" idx="5"/>
+          </p:nvPr>
+        </p:nvSpPr>
+        <p:spPr/>
+        <p:txBody>
+          <a:bodyPr xmlns:a="http://schemas.openxmlformats.org/drawingml/2006/main"/>
+          <a:lstStyle xmlns:a="http://schemas.openxmlformats.org/drawingml/2006/main"/>
+          <a:p xmlns:a="http://schemas.openxmlformats.org/drawingml/2006/main"/>
+        </p:txBody>
+      </p:sp>
+    </p:spTree>
+  </p:cSld>
+  <p:clrMapOvr>
+    <a:masterClrMapping xmlns:a="http://schemas.openxmlformats.org/drawingml/2006/main"/>
+  </p:clrMapOvr>
+</p:notes>
+</file>
+
+<file path=ppt/notesSlides/notesSlide20.xml><?xml version="1.0" encoding="utf-8"?>
+<p:notes xmlns:p="http://schemas.openxmlformats.org/presentationml/2006/main">
+  <p:cSld>
+    <p:spTree>
+      <p:nvGrpSpPr>
+        <p:cNvPr id="1" name=""/>
+        <p:cNvGrpSpPr/>
+        <p:nvPr/>
+      </p:nvGrpSpPr>
+      <p:grpSpPr>
+        <a:xfrm xmlns:a="http://schemas.openxmlformats.org/drawingml/2006/main"/>
+      </p:grpSpPr>
+      <p:sp>
+        <p:nvSpPr>
+          <p:cNvPr id="2" name="Slide Image Placeholder 1"/>
+          <p:cNvSpPr>
+            <a:spLocks xmlns:a="http://schemas.openxmlformats.org/drawingml/2006/main" noGrp="1"/>
+          </p:cNvSpPr>
+          <p:nvPr>
+            <p:ph type="sldImg" idx="0"/>
+          </p:nvPr>
+        </p:nvSpPr>
+        <p:spPr/>
+      </p:sp>
+      <p:sp>
+        <p:nvSpPr>
+          <p:cNvPr id="3" name="Notes Placeholder 2"/>
+          <p:cNvSpPr>
+            <a:spLocks xmlns:a="http://schemas.openxmlformats.org/drawingml/2006/main" noGrp="1"/>
+          </p:cNvSpPr>
+          <p:nvPr>
+            <p:ph type="body" idx="1"/>
+          </p:nvPr>
+        </p:nvSpPr>
+        <p:spPr/>
+        <p:txBody>
+          <a:bodyPr xmlns:a="http://schemas.openxmlformats.org/drawingml/2006/main"/>
+          <a:lstStyle xmlns:a="http://schemas.openxmlformats.org/drawingml/2006/main"/>
+          <a:p xmlns:a="http://schemas.openxmlformats.org/drawingml/2006/main"/>
+        </p:txBody>
+      </p:sp>
+      <p:sp>
+        <p:nvSpPr>
+          <p:cNvPr id="4" name="Slide Number Placeholder 3"/>
+          <p:cNvSpPr>
+            <a:spLocks xmlns:a="http://schemas.openxmlformats.org/drawingml/2006/main" noGrp="1"/>
+          </p:cNvSpPr>
+          <p:nvPr>
+            <p:ph type="sldNum" idx="5"/>
+          </p:nvPr>
+        </p:nvSpPr>
+        <p:spPr/>
+        <p:txBody>
+          <a:bodyPr xmlns:a="http://schemas.openxmlformats.org/drawingml/2006/main"/>
+          <a:lstStyle xmlns:a="http://schemas.openxmlformats.org/drawingml/2006/main"/>
+          <a:p xmlns:a="http://schemas.openxmlformats.org/drawingml/2006/main"/>
+        </p:txBody>
+      </p:sp>
+    </p:spTree>
+  </p:cSld>
+  <p:clrMapOvr>
+    <a:masterClrMapping xmlns:a="http://schemas.openxmlformats.org/drawingml/2006/main"/>
+  </p:clrMapOvr>
+</p:notes>
+</file>
+
+<file path=ppt/notesSlides/notesSlide21.xml><?xml version="1.0" encoding="utf-8"?>
+<p:notes xmlns:p="http://schemas.openxmlformats.org/presentationml/2006/main">
+  <p:cSld>
+    <p:spTree>
+      <p:nvGrpSpPr>
+        <p:cNvPr id="1" name=""/>
+        <p:cNvGrpSpPr/>
+        <p:nvPr/>
+      </p:nvGrpSpPr>
+      <p:grpSpPr>
+        <a:xfrm xmlns:a="http://schemas.openxmlformats.org/drawingml/2006/main"/>
+      </p:grpSpPr>
+      <p:sp>
+        <p:nvSpPr>
+          <p:cNvPr id="2" name="Slide Image Placeholder 1"/>
+          <p:cNvSpPr>
+            <a:spLocks xmlns:a="http://schemas.openxmlformats.org/drawingml/2006/main" noGrp="1"/>
+          </p:cNvSpPr>
+          <p:nvPr>
+            <p:ph type="sldImg" idx="0"/>
+          </p:nvPr>
+        </p:nvSpPr>
+        <p:spPr/>
+      </p:sp>
+      <p:sp>
+        <p:nvSpPr>
+          <p:cNvPr id="3" name="Notes Placeholder 2"/>
+          <p:cNvSpPr>
+            <a:spLocks xmlns:a="http://schemas.openxmlformats.org/drawingml/2006/main" noGrp="1"/>
+          </p:cNvSpPr>
+          <p:nvPr>
+            <p:ph type="body" idx="1"/>
+          </p:nvPr>
+        </p:nvSpPr>
+        <p:spPr/>
+        <p:txBody>
+          <a:bodyPr xmlns:a="http://schemas.openxmlformats.org/drawingml/2006/main"/>
+          <a:lstStyle xmlns:a="http://schemas.openxmlformats.org/drawingml/2006/main"/>
+          <a:p xmlns:a="http://schemas.openxmlformats.org/drawingml/2006/main"/>
+        </p:txBody>
+      </p:sp>
+      <p:sp>
+        <p:nvSpPr>
+          <p:cNvPr id="4" name="Slide Number Placeholder 3"/>
+          <p:cNvSpPr>
+            <a:spLocks xmlns:a="http://schemas.openxmlformats.org/drawingml/2006/main" noGrp="1"/>
+          </p:cNvSpPr>
+          <p:nvPr>
+            <p:ph type="sldNum" idx="5"/>
+          </p:nvPr>
+        </p:nvSpPr>
+        <p:spPr/>
+        <p:txBody>
+          <a:bodyPr xmlns:a="http://schemas.openxmlformats.org/drawingml/2006/main"/>
+          <a:lstStyle xmlns:a="http://schemas.openxmlformats.org/drawingml/2006/main"/>
+          <a:p xmlns:a="http://schemas.openxmlformats.org/drawingml/2006/main"/>
+        </p:txBody>
+      </p:sp>
+    </p:spTree>
+  </p:cSld>
+  <p:clrMapOvr>
+    <a:masterClrMapping xmlns:a="http://schemas.openxmlformats.org/drawingml/2006/main"/>
+  </p:clrMapOvr>
+</p:notes>
+</file>
+
+<file path=ppt/notesSlides/notesSlide22.xml><?xml version="1.0" encoding="utf-8"?>
+<p:notes xmlns:p="http://schemas.openxmlformats.org/presentationml/2006/main">
+  <p:cSld>
+    <p:spTree>
+      <p:nvGrpSpPr>
+        <p:cNvPr id="1" name=""/>
+        <p:cNvGrpSpPr/>
+        <p:nvPr/>
+      </p:nvGrpSpPr>
+      <p:grpSpPr>
+        <a:xfrm xmlns:a="http://schemas.openxmlformats.org/drawingml/2006/main"/>
+      </p:grpSpPr>
+      <p:sp>
+        <p:nvSpPr>
+          <p:cNvPr id="2" name="Slide Image Placeholder 1"/>
+          <p:cNvSpPr>
+            <a:spLocks xmlns:a="http://schemas.openxmlformats.org/drawingml/2006/main" noGrp="1"/>
+          </p:cNvSpPr>
+          <p:nvPr>
+            <p:ph type="sldImg" idx="0"/>
+          </p:nvPr>
+        </p:nvSpPr>
+        <p:spPr/>
+      </p:sp>
+      <p:sp>
+        <p:nvSpPr>
+          <p:cNvPr id="3" name="Notes Placeholder 2"/>
+          <p:cNvSpPr>
+            <a:spLocks xmlns:a="http://schemas.openxmlformats.org/drawingml/2006/main" noGrp="1"/>
+          </p:cNvSpPr>
+          <p:nvPr>
+            <p:ph type="body" idx="1"/>
+          </p:nvPr>
+        </p:nvSpPr>
+        <p:spPr/>
+        <p:txBody>
+          <a:bodyPr xmlns:a="http://schemas.openxmlformats.org/drawingml/2006/main"/>
+          <a:lstStyle xmlns:a="http://schemas.openxmlformats.org/drawingml/2006/main"/>
+          <a:p xmlns:a="http://schemas.openxmlformats.org/drawingml/2006/main"/>
+        </p:txBody>
+      </p:sp>
+      <p:sp>
+        <p:nvSpPr>
+          <p:cNvPr id="4" name="Slide Number Placeholder 3"/>
+          <p:cNvSpPr>
+            <a:spLocks xmlns:a="http://schemas.openxmlformats.org/drawingml/2006/main" noGrp="1"/>
+          </p:cNvSpPr>
+          <p:nvPr>
+            <p:ph type="sldNum" idx="5"/>
+          </p:nvPr>
+        </p:nvSpPr>
+        <p:spPr/>
+        <p:txBody>
+          <a:bodyPr xmlns:a="http://schemas.openxmlformats.org/drawingml/2006/main"/>
+          <a:lstStyle xmlns:a="http://schemas.openxmlformats.org/drawingml/2006/main"/>
+          <a:p xmlns:a="http://schemas.openxmlformats.org/drawingml/2006/main"/>
+        </p:txBody>
+      </p:sp>
+    </p:spTree>
+  </p:cSld>
+  <p:clrMapOvr>
+    <a:masterClrMapping xmlns:a="http://schemas.openxmlformats.org/drawingml/2006/main"/>
+  </p:clrMapOvr>
+</p:notes>
+</file>
+
+<file path=ppt/notesSlides/notesSlide23.xml><?xml version="1.0" encoding="utf-8"?>
 <p:notes xmlns:p="http://schemas.openxmlformats.org/presentationml/2006/main">
   <p:cSld>
     <p:spTree>
@@ -1673,7 +2075,7 @@
   </p:cSld>
   <p:clrMap bg1="lt1" tx1="dk1" bg2="lt2" tx2="dk2" accent1="accent1" accent2="accent2" accent3="accent3" accent4="accent4" accent5="accent5" accent6="accent6" hlink="hlink" folHlink="folHlink"/>
   <p:sldLayoutIdLst>
-    <p:sldLayoutId xmlns:r="http://schemas.openxmlformats.org/officeDocument/2006/relationships" id="2147483649" r:id="R48674be5d3da4449"/>
+    <p:sldLayoutId xmlns:r="http://schemas.openxmlformats.org/officeDocument/2006/relationships" id="2147483649" r:id="Re940d0972a354b1b"/>
   </p:sldLayoutIdLst>
   <p:txStyles>
     <p:titleStyle>
@@ -2224,7 +2626,7 @@
           <p:cNvPr id="1" name="">
             <a:extLst xmlns:a="http://schemas.openxmlformats.org/drawingml/2006/main">
               <a:ext uri="{FF2B5EF4-FFF2-40B4-BE49-F238E27FC236}">
-                <a16:creationId xmlns:a16="http://schemas.microsoft.com/office/drawing/2014/main" id="{22DD9EAA-DED7-4A68-9ED9-7E1AFAEFB75B}"/>
+                <a16:creationId xmlns:a16="http://schemas.microsoft.com/office/drawing/2014/main" id="{59BB3E52-9162-40E8-AE58-C6DEA8BB3053}"/>
               </a:ext>
             </a:extLst>
           </p:cNvPr>
@@ -2274,7 +2676,7 @@
           <p:cNvPr id="2" name="">
             <a:extLst xmlns:a="http://schemas.openxmlformats.org/drawingml/2006/main">
               <a:ext uri="{FF2B5EF4-FFF2-40B4-BE49-F238E27FC236}">
-                <a16:creationId xmlns:a16="http://schemas.microsoft.com/office/drawing/2014/main" id="{74D4798E-90B8-4E56-8BD3-53ED7F5EFF2A}"/>
+                <a16:creationId xmlns:a16="http://schemas.microsoft.com/office/drawing/2014/main" id="{38976D15-4D07-43E2-92B1-48D91A5B7404}"/>
               </a:ext>
             </a:extLst>
           </p:cNvPr>
@@ -2324,7 +2726,7 @@
           <p:cNvPr id="3" name="">
             <a:extLst xmlns:a="http://schemas.openxmlformats.org/drawingml/2006/main">
               <a:ext uri="{FF2B5EF4-FFF2-40B4-BE49-F238E27FC236}">
-                <a16:creationId xmlns:a16="http://schemas.microsoft.com/office/drawing/2014/main" id="{2108B7D8-3993-4710-855B-A725AED2FBA4}"/>
+                <a16:creationId xmlns:a16="http://schemas.microsoft.com/office/drawing/2014/main" id="{0D7755E5-19CD-49ED-AC67-B73AECF8A498}"/>
               </a:ext>
             </a:extLst>
           </p:cNvPr>
@@ -2374,7 +2776,7 @@
           <p:cNvPr id="4" name="">
             <a:extLst xmlns:a="http://schemas.openxmlformats.org/drawingml/2006/main">
               <a:ext uri="{FF2B5EF4-FFF2-40B4-BE49-F238E27FC236}">
-                <a16:creationId xmlns:a16="http://schemas.microsoft.com/office/drawing/2014/main" id="{168EF6BD-500C-47C0-9193-1F14C389A897}"/>
+                <a16:creationId xmlns:a16="http://schemas.microsoft.com/office/drawing/2014/main" id="{6160136D-5195-45F5-A72D-CCF9B768D391}"/>
               </a:ext>
             </a:extLst>
           </p:cNvPr>
@@ -2405,7 +2807,7 @@
           <p:cNvPr id="5" name="">
             <a:extLst xmlns:a="http://schemas.openxmlformats.org/drawingml/2006/main">
               <a:ext uri="{FF2B5EF4-FFF2-40B4-BE49-F238E27FC236}">
-                <a16:creationId xmlns:a16="http://schemas.microsoft.com/office/drawing/2014/main" id="{EB2A158B-2493-48D7-B6A6-AF7D1575D2C8}"/>
+                <a16:creationId xmlns:a16="http://schemas.microsoft.com/office/drawing/2014/main" id="{AFC51EA1-60C4-4523-9A9F-610C30AD4EF4}"/>
               </a:ext>
             </a:extLst>
           </p:cNvPr>
@@ -2455,7 +2857,7 @@
           <p:cNvPr id="6" name="">
             <a:extLst xmlns:a="http://schemas.openxmlformats.org/drawingml/2006/main">
               <a:ext uri="{FF2B5EF4-FFF2-40B4-BE49-F238E27FC236}">
-                <a16:creationId xmlns:a16="http://schemas.microsoft.com/office/drawing/2014/main" id="{531B1FE1-037C-4E09-93FF-0967BE4B99BB}"/>
+                <a16:creationId xmlns:a16="http://schemas.microsoft.com/office/drawing/2014/main" id="{2640BD6F-79DD-491F-B873-3E51361F9D97}"/>
               </a:ext>
             </a:extLst>
           </p:cNvPr>
@@ -2486,7 +2888,7 @@
           <p:cNvPr id="7" name="">
             <a:extLst xmlns:a="http://schemas.openxmlformats.org/drawingml/2006/main">
               <a:ext uri="{FF2B5EF4-FFF2-40B4-BE49-F238E27FC236}">
-                <a16:creationId xmlns:a16="http://schemas.microsoft.com/office/drawing/2014/main" id="{0645951D-59D7-481A-94F5-A566A74D08CD}"/>
+                <a16:creationId xmlns:a16="http://schemas.microsoft.com/office/drawing/2014/main" id="{DAB0027C-26D8-40BA-A3DB-ABC4E2A986DC}"/>
               </a:ext>
             </a:extLst>
           </p:cNvPr>
@@ -2536,7 +2938,7 @@
           <p:cNvPr id="8" name="">
             <a:extLst xmlns:a="http://schemas.openxmlformats.org/drawingml/2006/main">
               <a:ext uri="{FF2B5EF4-FFF2-40B4-BE49-F238E27FC236}">
-                <a16:creationId xmlns:a16="http://schemas.microsoft.com/office/drawing/2014/main" id="{B5F49E97-235D-43EA-BFA4-2AA41194BC17}"/>
+                <a16:creationId xmlns:a16="http://schemas.microsoft.com/office/drawing/2014/main" id="{5E7BEF9E-8944-423C-968B-58A9006D79F1}"/>
               </a:ext>
             </a:extLst>
           </p:cNvPr>
@@ -2618,7 +3020,7 @@
     </p:spTree>
     <p:extLst>
       <p:ext uri="{BB962C8B-B14F-4D97-AF65-F5344CB8AC3E}">
-        <p14:creationId xmlns:p14="http://schemas.microsoft.com/office/powerpoint/2010/main" val="1741620921"/>
+        <p14:creationId xmlns:p14="http://schemas.microsoft.com/office/powerpoint/2010/main" val="1689252231"/>
       </p:ext>
     </p:extLst>
   </p:cSld>
@@ -2649,7 +3051,7 @@
           <p:cNvPr id="1" name="">
             <a:extLst xmlns:a="http://schemas.openxmlformats.org/drawingml/2006/main">
               <a:ext uri="{FF2B5EF4-FFF2-40B4-BE49-F238E27FC236}">
-                <a16:creationId xmlns:a16="http://schemas.microsoft.com/office/drawing/2014/main" id="{E9433120-54E9-48E7-B64D-7D58861E3762}"/>
+                <a16:creationId xmlns:a16="http://schemas.microsoft.com/office/drawing/2014/main" id="{7385A021-9C60-4029-AA59-CEA877CB382E}"/>
               </a:ext>
             </a:extLst>
           </p:cNvPr>
@@ -2699,7 +3101,7 @@
           <p:cNvPr id="2" name="">
             <a:extLst xmlns:a="http://schemas.openxmlformats.org/drawingml/2006/main">
               <a:ext uri="{FF2B5EF4-FFF2-40B4-BE49-F238E27FC236}">
-                <a16:creationId xmlns:a16="http://schemas.microsoft.com/office/drawing/2014/main" id="{377AAB0A-234E-4BF8-8749-607462636B49}"/>
+                <a16:creationId xmlns:a16="http://schemas.microsoft.com/office/drawing/2014/main" id="{BF64F2CB-0818-483E-80D8-A4963800CD29}"/>
               </a:ext>
             </a:extLst>
           </p:cNvPr>
@@ -2749,7 +3151,7 @@
           <p:cNvPr id="3" name="">
             <a:extLst xmlns:a="http://schemas.openxmlformats.org/drawingml/2006/main">
               <a:ext uri="{FF2B5EF4-FFF2-40B4-BE49-F238E27FC236}">
-                <a16:creationId xmlns:a16="http://schemas.microsoft.com/office/drawing/2014/main" id="{A123B74E-EBC7-47F6-BDF4-4275072C5F00}"/>
+                <a16:creationId xmlns:a16="http://schemas.microsoft.com/office/drawing/2014/main" id="{45A51AFB-8D32-4984-A2A4-E245F6222A52}"/>
               </a:ext>
             </a:extLst>
           </p:cNvPr>
@@ -2780,7 +3182,7 @@
           <p:cNvPr id="4" name="">
             <a:extLst xmlns:a="http://schemas.openxmlformats.org/drawingml/2006/main">
               <a:ext uri="{FF2B5EF4-FFF2-40B4-BE49-F238E27FC236}">
-                <a16:creationId xmlns:a16="http://schemas.microsoft.com/office/drawing/2014/main" id="{22888014-DF4E-4741-A439-49705E9F56CC}"/>
+                <a16:creationId xmlns:a16="http://schemas.microsoft.com/office/drawing/2014/main" id="{82FEA1D7-D43E-4826-BC85-571A3E78AC3C}"/>
               </a:ext>
             </a:extLst>
           </p:cNvPr>
@@ -2830,7 +3232,7 @@
           <p:cNvPr id="5" name="">
             <a:extLst xmlns:a="http://schemas.openxmlformats.org/drawingml/2006/main">
               <a:ext uri="{FF2B5EF4-FFF2-40B4-BE49-F238E27FC236}">
-                <a16:creationId xmlns:a16="http://schemas.microsoft.com/office/drawing/2014/main" id="{E2CB7C25-C316-4C07-B795-201F3C558FFC}"/>
+                <a16:creationId xmlns:a16="http://schemas.microsoft.com/office/drawing/2014/main" id="{2D323D4A-DFCA-42B2-BC89-449A4DCF46CB}"/>
               </a:ext>
             </a:extLst>
           </p:cNvPr>
@@ -2880,7 +3282,7 @@
           <p:cNvPr id="6" name="">
             <a:extLst xmlns:a="http://schemas.openxmlformats.org/drawingml/2006/main">
               <a:ext uri="{FF2B5EF4-FFF2-40B4-BE49-F238E27FC236}">
-                <a16:creationId xmlns:a16="http://schemas.microsoft.com/office/drawing/2014/main" id="{008E636A-20FC-473C-8E32-BC1D34EEC805}"/>
+                <a16:creationId xmlns:a16="http://schemas.microsoft.com/office/drawing/2014/main" id="{144591CE-BF27-447B-AC11-0F77CCF6D3FA}"/>
               </a:ext>
             </a:extLst>
           </p:cNvPr>
@@ -2930,7 +3332,7 @@
           <p:cNvPr id="7" name="">
             <a:extLst xmlns:a="http://schemas.openxmlformats.org/drawingml/2006/main">
               <a:ext uri="{FF2B5EF4-FFF2-40B4-BE49-F238E27FC236}">
-                <a16:creationId xmlns:a16="http://schemas.microsoft.com/office/drawing/2014/main" id="{81C1E11A-DA31-4027-AF79-CB2768896CC9}"/>
+                <a16:creationId xmlns:a16="http://schemas.microsoft.com/office/drawing/2014/main" id="{2FE2F7B3-6722-46C6-AE1D-6D55784A5D40}"/>
               </a:ext>
             </a:extLst>
           </p:cNvPr>
@@ -2980,7 +3382,7 @@
           <p:cNvPr id="8" name="">
             <a:extLst xmlns:a="http://schemas.openxmlformats.org/drawingml/2006/main">
               <a:ext uri="{FF2B5EF4-FFF2-40B4-BE49-F238E27FC236}">
-                <a16:creationId xmlns:a16="http://schemas.microsoft.com/office/drawing/2014/main" id="{070DD0C6-3850-41AD-AF31-5242E3D0E32E}"/>
+                <a16:creationId xmlns:a16="http://schemas.microsoft.com/office/drawing/2014/main" id="{88B88587-6F76-4CAC-9028-F1F4AEBC0797}"/>
               </a:ext>
             </a:extLst>
           </p:cNvPr>
@@ -3030,7 +3432,7 @@
           <p:cNvPr id="9" name="">
             <a:extLst xmlns:a="http://schemas.openxmlformats.org/drawingml/2006/main">
               <a:ext uri="{FF2B5EF4-FFF2-40B4-BE49-F238E27FC236}">
-                <a16:creationId xmlns:a16="http://schemas.microsoft.com/office/drawing/2014/main" id="{F2DE1AD5-1493-4952-A325-9A0E993FF858}"/>
+                <a16:creationId xmlns:a16="http://schemas.microsoft.com/office/drawing/2014/main" id="{81188256-06B7-4159-A280-42578B36C10C}"/>
               </a:ext>
             </a:extLst>
           </p:cNvPr>
@@ -3080,7 +3482,7 @@
           <p:cNvPr id="10" name="">
             <a:extLst xmlns:a="http://schemas.openxmlformats.org/drawingml/2006/main">
               <a:ext uri="{FF2B5EF4-FFF2-40B4-BE49-F238E27FC236}">
-                <a16:creationId xmlns:a16="http://schemas.microsoft.com/office/drawing/2014/main" id="{90C25DD9-2476-4EAF-9760-8A4E9803B1D9}"/>
+                <a16:creationId xmlns:a16="http://schemas.microsoft.com/office/drawing/2014/main" id="{2A4309AB-94AB-408F-8D68-4ED044358569}"/>
               </a:ext>
             </a:extLst>
           </p:cNvPr>
@@ -3130,7 +3532,7 @@
           <p:cNvPr id="11" name="">
             <a:extLst xmlns:a="http://schemas.openxmlformats.org/drawingml/2006/main">
               <a:ext uri="{FF2B5EF4-FFF2-40B4-BE49-F238E27FC236}">
-                <a16:creationId xmlns:a16="http://schemas.microsoft.com/office/drawing/2014/main" id="{E00CDFB8-B9C2-4BDF-90EE-82123BA8E721}"/>
+                <a16:creationId xmlns:a16="http://schemas.microsoft.com/office/drawing/2014/main" id="{0FFD3B68-D515-4FBD-9976-4D07F45CE8B8}"/>
               </a:ext>
             </a:extLst>
           </p:cNvPr>
@@ -3180,7 +3582,7 @@
           <p:cNvPr id="12" name="">
             <a:extLst xmlns:a="http://schemas.openxmlformats.org/drawingml/2006/main">
               <a:ext uri="{FF2B5EF4-FFF2-40B4-BE49-F238E27FC236}">
-                <a16:creationId xmlns:a16="http://schemas.microsoft.com/office/drawing/2014/main" id="{306A68B5-1FF9-4F48-AE3D-99B240DFE1F9}"/>
+                <a16:creationId xmlns:a16="http://schemas.microsoft.com/office/drawing/2014/main" id="{9C4A2045-944D-47CC-8EB4-01F168C63C4F}"/>
               </a:ext>
             </a:extLst>
           </p:cNvPr>
@@ -3230,7 +3632,7 @@
           <p:cNvPr id="13" name="">
             <a:extLst xmlns:a="http://schemas.openxmlformats.org/drawingml/2006/main">
               <a:ext uri="{FF2B5EF4-FFF2-40B4-BE49-F238E27FC236}">
-                <a16:creationId xmlns:a16="http://schemas.microsoft.com/office/drawing/2014/main" id="{D83FF65D-7C2F-4140-9656-9C9B5B92AC23}"/>
+                <a16:creationId xmlns:a16="http://schemas.microsoft.com/office/drawing/2014/main" id="{0E23F1EB-F0A8-43A0-9AB8-C6036008466F}"/>
               </a:ext>
             </a:extLst>
           </p:cNvPr>
@@ -3263,7 +3665,7 @@
           <p:cNvPr id="14" name="">
             <a:extLst xmlns:a="http://schemas.openxmlformats.org/drawingml/2006/main">
               <a:ext uri="{FF2B5EF4-FFF2-40B4-BE49-F238E27FC236}">
-                <a16:creationId xmlns:a16="http://schemas.microsoft.com/office/drawing/2014/main" id="{CC4D7CB7-6EF8-420F-B5C5-171871E04535}"/>
+                <a16:creationId xmlns:a16="http://schemas.microsoft.com/office/drawing/2014/main" id="{C8004F40-7D42-4AB6-8C8D-5CDF4F0857A5}"/>
               </a:ext>
             </a:extLst>
           </p:cNvPr>
@@ -3313,7 +3715,7 @@
           <p:cNvPr id="15" name="">
             <a:extLst xmlns:a="http://schemas.openxmlformats.org/drawingml/2006/main">
               <a:ext uri="{FF2B5EF4-FFF2-40B4-BE49-F238E27FC236}">
-                <a16:creationId xmlns:a16="http://schemas.microsoft.com/office/drawing/2014/main" id="{3109ADDB-48A8-4412-B2E4-8CAFD94E7DA1}"/>
+                <a16:creationId xmlns:a16="http://schemas.microsoft.com/office/drawing/2014/main" id="{EFC7893A-A3EA-4063-BCF9-7264573C62A5}"/>
               </a:ext>
             </a:extLst>
           </p:cNvPr>
@@ -3361,7 +3763,7 @@
     </p:spTree>
     <p:extLst>
       <p:ext uri="{BB962C8B-B14F-4D97-AF65-F5344CB8AC3E}">
-        <p14:creationId xmlns:p14="http://schemas.microsoft.com/office/powerpoint/2010/main" val="2059781940"/>
+        <p14:creationId xmlns:p14="http://schemas.microsoft.com/office/powerpoint/2010/main" val="400742922"/>
       </p:ext>
     </p:extLst>
   </p:cSld>
@@ -3392,7 +3794,7 @@
           <p:cNvPr id="1" name="">
             <a:extLst xmlns:a="http://schemas.openxmlformats.org/drawingml/2006/main">
               <a:ext uri="{FF2B5EF4-FFF2-40B4-BE49-F238E27FC236}">
-                <a16:creationId xmlns:a16="http://schemas.microsoft.com/office/drawing/2014/main" id="{BAB78496-6B8D-498C-9F6D-D0A8682DA063}"/>
+                <a16:creationId xmlns:a16="http://schemas.microsoft.com/office/drawing/2014/main" id="{4211F84F-FA20-4763-9A66-4EAA48070BD8}"/>
               </a:ext>
             </a:extLst>
           </p:cNvPr>
@@ -3442,7 +3844,7 @@
           <p:cNvPr id="2" name="">
             <a:extLst xmlns:a="http://schemas.openxmlformats.org/drawingml/2006/main">
               <a:ext uri="{FF2B5EF4-FFF2-40B4-BE49-F238E27FC236}">
-                <a16:creationId xmlns:a16="http://schemas.microsoft.com/office/drawing/2014/main" id="{C43701A2-ED47-4AFC-8CA8-F9E9209F1255}"/>
+                <a16:creationId xmlns:a16="http://schemas.microsoft.com/office/drawing/2014/main" id="{92432B98-F985-4CD7-97B7-C36E70664DC3}"/>
               </a:ext>
             </a:extLst>
           </p:cNvPr>
@@ -3492,7 +3894,7 @@
           <p:cNvPr id="3" name="">
             <a:extLst xmlns:a="http://schemas.openxmlformats.org/drawingml/2006/main">
               <a:ext uri="{FF2B5EF4-FFF2-40B4-BE49-F238E27FC236}">
-                <a16:creationId xmlns:a16="http://schemas.microsoft.com/office/drawing/2014/main" id="{9EBA40C5-3BC3-4CD0-BCE0-4A052156F139}"/>
+                <a16:creationId xmlns:a16="http://schemas.microsoft.com/office/drawing/2014/main" id="{ED203186-2BAD-4ED9-A00D-CD2C82C612C7}"/>
               </a:ext>
             </a:extLst>
           </p:cNvPr>
@@ -3523,7 +3925,7 @@
           <p:cNvPr id="4" name="">
             <a:extLst xmlns:a="http://schemas.openxmlformats.org/drawingml/2006/main">
               <a:ext uri="{FF2B5EF4-FFF2-40B4-BE49-F238E27FC236}">
-                <a16:creationId xmlns:a16="http://schemas.microsoft.com/office/drawing/2014/main" id="{1BF0108E-FFFE-4644-A73C-AB2EBF4AD59B}"/>
+                <a16:creationId xmlns:a16="http://schemas.microsoft.com/office/drawing/2014/main" id="{3ACE3083-E3CC-4ACF-9B57-6F47F2FD7DCC}"/>
               </a:ext>
             </a:extLst>
           </p:cNvPr>
@@ -3573,7 +3975,7 @@
           <p:cNvPr id="5" name="">
             <a:extLst xmlns:a="http://schemas.openxmlformats.org/drawingml/2006/main">
               <a:ext uri="{FF2B5EF4-FFF2-40B4-BE49-F238E27FC236}">
-                <a16:creationId xmlns:a16="http://schemas.microsoft.com/office/drawing/2014/main" id="{18F2328B-BF2F-4628-9415-1077679B85A7}"/>
+                <a16:creationId xmlns:a16="http://schemas.microsoft.com/office/drawing/2014/main" id="{8289A70F-51F6-4E4E-ACE5-3491869587C3}"/>
               </a:ext>
             </a:extLst>
           </p:cNvPr>
@@ -3604,7 +4006,7 @@
           <p:cNvPr id="6" name="">
             <a:extLst xmlns:a="http://schemas.openxmlformats.org/drawingml/2006/main">
               <a:ext uri="{FF2B5EF4-FFF2-40B4-BE49-F238E27FC236}">
-                <a16:creationId xmlns:a16="http://schemas.microsoft.com/office/drawing/2014/main" id="{E59E8A10-FBF2-4ECA-B4FE-A57A7E3946D2}"/>
+                <a16:creationId xmlns:a16="http://schemas.microsoft.com/office/drawing/2014/main" id="{6472C047-305F-4CD7-943E-CF04FD1AA1D6}"/>
               </a:ext>
             </a:extLst>
           </p:cNvPr>
@@ -3654,7 +4056,7 @@
           <p:cNvPr id="7" name="">
             <a:extLst xmlns:a="http://schemas.openxmlformats.org/drawingml/2006/main">
               <a:ext uri="{FF2B5EF4-FFF2-40B4-BE49-F238E27FC236}">
-                <a16:creationId xmlns:a16="http://schemas.microsoft.com/office/drawing/2014/main" id="{C1D56FAB-09FB-44F2-AA9F-6FFCDBC2433C}"/>
+                <a16:creationId xmlns:a16="http://schemas.microsoft.com/office/drawing/2014/main" id="{EABEA74D-9CF9-4CCE-9A12-6DCE038D844D}"/>
               </a:ext>
             </a:extLst>
           </p:cNvPr>
@@ -3702,7 +4104,7 @@
     </p:spTree>
     <p:extLst>
       <p:ext uri="{BB962C8B-B14F-4D97-AF65-F5344CB8AC3E}">
-        <p14:creationId xmlns:p14="http://schemas.microsoft.com/office/powerpoint/2010/main" val="1272524852"/>
+        <p14:creationId xmlns:p14="http://schemas.microsoft.com/office/powerpoint/2010/main" val="459008695"/>
       </p:ext>
     </p:extLst>
   </p:cSld>
@@ -3733,7 +4135,7 @@
           <p:cNvPr id="1" name="">
             <a:extLst xmlns:a="http://schemas.openxmlformats.org/drawingml/2006/main">
               <a:ext uri="{FF2B5EF4-FFF2-40B4-BE49-F238E27FC236}">
-                <a16:creationId xmlns:a16="http://schemas.microsoft.com/office/drawing/2014/main" id="{D94409FE-8D27-47EB-A7EF-5446947686A8}"/>
+                <a16:creationId xmlns:a16="http://schemas.microsoft.com/office/drawing/2014/main" id="{18326ED2-0C5D-44BF-9032-3741CAF5737A}"/>
               </a:ext>
             </a:extLst>
           </p:cNvPr>
@@ -3783,7 +4185,7 @@
           <p:cNvPr id="2" name="">
             <a:extLst xmlns:a="http://schemas.openxmlformats.org/drawingml/2006/main">
               <a:ext uri="{FF2B5EF4-FFF2-40B4-BE49-F238E27FC236}">
-                <a16:creationId xmlns:a16="http://schemas.microsoft.com/office/drawing/2014/main" id="{DC3CC4F6-EEC9-4F98-AB06-2111D81B603C}"/>
+                <a16:creationId xmlns:a16="http://schemas.microsoft.com/office/drawing/2014/main" id="{020CBFED-5DE1-438D-A2AB-1B5428D39152}"/>
               </a:ext>
             </a:extLst>
           </p:cNvPr>
@@ -3833,7 +4235,7 @@
           <p:cNvPr id="3" name="">
             <a:extLst xmlns:a="http://schemas.openxmlformats.org/drawingml/2006/main">
               <a:ext uri="{FF2B5EF4-FFF2-40B4-BE49-F238E27FC236}">
-                <a16:creationId xmlns:a16="http://schemas.microsoft.com/office/drawing/2014/main" id="{F6D9BC46-D8E9-4DA8-A754-002431DE46D0}"/>
+                <a16:creationId xmlns:a16="http://schemas.microsoft.com/office/drawing/2014/main" id="{EC9AD9DB-BA18-4907-862E-69CA40ACB85D}"/>
               </a:ext>
             </a:extLst>
           </p:cNvPr>
@@ -3864,7 +4266,7 @@
           <p:cNvPr id="4" name="">
             <a:extLst xmlns:a="http://schemas.openxmlformats.org/drawingml/2006/main">
               <a:ext uri="{FF2B5EF4-FFF2-40B4-BE49-F238E27FC236}">
-                <a16:creationId xmlns:a16="http://schemas.microsoft.com/office/drawing/2014/main" id="{9381AF91-F9B8-44CB-A9EC-936FBCE3D1AD}"/>
+                <a16:creationId xmlns:a16="http://schemas.microsoft.com/office/drawing/2014/main" id="{B62CF4CA-03ED-409B-A72E-F994C2A7446B}"/>
               </a:ext>
             </a:extLst>
           </p:cNvPr>
@@ -3876,7 +4278,7 @@
         <p:spPr>
           <a:xfrm xmlns:a="http://schemas.openxmlformats.org/drawingml/2006/main">
             <a:off x="819150" y="2152650"/>
-            <a:ext cx="2333625" cy="1200150"/>
+            <a:ext cx="2333625" cy="1428750"/>
           </a:xfrm>
           <a:prstGeom xmlns:a="http://schemas.openxmlformats.org/drawingml/2006/main" prst="rect">
             <a:avLst/>
@@ -3897,7 +4299,7 @@
           <p:cNvPr id="5" name="">
             <a:extLst xmlns:a="http://schemas.openxmlformats.org/drawingml/2006/main">
               <a:ext uri="{FF2B5EF4-FFF2-40B4-BE49-F238E27FC236}">
-                <a16:creationId xmlns:a16="http://schemas.microsoft.com/office/drawing/2014/main" id="{926E6486-5646-4AD0-8731-963A520563D3}"/>
+                <a16:creationId xmlns:a16="http://schemas.microsoft.com/office/drawing/2014/main" id="{AB7EAB94-8874-484C-BC4E-E92A281CD231}"/>
               </a:ext>
             </a:extLst>
           </p:cNvPr>
@@ -3947,7 +4349,7 @@
           <p:cNvPr id="6" name="">
             <a:extLst xmlns:a="http://schemas.openxmlformats.org/drawingml/2006/main">
               <a:ext uri="{FF2B5EF4-FFF2-40B4-BE49-F238E27FC236}">
-                <a16:creationId xmlns:a16="http://schemas.microsoft.com/office/drawing/2014/main" id="{AC448AA7-7C54-4C6B-BBF9-7D72856BCFFE}"/>
+                <a16:creationId xmlns:a16="http://schemas.microsoft.com/office/drawing/2014/main" id="{B558EE7F-3E14-48B2-BF6A-431CFF1F5A27}"/>
               </a:ext>
             </a:extLst>
           </p:cNvPr>
@@ -3997,7 +4399,7 @@
           <p:cNvPr id="7" name="">
             <a:extLst xmlns:a="http://schemas.openxmlformats.org/drawingml/2006/main">
               <a:ext uri="{FF2B5EF4-FFF2-40B4-BE49-F238E27FC236}">
-                <a16:creationId xmlns:a16="http://schemas.microsoft.com/office/drawing/2014/main" id="{07B95273-76CF-47FF-9E93-68188C85FA69}"/>
+                <a16:creationId xmlns:a16="http://schemas.microsoft.com/office/drawing/2014/main" id="{A548452D-CAA2-447D-9DAB-4D6F7AC63B31}"/>
               </a:ext>
             </a:extLst>
           </p:cNvPr>
@@ -4009,7 +4411,7 @@
         <p:spPr>
           <a:xfrm xmlns:a="http://schemas.openxmlformats.org/drawingml/2006/main">
             <a:off x="990600" y="2971800"/>
-            <a:ext cx="1990725" cy="323850"/>
+            <a:ext cx="1990725" cy="552450"/>
           </a:xfrm>
           <a:prstGeom xmlns:a="http://schemas.openxmlformats.org/drawingml/2006/main" prst="rect">
             <a:avLst/>
@@ -4047,7 +4449,7 @@
           <p:cNvPr id="8" name="">
             <a:extLst xmlns:a="http://schemas.openxmlformats.org/drawingml/2006/main">
               <a:ext uri="{FF2B5EF4-FFF2-40B4-BE49-F238E27FC236}">
-                <a16:creationId xmlns:a16="http://schemas.microsoft.com/office/drawing/2014/main" id="{0A43E010-8C1E-4D1E-A966-1FE0651E28DD}"/>
+                <a16:creationId xmlns:a16="http://schemas.microsoft.com/office/drawing/2014/main" id="{6F7EA969-5AA0-49B7-A17C-A752BCCED253}"/>
               </a:ext>
             </a:extLst>
           </p:cNvPr>
@@ -4059,7 +4461,7 @@
         <p:spPr>
           <a:xfrm xmlns:a="http://schemas.openxmlformats.org/drawingml/2006/main">
             <a:off x="3524250" y="2152650"/>
-            <a:ext cx="2333625" cy="1200150"/>
+            <a:ext cx="2333625" cy="1428750"/>
           </a:xfrm>
           <a:prstGeom xmlns:a="http://schemas.openxmlformats.org/drawingml/2006/main" prst="rect">
             <a:avLst/>
@@ -4080,7 +4482,7 @@
           <p:cNvPr id="9" name="">
             <a:extLst xmlns:a="http://schemas.openxmlformats.org/drawingml/2006/main">
               <a:ext uri="{FF2B5EF4-FFF2-40B4-BE49-F238E27FC236}">
-                <a16:creationId xmlns:a16="http://schemas.microsoft.com/office/drawing/2014/main" id="{7941A2AA-93C8-475B-ABFA-82B856044C8E}"/>
+                <a16:creationId xmlns:a16="http://schemas.microsoft.com/office/drawing/2014/main" id="{03AE1B82-D94C-4D70-B78B-05BFFF9E631F}"/>
               </a:ext>
             </a:extLst>
           </p:cNvPr>
@@ -4130,7 +4532,7 @@
           <p:cNvPr id="10" name="">
             <a:extLst xmlns:a="http://schemas.openxmlformats.org/drawingml/2006/main">
               <a:ext uri="{FF2B5EF4-FFF2-40B4-BE49-F238E27FC236}">
-                <a16:creationId xmlns:a16="http://schemas.microsoft.com/office/drawing/2014/main" id="{D289D85E-767F-4440-920B-3D49876A70F1}"/>
+                <a16:creationId xmlns:a16="http://schemas.microsoft.com/office/drawing/2014/main" id="{92264780-4677-4C96-AF56-C193C9833763}"/>
               </a:ext>
             </a:extLst>
           </p:cNvPr>
@@ -4180,7 +4582,7 @@
           <p:cNvPr id="11" name="">
             <a:extLst xmlns:a="http://schemas.openxmlformats.org/drawingml/2006/main">
               <a:ext uri="{FF2B5EF4-FFF2-40B4-BE49-F238E27FC236}">
-                <a16:creationId xmlns:a16="http://schemas.microsoft.com/office/drawing/2014/main" id="{C9914161-045C-4C05-9CC9-2ACB7023B031}"/>
+                <a16:creationId xmlns:a16="http://schemas.microsoft.com/office/drawing/2014/main" id="{E6E5551B-3A4B-4EF9-8100-2CC005A3D3D7}"/>
               </a:ext>
             </a:extLst>
           </p:cNvPr>
@@ -4192,7 +4594,7 @@
         <p:spPr>
           <a:xfrm xmlns:a="http://schemas.openxmlformats.org/drawingml/2006/main">
             <a:off x="3695700" y="2971800"/>
-            <a:ext cx="1990725" cy="323850"/>
+            <a:ext cx="1990725" cy="552450"/>
           </a:xfrm>
           <a:prstGeom xmlns:a="http://schemas.openxmlformats.org/drawingml/2006/main" prst="rect">
             <a:avLst/>
@@ -4230,7 +4632,7 @@
           <p:cNvPr id="12" name="">
             <a:extLst xmlns:a="http://schemas.openxmlformats.org/drawingml/2006/main">
               <a:ext uri="{FF2B5EF4-FFF2-40B4-BE49-F238E27FC236}">
-                <a16:creationId xmlns:a16="http://schemas.microsoft.com/office/drawing/2014/main" id="{C168FAA0-81EA-40C7-B5C5-576807DE6921}"/>
+                <a16:creationId xmlns:a16="http://schemas.microsoft.com/office/drawing/2014/main" id="{CE184D7A-E7A9-42F8-8F28-F0427547DCB2}"/>
               </a:ext>
             </a:extLst>
           </p:cNvPr>
@@ -4242,7 +4644,7 @@
         <p:spPr>
           <a:xfrm xmlns:a="http://schemas.openxmlformats.org/drawingml/2006/main">
             <a:off x="6229350" y="2152650"/>
-            <a:ext cx="2333625" cy="1200150"/>
+            <a:ext cx="2333625" cy="1428750"/>
           </a:xfrm>
           <a:prstGeom xmlns:a="http://schemas.openxmlformats.org/drawingml/2006/main" prst="rect">
             <a:avLst/>
@@ -4263,7 +4665,7 @@
           <p:cNvPr id="13" name="">
             <a:extLst xmlns:a="http://schemas.openxmlformats.org/drawingml/2006/main">
               <a:ext uri="{FF2B5EF4-FFF2-40B4-BE49-F238E27FC236}">
-                <a16:creationId xmlns:a16="http://schemas.microsoft.com/office/drawing/2014/main" id="{4246C54F-C939-44CB-B12F-E777AF3F485F}"/>
+                <a16:creationId xmlns:a16="http://schemas.microsoft.com/office/drawing/2014/main" id="{BE74687A-78B9-47C2-85C5-8EC20206CD92}"/>
               </a:ext>
             </a:extLst>
           </p:cNvPr>
@@ -4313,7 +4715,7 @@
           <p:cNvPr id="14" name="">
             <a:extLst xmlns:a="http://schemas.openxmlformats.org/drawingml/2006/main">
               <a:ext uri="{FF2B5EF4-FFF2-40B4-BE49-F238E27FC236}">
-                <a16:creationId xmlns:a16="http://schemas.microsoft.com/office/drawing/2014/main" id="{534BA515-B339-4C53-B80A-21E57E283A49}"/>
+                <a16:creationId xmlns:a16="http://schemas.microsoft.com/office/drawing/2014/main" id="{969C08B4-4571-49EC-BB16-E23F3E23FD8C}"/>
               </a:ext>
             </a:extLst>
           </p:cNvPr>
@@ -4363,7 +4765,7 @@
           <p:cNvPr id="15" name="">
             <a:extLst xmlns:a="http://schemas.openxmlformats.org/drawingml/2006/main">
               <a:ext uri="{FF2B5EF4-FFF2-40B4-BE49-F238E27FC236}">
-                <a16:creationId xmlns:a16="http://schemas.microsoft.com/office/drawing/2014/main" id="{3B2A0946-494D-478C-AABB-650D08EABCEE}"/>
+                <a16:creationId xmlns:a16="http://schemas.microsoft.com/office/drawing/2014/main" id="{009054D5-9C14-4B65-90A3-2A13C2032F38}"/>
               </a:ext>
             </a:extLst>
           </p:cNvPr>
@@ -4375,7 +4777,7 @@
         <p:spPr>
           <a:xfrm xmlns:a="http://schemas.openxmlformats.org/drawingml/2006/main">
             <a:off x="6400800" y="2971800"/>
-            <a:ext cx="1990725" cy="323850"/>
+            <a:ext cx="1990725" cy="552450"/>
           </a:xfrm>
           <a:prstGeom xmlns:a="http://schemas.openxmlformats.org/drawingml/2006/main" prst="rect">
             <a:avLst/>
@@ -4413,7 +4815,7 @@
           <p:cNvPr id="16" name="">
             <a:extLst xmlns:a="http://schemas.openxmlformats.org/drawingml/2006/main">
               <a:ext uri="{FF2B5EF4-FFF2-40B4-BE49-F238E27FC236}">
-                <a16:creationId xmlns:a16="http://schemas.microsoft.com/office/drawing/2014/main" id="{2C301819-07BA-4164-87F1-05CAF99C69F3}"/>
+                <a16:creationId xmlns:a16="http://schemas.microsoft.com/office/drawing/2014/main" id="{18B7F644-FE00-480F-AA59-BBD22705E3E9}"/>
               </a:ext>
             </a:extLst>
           </p:cNvPr>
@@ -4425,7 +4827,7 @@
         <p:spPr>
           <a:xfrm xmlns:a="http://schemas.openxmlformats.org/drawingml/2006/main">
             <a:off x="8934450" y="2152650"/>
-            <a:ext cx="2333625" cy="1200150"/>
+            <a:ext cx="2333625" cy="1428750"/>
           </a:xfrm>
           <a:prstGeom xmlns:a="http://schemas.openxmlformats.org/drawingml/2006/main" prst="rect">
             <a:avLst/>
@@ -4446,7 +4848,7 @@
           <p:cNvPr id="17" name="">
             <a:extLst xmlns:a="http://schemas.openxmlformats.org/drawingml/2006/main">
               <a:ext uri="{FF2B5EF4-FFF2-40B4-BE49-F238E27FC236}">
-                <a16:creationId xmlns:a16="http://schemas.microsoft.com/office/drawing/2014/main" id="{8CC08740-0A01-4C0C-9D92-27EDDA824070}"/>
+                <a16:creationId xmlns:a16="http://schemas.microsoft.com/office/drawing/2014/main" id="{5F1B45B4-CF71-410B-83B4-5FB2FDBFBC37}"/>
               </a:ext>
             </a:extLst>
           </p:cNvPr>
@@ -4496,7 +4898,7 @@
           <p:cNvPr id="18" name="">
             <a:extLst xmlns:a="http://schemas.openxmlformats.org/drawingml/2006/main">
               <a:ext uri="{FF2B5EF4-FFF2-40B4-BE49-F238E27FC236}">
-                <a16:creationId xmlns:a16="http://schemas.microsoft.com/office/drawing/2014/main" id="{E8FBA8DF-C648-4BC9-A4F5-5D8A119013C1}"/>
+                <a16:creationId xmlns:a16="http://schemas.microsoft.com/office/drawing/2014/main" id="{F20FB1DA-8365-49A2-A149-B952245BFF10}"/>
               </a:ext>
             </a:extLst>
           </p:cNvPr>
@@ -4546,7 +4948,7 @@
           <p:cNvPr id="19" name="">
             <a:extLst xmlns:a="http://schemas.openxmlformats.org/drawingml/2006/main">
               <a:ext uri="{FF2B5EF4-FFF2-40B4-BE49-F238E27FC236}">
-                <a16:creationId xmlns:a16="http://schemas.microsoft.com/office/drawing/2014/main" id="{3E482B9E-055E-4018-A6F8-7335BAFBE52B}"/>
+                <a16:creationId xmlns:a16="http://schemas.microsoft.com/office/drawing/2014/main" id="{A096E9ED-07A2-4F5C-86C2-EAD1F08475BC}"/>
               </a:ext>
             </a:extLst>
           </p:cNvPr>
@@ -4558,7 +4960,7 @@
         <p:spPr>
           <a:xfrm xmlns:a="http://schemas.openxmlformats.org/drawingml/2006/main">
             <a:off x="9105900" y="2971800"/>
-            <a:ext cx="1990725" cy="323850"/>
+            <a:ext cx="1990725" cy="552450"/>
           </a:xfrm>
           <a:prstGeom xmlns:a="http://schemas.openxmlformats.org/drawingml/2006/main" prst="rect">
             <a:avLst/>
@@ -4596,7 +4998,7 @@
           <p:cNvPr id="20" name="">
             <a:extLst xmlns:a="http://schemas.openxmlformats.org/drawingml/2006/main">
               <a:ext uri="{FF2B5EF4-FFF2-40B4-BE49-F238E27FC236}">
-                <a16:creationId xmlns:a16="http://schemas.microsoft.com/office/drawing/2014/main" id="{577B79E9-1BB6-4C1E-A96D-1790E0B2EE54}"/>
+                <a16:creationId xmlns:a16="http://schemas.microsoft.com/office/drawing/2014/main" id="{6219B49B-9873-4C54-9AD3-2C0C021463ED}"/>
               </a:ext>
             </a:extLst>
           </p:cNvPr>
@@ -4644,7 +5046,7 @@
     </p:spTree>
     <p:extLst>
       <p:ext uri="{BB962C8B-B14F-4D97-AF65-F5344CB8AC3E}">
-        <p14:creationId xmlns:p14="http://schemas.microsoft.com/office/powerpoint/2010/main" val="1722505646"/>
+        <p14:creationId xmlns:p14="http://schemas.microsoft.com/office/powerpoint/2010/main" val="1014400353"/>
       </p:ext>
     </p:extLst>
   </p:cSld>
@@ -4675,7 +5077,7 @@
           <p:cNvPr id="1" name="">
             <a:extLst xmlns:a="http://schemas.openxmlformats.org/drawingml/2006/main">
               <a:ext uri="{FF2B5EF4-FFF2-40B4-BE49-F238E27FC236}">
-                <a16:creationId xmlns:a16="http://schemas.microsoft.com/office/drawing/2014/main" id="{223799F1-D6BF-4BC1-93A5-BD6951CEC742}"/>
+                <a16:creationId xmlns:a16="http://schemas.microsoft.com/office/drawing/2014/main" id="{DFFEAB07-6A74-482F-BCB9-25BCB18B96DB}"/>
               </a:ext>
             </a:extLst>
           </p:cNvPr>
@@ -4725,7 +5127,7 @@
           <p:cNvPr id="2" name="">
             <a:extLst xmlns:a="http://schemas.openxmlformats.org/drawingml/2006/main">
               <a:ext uri="{FF2B5EF4-FFF2-40B4-BE49-F238E27FC236}">
-                <a16:creationId xmlns:a16="http://schemas.microsoft.com/office/drawing/2014/main" id="{6A34D0D8-8461-41CD-BD0B-0E16C6C85D76}"/>
+                <a16:creationId xmlns:a16="http://schemas.microsoft.com/office/drawing/2014/main" id="{E742E6A5-0500-4B7B-B6DC-6B5DA87421B9}"/>
               </a:ext>
             </a:extLst>
           </p:cNvPr>
@@ -4775,7 +5177,7 @@
           <p:cNvPr id="3" name="">
             <a:extLst xmlns:a="http://schemas.openxmlformats.org/drawingml/2006/main">
               <a:ext uri="{FF2B5EF4-FFF2-40B4-BE49-F238E27FC236}">
-                <a16:creationId xmlns:a16="http://schemas.microsoft.com/office/drawing/2014/main" id="{25761B01-669B-41B5-8EC0-D8DEC8317240}"/>
+                <a16:creationId xmlns:a16="http://schemas.microsoft.com/office/drawing/2014/main" id="{42B7F470-7E50-496C-A9B8-2D0CA4719876}"/>
               </a:ext>
             </a:extLst>
           </p:cNvPr>
@@ -4810,7 +5212,7 @@
           <p:nvPr/>
         </p:nvPicPr>
         <p:blipFill>
-          <a:blip xmlns:r="http://schemas.openxmlformats.org/officeDocument/2006/relationships" xmlns:a="http://schemas.openxmlformats.org/drawingml/2006/main" r:embed="Rdb4ccd48a1ef407b"/>
+          <a:blip xmlns:r="http://schemas.openxmlformats.org/officeDocument/2006/relationships" xmlns:a="http://schemas.openxmlformats.org/drawingml/2006/main" r:embed="R3199541267de4371"/>
           <a:stretch xmlns:a="http://schemas.openxmlformats.org/drawingml/2006/main"/>
         </p:blipFill>
         <p:spPr>
@@ -4828,7 +5230,7 @@
           <p:cNvPr id="5" name="">
             <a:extLst xmlns:a="http://schemas.openxmlformats.org/drawingml/2006/main">
               <a:ext uri="{FF2B5EF4-FFF2-40B4-BE49-F238E27FC236}">
-                <a16:creationId xmlns:a16="http://schemas.microsoft.com/office/drawing/2014/main" id="{D31C325D-BE86-44D5-8410-932A9DB6227A}"/>
+                <a16:creationId xmlns:a16="http://schemas.microsoft.com/office/drawing/2014/main" id="{584FFD6A-287D-4047-B123-CDBC09A39521}"/>
               </a:ext>
             </a:extLst>
           </p:cNvPr>
@@ -4878,7 +5280,7 @@
           <p:cNvPr id="6" name="">
             <a:extLst xmlns:a="http://schemas.openxmlformats.org/drawingml/2006/main">
               <a:ext uri="{FF2B5EF4-FFF2-40B4-BE49-F238E27FC236}">
-                <a16:creationId xmlns:a16="http://schemas.microsoft.com/office/drawing/2014/main" id="{56E8C882-7CB3-42D9-80C2-5A28F72CFBC6}"/>
+                <a16:creationId xmlns:a16="http://schemas.microsoft.com/office/drawing/2014/main" id="{7026A023-D6D0-4D66-B542-E0B9DA54D75B}"/>
               </a:ext>
             </a:extLst>
           </p:cNvPr>
@@ -4926,7 +5328,7 @@
     </p:spTree>
     <p:extLst>
       <p:ext uri="{BB962C8B-B14F-4D97-AF65-F5344CB8AC3E}">
-        <p14:creationId xmlns:p14="http://schemas.microsoft.com/office/powerpoint/2010/main" val="1009614114"/>
+        <p14:creationId xmlns:p14="http://schemas.microsoft.com/office/powerpoint/2010/main" val="89913412"/>
       </p:ext>
     </p:extLst>
   </p:cSld>
@@ -4957,7 +5359,7 @@
           <p:cNvPr id="1" name="">
             <a:extLst xmlns:a="http://schemas.openxmlformats.org/drawingml/2006/main">
               <a:ext uri="{FF2B5EF4-FFF2-40B4-BE49-F238E27FC236}">
-                <a16:creationId xmlns:a16="http://schemas.microsoft.com/office/drawing/2014/main" id="{6C634AD6-EF0A-4918-AEA4-BBF8C9881F9F}"/>
+                <a16:creationId xmlns:a16="http://schemas.microsoft.com/office/drawing/2014/main" id="{442D9A59-504B-460E-95C1-75AA28CB624D}"/>
               </a:ext>
             </a:extLst>
           </p:cNvPr>
@@ -5007,7 +5409,7 @@
           <p:cNvPr id="2" name="">
             <a:extLst xmlns:a="http://schemas.openxmlformats.org/drawingml/2006/main">
               <a:ext uri="{FF2B5EF4-FFF2-40B4-BE49-F238E27FC236}">
-                <a16:creationId xmlns:a16="http://schemas.microsoft.com/office/drawing/2014/main" id="{4589C4A9-22E5-4BA8-8646-7ECB09F8273D}"/>
+                <a16:creationId xmlns:a16="http://schemas.microsoft.com/office/drawing/2014/main" id="{3694F35A-D713-4214-B030-70BD6B4ADF65}"/>
               </a:ext>
             </a:extLst>
           </p:cNvPr>
@@ -5057,7 +5459,7 @@
           <p:cNvPr id="3" name="">
             <a:extLst xmlns:a="http://schemas.openxmlformats.org/drawingml/2006/main">
               <a:ext uri="{FF2B5EF4-FFF2-40B4-BE49-F238E27FC236}">
-                <a16:creationId xmlns:a16="http://schemas.microsoft.com/office/drawing/2014/main" id="{05D8BBAD-784A-4C55-AD4C-530DA7210E76}"/>
+                <a16:creationId xmlns:a16="http://schemas.microsoft.com/office/drawing/2014/main" id="{32146D89-AF59-4B09-B036-48F8C8021EE7}"/>
               </a:ext>
             </a:extLst>
           </p:cNvPr>
@@ -5092,7 +5494,7 @@
           <p:nvPr/>
         </p:nvPicPr>
         <p:blipFill>
-          <a:blip xmlns:r="http://schemas.openxmlformats.org/officeDocument/2006/relationships" xmlns:a="http://schemas.openxmlformats.org/drawingml/2006/main" r:embed="R3d44d20a57bd4082"/>
+          <a:blip xmlns:r="http://schemas.openxmlformats.org/officeDocument/2006/relationships" xmlns:a="http://schemas.openxmlformats.org/drawingml/2006/main" r:embed="R82e98b5ef37c4671"/>
           <a:stretch xmlns:a="http://schemas.openxmlformats.org/drawingml/2006/main"/>
         </p:blipFill>
         <p:spPr>
@@ -5110,7 +5512,7 @@
           <p:cNvPr id="5" name="">
             <a:extLst xmlns:a="http://schemas.openxmlformats.org/drawingml/2006/main">
               <a:ext uri="{FF2B5EF4-FFF2-40B4-BE49-F238E27FC236}">
-                <a16:creationId xmlns:a16="http://schemas.microsoft.com/office/drawing/2014/main" id="{73DA46D4-0353-4A50-9CB7-4EDB70E56449}"/>
+                <a16:creationId xmlns:a16="http://schemas.microsoft.com/office/drawing/2014/main" id="{D5F9B0B7-A021-4DCB-97D7-605D7CC12044}"/>
               </a:ext>
             </a:extLst>
           </p:cNvPr>
@@ -5160,7 +5562,7 @@
           <p:cNvPr id="6" name="">
             <a:extLst xmlns:a="http://schemas.openxmlformats.org/drawingml/2006/main">
               <a:ext uri="{FF2B5EF4-FFF2-40B4-BE49-F238E27FC236}">
-                <a16:creationId xmlns:a16="http://schemas.microsoft.com/office/drawing/2014/main" id="{885340DF-2D6C-47CE-8A1A-E075562DF56A}"/>
+                <a16:creationId xmlns:a16="http://schemas.microsoft.com/office/drawing/2014/main" id="{F1B34223-F11B-4060-8668-16E6B1B995B6}"/>
               </a:ext>
             </a:extLst>
           </p:cNvPr>
@@ -5208,7 +5610,7 @@
     </p:spTree>
     <p:extLst>
       <p:ext uri="{BB962C8B-B14F-4D97-AF65-F5344CB8AC3E}">
-        <p14:creationId xmlns:p14="http://schemas.microsoft.com/office/powerpoint/2010/main" val="1178976824"/>
+        <p14:creationId xmlns:p14="http://schemas.microsoft.com/office/powerpoint/2010/main" val="1883694481"/>
       </p:ext>
     </p:extLst>
   </p:cSld>
@@ -5239,7 +5641,7 @@
           <p:cNvPr id="1" name="">
             <a:extLst xmlns:a="http://schemas.openxmlformats.org/drawingml/2006/main">
               <a:ext uri="{FF2B5EF4-FFF2-40B4-BE49-F238E27FC236}">
-                <a16:creationId xmlns:a16="http://schemas.microsoft.com/office/drawing/2014/main" id="{267BF6E0-143E-42B9-8D8A-A902B14E8C20}"/>
+                <a16:creationId xmlns:a16="http://schemas.microsoft.com/office/drawing/2014/main" id="{7084002D-9CB1-4E18-900B-ABF9BE045AF5}"/>
               </a:ext>
             </a:extLst>
           </p:cNvPr>
@@ -5289,7 +5691,7 @@
           <p:cNvPr id="2" name="">
             <a:extLst xmlns:a="http://schemas.openxmlformats.org/drawingml/2006/main">
               <a:ext uri="{FF2B5EF4-FFF2-40B4-BE49-F238E27FC236}">
-                <a16:creationId xmlns:a16="http://schemas.microsoft.com/office/drawing/2014/main" id="{27DF5611-408C-4B57-AF5B-15B7B5F2B405}"/>
+                <a16:creationId xmlns:a16="http://schemas.microsoft.com/office/drawing/2014/main" id="{031D970B-BBFA-41C3-B4E6-04E8CDCCB151}"/>
               </a:ext>
             </a:extLst>
           </p:cNvPr>
@@ -5339,7 +5741,7 @@
           <p:cNvPr id="3" name="">
             <a:extLst xmlns:a="http://schemas.openxmlformats.org/drawingml/2006/main">
               <a:ext uri="{FF2B5EF4-FFF2-40B4-BE49-F238E27FC236}">
-                <a16:creationId xmlns:a16="http://schemas.microsoft.com/office/drawing/2014/main" id="{467C111F-3567-4A5A-829D-0E25ACC75EDA}"/>
+                <a16:creationId xmlns:a16="http://schemas.microsoft.com/office/drawing/2014/main" id="{34509383-1AC5-43C1-8431-7D85E95D2FBB}"/>
               </a:ext>
             </a:extLst>
           </p:cNvPr>
@@ -5374,7 +5776,7 @@
           <p:nvPr/>
         </p:nvPicPr>
         <p:blipFill>
-          <a:blip xmlns:r="http://schemas.openxmlformats.org/officeDocument/2006/relationships" xmlns:a="http://schemas.openxmlformats.org/drawingml/2006/main" r:embed="R3bb354eaefd94b65"/>
+          <a:blip xmlns:r="http://schemas.openxmlformats.org/officeDocument/2006/relationships" xmlns:a="http://schemas.openxmlformats.org/drawingml/2006/main" r:embed="Rbfc5507bbc3f42a1"/>
           <a:stretch xmlns:a="http://schemas.openxmlformats.org/drawingml/2006/main"/>
         </p:blipFill>
         <p:spPr>
@@ -5396,7 +5798,7 @@
           <p:nvPr/>
         </p:nvPicPr>
         <p:blipFill>
-          <a:blip xmlns:r="http://schemas.openxmlformats.org/officeDocument/2006/relationships" xmlns:a="http://schemas.openxmlformats.org/drawingml/2006/main" r:embed="R7c7901c779094e86"/>
+          <a:blip xmlns:r="http://schemas.openxmlformats.org/officeDocument/2006/relationships" xmlns:a="http://schemas.openxmlformats.org/drawingml/2006/main" r:embed="Rb30187a4fa2c4d77"/>
           <a:stretch xmlns:a="http://schemas.openxmlformats.org/drawingml/2006/main"/>
         </p:blipFill>
         <p:spPr>
@@ -5414,7 +5816,7 @@
           <p:cNvPr id="6" name="">
             <a:extLst xmlns:a="http://schemas.openxmlformats.org/drawingml/2006/main">
               <a:ext uri="{FF2B5EF4-FFF2-40B4-BE49-F238E27FC236}">
-                <a16:creationId xmlns:a16="http://schemas.microsoft.com/office/drawing/2014/main" id="{32515E30-2D23-42CE-A7B4-559F846E6F2D}"/>
+                <a16:creationId xmlns:a16="http://schemas.microsoft.com/office/drawing/2014/main" id="{CCA7F3D0-81B4-4E46-9925-29F41E116426}"/>
               </a:ext>
             </a:extLst>
           </p:cNvPr>
@@ -5462,7 +5864,7 @@
     </p:spTree>
     <p:extLst>
       <p:ext uri="{BB962C8B-B14F-4D97-AF65-F5344CB8AC3E}">
-        <p14:creationId xmlns:p14="http://schemas.microsoft.com/office/powerpoint/2010/main" val="1806072866"/>
+        <p14:creationId xmlns:p14="http://schemas.microsoft.com/office/powerpoint/2010/main" val="214338291"/>
       </p:ext>
     </p:extLst>
   </p:cSld>
@@ -5493,7 +5895,7 @@
           <p:cNvPr id="1" name="">
             <a:extLst xmlns:a="http://schemas.openxmlformats.org/drawingml/2006/main">
               <a:ext uri="{FF2B5EF4-FFF2-40B4-BE49-F238E27FC236}">
-                <a16:creationId xmlns:a16="http://schemas.microsoft.com/office/drawing/2014/main" id="{642CA9DE-E36F-4458-B86D-7DBD6C3E34C9}"/>
+                <a16:creationId xmlns:a16="http://schemas.microsoft.com/office/drawing/2014/main" id="{FD89FFC0-65E4-47C6-938B-8D5E0E52B3BE}"/>
               </a:ext>
             </a:extLst>
           </p:cNvPr>
@@ -5543,7 +5945,7 @@
           <p:cNvPr id="2" name="">
             <a:extLst xmlns:a="http://schemas.openxmlformats.org/drawingml/2006/main">
               <a:ext uri="{FF2B5EF4-FFF2-40B4-BE49-F238E27FC236}">
-                <a16:creationId xmlns:a16="http://schemas.microsoft.com/office/drawing/2014/main" id="{FAB409D2-306A-4801-BA1E-2B9398E43528}"/>
+                <a16:creationId xmlns:a16="http://schemas.microsoft.com/office/drawing/2014/main" id="{B7D6939B-0C66-4ADB-A6A6-887B95EF5089}"/>
               </a:ext>
             </a:extLst>
           </p:cNvPr>
@@ -5593,7 +5995,7 @@
           <p:cNvPr id="3" name="">
             <a:extLst xmlns:a="http://schemas.openxmlformats.org/drawingml/2006/main">
               <a:ext uri="{FF2B5EF4-FFF2-40B4-BE49-F238E27FC236}">
-                <a16:creationId xmlns:a16="http://schemas.microsoft.com/office/drawing/2014/main" id="{5AEF41AD-3F7C-44BF-BA72-34B85539F54E}"/>
+                <a16:creationId xmlns:a16="http://schemas.microsoft.com/office/drawing/2014/main" id="{9D9ED347-0490-4E2C-AE4C-644A213E9CDA}"/>
               </a:ext>
             </a:extLst>
           </p:cNvPr>
@@ -5628,7 +6030,7 @@
           <p:nvPr/>
         </p:nvPicPr>
         <p:blipFill>
-          <a:blip xmlns:r="http://schemas.openxmlformats.org/officeDocument/2006/relationships" xmlns:a="http://schemas.openxmlformats.org/drawingml/2006/main" r:embed="R56ce0e7682184027"/>
+          <a:blip xmlns:r="http://schemas.openxmlformats.org/officeDocument/2006/relationships" xmlns:a="http://schemas.openxmlformats.org/drawingml/2006/main" r:embed="Rf914140a42104ff2"/>
           <a:stretch xmlns:a="http://schemas.openxmlformats.org/drawingml/2006/main"/>
         </p:blipFill>
         <p:spPr>
@@ -5646,7 +6048,7 @@
           <p:cNvPr id="5" name="">
             <a:extLst xmlns:a="http://schemas.openxmlformats.org/drawingml/2006/main">
               <a:ext uri="{FF2B5EF4-FFF2-40B4-BE49-F238E27FC236}">
-                <a16:creationId xmlns:a16="http://schemas.microsoft.com/office/drawing/2014/main" id="{16F48DE2-BBCC-4DA0-99D7-98119485A152}"/>
+                <a16:creationId xmlns:a16="http://schemas.microsoft.com/office/drawing/2014/main" id="{D309C644-BB0C-4E78-95DC-FA37C91BF075}"/>
               </a:ext>
             </a:extLst>
           </p:cNvPr>
@@ -5696,7 +6098,7 @@
           <p:cNvPr id="6" name="">
             <a:extLst xmlns:a="http://schemas.openxmlformats.org/drawingml/2006/main">
               <a:ext uri="{FF2B5EF4-FFF2-40B4-BE49-F238E27FC236}">
-                <a16:creationId xmlns:a16="http://schemas.microsoft.com/office/drawing/2014/main" id="{33D6C3B4-8EB8-4551-840A-454ECA07CC94}"/>
+                <a16:creationId xmlns:a16="http://schemas.microsoft.com/office/drawing/2014/main" id="{A5F4AEB9-4EE4-480A-8EEB-FF6DDCF23B94}"/>
               </a:ext>
             </a:extLst>
           </p:cNvPr>
@@ -5744,7 +6146,7 @@
     </p:spTree>
     <p:extLst>
       <p:ext uri="{BB962C8B-B14F-4D97-AF65-F5344CB8AC3E}">
-        <p14:creationId xmlns:p14="http://schemas.microsoft.com/office/powerpoint/2010/main" val="1372516781"/>
+        <p14:creationId xmlns:p14="http://schemas.microsoft.com/office/powerpoint/2010/main" val="1428667124"/>
       </p:ext>
     </p:extLst>
   </p:cSld>
@@ -5775,7 +6177,7 @@
           <p:cNvPr id="1" name="">
             <a:extLst xmlns:a="http://schemas.openxmlformats.org/drawingml/2006/main">
               <a:ext uri="{FF2B5EF4-FFF2-40B4-BE49-F238E27FC236}">
-                <a16:creationId xmlns:a16="http://schemas.microsoft.com/office/drawing/2014/main" id="{B70F0E02-B4B5-495B-9E85-6D703003DEED}"/>
+                <a16:creationId xmlns:a16="http://schemas.microsoft.com/office/drawing/2014/main" id="{19C03A69-E0D5-4558-B92A-3E78C3DF8EE6}"/>
               </a:ext>
             </a:extLst>
           </p:cNvPr>
@@ -5825,7 +6227,7 @@
           <p:cNvPr id="2" name="">
             <a:extLst xmlns:a="http://schemas.openxmlformats.org/drawingml/2006/main">
               <a:ext uri="{FF2B5EF4-FFF2-40B4-BE49-F238E27FC236}">
-                <a16:creationId xmlns:a16="http://schemas.microsoft.com/office/drawing/2014/main" id="{CF831CC8-E204-4CDB-B3A3-A5BD45E5E571}"/>
+                <a16:creationId xmlns:a16="http://schemas.microsoft.com/office/drawing/2014/main" id="{31484649-EC46-4AE9-9598-2F8C8D900941}"/>
               </a:ext>
             </a:extLst>
           </p:cNvPr>
@@ -5875,7 +6277,7 @@
           <p:cNvPr id="3" name="">
             <a:extLst xmlns:a="http://schemas.openxmlformats.org/drawingml/2006/main">
               <a:ext uri="{FF2B5EF4-FFF2-40B4-BE49-F238E27FC236}">
-                <a16:creationId xmlns:a16="http://schemas.microsoft.com/office/drawing/2014/main" id="{69B448A7-543C-46F8-BF47-33BDCEE7D56E}"/>
+                <a16:creationId xmlns:a16="http://schemas.microsoft.com/office/drawing/2014/main" id="{E0562B35-8C1F-42AE-9584-4D47D85908CE}"/>
               </a:ext>
             </a:extLst>
           </p:cNvPr>
@@ -5906,7 +6308,7 @@
           <p:cNvPr id="4" name="">
             <a:extLst xmlns:a="http://schemas.openxmlformats.org/drawingml/2006/main">
               <a:ext uri="{FF2B5EF4-FFF2-40B4-BE49-F238E27FC236}">
-                <a16:creationId xmlns:a16="http://schemas.microsoft.com/office/drawing/2014/main" id="{5C1A2757-358E-4795-AF5B-FD84C9FD8433}"/>
+                <a16:creationId xmlns:a16="http://schemas.microsoft.com/office/drawing/2014/main" id="{3DFAE681-AEEF-4D4A-BD13-6346AA5695B9}"/>
               </a:ext>
             </a:extLst>
           </p:cNvPr>
@@ -5956,7 +6358,7 @@
           <p:cNvPr id="5" name="">
             <a:extLst xmlns:a="http://schemas.openxmlformats.org/drawingml/2006/main">
               <a:ext uri="{FF2B5EF4-FFF2-40B4-BE49-F238E27FC236}">
-                <a16:creationId xmlns:a16="http://schemas.microsoft.com/office/drawing/2014/main" id="{84E21A71-3346-4484-B58D-C43DDED0DAE6}"/>
+                <a16:creationId xmlns:a16="http://schemas.microsoft.com/office/drawing/2014/main" id="{121D3E9E-B15C-4CEB-AF0A-FA55243C0635}"/>
               </a:ext>
             </a:extLst>
           </p:cNvPr>
@@ -6006,7 +6408,7 @@
           <p:cNvPr id="6" name="">
             <a:extLst xmlns:a="http://schemas.openxmlformats.org/drawingml/2006/main">
               <a:ext uri="{FF2B5EF4-FFF2-40B4-BE49-F238E27FC236}">
-                <a16:creationId xmlns:a16="http://schemas.microsoft.com/office/drawing/2014/main" id="{017FD423-A7FB-4B1D-94AF-B8F783EEA01E}"/>
+                <a16:creationId xmlns:a16="http://schemas.microsoft.com/office/drawing/2014/main" id="{2E3959AD-9F29-4594-9BE8-9BECC6246A02}"/>
               </a:ext>
             </a:extLst>
           </p:cNvPr>
@@ -6056,7 +6458,7 @@
           <p:cNvPr id="7" name="">
             <a:extLst xmlns:a="http://schemas.openxmlformats.org/drawingml/2006/main">
               <a:ext uri="{FF2B5EF4-FFF2-40B4-BE49-F238E27FC236}">
-                <a16:creationId xmlns:a16="http://schemas.microsoft.com/office/drawing/2014/main" id="{355CCE95-6906-441B-AB28-8A5100E63196}"/>
+                <a16:creationId xmlns:a16="http://schemas.microsoft.com/office/drawing/2014/main" id="{CBF60CA4-5420-400E-B6C4-86E131DB6982}"/>
               </a:ext>
             </a:extLst>
           </p:cNvPr>
@@ -6106,7 +6508,7 @@
           <p:cNvPr id="8" name="">
             <a:extLst xmlns:a="http://schemas.openxmlformats.org/drawingml/2006/main">
               <a:ext uri="{FF2B5EF4-FFF2-40B4-BE49-F238E27FC236}">
-                <a16:creationId xmlns:a16="http://schemas.microsoft.com/office/drawing/2014/main" id="{6EE7B62B-1697-47D3-A422-CCD27A606808}"/>
+                <a16:creationId xmlns:a16="http://schemas.microsoft.com/office/drawing/2014/main" id="{B5E6935C-555F-4656-AB6E-8FBEC6C969C4}"/>
               </a:ext>
             </a:extLst>
           </p:cNvPr>
@@ -6156,7 +6558,7 @@
           <p:cNvPr id="9" name="">
             <a:extLst xmlns:a="http://schemas.openxmlformats.org/drawingml/2006/main">
               <a:ext uri="{FF2B5EF4-FFF2-40B4-BE49-F238E27FC236}">
-                <a16:creationId xmlns:a16="http://schemas.microsoft.com/office/drawing/2014/main" id="{CE139752-EEE6-475C-AF2B-BD0455694AED}"/>
+                <a16:creationId xmlns:a16="http://schemas.microsoft.com/office/drawing/2014/main" id="{1E751A89-82DA-4B25-8160-83C87B76F734}"/>
               </a:ext>
             </a:extLst>
           </p:cNvPr>
@@ -6206,7 +6608,7 @@
           <p:cNvPr id="10" name="">
             <a:extLst xmlns:a="http://schemas.openxmlformats.org/drawingml/2006/main">
               <a:ext uri="{FF2B5EF4-FFF2-40B4-BE49-F238E27FC236}">
-                <a16:creationId xmlns:a16="http://schemas.microsoft.com/office/drawing/2014/main" id="{36265261-C1F9-4417-93DE-B3199706EB62}"/>
+                <a16:creationId xmlns:a16="http://schemas.microsoft.com/office/drawing/2014/main" id="{81B6EE59-C676-4EA8-A9CB-0D965DF5026E}"/>
               </a:ext>
             </a:extLst>
           </p:cNvPr>
@@ -6256,7 +6658,7 @@
           <p:cNvPr id="11" name="">
             <a:extLst xmlns:a="http://schemas.openxmlformats.org/drawingml/2006/main">
               <a:ext uri="{FF2B5EF4-FFF2-40B4-BE49-F238E27FC236}">
-                <a16:creationId xmlns:a16="http://schemas.microsoft.com/office/drawing/2014/main" id="{7725340E-E51E-4B3E-84C3-015B5152A235}"/>
+                <a16:creationId xmlns:a16="http://schemas.microsoft.com/office/drawing/2014/main" id="{468D56C0-EAE6-4F22-A248-715C4652467B}"/>
               </a:ext>
             </a:extLst>
           </p:cNvPr>
@@ -6306,7 +6708,7 @@
           <p:cNvPr id="12" name="">
             <a:extLst xmlns:a="http://schemas.openxmlformats.org/drawingml/2006/main">
               <a:ext uri="{FF2B5EF4-FFF2-40B4-BE49-F238E27FC236}">
-                <a16:creationId xmlns:a16="http://schemas.microsoft.com/office/drawing/2014/main" id="{53AFDD3D-0A17-4F21-9F6D-0A16A249F7A1}"/>
+                <a16:creationId xmlns:a16="http://schemas.microsoft.com/office/drawing/2014/main" id="{22499567-7C26-4CC2-8890-C2BD041627BF}"/>
               </a:ext>
             </a:extLst>
           </p:cNvPr>
@@ -6354,7 +6756,1290 @@
     </p:spTree>
     <p:extLst>
       <p:ext uri="{BB962C8B-B14F-4D97-AF65-F5344CB8AC3E}">
-        <p14:creationId xmlns:p14="http://schemas.microsoft.com/office/powerpoint/2010/main" val="1600121359"/>
+        <p14:creationId xmlns:p14="http://schemas.microsoft.com/office/powerpoint/2010/main" val="708450153"/>
+      </p:ext>
+    </p:extLst>
+  </p:cSld>
+</p:sld>
+</file>
+
+<file path=ppt/slides/slide18.xml><?xml version="1.0" encoding="utf-8"?>
+<p:sld xmlns:p="http://schemas.openxmlformats.org/presentationml/2006/main">
+  <p:cSld>
+    <p:bg>
+      <p:bgPr>
+        <a:solidFill xmlns:a="http://schemas.openxmlformats.org/drawingml/2006/main">
+          <a:srgbClr val="FFFFFF"/>
+        </a:solidFill>
+      </p:bgPr>
+    </p:bg>
+    <p:spTree>
+      <p:nvGrpSpPr>
+        <p:cNvPr id="1" name=""/>
+        <p:cNvGrpSpPr/>
+        <p:nvPr/>
+      </p:nvGrpSpPr>
+      <p:grpSpPr>
+        <a:xfrm xmlns:a="http://schemas.openxmlformats.org/drawingml/2006/main"/>
+      </p:grpSpPr>
+      <p:sp>
+        <p:nvSpPr>
+          <p:cNvPr id="1" name="">
+            <a:extLst xmlns:a="http://schemas.openxmlformats.org/drawingml/2006/main">
+              <a:ext uri="{FF2B5EF4-FFF2-40B4-BE49-F238E27FC236}">
+                <a16:creationId xmlns:a16="http://schemas.microsoft.com/office/drawing/2014/main" id="{34E8EC29-958E-478F-BFBE-157BB981A44E}"/>
+              </a:ext>
+            </a:extLst>
+          </p:cNvPr>
+          <p:cNvSpPr>
+            <a:spLocks xmlns:a="http://schemas.openxmlformats.org/drawingml/2006/main" noGrp="1"/>
+          </p:cNvSpPr>
+          <p:nvPr/>
+        </p:nvSpPr>
+        <p:spPr>
+          <a:xfrm xmlns:a="http://schemas.openxmlformats.org/drawingml/2006/main">
+            <a:off x="685800" y="495300"/>
+            <a:ext cx="4762500" cy="419100"/>
+          </a:xfrm>
+          <a:prstGeom xmlns:a="http://schemas.openxmlformats.org/drawingml/2006/main" prst="rect">
+            <a:avLst/>
+          </a:prstGeom>
+          <a:noFill xmlns:a="http://schemas.openxmlformats.org/drawingml/2006/main"/>
+          <a:ln xmlns:a="http://schemas.openxmlformats.org/drawingml/2006/main" w="0">
+            <a:noFill/>
+            <a:prstDash val="solid"/>
+          </a:ln>
+        </p:spPr>
+        <p:txBody>
+          <a:bodyPr xmlns:a="http://schemas.openxmlformats.org/drawingml/2006/main"/>
+          <a:lstStyle xmlns:a="http://schemas.openxmlformats.org/drawingml/2006/main"/>
+          <a:p xmlns:a="http://schemas.openxmlformats.org/drawingml/2006/main">
+            <a:pPr algn="l">
+              <a:defRPr sz="2400" b="1" i="0">
+                <a:solidFill>
+                  <a:srgbClr val="555555"/>
+                </a:solidFill>
+              </a:defRPr>
+            </a:pPr>
+            <a:r>
+              <a:rPr sz="2400" b="1" i="0">
+                <a:solidFill>
+                  <a:srgbClr val="555555"/>
+                </a:solidFill>
+              </a:rPr>
+              <a:t>Transition</a:t>
+            </a:r>
+          </a:p>
+        </p:txBody>
+      </p:sp>
+      <p:sp>
+        <p:nvSpPr>
+          <p:cNvPr id="2" name="">
+            <a:extLst xmlns:a="http://schemas.openxmlformats.org/drawingml/2006/main">
+              <a:ext uri="{FF2B5EF4-FFF2-40B4-BE49-F238E27FC236}">
+                <a16:creationId xmlns:a16="http://schemas.microsoft.com/office/drawing/2014/main" id="{F0E955BF-E15D-47A3-9BA9-7C4478E5BF56}"/>
+              </a:ext>
+            </a:extLst>
+          </p:cNvPr>
+          <p:cNvSpPr>
+            <a:spLocks xmlns:a="http://schemas.openxmlformats.org/drawingml/2006/main" noGrp="1"/>
+          </p:cNvSpPr>
+          <p:nvPr/>
+        </p:nvSpPr>
+        <p:spPr>
+          <a:xfrm xmlns:a="http://schemas.openxmlformats.org/drawingml/2006/main">
+            <a:off x="685800" y="1600200"/>
+            <a:ext cx="8572500" cy="876300"/>
+          </a:xfrm>
+          <a:prstGeom xmlns:a="http://schemas.openxmlformats.org/drawingml/2006/main" prst="rect">
+            <a:avLst/>
+          </a:prstGeom>
+          <a:noFill xmlns:a="http://schemas.openxmlformats.org/drawingml/2006/main"/>
+          <a:ln xmlns:a="http://schemas.openxmlformats.org/drawingml/2006/main" w="0">
+            <a:noFill/>
+            <a:prstDash val="solid"/>
+          </a:ln>
+        </p:spPr>
+        <p:txBody>
+          <a:bodyPr xmlns:a="http://schemas.openxmlformats.org/drawingml/2006/main"/>
+          <a:lstStyle xmlns:a="http://schemas.openxmlformats.org/drawingml/2006/main"/>
+          <a:p xmlns:a="http://schemas.openxmlformats.org/drawingml/2006/main">
+            <a:pPr algn="l">
+              <a:defRPr sz="3900" b="1" i="0">
+                <a:solidFill>
+                  <a:srgbClr val="000000"/>
+                </a:solidFill>
+              </a:defRPr>
+            </a:pPr>
+            <a:r>
+              <a:rPr sz="3900" b="1" i="0">
+                <a:solidFill>
+                  <a:srgbClr val="000000"/>
+                </a:solidFill>
+              </a:rPr>
+              <a:t>Threshold policy is the first decision layer to audit</a:t>
+            </a:r>
+          </a:p>
+        </p:txBody>
+      </p:sp>
+      <p:sp>
+        <p:nvSpPr>
+          <p:cNvPr id="3" name="">
+            <a:extLst xmlns:a="http://schemas.openxmlformats.org/drawingml/2006/main">
+              <a:ext uri="{FF2B5EF4-FFF2-40B4-BE49-F238E27FC236}">
+                <a16:creationId xmlns:a16="http://schemas.microsoft.com/office/drawing/2014/main" id="{C2144B4B-2DAE-405D-8314-B2CCEAE0B943}"/>
+              </a:ext>
+            </a:extLst>
+          </p:cNvPr>
+          <p:cNvSpPr>
+            <a:spLocks xmlns:a="http://schemas.openxmlformats.org/drawingml/2006/main" noGrp="1"/>
+          </p:cNvSpPr>
+          <p:nvPr/>
+        </p:nvSpPr>
+        <p:spPr>
+          <a:xfrm xmlns:a="http://schemas.openxmlformats.org/drawingml/2006/main">
+            <a:off x="723900" y="3105150"/>
+            <a:ext cx="5715000" cy="19050"/>
+          </a:xfrm>
+          <a:prstGeom xmlns:a="http://schemas.openxmlformats.org/drawingml/2006/main" prst="rect">
+            <a:avLst/>
+          </a:prstGeom>
+          <a:solidFill xmlns:a="http://schemas.openxmlformats.org/drawingml/2006/main">
+            <a:srgbClr val="B8BCC4"/>
+          </a:solidFill>
+          <a:ln xmlns:a="http://schemas.openxmlformats.org/drawingml/2006/main" w="0">
+            <a:noFill/>
+            <a:prstDash val="solid"/>
+          </a:ln>
+        </p:spPr>
+      </p:sp>
+      <p:sp>
+        <p:nvSpPr>
+          <p:cNvPr id="4" name="">
+            <a:extLst xmlns:a="http://schemas.openxmlformats.org/drawingml/2006/main">
+              <a:ext uri="{FF2B5EF4-FFF2-40B4-BE49-F238E27FC236}">
+                <a16:creationId xmlns:a16="http://schemas.microsoft.com/office/drawing/2014/main" id="{2BBEFD98-4ADB-4CB2-9B9A-644485754F61}"/>
+              </a:ext>
+            </a:extLst>
+          </p:cNvPr>
+          <p:cNvSpPr>
+            <a:spLocks xmlns:a="http://schemas.openxmlformats.org/drawingml/2006/main" noGrp="1"/>
+          </p:cNvSpPr>
+          <p:nvPr/>
+        </p:nvSpPr>
+        <p:spPr>
+          <a:xfrm xmlns:a="http://schemas.openxmlformats.org/drawingml/2006/main">
+            <a:off x="723900" y="3467100"/>
+            <a:ext cx="7524750" cy="1066800"/>
+          </a:xfrm>
+          <a:prstGeom xmlns:a="http://schemas.openxmlformats.org/drawingml/2006/main" prst="rect">
+            <a:avLst/>
+          </a:prstGeom>
+          <a:noFill xmlns:a="http://schemas.openxmlformats.org/drawingml/2006/main"/>
+          <a:ln xmlns:a="http://schemas.openxmlformats.org/drawingml/2006/main" w="0">
+            <a:noFill/>
+            <a:prstDash val="solid"/>
+          </a:ln>
+        </p:spPr>
+        <p:txBody>
+          <a:bodyPr xmlns:a="http://schemas.openxmlformats.org/drawingml/2006/main"/>
+          <a:lstStyle xmlns:a="http://schemas.openxmlformats.org/drawingml/2006/main"/>
+          <a:p xmlns:a="http://schemas.openxmlformats.org/drawingml/2006/main">
+            <a:pPr algn="l">
+              <a:defRPr sz="1800" b="0" i="0">
+                <a:solidFill>
+                  <a:srgbClr val="222222"/>
+                </a:solidFill>
+              </a:defRPr>
+            </a:pPr>
+            <a:r>
+              <a:rPr sz="1800" b="0" i="0">
+                <a:solidFill>
+                  <a:srgbClr val="222222"/>
+                </a:solidFill>
+              </a:rPr>
+              <a:t>ML-P1b keeps the GLM fixed and changes only the rule that converts probability into long/flat exposure. Thresholds are chosen before OOS replay using TRAIN data only.</a:t>
+            </a:r>
+          </a:p>
+        </p:txBody>
+      </p:sp>
+      <p:sp>
+        <p:nvSpPr>
+          <p:cNvPr id="5" name="">
+            <a:extLst xmlns:a="http://schemas.openxmlformats.org/drawingml/2006/main">
+              <a:ext uri="{FF2B5EF4-FFF2-40B4-BE49-F238E27FC236}">
+                <a16:creationId xmlns:a16="http://schemas.microsoft.com/office/drawing/2014/main" id="{53B0E8F9-2E9C-455B-9EC0-39A65E836BAA}"/>
+              </a:ext>
+            </a:extLst>
+          </p:cNvPr>
+          <p:cNvSpPr>
+            <a:spLocks xmlns:a="http://schemas.openxmlformats.org/drawingml/2006/main" noGrp="1"/>
+          </p:cNvSpPr>
+          <p:nvPr/>
+        </p:nvSpPr>
+        <p:spPr>
+          <a:xfrm xmlns:a="http://schemas.openxmlformats.org/drawingml/2006/main">
+            <a:off x="8801100" y="0"/>
+            <a:ext cx="3390900" cy="6858000"/>
+          </a:xfrm>
+          <a:prstGeom xmlns:a="http://schemas.openxmlformats.org/drawingml/2006/main" prst="rect">
+            <a:avLst/>
+          </a:prstGeom>
+          <a:solidFill xmlns:a="http://schemas.openxmlformats.org/drawingml/2006/main">
+            <a:srgbClr val="EDEDED"/>
+          </a:solidFill>
+          <a:ln xmlns:a="http://schemas.openxmlformats.org/drawingml/2006/main" w="0">
+            <a:noFill/>
+            <a:prstDash val="solid"/>
+          </a:ln>
+        </p:spPr>
+      </p:sp>
+      <p:sp>
+        <p:nvSpPr>
+          <p:cNvPr id="6" name="">
+            <a:extLst xmlns:a="http://schemas.openxmlformats.org/drawingml/2006/main">
+              <a:ext uri="{FF2B5EF4-FFF2-40B4-BE49-F238E27FC236}">
+                <a16:creationId xmlns:a16="http://schemas.microsoft.com/office/drawing/2014/main" id="{9C834491-50DD-49A3-BC25-70465B35FBBE}"/>
+              </a:ext>
+            </a:extLst>
+          </p:cNvPr>
+          <p:cNvSpPr>
+            <a:spLocks xmlns:a="http://schemas.openxmlformats.org/drawingml/2006/main" noGrp="1"/>
+          </p:cNvSpPr>
+          <p:nvPr/>
+        </p:nvSpPr>
+        <p:spPr>
+          <a:xfrm xmlns:a="http://schemas.openxmlformats.org/drawingml/2006/main">
+            <a:off x="9353550" y="2343150"/>
+            <a:ext cx="2190750" cy="438150"/>
+          </a:xfrm>
+          <a:prstGeom xmlns:a="http://schemas.openxmlformats.org/drawingml/2006/main" prst="rect">
+            <a:avLst/>
+          </a:prstGeom>
+          <a:noFill xmlns:a="http://schemas.openxmlformats.org/drawingml/2006/main"/>
+          <a:ln xmlns:a="http://schemas.openxmlformats.org/drawingml/2006/main" w="0">
+            <a:noFill/>
+            <a:prstDash val="solid"/>
+          </a:ln>
+        </p:spPr>
+        <p:txBody>
+          <a:bodyPr xmlns:a="http://schemas.openxmlformats.org/drawingml/2006/main"/>
+          <a:lstStyle xmlns:a="http://schemas.openxmlformats.org/drawingml/2006/main"/>
+          <a:p xmlns:a="http://schemas.openxmlformats.org/drawingml/2006/main">
+            <a:pPr algn="ctr">
+              <a:defRPr sz="3150" b="1" i="0">
+                <a:solidFill>
+                  <a:srgbClr val="000000"/>
+                </a:solidFill>
+              </a:defRPr>
+            </a:pPr>
+            <a:r>
+              <a:rPr sz="3150" b="1" i="0">
+                <a:solidFill>
+                  <a:srgbClr val="000000"/>
+                </a:solidFill>
+              </a:rPr>
+              <a:t>ML-P1b</a:t>
+            </a:r>
+          </a:p>
+        </p:txBody>
+      </p:sp>
+      <p:sp>
+        <p:nvSpPr>
+          <p:cNvPr id="7" name="">
+            <a:extLst xmlns:a="http://schemas.openxmlformats.org/drawingml/2006/main">
+              <a:ext uri="{FF2B5EF4-FFF2-40B4-BE49-F238E27FC236}">
+                <a16:creationId xmlns:a16="http://schemas.microsoft.com/office/drawing/2014/main" id="{690CCFC5-62A0-48B4-A915-333252D6DA56}"/>
+              </a:ext>
+            </a:extLst>
+          </p:cNvPr>
+          <p:cNvSpPr>
+            <a:spLocks xmlns:a="http://schemas.openxmlformats.org/drawingml/2006/main" noGrp="1"/>
+          </p:cNvSpPr>
+          <p:nvPr/>
+        </p:nvSpPr>
+        <p:spPr>
+          <a:xfrm xmlns:a="http://schemas.openxmlformats.org/drawingml/2006/main">
+            <a:off x="9067800" y="3067050"/>
+            <a:ext cx="2762250" cy="400050"/>
+          </a:xfrm>
+          <a:prstGeom xmlns:a="http://schemas.openxmlformats.org/drawingml/2006/main" prst="rect">
+            <a:avLst/>
+          </a:prstGeom>
+          <a:noFill xmlns:a="http://schemas.openxmlformats.org/drawingml/2006/main"/>
+          <a:ln xmlns:a="http://schemas.openxmlformats.org/drawingml/2006/main" w="0">
+            <a:noFill/>
+            <a:prstDash val="solid"/>
+          </a:ln>
+        </p:spPr>
+        <p:txBody>
+          <a:bodyPr xmlns:a="http://schemas.openxmlformats.org/drawingml/2006/main"/>
+          <a:lstStyle xmlns:a="http://schemas.openxmlformats.org/drawingml/2006/main"/>
+          <a:p xmlns:a="http://schemas.openxmlformats.org/drawingml/2006/main">
+            <a:pPr algn="ctr">
+              <a:defRPr sz="1875" b="0" i="0">
+                <a:solidFill>
+                  <a:srgbClr val="222222"/>
+                </a:solidFill>
+              </a:defRPr>
+            </a:pPr>
+            <a:r>
+              <a:rPr sz="1875" b="0" i="0">
+                <a:solidFill>
+                  <a:srgbClr val="222222"/>
+                </a:solidFill>
+              </a:rPr>
+              <a:t>Threshold diagnostic</a:t>
+            </a:r>
+          </a:p>
+        </p:txBody>
+      </p:sp>
+    </p:spTree>
+    <p:extLst>
+      <p:ext uri="{BB962C8B-B14F-4D97-AF65-F5344CB8AC3E}">
+        <p14:creationId xmlns:p14="http://schemas.microsoft.com/office/powerpoint/2010/main" val="224704740"/>
+      </p:ext>
+    </p:extLst>
+  </p:cSld>
+</p:sld>
+</file>
+
+<file path=ppt/slides/slide19.xml><?xml version="1.0" encoding="utf-8"?>
+<p:sld xmlns:p="http://schemas.openxmlformats.org/presentationml/2006/main">
+  <p:cSld>
+    <p:bg>
+      <p:bgPr>
+        <a:solidFill xmlns:a="http://schemas.openxmlformats.org/drawingml/2006/main">
+          <a:srgbClr val="FFFFFF"/>
+        </a:solidFill>
+      </p:bgPr>
+    </p:bg>
+    <p:spTree>
+      <p:nvGrpSpPr>
+        <p:cNvPr id="1" name=""/>
+        <p:cNvGrpSpPr/>
+        <p:nvPr/>
+      </p:nvGrpSpPr>
+      <p:grpSpPr>
+        <a:xfrm xmlns:a="http://schemas.openxmlformats.org/drawingml/2006/main"/>
+      </p:grpSpPr>
+      <p:sp>
+        <p:nvSpPr>
+          <p:cNvPr id="1" name="">
+            <a:extLst xmlns:a="http://schemas.openxmlformats.org/drawingml/2006/main">
+              <a:ext uri="{FF2B5EF4-FFF2-40B4-BE49-F238E27FC236}">
+                <a16:creationId xmlns:a16="http://schemas.microsoft.com/office/drawing/2014/main" id="{67FF79A3-3E11-41F8-94A6-05B5A854F5CB}"/>
+              </a:ext>
+            </a:extLst>
+          </p:cNvPr>
+          <p:cNvSpPr>
+            <a:spLocks xmlns:a="http://schemas.openxmlformats.org/drawingml/2006/main" noGrp="1"/>
+          </p:cNvSpPr>
+          <p:nvPr/>
+        </p:nvSpPr>
+        <p:spPr>
+          <a:xfrm xmlns:a="http://schemas.openxmlformats.org/drawingml/2006/main">
+            <a:off x="685800" y="400050"/>
+            <a:ext cx="8572500" cy="247650"/>
+          </a:xfrm>
+          <a:prstGeom xmlns:a="http://schemas.openxmlformats.org/drawingml/2006/main" prst="rect">
+            <a:avLst/>
+          </a:prstGeom>
+          <a:noFill xmlns:a="http://schemas.openxmlformats.org/drawingml/2006/main"/>
+          <a:ln xmlns:a="http://schemas.openxmlformats.org/drawingml/2006/main" w="0">
+            <a:noFill/>
+            <a:prstDash val="solid"/>
+          </a:ln>
+        </p:spPr>
+        <p:txBody>
+          <a:bodyPr xmlns:a="http://schemas.openxmlformats.org/drawingml/2006/main"/>
+          <a:lstStyle xmlns:a="http://schemas.openxmlformats.org/drawingml/2006/main"/>
+          <a:p xmlns:a="http://schemas.openxmlformats.org/drawingml/2006/main">
+            <a:pPr algn="l">
+              <a:defRPr sz="975" b="1" i="0">
+                <a:solidFill>
+                  <a:srgbClr val="555555"/>
+                </a:solidFill>
+              </a:defRPr>
+            </a:pPr>
+            <a:r>
+              <a:rPr sz="975" b="1" i="0">
+                <a:solidFill>
+                  <a:srgbClr val="555555"/>
+                </a:solidFill>
+              </a:rPr>
+              <a:t>GEN5.4 ML DECISION ENGINE</a:t>
+            </a:r>
+          </a:p>
+        </p:txBody>
+      </p:sp>
+      <p:sp>
+        <p:nvSpPr>
+          <p:cNvPr id="2" name="">
+            <a:extLst xmlns:a="http://schemas.openxmlformats.org/drawingml/2006/main">
+              <a:ext uri="{FF2B5EF4-FFF2-40B4-BE49-F238E27FC236}">
+                <a16:creationId xmlns:a16="http://schemas.microsoft.com/office/drawing/2014/main" id="{0E5BCF7C-0491-452A-97F2-4574A3475A79}"/>
+              </a:ext>
+            </a:extLst>
+          </p:cNvPr>
+          <p:cNvSpPr>
+            <a:spLocks xmlns:a="http://schemas.openxmlformats.org/drawingml/2006/main" noGrp="1"/>
+          </p:cNvSpPr>
+          <p:nvPr/>
+        </p:nvSpPr>
+        <p:spPr>
+          <a:xfrm xmlns:a="http://schemas.openxmlformats.org/drawingml/2006/main">
+            <a:off x="685800" y="723900"/>
+            <a:ext cx="10287000" cy="876300"/>
+          </a:xfrm>
+          <a:prstGeom xmlns:a="http://schemas.openxmlformats.org/drawingml/2006/main" prst="rect">
+            <a:avLst/>
+          </a:prstGeom>
+          <a:noFill xmlns:a="http://schemas.openxmlformats.org/drawingml/2006/main"/>
+          <a:ln xmlns:a="http://schemas.openxmlformats.org/drawingml/2006/main" w="0">
+            <a:noFill/>
+            <a:prstDash val="solid"/>
+          </a:ln>
+        </p:spPr>
+        <p:txBody>
+          <a:bodyPr xmlns:a="http://schemas.openxmlformats.org/drawingml/2006/main"/>
+          <a:lstStyle xmlns:a="http://schemas.openxmlformats.org/drawingml/2006/main"/>
+          <a:p xmlns:a="http://schemas.openxmlformats.org/drawingml/2006/main">
+            <a:pPr algn="l">
+              <a:defRPr sz="2850" b="1" i="0">
+                <a:solidFill>
+                  <a:srgbClr val="000000"/>
+                </a:solidFill>
+              </a:defRPr>
+            </a:pPr>
+            <a:r>
+              <a:rPr sz="2850" b="1" i="0">
+                <a:solidFill>
+                  <a:srgbClr val="000000"/>
+                </a:solidFill>
+              </a:rPr>
+              <a:t>The participation policy helped, but not enough</a:t>
+            </a:r>
+          </a:p>
+        </p:txBody>
+      </p:sp>
+      <p:sp>
+        <p:nvSpPr>
+          <p:cNvPr id="3" name="">
+            <a:extLst xmlns:a="http://schemas.openxmlformats.org/drawingml/2006/main">
+              <a:ext uri="{FF2B5EF4-FFF2-40B4-BE49-F238E27FC236}">
+                <a16:creationId xmlns:a16="http://schemas.microsoft.com/office/drawing/2014/main" id="{96CD3460-6782-4834-8F14-75ADCB2B908C}"/>
+              </a:ext>
+            </a:extLst>
+          </p:cNvPr>
+          <p:cNvSpPr>
+            <a:spLocks xmlns:a="http://schemas.openxmlformats.org/drawingml/2006/main" noGrp="1"/>
+          </p:cNvSpPr>
+          <p:nvPr/>
+        </p:nvSpPr>
+        <p:spPr>
+          <a:xfrm xmlns:a="http://schemas.openxmlformats.org/drawingml/2006/main">
+            <a:off x="685800" y="1657350"/>
+            <a:ext cx="10820400" cy="19050"/>
+          </a:xfrm>
+          <a:prstGeom xmlns:a="http://schemas.openxmlformats.org/drawingml/2006/main" prst="rect">
+            <a:avLst/>
+          </a:prstGeom>
+          <a:solidFill xmlns:a="http://schemas.openxmlformats.org/drawingml/2006/main">
+            <a:srgbClr val="B8BCC4"/>
+          </a:solidFill>
+          <a:ln xmlns:a="http://schemas.openxmlformats.org/drawingml/2006/main" w="0">
+            <a:noFill/>
+            <a:prstDash val="solid"/>
+          </a:ln>
+        </p:spPr>
+      </p:sp>
+      <p:sp>
+        <p:nvSpPr>
+          <p:cNvPr id="4" name="">
+            <a:extLst xmlns:a="http://schemas.openxmlformats.org/drawingml/2006/main">
+              <a:ext uri="{FF2B5EF4-FFF2-40B4-BE49-F238E27FC236}">
+                <a16:creationId xmlns:a16="http://schemas.microsoft.com/office/drawing/2014/main" id="{7ADDECE5-B9E2-4F4E-B2D4-EE31D121644F}"/>
+              </a:ext>
+            </a:extLst>
+          </p:cNvPr>
+          <p:cNvSpPr>
+            <a:spLocks xmlns:a="http://schemas.openxmlformats.org/drawingml/2006/main" noGrp="1"/>
+          </p:cNvSpPr>
+          <p:nvPr/>
+        </p:nvSpPr>
+        <p:spPr>
+          <a:xfrm xmlns:a="http://schemas.openxmlformats.org/drawingml/2006/main">
+            <a:off x="704850" y="2152650"/>
+            <a:ext cx="2333625" cy="1428750"/>
+          </a:xfrm>
+          <a:prstGeom xmlns:a="http://schemas.openxmlformats.org/drawingml/2006/main" prst="rect">
+            <a:avLst/>
+          </a:prstGeom>
+          <a:solidFill xmlns:a="http://schemas.openxmlformats.org/drawingml/2006/main">
+            <a:srgbClr val="EDEDED"/>
+          </a:solidFill>
+          <a:ln xmlns:a="http://schemas.openxmlformats.org/drawingml/2006/main" w="9525">
+            <a:solidFill>
+              <a:srgbClr val="B8BCC4"/>
+            </a:solidFill>
+            <a:prstDash val="solid"/>
+          </a:ln>
+        </p:spPr>
+      </p:sp>
+      <p:sp>
+        <p:nvSpPr>
+          <p:cNvPr id="5" name="">
+            <a:extLst xmlns:a="http://schemas.openxmlformats.org/drawingml/2006/main">
+              <a:ext uri="{FF2B5EF4-FFF2-40B4-BE49-F238E27FC236}">
+                <a16:creationId xmlns:a16="http://schemas.microsoft.com/office/drawing/2014/main" id="{DC6C26FA-5CA5-4618-9D04-6F5179C9B167}"/>
+              </a:ext>
+            </a:extLst>
+          </p:cNvPr>
+          <p:cNvSpPr>
+            <a:spLocks xmlns:a="http://schemas.openxmlformats.org/drawingml/2006/main" noGrp="1"/>
+          </p:cNvSpPr>
+          <p:nvPr/>
+        </p:nvSpPr>
+        <p:spPr>
+          <a:xfrm xmlns:a="http://schemas.openxmlformats.org/drawingml/2006/main">
+            <a:off x="876300" y="2305050"/>
+            <a:ext cx="1990725" cy="171450"/>
+          </a:xfrm>
+          <a:prstGeom xmlns:a="http://schemas.openxmlformats.org/drawingml/2006/main" prst="rect">
+            <a:avLst/>
+          </a:prstGeom>
+          <a:noFill xmlns:a="http://schemas.openxmlformats.org/drawingml/2006/main"/>
+          <a:ln xmlns:a="http://schemas.openxmlformats.org/drawingml/2006/main" w="0">
+            <a:noFill/>
+            <a:prstDash val="solid"/>
+          </a:ln>
+        </p:spPr>
+        <p:txBody>
+          <a:bodyPr xmlns:a="http://schemas.openxmlformats.org/drawingml/2006/main"/>
+          <a:lstStyle xmlns:a="http://schemas.openxmlformats.org/drawingml/2006/main"/>
+          <a:p xmlns:a="http://schemas.openxmlformats.org/drawingml/2006/main">
+            <a:pPr algn="l">
+              <a:defRPr sz="900" b="1" i="0">
+                <a:solidFill>
+                  <a:srgbClr val="555555"/>
+                </a:solidFill>
+              </a:defRPr>
+            </a:pPr>
+            <a:r>
+              <a:rPr sz="900" b="1" i="0">
+                <a:solidFill>
+                  <a:srgbClr val="555555"/>
+                </a:solidFill>
+              </a:rPr>
+              <a:t>POLICIES TESTED</a:t>
+            </a:r>
+          </a:p>
+        </p:txBody>
+      </p:sp>
+      <p:sp>
+        <p:nvSpPr>
+          <p:cNvPr id="6" name="">
+            <a:extLst xmlns:a="http://schemas.openxmlformats.org/drawingml/2006/main">
+              <a:ext uri="{FF2B5EF4-FFF2-40B4-BE49-F238E27FC236}">
+                <a16:creationId xmlns:a16="http://schemas.microsoft.com/office/drawing/2014/main" id="{94E3BCC9-B0B2-4357-B1AF-F4D3006ED677}"/>
+              </a:ext>
+            </a:extLst>
+          </p:cNvPr>
+          <p:cNvSpPr>
+            <a:spLocks xmlns:a="http://schemas.openxmlformats.org/drawingml/2006/main" noGrp="1"/>
+          </p:cNvSpPr>
+          <p:nvPr/>
+        </p:nvSpPr>
+        <p:spPr>
+          <a:xfrm xmlns:a="http://schemas.openxmlformats.org/drawingml/2006/main">
+            <a:off x="876300" y="2552700"/>
+            <a:ext cx="1990725" cy="361950"/>
+          </a:xfrm>
+          <a:prstGeom xmlns:a="http://schemas.openxmlformats.org/drawingml/2006/main" prst="rect">
+            <a:avLst/>
+          </a:prstGeom>
+          <a:noFill xmlns:a="http://schemas.openxmlformats.org/drawingml/2006/main"/>
+          <a:ln xmlns:a="http://schemas.openxmlformats.org/drawingml/2006/main" w="0">
+            <a:noFill/>
+            <a:prstDash val="solid"/>
+          </a:ln>
+        </p:spPr>
+        <p:txBody>
+          <a:bodyPr xmlns:a="http://schemas.openxmlformats.org/drawingml/2006/main"/>
+          <a:lstStyle xmlns:a="http://schemas.openxmlformats.org/drawingml/2006/main"/>
+          <a:p xmlns:a="http://schemas.openxmlformats.org/drawingml/2006/main">
+            <a:pPr algn="l">
+              <a:defRPr sz="2250" b="1" i="0">
+                <a:solidFill>
+                  <a:srgbClr val="000000"/>
+                </a:solidFill>
+              </a:defRPr>
+            </a:pPr>
+            <a:r>
+              <a:rPr sz="2250" b="1" i="0">
+                <a:solidFill>
+                  <a:srgbClr val="000000"/>
+                </a:solidFill>
+              </a:rPr>
+              <a:t>3</a:t>
+            </a:r>
+          </a:p>
+        </p:txBody>
+      </p:sp>
+      <p:sp>
+        <p:nvSpPr>
+          <p:cNvPr id="7" name="">
+            <a:extLst xmlns:a="http://schemas.openxmlformats.org/drawingml/2006/main">
+              <a:ext uri="{FF2B5EF4-FFF2-40B4-BE49-F238E27FC236}">
+                <a16:creationId xmlns:a16="http://schemas.microsoft.com/office/drawing/2014/main" id="{CAFCB317-1862-42E5-A944-1F091BACBCCA}"/>
+              </a:ext>
+            </a:extLst>
+          </p:cNvPr>
+          <p:cNvSpPr>
+            <a:spLocks xmlns:a="http://schemas.openxmlformats.org/drawingml/2006/main" noGrp="1"/>
+          </p:cNvSpPr>
+          <p:nvPr/>
+        </p:nvSpPr>
+        <p:spPr>
+          <a:xfrm xmlns:a="http://schemas.openxmlformats.org/drawingml/2006/main">
+            <a:off x="876300" y="2971800"/>
+            <a:ext cx="1990725" cy="552450"/>
+          </a:xfrm>
+          <a:prstGeom xmlns:a="http://schemas.openxmlformats.org/drawingml/2006/main" prst="rect">
+            <a:avLst/>
+          </a:prstGeom>
+          <a:noFill xmlns:a="http://schemas.openxmlformats.org/drawingml/2006/main"/>
+          <a:ln xmlns:a="http://schemas.openxmlformats.org/drawingml/2006/main" w="0">
+            <a:noFill/>
+            <a:prstDash val="solid"/>
+          </a:ln>
+        </p:spPr>
+        <p:txBody>
+          <a:bodyPr xmlns:a="http://schemas.openxmlformats.org/drawingml/2006/main"/>
+          <a:lstStyle xmlns:a="http://schemas.openxmlformats.org/drawingml/2006/main"/>
+          <a:p xmlns:a="http://schemas.openxmlformats.org/drawingml/2006/main">
+            <a:pPr algn="l">
+              <a:defRPr sz="1125" b="0" i="0">
+                <a:solidFill>
+                  <a:srgbClr val="555555"/>
+                </a:solidFill>
+              </a:defRPr>
+            </a:pPr>
+            <a:r>
+              <a:rPr sz="1125" b="0" i="0">
+                <a:solidFill>
+                  <a:srgbClr val="555555"/>
+                </a:solidFill>
+              </a:rPr>
+              <a:t>Fixed, TRAIN quantile, and TRAIN forward-return grid.</a:t>
+            </a:r>
+          </a:p>
+        </p:txBody>
+      </p:sp>
+      <p:sp>
+        <p:nvSpPr>
+          <p:cNvPr id="8" name="">
+            <a:extLst xmlns:a="http://schemas.openxmlformats.org/drawingml/2006/main">
+              <a:ext uri="{FF2B5EF4-FFF2-40B4-BE49-F238E27FC236}">
+                <a16:creationId xmlns:a16="http://schemas.microsoft.com/office/drawing/2014/main" id="{6EB706B0-1881-4EA5-9AF2-2F5F5D36A679}"/>
+              </a:ext>
+            </a:extLst>
+          </p:cNvPr>
+          <p:cNvSpPr>
+            <a:spLocks xmlns:a="http://schemas.openxmlformats.org/drawingml/2006/main" noGrp="1"/>
+          </p:cNvSpPr>
+          <p:nvPr/>
+        </p:nvSpPr>
+        <p:spPr>
+          <a:xfrm xmlns:a="http://schemas.openxmlformats.org/drawingml/2006/main">
+            <a:off x="3409950" y="2152650"/>
+            <a:ext cx="2333625" cy="1428750"/>
+          </a:xfrm>
+          <a:prstGeom xmlns:a="http://schemas.openxmlformats.org/drawingml/2006/main" prst="rect">
+            <a:avLst/>
+          </a:prstGeom>
+          <a:solidFill xmlns:a="http://schemas.openxmlformats.org/drawingml/2006/main">
+            <a:srgbClr val="EDEDED"/>
+          </a:solidFill>
+          <a:ln xmlns:a="http://schemas.openxmlformats.org/drawingml/2006/main" w="9525">
+            <a:solidFill>
+              <a:srgbClr val="B8BCC4"/>
+            </a:solidFill>
+            <a:prstDash val="solid"/>
+          </a:ln>
+        </p:spPr>
+      </p:sp>
+      <p:sp>
+        <p:nvSpPr>
+          <p:cNvPr id="9" name="">
+            <a:extLst xmlns:a="http://schemas.openxmlformats.org/drawingml/2006/main">
+              <a:ext uri="{FF2B5EF4-FFF2-40B4-BE49-F238E27FC236}">
+                <a16:creationId xmlns:a16="http://schemas.microsoft.com/office/drawing/2014/main" id="{3A06383F-AF2B-4CB4-BA3F-CCE8BB06A11B}"/>
+              </a:ext>
+            </a:extLst>
+          </p:cNvPr>
+          <p:cNvSpPr>
+            <a:spLocks xmlns:a="http://schemas.openxmlformats.org/drawingml/2006/main" noGrp="1"/>
+          </p:cNvSpPr>
+          <p:nvPr/>
+        </p:nvSpPr>
+        <p:spPr>
+          <a:xfrm xmlns:a="http://schemas.openxmlformats.org/drawingml/2006/main">
+            <a:off x="3581400" y="2305050"/>
+            <a:ext cx="1990725" cy="171450"/>
+          </a:xfrm>
+          <a:prstGeom xmlns:a="http://schemas.openxmlformats.org/drawingml/2006/main" prst="rect">
+            <a:avLst/>
+          </a:prstGeom>
+          <a:noFill xmlns:a="http://schemas.openxmlformats.org/drawingml/2006/main"/>
+          <a:ln xmlns:a="http://schemas.openxmlformats.org/drawingml/2006/main" w="0">
+            <a:noFill/>
+            <a:prstDash val="solid"/>
+          </a:ln>
+        </p:spPr>
+        <p:txBody>
+          <a:bodyPr xmlns:a="http://schemas.openxmlformats.org/drawingml/2006/main"/>
+          <a:lstStyle xmlns:a="http://schemas.openxmlformats.org/drawingml/2006/main"/>
+          <a:p xmlns:a="http://schemas.openxmlformats.org/drawingml/2006/main">
+            <a:pPr algn="l">
+              <a:defRPr sz="900" b="1" i="0">
+                <a:solidFill>
+                  <a:srgbClr val="555555"/>
+                </a:solidFill>
+              </a:defRPr>
+            </a:pPr>
+            <a:r>
+              <a:rPr sz="900" b="1" i="0">
+                <a:solidFill>
+                  <a:srgbClr val="555555"/>
+                </a:solidFill>
+              </a:rPr>
+              <a:t>GUARDRAILS</a:t>
+            </a:r>
+          </a:p>
+        </p:txBody>
+      </p:sp>
+      <p:sp>
+        <p:nvSpPr>
+          <p:cNvPr id="10" name="">
+            <a:extLst xmlns:a="http://schemas.openxmlformats.org/drawingml/2006/main">
+              <a:ext uri="{FF2B5EF4-FFF2-40B4-BE49-F238E27FC236}">
+                <a16:creationId xmlns:a16="http://schemas.microsoft.com/office/drawing/2014/main" id="{4A75C703-94FD-480B-93F9-45FDA640892B}"/>
+              </a:ext>
+            </a:extLst>
+          </p:cNvPr>
+          <p:cNvSpPr>
+            <a:spLocks xmlns:a="http://schemas.openxmlformats.org/drawingml/2006/main" noGrp="1"/>
+          </p:cNvSpPr>
+          <p:nvPr/>
+        </p:nvSpPr>
+        <p:spPr>
+          <a:xfrm xmlns:a="http://schemas.openxmlformats.org/drawingml/2006/main">
+            <a:off x="3581400" y="2552700"/>
+            <a:ext cx="1990725" cy="361950"/>
+          </a:xfrm>
+          <a:prstGeom xmlns:a="http://schemas.openxmlformats.org/drawingml/2006/main" prst="rect">
+            <a:avLst/>
+          </a:prstGeom>
+          <a:noFill xmlns:a="http://schemas.openxmlformats.org/drawingml/2006/main"/>
+          <a:ln xmlns:a="http://schemas.openxmlformats.org/drawingml/2006/main" w="0">
+            <a:noFill/>
+            <a:prstDash val="solid"/>
+          </a:ln>
+        </p:spPr>
+        <p:txBody>
+          <a:bodyPr xmlns:a="http://schemas.openxmlformats.org/drawingml/2006/main"/>
+          <a:lstStyle xmlns:a="http://schemas.openxmlformats.org/drawingml/2006/main"/>
+          <a:p xmlns:a="http://schemas.openxmlformats.org/drawingml/2006/main">
+            <a:pPr algn="l">
+              <a:defRPr sz="2250" b="1" i="0">
+                <a:solidFill>
+                  <a:srgbClr val="000000"/>
+                </a:solidFill>
+              </a:defRPr>
+            </a:pPr>
+            <a:r>
+              <a:rPr sz="2250" b="1" i="0">
+                <a:solidFill>
+                  <a:srgbClr val="000000"/>
+                </a:solidFill>
+              </a:rPr>
+              <a:t>All PASS</a:t>
+            </a:r>
+          </a:p>
+        </p:txBody>
+      </p:sp>
+      <p:sp>
+        <p:nvSpPr>
+          <p:cNvPr id="11" name="">
+            <a:extLst xmlns:a="http://schemas.openxmlformats.org/drawingml/2006/main">
+              <a:ext uri="{FF2B5EF4-FFF2-40B4-BE49-F238E27FC236}">
+                <a16:creationId xmlns:a16="http://schemas.microsoft.com/office/drawing/2014/main" id="{43BE98BE-D69A-4F0D-BBA3-F40A53AAE7D4}"/>
+              </a:ext>
+            </a:extLst>
+          </p:cNvPr>
+          <p:cNvSpPr>
+            <a:spLocks xmlns:a="http://schemas.openxmlformats.org/drawingml/2006/main" noGrp="1"/>
+          </p:cNvSpPr>
+          <p:nvPr/>
+        </p:nvSpPr>
+        <p:spPr>
+          <a:xfrm xmlns:a="http://schemas.openxmlformats.org/drawingml/2006/main">
+            <a:off x="3581400" y="2971800"/>
+            <a:ext cx="1990725" cy="552450"/>
+          </a:xfrm>
+          <a:prstGeom xmlns:a="http://schemas.openxmlformats.org/drawingml/2006/main" prst="rect">
+            <a:avLst/>
+          </a:prstGeom>
+          <a:noFill xmlns:a="http://schemas.openxmlformats.org/drawingml/2006/main"/>
+          <a:ln xmlns:a="http://schemas.openxmlformats.org/drawingml/2006/main" w="0">
+            <a:noFill/>
+            <a:prstDash val="solid"/>
+          </a:ln>
+        </p:spPr>
+        <p:txBody>
+          <a:bodyPr xmlns:a="http://schemas.openxmlformats.org/drawingml/2006/main"/>
+          <a:lstStyle xmlns:a="http://schemas.openxmlformats.org/drawingml/2006/main"/>
+          <a:p xmlns:a="http://schemas.openxmlformats.org/drawingml/2006/main">
+            <a:pPr algn="l">
+              <a:defRPr sz="1125" b="0" i="0">
+                <a:solidFill>
+                  <a:srgbClr val="555555"/>
+                </a:solidFill>
+              </a:defRPr>
+            </a:pPr>
+            <a:r>
+              <a:rPr sz="1125" b="0" i="0">
+                <a:solidFill>
+                  <a:srgbClr val="555555"/>
+                </a:solidFill>
+              </a:rPr>
+              <a:t>Fit and policy selection stay inside TRAIN.</a:t>
+            </a:r>
+          </a:p>
+        </p:txBody>
+      </p:sp>
+      <p:sp>
+        <p:nvSpPr>
+          <p:cNvPr id="12" name="">
+            <a:extLst xmlns:a="http://schemas.openxmlformats.org/drawingml/2006/main">
+              <a:ext uri="{FF2B5EF4-FFF2-40B4-BE49-F238E27FC236}">
+                <a16:creationId xmlns:a16="http://schemas.microsoft.com/office/drawing/2014/main" id="{EB5FF88D-DF49-4827-97F3-52D8333E209C}"/>
+              </a:ext>
+            </a:extLst>
+          </p:cNvPr>
+          <p:cNvSpPr>
+            <a:spLocks xmlns:a="http://schemas.openxmlformats.org/drawingml/2006/main" noGrp="1"/>
+          </p:cNvSpPr>
+          <p:nvPr/>
+        </p:nvSpPr>
+        <p:spPr>
+          <a:xfrm xmlns:a="http://schemas.openxmlformats.org/drawingml/2006/main">
+            <a:off x="6115050" y="2152650"/>
+            <a:ext cx="2333625" cy="1428750"/>
+          </a:xfrm>
+          <a:prstGeom xmlns:a="http://schemas.openxmlformats.org/drawingml/2006/main" prst="rect">
+            <a:avLst/>
+          </a:prstGeom>
+          <a:solidFill xmlns:a="http://schemas.openxmlformats.org/drawingml/2006/main">
+            <a:srgbClr val="EDEDED"/>
+          </a:solidFill>
+          <a:ln xmlns:a="http://schemas.openxmlformats.org/drawingml/2006/main" w="9525">
+            <a:solidFill>
+              <a:srgbClr val="B8BCC4"/>
+            </a:solidFill>
+            <a:prstDash val="solid"/>
+          </a:ln>
+        </p:spPr>
+      </p:sp>
+      <p:sp>
+        <p:nvSpPr>
+          <p:cNvPr id="13" name="">
+            <a:extLst xmlns:a="http://schemas.openxmlformats.org/drawingml/2006/main">
+              <a:ext uri="{FF2B5EF4-FFF2-40B4-BE49-F238E27FC236}">
+                <a16:creationId xmlns:a16="http://schemas.microsoft.com/office/drawing/2014/main" id="{DB5EFE55-7FA1-460B-9CCB-FAC41DC5E905}"/>
+              </a:ext>
+            </a:extLst>
+          </p:cNvPr>
+          <p:cNvSpPr>
+            <a:spLocks xmlns:a="http://schemas.openxmlformats.org/drawingml/2006/main" noGrp="1"/>
+          </p:cNvSpPr>
+          <p:nvPr/>
+        </p:nvSpPr>
+        <p:spPr>
+          <a:xfrm xmlns:a="http://schemas.openxmlformats.org/drawingml/2006/main">
+            <a:off x="6286500" y="2305050"/>
+            <a:ext cx="1990725" cy="171450"/>
+          </a:xfrm>
+          <a:prstGeom xmlns:a="http://schemas.openxmlformats.org/drawingml/2006/main" prst="rect">
+            <a:avLst/>
+          </a:prstGeom>
+          <a:noFill xmlns:a="http://schemas.openxmlformats.org/drawingml/2006/main"/>
+          <a:ln xmlns:a="http://schemas.openxmlformats.org/drawingml/2006/main" w="0">
+            <a:noFill/>
+            <a:prstDash val="solid"/>
+          </a:ln>
+        </p:spPr>
+        <p:txBody>
+          <a:bodyPr xmlns:a="http://schemas.openxmlformats.org/drawingml/2006/main"/>
+          <a:lstStyle xmlns:a="http://schemas.openxmlformats.org/drawingml/2006/main"/>
+          <a:p xmlns:a="http://schemas.openxmlformats.org/drawingml/2006/main">
+            <a:pPr algn="l">
+              <a:defRPr sz="900" b="1" i="0">
+                <a:solidFill>
+                  <a:srgbClr val="555555"/>
+                </a:solidFill>
+              </a:defRPr>
+            </a:pPr>
+            <a:r>
+              <a:rPr sz="900" b="1" i="0">
+                <a:solidFill>
+                  <a:srgbClr val="555555"/>
+                </a:solidFill>
+              </a:rPr>
+              <a:t>2020 GRID RETURN</a:t>
+            </a:r>
+          </a:p>
+        </p:txBody>
+      </p:sp>
+      <p:sp>
+        <p:nvSpPr>
+          <p:cNvPr id="14" name="">
+            <a:extLst xmlns:a="http://schemas.openxmlformats.org/drawingml/2006/main">
+              <a:ext uri="{FF2B5EF4-FFF2-40B4-BE49-F238E27FC236}">
+                <a16:creationId xmlns:a16="http://schemas.microsoft.com/office/drawing/2014/main" id="{209F3205-A369-4F53-81AA-0784AAC944BB}"/>
+              </a:ext>
+            </a:extLst>
+          </p:cNvPr>
+          <p:cNvSpPr>
+            <a:spLocks xmlns:a="http://schemas.openxmlformats.org/drawingml/2006/main" noGrp="1"/>
+          </p:cNvSpPr>
+          <p:nvPr/>
+        </p:nvSpPr>
+        <p:spPr>
+          <a:xfrm xmlns:a="http://schemas.openxmlformats.org/drawingml/2006/main">
+            <a:off x="6286500" y="2552700"/>
+            <a:ext cx="1990725" cy="361950"/>
+          </a:xfrm>
+          <a:prstGeom xmlns:a="http://schemas.openxmlformats.org/drawingml/2006/main" prst="rect">
+            <a:avLst/>
+          </a:prstGeom>
+          <a:noFill xmlns:a="http://schemas.openxmlformats.org/drawingml/2006/main"/>
+          <a:ln xmlns:a="http://schemas.openxmlformats.org/drawingml/2006/main" w="0">
+            <a:noFill/>
+            <a:prstDash val="solid"/>
+          </a:ln>
+        </p:spPr>
+        <p:txBody>
+          <a:bodyPr xmlns:a="http://schemas.openxmlformats.org/drawingml/2006/main"/>
+          <a:lstStyle xmlns:a="http://schemas.openxmlformats.org/drawingml/2006/main"/>
+          <a:p xmlns:a="http://schemas.openxmlformats.org/drawingml/2006/main">
+            <a:pPr algn="l">
+              <a:defRPr sz="2250" b="1" i="0">
+                <a:solidFill>
+                  <a:srgbClr val="000000"/>
+                </a:solidFill>
+              </a:defRPr>
+            </a:pPr>
+            <a:r>
+              <a:rPr sz="2250" b="1" i="0">
+                <a:solidFill>
+                  <a:srgbClr val="000000"/>
+                </a:solidFill>
+              </a:rPr>
+              <a:t>30.0%</a:t>
+            </a:r>
+          </a:p>
+        </p:txBody>
+      </p:sp>
+      <p:sp>
+        <p:nvSpPr>
+          <p:cNvPr id="15" name="">
+            <a:extLst xmlns:a="http://schemas.openxmlformats.org/drawingml/2006/main">
+              <a:ext uri="{FF2B5EF4-FFF2-40B4-BE49-F238E27FC236}">
+                <a16:creationId xmlns:a16="http://schemas.microsoft.com/office/drawing/2014/main" id="{0E8ADDF2-425B-4C83-8D70-ABF76F09CD38}"/>
+              </a:ext>
+            </a:extLst>
+          </p:cNvPr>
+          <p:cNvSpPr>
+            <a:spLocks xmlns:a="http://schemas.openxmlformats.org/drawingml/2006/main" noGrp="1"/>
+          </p:cNvSpPr>
+          <p:nvPr/>
+        </p:nvSpPr>
+        <p:spPr>
+          <a:xfrm xmlns:a="http://schemas.openxmlformats.org/drawingml/2006/main">
+            <a:off x="6286500" y="2971800"/>
+            <a:ext cx="1990725" cy="552450"/>
+          </a:xfrm>
+          <a:prstGeom xmlns:a="http://schemas.openxmlformats.org/drawingml/2006/main" prst="rect">
+            <a:avLst/>
+          </a:prstGeom>
+          <a:noFill xmlns:a="http://schemas.openxmlformats.org/drawingml/2006/main"/>
+          <a:ln xmlns:a="http://schemas.openxmlformats.org/drawingml/2006/main" w="0">
+            <a:noFill/>
+            <a:prstDash val="solid"/>
+          </a:ln>
+        </p:spPr>
+        <p:txBody>
+          <a:bodyPr xmlns:a="http://schemas.openxmlformats.org/drawingml/2006/main"/>
+          <a:lstStyle xmlns:a="http://schemas.openxmlformats.org/drawingml/2006/main"/>
+          <a:p xmlns:a="http://schemas.openxmlformats.org/drawingml/2006/main">
+            <a:pPr algn="l">
+              <a:defRPr sz="1125" b="0" i="0">
+                <a:solidFill>
+                  <a:srgbClr val="555555"/>
+                </a:solidFill>
+              </a:defRPr>
+            </a:pPr>
+            <a:r>
+              <a:rPr sz="1125" b="0" i="0">
+                <a:solidFill>
+                  <a:srgbClr val="555555"/>
+                </a:solidFill>
+              </a:rPr>
+              <a:t>Fixed was 8.0%; basket hold was 214.0%.</a:t>
+            </a:r>
+          </a:p>
+        </p:txBody>
+      </p:sp>
+      <p:sp>
+        <p:nvSpPr>
+          <p:cNvPr id="16" name="">
+            <a:extLst xmlns:a="http://schemas.openxmlformats.org/drawingml/2006/main">
+              <a:ext uri="{FF2B5EF4-FFF2-40B4-BE49-F238E27FC236}">
+                <a16:creationId xmlns:a16="http://schemas.microsoft.com/office/drawing/2014/main" id="{C5FA5CCA-529F-4297-9EB7-008FDB830341}"/>
+              </a:ext>
+            </a:extLst>
+          </p:cNvPr>
+          <p:cNvSpPr>
+            <a:spLocks xmlns:a="http://schemas.openxmlformats.org/drawingml/2006/main" noGrp="1"/>
+          </p:cNvSpPr>
+          <p:nvPr/>
+        </p:nvSpPr>
+        <p:spPr>
+          <a:xfrm xmlns:a="http://schemas.openxmlformats.org/drawingml/2006/main">
+            <a:off x="8820150" y="2152650"/>
+            <a:ext cx="2333625" cy="1428750"/>
+          </a:xfrm>
+          <a:prstGeom xmlns:a="http://schemas.openxmlformats.org/drawingml/2006/main" prst="rect">
+            <a:avLst/>
+          </a:prstGeom>
+          <a:solidFill xmlns:a="http://schemas.openxmlformats.org/drawingml/2006/main">
+            <a:srgbClr val="EDEDED"/>
+          </a:solidFill>
+          <a:ln xmlns:a="http://schemas.openxmlformats.org/drawingml/2006/main" w="9525">
+            <a:solidFill>
+              <a:srgbClr val="B8BCC4"/>
+            </a:solidFill>
+            <a:prstDash val="solid"/>
+          </a:ln>
+        </p:spPr>
+      </p:sp>
+      <p:sp>
+        <p:nvSpPr>
+          <p:cNvPr id="17" name="">
+            <a:extLst xmlns:a="http://schemas.openxmlformats.org/drawingml/2006/main">
+              <a:ext uri="{FF2B5EF4-FFF2-40B4-BE49-F238E27FC236}">
+                <a16:creationId xmlns:a16="http://schemas.microsoft.com/office/drawing/2014/main" id="{A8330618-2B36-451B-B5FA-98E98F3E4B2F}"/>
+              </a:ext>
+            </a:extLst>
+          </p:cNvPr>
+          <p:cNvSpPr>
+            <a:spLocks xmlns:a="http://schemas.openxmlformats.org/drawingml/2006/main" noGrp="1"/>
+          </p:cNvSpPr>
+          <p:nvPr/>
+        </p:nvSpPr>
+        <p:spPr>
+          <a:xfrm xmlns:a="http://schemas.openxmlformats.org/drawingml/2006/main">
+            <a:off x="8991600" y="2305050"/>
+            <a:ext cx="1990725" cy="171450"/>
+          </a:xfrm>
+          <a:prstGeom xmlns:a="http://schemas.openxmlformats.org/drawingml/2006/main" prst="rect">
+            <a:avLst/>
+          </a:prstGeom>
+          <a:noFill xmlns:a="http://schemas.openxmlformats.org/drawingml/2006/main"/>
+          <a:ln xmlns:a="http://schemas.openxmlformats.org/drawingml/2006/main" w="0">
+            <a:noFill/>
+            <a:prstDash val="solid"/>
+          </a:ln>
+        </p:spPr>
+        <p:txBody>
+          <a:bodyPr xmlns:a="http://schemas.openxmlformats.org/drawingml/2006/main"/>
+          <a:lstStyle xmlns:a="http://schemas.openxmlformats.org/drawingml/2006/main"/>
+          <a:p xmlns:a="http://schemas.openxmlformats.org/drawingml/2006/main">
+            <a:pPr algn="l">
+              <a:defRPr sz="900" b="1" i="0">
+                <a:solidFill>
+                  <a:srgbClr val="555555"/>
+                </a:solidFill>
+              </a:defRPr>
+            </a:pPr>
+            <a:r>
+              <a:rPr sz="900" b="1" i="0">
+                <a:solidFill>
+                  <a:srgbClr val="555555"/>
+                </a:solidFill>
+              </a:rPr>
+              <a:t>2022 QUANTILE RETURN</a:t>
+            </a:r>
+          </a:p>
+        </p:txBody>
+      </p:sp>
+      <p:sp>
+        <p:nvSpPr>
+          <p:cNvPr id="18" name="">
+            <a:extLst xmlns:a="http://schemas.openxmlformats.org/drawingml/2006/main">
+              <a:ext uri="{FF2B5EF4-FFF2-40B4-BE49-F238E27FC236}">
+                <a16:creationId xmlns:a16="http://schemas.microsoft.com/office/drawing/2014/main" id="{22187A75-6FDF-4C32-B600-FC6FCBC29DAB}"/>
+              </a:ext>
+            </a:extLst>
+          </p:cNvPr>
+          <p:cNvSpPr>
+            <a:spLocks xmlns:a="http://schemas.openxmlformats.org/drawingml/2006/main" noGrp="1"/>
+          </p:cNvSpPr>
+          <p:nvPr/>
+        </p:nvSpPr>
+        <p:spPr>
+          <a:xfrm xmlns:a="http://schemas.openxmlformats.org/drawingml/2006/main">
+            <a:off x="8991600" y="2552700"/>
+            <a:ext cx="1990725" cy="361950"/>
+          </a:xfrm>
+          <a:prstGeom xmlns:a="http://schemas.openxmlformats.org/drawingml/2006/main" prst="rect">
+            <a:avLst/>
+          </a:prstGeom>
+          <a:noFill xmlns:a="http://schemas.openxmlformats.org/drawingml/2006/main"/>
+          <a:ln xmlns:a="http://schemas.openxmlformats.org/drawingml/2006/main" w="0">
+            <a:noFill/>
+            <a:prstDash val="solid"/>
+          </a:ln>
+        </p:spPr>
+        <p:txBody>
+          <a:bodyPr xmlns:a="http://schemas.openxmlformats.org/drawingml/2006/main"/>
+          <a:lstStyle xmlns:a="http://schemas.openxmlformats.org/drawingml/2006/main"/>
+          <a:p xmlns:a="http://schemas.openxmlformats.org/drawingml/2006/main">
+            <a:pPr algn="l">
+              <a:defRPr sz="2250" b="1" i="0">
+                <a:solidFill>
+                  <a:srgbClr val="000000"/>
+                </a:solidFill>
+              </a:defRPr>
+            </a:pPr>
+            <a:r>
+              <a:rPr sz="2250" b="1" i="0">
+                <a:solidFill>
+                  <a:srgbClr val="000000"/>
+                </a:solidFill>
+              </a:rPr>
+              <a:t>-39.5%</a:t>
+            </a:r>
+          </a:p>
+        </p:txBody>
+      </p:sp>
+      <p:sp>
+        <p:nvSpPr>
+          <p:cNvPr id="19" name="">
+            <a:extLst xmlns:a="http://schemas.openxmlformats.org/drawingml/2006/main">
+              <a:ext uri="{FF2B5EF4-FFF2-40B4-BE49-F238E27FC236}">
+                <a16:creationId xmlns:a16="http://schemas.microsoft.com/office/drawing/2014/main" id="{EA9799A9-97F7-4DD2-9684-0427FFF566F3}"/>
+              </a:ext>
+            </a:extLst>
+          </p:cNvPr>
+          <p:cNvSpPr>
+            <a:spLocks xmlns:a="http://schemas.openxmlformats.org/drawingml/2006/main" noGrp="1"/>
+          </p:cNvSpPr>
+          <p:nvPr/>
+        </p:nvSpPr>
+        <p:spPr>
+          <a:xfrm xmlns:a="http://schemas.openxmlformats.org/drawingml/2006/main">
+            <a:off x="8991600" y="2971800"/>
+            <a:ext cx="1990725" cy="552450"/>
+          </a:xfrm>
+          <a:prstGeom xmlns:a="http://schemas.openxmlformats.org/drawingml/2006/main" prst="rect">
+            <a:avLst/>
+          </a:prstGeom>
+          <a:noFill xmlns:a="http://schemas.openxmlformats.org/drawingml/2006/main"/>
+          <a:ln xmlns:a="http://schemas.openxmlformats.org/drawingml/2006/main" w="0">
+            <a:noFill/>
+            <a:prstDash val="solid"/>
+          </a:ln>
+        </p:spPr>
+        <p:txBody>
+          <a:bodyPr xmlns:a="http://schemas.openxmlformats.org/drawingml/2006/main"/>
+          <a:lstStyle xmlns:a="http://schemas.openxmlformats.org/drawingml/2006/main"/>
+          <a:p xmlns:a="http://schemas.openxmlformats.org/drawingml/2006/main">
+            <a:pPr algn="l">
+              <a:defRPr sz="1125" b="0" i="0">
+                <a:solidFill>
+                  <a:srgbClr val="555555"/>
+                </a:solidFill>
+              </a:defRPr>
+            </a:pPr>
+            <a:r>
+              <a:rPr sz="1125" b="0" i="0">
+                <a:solidFill>
+                  <a:srgbClr val="555555"/>
+                </a:solidFill>
+              </a:rPr>
+              <a:t>Fixed was -42.4%; basket hold was -54.2%.</a:t>
+            </a:r>
+          </a:p>
+        </p:txBody>
+      </p:sp>
+      <p:sp>
+        <p:nvSpPr>
+          <p:cNvPr id="20" name="">
+            <a:extLst xmlns:a="http://schemas.openxmlformats.org/drawingml/2006/main">
+              <a:ext uri="{FF2B5EF4-FFF2-40B4-BE49-F238E27FC236}">
+                <a16:creationId xmlns:a16="http://schemas.microsoft.com/office/drawing/2014/main" id="{234ED678-F0BD-443D-BBED-C8ED70AA8C1E}"/>
+              </a:ext>
+            </a:extLst>
+          </p:cNvPr>
+          <p:cNvSpPr>
+            <a:spLocks xmlns:a="http://schemas.openxmlformats.org/drawingml/2006/main" noGrp="1"/>
+          </p:cNvSpPr>
+          <p:nvPr/>
+        </p:nvSpPr>
+        <p:spPr>
+          <a:xfrm xmlns:a="http://schemas.openxmlformats.org/drawingml/2006/main">
+            <a:off x="1066800" y="4095750"/>
+            <a:ext cx="9334500" cy="914400"/>
+          </a:xfrm>
+          <a:prstGeom xmlns:a="http://schemas.openxmlformats.org/drawingml/2006/main" prst="rect">
+            <a:avLst/>
+          </a:prstGeom>
+          <a:noFill xmlns:a="http://schemas.openxmlformats.org/drawingml/2006/main"/>
+          <a:ln xmlns:a="http://schemas.openxmlformats.org/drawingml/2006/main" w="0">
+            <a:noFill/>
+            <a:prstDash val="solid"/>
+          </a:ln>
+        </p:spPr>
+        <p:txBody>
+          <a:bodyPr xmlns:a="http://schemas.openxmlformats.org/drawingml/2006/main"/>
+          <a:lstStyle xmlns:a="http://schemas.openxmlformats.org/drawingml/2006/main"/>
+          <a:p xmlns:a="http://schemas.openxmlformats.org/drawingml/2006/main">
+            <a:pPr algn="ctr">
+              <a:defRPr sz="2100" b="1" i="0">
+                <a:solidFill>
+                  <a:srgbClr val="000000"/>
+                </a:solidFill>
+              </a:defRPr>
+            </a:pPr>
+            <a:r>
+              <a:rPr sz="2100" b="1" i="0">
+                <a:solidFill>
+                  <a:srgbClr val="000000"/>
+                </a:solidFill>
+              </a:rPr>
+              <a:t>The grid policy raised 2020 exposure and return, which confirms threshold choice matters. It still left most of the high-beta rally unowned, so the problem is not just the original 0.55 / 0.50 cutoff.</a:t>
+            </a:r>
+          </a:p>
+        </p:txBody>
+      </p:sp>
+    </p:spTree>
+    <p:extLst>
+      <p:ext uri="{BB962C8B-B14F-4D97-AF65-F5344CB8AC3E}">
+        <p14:creationId xmlns:p14="http://schemas.microsoft.com/office/powerpoint/2010/main" val="1609177328"/>
       </p:ext>
     </p:extLst>
   </p:cSld>
@@ -6385,7 +8070,7 @@
           <p:cNvPr id="1" name="">
             <a:extLst xmlns:a="http://schemas.openxmlformats.org/drawingml/2006/main">
               <a:ext uri="{FF2B5EF4-FFF2-40B4-BE49-F238E27FC236}">
-                <a16:creationId xmlns:a16="http://schemas.microsoft.com/office/drawing/2014/main" id="{E36542FA-F233-4D13-B547-F790B39EB006}"/>
+                <a16:creationId xmlns:a16="http://schemas.microsoft.com/office/drawing/2014/main" id="{CAA4FAD7-0BF6-42B1-8AA3-D50B4649B2F7}"/>
               </a:ext>
             </a:extLst>
           </p:cNvPr>
@@ -6435,7 +8120,7 @@
           <p:cNvPr id="2" name="">
             <a:extLst xmlns:a="http://schemas.openxmlformats.org/drawingml/2006/main">
               <a:ext uri="{FF2B5EF4-FFF2-40B4-BE49-F238E27FC236}">
-                <a16:creationId xmlns:a16="http://schemas.microsoft.com/office/drawing/2014/main" id="{98AA86FC-52B0-4F43-B0A0-88CB7483313E}"/>
+                <a16:creationId xmlns:a16="http://schemas.microsoft.com/office/drawing/2014/main" id="{92AFED92-0C86-47B4-BFFC-4FF382A05AF3}"/>
               </a:ext>
             </a:extLst>
           </p:cNvPr>
@@ -6485,7 +8170,7 @@
           <p:cNvPr id="3" name="">
             <a:extLst xmlns:a="http://schemas.openxmlformats.org/drawingml/2006/main">
               <a:ext uri="{FF2B5EF4-FFF2-40B4-BE49-F238E27FC236}">
-                <a16:creationId xmlns:a16="http://schemas.microsoft.com/office/drawing/2014/main" id="{E2D7AF07-2065-454F-B243-B3F7F8DD9F31}"/>
+                <a16:creationId xmlns:a16="http://schemas.microsoft.com/office/drawing/2014/main" id="{625BF5F8-34D1-41D3-9BF3-D6885FE15D22}"/>
               </a:ext>
             </a:extLst>
           </p:cNvPr>
@@ -6516,7 +8201,7 @@
           <p:cNvPr id="4" name="">
             <a:extLst xmlns:a="http://schemas.openxmlformats.org/drawingml/2006/main">
               <a:ext uri="{FF2B5EF4-FFF2-40B4-BE49-F238E27FC236}">
-                <a16:creationId xmlns:a16="http://schemas.microsoft.com/office/drawing/2014/main" id="{75839C31-D04D-41CE-96C0-64F2392A2050}"/>
+                <a16:creationId xmlns:a16="http://schemas.microsoft.com/office/drawing/2014/main" id="{F7A92931-E2E9-49F5-A345-EEE8B8F69469}"/>
               </a:ext>
             </a:extLst>
           </p:cNvPr>
@@ -6566,7 +8251,7 @@
           <p:cNvPr id="5" name="">
             <a:extLst xmlns:a="http://schemas.openxmlformats.org/drawingml/2006/main">
               <a:ext uri="{FF2B5EF4-FFF2-40B4-BE49-F238E27FC236}">
-                <a16:creationId xmlns:a16="http://schemas.microsoft.com/office/drawing/2014/main" id="{B250E0EF-7F93-4459-A211-4CFE69A12981}"/>
+                <a16:creationId xmlns:a16="http://schemas.microsoft.com/office/drawing/2014/main" id="{EA00084F-8DFC-455A-9203-64D9AA7AAD3F}"/>
               </a:ext>
             </a:extLst>
           </p:cNvPr>
@@ -6616,7 +8301,7 @@
           <p:cNvPr id="6" name="">
             <a:extLst xmlns:a="http://schemas.openxmlformats.org/drawingml/2006/main">
               <a:ext uri="{FF2B5EF4-FFF2-40B4-BE49-F238E27FC236}">
-                <a16:creationId xmlns:a16="http://schemas.microsoft.com/office/drawing/2014/main" id="{5BCB7FBC-677F-437E-93EB-CD384D83AF80}"/>
+                <a16:creationId xmlns:a16="http://schemas.microsoft.com/office/drawing/2014/main" id="{B1876AB4-97B5-40DC-93A3-D8480D2474C2}"/>
               </a:ext>
             </a:extLst>
           </p:cNvPr>
@@ -6666,7 +8351,7 @@
           <p:cNvPr id="7" name="">
             <a:extLst xmlns:a="http://schemas.openxmlformats.org/drawingml/2006/main">
               <a:ext uri="{FF2B5EF4-FFF2-40B4-BE49-F238E27FC236}">
-                <a16:creationId xmlns:a16="http://schemas.microsoft.com/office/drawing/2014/main" id="{9DEDB69F-E2E1-418B-AD5A-A33102B57D37}"/>
+                <a16:creationId xmlns:a16="http://schemas.microsoft.com/office/drawing/2014/main" id="{11CE9A5B-1E28-44FE-B9BA-30472B4EFB39}"/>
               </a:ext>
             </a:extLst>
           </p:cNvPr>
@@ -6716,7 +8401,7 @@
           <p:cNvPr id="8" name="">
             <a:extLst xmlns:a="http://schemas.openxmlformats.org/drawingml/2006/main">
               <a:ext uri="{FF2B5EF4-FFF2-40B4-BE49-F238E27FC236}">
-                <a16:creationId xmlns:a16="http://schemas.microsoft.com/office/drawing/2014/main" id="{1C7143CA-8817-4B70-967B-FC3C5C42BC77}"/>
+                <a16:creationId xmlns:a16="http://schemas.microsoft.com/office/drawing/2014/main" id="{F6A92327-D574-48D4-BB4F-EE496044892E}"/>
               </a:ext>
             </a:extLst>
           </p:cNvPr>
@@ -6766,7 +8451,7 @@
           <p:cNvPr id="9" name="">
             <a:extLst xmlns:a="http://schemas.openxmlformats.org/drawingml/2006/main">
               <a:ext uri="{FF2B5EF4-FFF2-40B4-BE49-F238E27FC236}">
-                <a16:creationId xmlns:a16="http://schemas.microsoft.com/office/drawing/2014/main" id="{6E9353EA-877B-42E2-8D32-A03D4691FE17}"/>
+                <a16:creationId xmlns:a16="http://schemas.microsoft.com/office/drawing/2014/main" id="{64D04879-EFC3-41EC-B171-19A811AC954C}"/>
               </a:ext>
             </a:extLst>
           </p:cNvPr>
@@ -6816,7 +8501,7 @@
           <p:cNvPr id="10" name="">
             <a:extLst xmlns:a="http://schemas.openxmlformats.org/drawingml/2006/main">
               <a:ext uri="{FF2B5EF4-FFF2-40B4-BE49-F238E27FC236}">
-                <a16:creationId xmlns:a16="http://schemas.microsoft.com/office/drawing/2014/main" id="{E828698A-FED4-4922-8C52-91F54AB4E579}"/>
+                <a16:creationId xmlns:a16="http://schemas.microsoft.com/office/drawing/2014/main" id="{0F9D01AC-E525-49D7-BB64-F8F4EBDEC847}"/>
               </a:ext>
             </a:extLst>
           </p:cNvPr>
@@ -6849,7 +8534,7 @@
           <p:cNvPr id="11" name="">
             <a:extLst xmlns:a="http://schemas.openxmlformats.org/drawingml/2006/main">
               <a:ext uri="{FF2B5EF4-FFF2-40B4-BE49-F238E27FC236}">
-                <a16:creationId xmlns:a16="http://schemas.microsoft.com/office/drawing/2014/main" id="{87E6B38D-58F5-400D-B2B6-B077881A3ABD}"/>
+                <a16:creationId xmlns:a16="http://schemas.microsoft.com/office/drawing/2014/main" id="{DC0343DD-D2A1-4986-B752-B3C7A0E12220}"/>
               </a:ext>
             </a:extLst>
           </p:cNvPr>
@@ -6882,7 +8567,7 @@
           <p:cNvPr id="12" name="">
             <a:extLst xmlns:a="http://schemas.openxmlformats.org/drawingml/2006/main">
               <a:ext uri="{FF2B5EF4-FFF2-40B4-BE49-F238E27FC236}">
-                <a16:creationId xmlns:a16="http://schemas.microsoft.com/office/drawing/2014/main" id="{30D3DFC3-3A91-4721-A77F-628DA1591DED}"/>
+                <a16:creationId xmlns:a16="http://schemas.microsoft.com/office/drawing/2014/main" id="{5094260E-FD8E-4742-82F4-4E1792BBB3B2}"/>
               </a:ext>
             </a:extLst>
           </p:cNvPr>
@@ -6915,7 +8600,7 @@
           <p:cNvPr id="13" name="">
             <a:extLst xmlns:a="http://schemas.openxmlformats.org/drawingml/2006/main">
               <a:ext uri="{FF2B5EF4-FFF2-40B4-BE49-F238E27FC236}">
-                <a16:creationId xmlns:a16="http://schemas.microsoft.com/office/drawing/2014/main" id="{E7E9F800-B400-4D11-8EC7-C9616CED9795}"/>
+                <a16:creationId xmlns:a16="http://schemas.microsoft.com/office/drawing/2014/main" id="{A3381E17-B9D3-4B02-A894-64D4532BCC96}"/>
               </a:ext>
             </a:extLst>
           </p:cNvPr>
@@ -6965,7 +8650,7 @@
           <p:cNvPr id="14" name="">
             <a:extLst xmlns:a="http://schemas.openxmlformats.org/drawingml/2006/main">
               <a:ext uri="{FF2B5EF4-FFF2-40B4-BE49-F238E27FC236}">
-                <a16:creationId xmlns:a16="http://schemas.microsoft.com/office/drawing/2014/main" id="{79948B6A-BADE-4BF8-B8DF-BB211E818ABF}"/>
+                <a16:creationId xmlns:a16="http://schemas.microsoft.com/office/drawing/2014/main" id="{87B13125-BD62-414A-8AB9-B1E04B09DCA5}"/>
               </a:ext>
             </a:extLst>
           </p:cNvPr>
@@ -7015,7 +8700,7 @@
           <p:cNvPr id="15" name="">
             <a:extLst xmlns:a="http://schemas.openxmlformats.org/drawingml/2006/main">
               <a:ext uri="{FF2B5EF4-FFF2-40B4-BE49-F238E27FC236}">
-                <a16:creationId xmlns:a16="http://schemas.microsoft.com/office/drawing/2014/main" id="{C162CA3C-445E-4EAA-9B6D-A672FAD83D07}"/>
+                <a16:creationId xmlns:a16="http://schemas.microsoft.com/office/drawing/2014/main" id="{6F5904BD-3B3E-4B7E-AE42-F2B953FC49BD}"/>
               </a:ext>
             </a:extLst>
           </p:cNvPr>
@@ -7065,7 +8750,7 @@
           <p:cNvPr id="16" name="">
             <a:extLst xmlns:a="http://schemas.openxmlformats.org/drawingml/2006/main">
               <a:ext uri="{FF2B5EF4-FFF2-40B4-BE49-F238E27FC236}">
-                <a16:creationId xmlns:a16="http://schemas.microsoft.com/office/drawing/2014/main" id="{9D1B2354-CB80-4D3A-AAA4-253B5F40F867}"/>
+                <a16:creationId xmlns:a16="http://schemas.microsoft.com/office/drawing/2014/main" id="{46FE5833-15AF-44DA-B30C-84E2ABCA21A8}"/>
               </a:ext>
             </a:extLst>
           </p:cNvPr>
@@ -7113,7 +8798,1435 @@
     </p:spTree>
     <p:extLst>
       <p:ext uri="{BB962C8B-B14F-4D97-AF65-F5344CB8AC3E}">
-        <p14:creationId xmlns:p14="http://schemas.microsoft.com/office/powerpoint/2010/main" val="1145742833"/>
+        <p14:creationId xmlns:p14="http://schemas.microsoft.com/office/powerpoint/2010/main" val="1952985074"/>
+      </p:ext>
+    </p:extLst>
+  </p:cSld>
+</p:sld>
+</file>
+
+<file path=ppt/slides/slide20.xml><?xml version="1.0" encoding="utf-8"?>
+<p:sld xmlns:p="http://schemas.openxmlformats.org/presentationml/2006/main">
+  <p:cSld>
+    <p:bg>
+      <p:bgPr>
+        <a:solidFill xmlns:a="http://schemas.openxmlformats.org/drawingml/2006/main">
+          <a:srgbClr val="FFFFFF"/>
+        </a:solidFill>
+      </p:bgPr>
+    </p:bg>
+    <p:spTree>
+      <p:nvGrpSpPr>
+        <p:cNvPr id="1" name=""/>
+        <p:cNvGrpSpPr/>
+        <p:nvPr/>
+      </p:nvGrpSpPr>
+      <p:grpSpPr>
+        <a:xfrm xmlns:a="http://schemas.openxmlformats.org/drawingml/2006/main"/>
+      </p:grpSpPr>
+      <p:sp>
+        <p:nvSpPr>
+          <p:cNvPr id="1" name="">
+            <a:extLst xmlns:a="http://schemas.openxmlformats.org/drawingml/2006/main">
+              <a:ext uri="{FF2B5EF4-FFF2-40B4-BE49-F238E27FC236}">
+                <a16:creationId xmlns:a16="http://schemas.microsoft.com/office/drawing/2014/main" id="{4C10A2AE-8C81-42EF-899A-9F1ECFE8B079}"/>
+              </a:ext>
+            </a:extLst>
+          </p:cNvPr>
+          <p:cNvSpPr>
+            <a:spLocks xmlns:a="http://schemas.openxmlformats.org/drawingml/2006/main" noGrp="1"/>
+          </p:cNvSpPr>
+          <p:nvPr/>
+        </p:nvSpPr>
+        <p:spPr>
+          <a:xfrm xmlns:a="http://schemas.openxmlformats.org/drawingml/2006/main">
+            <a:off x="685800" y="400050"/>
+            <a:ext cx="8572500" cy="247650"/>
+          </a:xfrm>
+          <a:prstGeom xmlns:a="http://schemas.openxmlformats.org/drawingml/2006/main" prst="rect">
+            <a:avLst/>
+          </a:prstGeom>
+          <a:noFill xmlns:a="http://schemas.openxmlformats.org/drawingml/2006/main"/>
+          <a:ln xmlns:a="http://schemas.openxmlformats.org/drawingml/2006/main" w="0">
+            <a:noFill/>
+            <a:prstDash val="solid"/>
+          </a:ln>
+        </p:spPr>
+        <p:txBody>
+          <a:bodyPr xmlns:a="http://schemas.openxmlformats.org/drawingml/2006/main"/>
+          <a:lstStyle xmlns:a="http://schemas.openxmlformats.org/drawingml/2006/main"/>
+          <a:p xmlns:a="http://schemas.openxmlformats.org/drawingml/2006/main">
+            <a:pPr algn="l">
+              <a:defRPr sz="975" b="1" i="0">
+                <a:solidFill>
+                  <a:srgbClr val="555555"/>
+                </a:solidFill>
+              </a:defRPr>
+            </a:pPr>
+            <a:r>
+              <a:rPr sz="975" b="1" i="0">
+                <a:solidFill>
+                  <a:srgbClr val="555555"/>
+                </a:solidFill>
+              </a:rPr>
+              <a:t>GEN5.4 ML DECISION ENGINE</a:t>
+            </a:r>
+          </a:p>
+        </p:txBody>
+      </p:sp>
+      <p:sp>
+        <p:nvSpPr>
+          <p:cNvPr id="2" name="">
+            <a:extLst xmlns:a="http://schemas.openxmlformats.org/drawingml/2006/main">
+              <a:ext uri="{FF2B5EF4-FFF2-40B4-BE49-F238E27FC236}">
+                <a16:creationId xmlns:a16="http://schemas.microsoft.com/office/drawing/2014/main" id="{A534B043-895F-4B4D-8A47-3E4A572722CB}"/>
+              </a:ext>
+            </a:extLst>
+          </p:cNvPr>
+          <p:cNvSpPr>
+            <a:spLocks xmlns:a="http://schemas.openxmlformats.org/drawingml/2006/main" noGrp="1"/>
+          </p:cNvSpPr>
+          <p:nvPr/>
+        </p:nvSpPr>
+        <p:spPr>
+          <a:xfrm xmlns:a="http://schemas.openxmlformats.org/drawingml/2006/main">
+            <a:off x="685800" y="723900"/>
+            <a:ext cx="10287000" cy="876300"/>
+          </a:xfrm>
+          <a:prstGeom xmlns:a="http://schemas.openxmlformats.org/drawingml/2006/main" prst="rect">
+            <a:avLst/>
+          </a:prstGeom>
+          <a:noFill xmlns:a="http://schemas.openxmlformats.org/drawingml/2006/main"/>
+          <a:ln xmlns:a="http://schemas.openxmlformats.org/drawingml/2006/main" w="0">
+            <a:noFill/>
+            <a:prstDash val="solid"/>
+          </a:ln>
+        </p:spPr>
+        <p:txBody>
+          <a:bodyPr xmlns:a="http://schemas.openxmlformats.org/drawingml/2006/main"/>
+          <a:lstStyle xmlns:a="http://schemas.openxmlformats.org/drawingml/2006/main"/>
+          <a:p xmlns:a="http://schemas.openxmlformats.org/drawingml/2006/main">
+            <a:pPr algn="l">
+              <a:defRPr sz="2850" b="1" i="0">
+                <a:solidFill>
+                  <a:srgbClr val="000000"/>
+                </a:solidFill>
+              </a:defRPr>
+            </a:pPr>
+            <a:r>
+              <a:rPr sz="2850" b="1" i="0">
+                <a:solidFill>
+                  <a:srgbClr val="000000"/>
+                </a:solidFill>
+              </a:rPr>
+              <a:t>The equity curves show a better but still underpowered rally response</a:t>
+            </a:r>
+          </a:p>
+        </p:txBody>
+      </p:sp>
+      <p:sp>
+        <p:nvSpPr>
+          <p:cNvPr id="3" name="">
+            <a:extLst xmlns:a="http://schemas.openxmlformats.org/drawingml/2006/main">
+              <a:ext uri="{FF2B5EF4-FFF2-40B4-BE49-F238E27FC236}">
+                <a16:creationId xmlns:a16="http://schemas.microsoft.com/office/drawing/2014/main" id="{EC11EACE-9AF2-448E-9921-758DA69E0594}"/>
+              </a:ext>
+            </a:extLst>
+          </p:cNvPr>
+          <p:cNvSpPr>
+            <a:spLocks xmlns:a="http://schemas.openxmlformats.org/drawingml/2006/main" noGrp="1"/>
+          </p:cNvSpPr>
+          <p:nvPr/>
+        </p:nvSpPr>
+        <p:spPr>
+          <a:xfrm xmlns:a="http://schemas.openxmlformats.org/drawingml/2006/main">
+            <a:off x="685800" y="1657350"/>
+            <a:ext cx="10820400" cy="19050"/>
+          </a:xfrm>
+          <a:prstGeom xmlns:a="http://schemas.openxmlformats.org/drawingml/2006/main" prst="rect">
+            <a:avLst/>
+          </a:prstGeom>
+          <a:solidFill xmlns:a="http://schemas.openxmlformats.org/drawingml/2006/main">
+            <a:srgbClr val="B8BCC4"/>
+          </a:solidFill>
+          <a:ln xmlns:a="http://schemas.openxmlformats.org/drawingml/2006/main" w="0">
+            <a:noFill/>
+            <a:prstDash val="solid"/>
+          </a:ln>
+        </p:spPr>
+      </p:sp>
+      <p:pic>
+        <p:nvPicPr>
+          <p:cNvPr id="10" name=""/>
+          <p:cNvPicPr>
+            <a:picLocks xmlns:a="http://schemas.openxmlformats.org/drawingml/2006/main" noChangeAspect="1"/>
+          </p:cNvPicPr>
+          <p:nvPr/>
+        </p:nvPicPr>
+        <p:blipFill>
+          <a:blip xmlns:r="http://schemas.openxmlformats.org/officeDocument/2006/relationships" xmlns:a="http://schemas.openxmlformats.org/drawingml/2006/main" r:embed="R7a44aacfeb704639"/>
+          <a:stretch xmlns:a="http://schemas.openxmlformats.org/drawingml/2006/main"/>
+        </p:blipFill>
+        <p:spPr>
+          <a:xfrm xmlns:a="http://schemas.openxmlformats.org/drawingml/2006/main">
+            <a:off x="835819" y="2000250"/>
+            <a:ext cx="6900863" cy="3943350"/>
+          </a:xfrm>
+          <a:prstGeom xmlns:a="http://schemas.openxmlformats.org/drawingml/2006/main" prst="rect">
+            <a:avLst/>
+          </a:prstGeom>
+        </p:spPr>
+      </p:pic>
+      <p:sp>
+        <p:nvSpPr>
+          <p:cNvPr id="5" name="">
+            <a:extLst xmlns:a="http://schemas.openxmlformats.org/drawingml/2006/main">
+              <a:ext uri="{FF2B5EF4-FFF2-40B4-BE49-F238E27FC236}">
+                <a16:creationId xmlns:a16="http://schemas.microsoft.com/office/drawing/2014/main" id="{B7C22DC2-87DE-4465-87EF-978435631070}"/>
+              </a:ext>
+            </a:extLst>
+          </p:cNvPr>
+          <p:cNvSpPr>
+            <a:spLocks xmlns:a="http://schemas.openxmlformats.org/drawingml/2006/main" noGrp="1"/>
+          </p:cNvSpPr>
+          <p:nvPr/>
+        </p:nvSpPr>
+        <p:spPr>
+          <a:xfrm xmlns:a="http://schemas.openxmlformats.org/drawingml/2006/main">
+            <a:off x="8477250" y="2133600"/>
+            <a:ext cx="2571750" cy="304800"/>
+          </a:xfrm>
+          <a:prstGeom xmlns:a="http://schemas.openxmlformats.org/drawingml/2006/main" prst="rect">
+            <a:avLst/>
+          </a:prstGeom>
+          <a:noFill xmlns:a="http://schemas.openxmlformats.org/drawingml/2006/main"/>
+          <a:ln xmlns:a="http://schemas.openxmlformats.org/drawingml/2006/main" w="0">
+            <a:noFill/>
+            <a:prstDash val="solid"/>
+          </a:ln>
+        </p:spPr>
+        <p:txBody>
+          <a:bodyPr xmlns:a="http://schemas.openxmlformats.org/drawingml/2006/main"/>
+          <a:lstStyle xmlns:a="http://schemas.openxmlformats.org/drawingml/2006/main"/>
+          <a:p xmlns:a="http://schemas.openxmlformats.org/drawingml/2006/main">
+            <a:pPr algn="l">
+              <a:defRPr sz="1950" b="1" i="0">
+                <a:solidFill>
+                  <a:srgbClr val="222222"/>
+                </a:solidFill>
+              </a:defRPr>
+            </a:pPr>
+            <a:r>
+              <a:rPr sz="1950" b="1" i="0">
+                <a:solidFill>
+                  <a:srgbClr val="222222"/>
+                </a:solidFill>
+              </a:rPr>
+              <a:t>What changed</a:t>
+            </a:r>
+          </a:p>
+        </p:txBody>
+      </p:sp>
+      <p:sp>
+        <p:nvSpPr>
+          <p:cNvPr id="6" name="">
+            <a:extLst xmlns:a="http://schemas.openxmlformats.org/drawingml/2006/main">
+              <a:ext uri="{FF2B5EF4-FFF2-40B4-BE49-F238E27FC236}">
+                <a16:creationId xmlns:a16="http://schemas.microsoft.com/office/drawing/2014/main" id="{64693799-1AA4-46DD-8844-F7194C729862}"/>
+              </a:ext>
+            </a:extLst>
+          </p:cNvPr>
+          <p:cNvSpPr>
+            <a:spLocks xmlns:a="http://schemas.openxmlformats.org/drawingml/2006/main" noGrp="1"/>
+          </p:cNvSpPr>
+          <p:nvPr/>
+        </p:nvSpPr>
+        <p:spPr>
+          <a:xfrm xmlns:a="http://schemas.openxmlformats.org/drawingml/2006/main">
+            <a:off x="8477250" y="2705100"/>
+            <a:ext cx="2705100" cy="2095500"/>
+          </a:xfrm>
+          <a:prstGeom xmlns:a="http://schemas.openxmlformats.org/drawingml/2006/main" prst="rect">
+            <a:avLst/>
+          </a:prstGeom>
+          <a:noFill xmlns:a="http://schemas.openxmlformats.org/drawingml/2006/main"/>
+          <a:ln xmlns:a="http://schemas.openxmlformats.org/drawingml/2006/main" w="0">
+            <a:noFill/>
+            <a:prstDash val="solid"/>
+          </a:ln>
+        </p:spPr>
+        <p:txBody>
+          <a:bodyPr xmlns:a="http://schemas.openxmlformats.org/drawingml/2006/main"/>
+          <a:lstStyle xmlns:a="http://schemas.openxmlformats.org/drawingml/2006/main"/>
+          <a:p xmlns:a="http://schemas.openxmlformats.org/drawingml/2006/main">
+            <a:pPr algn="l">
+              <a:defRPr sz="1650" b="0" i="0">
+                <a:solidFill>
+                  <a:srgbClr val="222222"/>
+                </a:solidFill>
+              </a:defRPr>
+            </a:pPr>
+            <a:r>
+              <a:rPr sz="1650" b="0" i="0">
+                <a:solidFill>
+                  <a:srgbClr val="222222"/>
+                </a:solidFill>
+              </a:rPr>
+              <a:t>The TRAIN grid policy lifted 2020 exposure from 27.6% to 34.8% and return from 8.0% to 30.0%. It still lagged the basket by -184.0%.</a:t>
+            </a:r>
+          </a:p>
+        </p:txBody>
+      </p:sp>
+    </p:spTree>
+    <p:extLst>
+      <p:ext uri="{BB962C8B-B14F-4D97-AF65-F5344CB8AC3E}">
+        <p14:creationId xmlns:p14="http://schemas.microsoft.com/office/powerpoint/2010/main" val="1298937151"/>
+      </p:ext>
+    </p:extLst>
+  </p:cSld>
+</p:sld>
+</file>
+
+<file path=ppt/slides/slide21.xml><?xml version="1.0" encoding="utf-8"?>
+<p:sld xmlns:p="http://schemas.openxmlformats.org/presentationml/2006/main">
+  <p:cSld>
+    <p:bg>
+      <p:bgPr>
+        <a:solidFill xmlns:a="http://schemas.openxmlformats.org/drawingml/2006/main">
+          <a:srgbClr val="FFFFFF"/>
+        </a:solidFill>
+      </p:bgPr>
+    </p:bg>
+    <p:spTree>
+      <p:nvGrpSpPr>
+        <p:cNvPr id="1" name=""/>
+        <p:cNvGrpSpPr/>
+        <p:nvPr/>
+      </p:nvGrpSpPr>
+      <p:grpSpPr>
+        <a:xfrm xmlns:a="http://schemas.openxmlformats.org/drawingml/2006/main"/>
+      </p:grpSpPr>
+      <p:sp>
+        <p:nvSpPr>
+          <p:cNvPr id="1" name="">
+            <a:extLst xmlns:a="http://schemas.openxmlformats.org/drawingml/2006/main">
+              <a:ext uri="{FF2B5EF4-FFF2-40B4-BE49-F238E27FC236}">
+                <a16:creationId xmlns:a16="http://schemas.microsoft.com/office/drawing/2014/main" id="{BCF0FBBD-D988-4492-8E98-AE0F074632C0}"/>
+              </a:ext>
+            </a:extLst>
+          </p:cNvPr>
+          <p:cNvSpPr>
+            <a:spLocks xmlns:a="http://schemas.openxmlformats.org/drawingml/2006/main" noGrp="1"/>
+          </p:cNvSpPr>
+          <p:nvPr/>
+        </p:nvSpPr>
+        <p:spPr>
+          <a:xfrm xmlns:a="http://schemas.openxmlformats.org/drawingml/2006/main">
+            <a:off x="685800" y="400050"/>
+            <a:ext cx="8572500" cy="247650"/>
+          </a:xfrm>
+          <a:prstGeom xmlns:a="http://schemas.openxmlformats.org/drawingml/2006/main" prst="rect">
+            <a:avLst/>
+          </a:prstGeom>
+          <a:noFill xmlns:a="http://schemas.openxmlformats.org/drawingml/2006/main"/>
+          <a:ln xmlns:a="http://schemas.openxmlformats.org/drawingml/2006/main" w="0">
+            <a:noFill/>
+            <a:prstDash val="solid"/>
+          </a:ln>
+        </p:spPr>
+        <p:txBody>
+          <a:bodyPr xmlns:a="http://schemas.openxmlformats.org/drawingml/2006/main"/>
+          <a:lstStyle xmlns:a="http://schemas.openxmlformats.org/drawingml/2006/main"/>
+          <a:p xmlns:a="http://schemas.openxmlformats.org/drawingml/2006/main">
+            <a:pPr algn="l">
+              <a:defRPr sz="975" b="1" i="0">
+                <a:solidFill>
+                  <a:srgbClr val="555555"/>
+                </a:solidFill>
+              </a:defRPr>
+            </a:pPr>
+            <a:r>
+              <a:rPr sz="975" b="1" i="0">
+                <a:solidFill>
+                  <a:srgbClr val="555555"/>
+                </a:solidFill>
+              </a:rPr>
+              <a:t>GEN5.4 ML DECISION ENGINE</a:t>
+            </a:r>
+          </a:p>
+        </p:txBody>
+      </p:sp>
+      <p:sp>
+        <p:nvSpPr>
+          <p:cNvPr id="2" name="">
+            <a:extLst xmlns:a="http://schemas.openxmlformats.org/drawingml/2006/main">
+              <a:ext uri="{FF2B5EF4-FFF2-40B4-BE49-F238E27FC236}">
+                <a16:creationId xmlns:a16="http://schemas.microsoft.com/office/drawing/2014/main" id="{A41327A0-7A27-42C2-BF57-6B055337311D}"/>
+              </a:ext>
+            </a:extLst>
+          </p:cNvPr>
+          <p:cNvSpPr>
+            <a:spLocks xmlns:a="http://schemas.openxmlformats.org/drawingml/2006/main" noGrp="1"/>
+          </p:cNvSpPr>
+          <p:nvPr/>
+        </p:nvSpPr>
+        <p:spPr>
+          <a:xfrm xmlns:a="http://schemas.openxmlformats.org/drawingml/2006/main">
+            <a:off x="685800" y="723900"/>
+            <a:ext cx="10287000" cy="876300"/>
+          </a:xfrm>
+          <a:prstGeom xmlns:a="http://schemas.openxmlformats.org/drawingml/2006/main" prst="rect">
+            <a:avLst/>
+          </a:prstGeom>
+          <a:noFill xmlns:a="http://schemas.openxmlformats.org/drawingml/2006/main"/>
+          <a:ln xmlns:a="http://schemas.openxmlformats.org/drawingml/2006/main" w="0">
+            <a:noFill/>
+            <a:prstDash val="solid"/>
+          </a:ln>
+        </p:spPr>
+        <p:txBody>
+          <a:bodyPr xmlns:a="http://schemas.openxmlformats.org/drawingml/2006/main"/>
+          <a:lstStyle xmlns:a="http://schemas.openxmlformats.org/drawingml/2006/main"/>
+          <a:p xmlns:a="http://schemas.openxmlformats.org/drawingml/2006/main">
+            <a:pPr algn="l">
+              <a:defRPr sz="2850" b="1" i="0">
+                <a:solidFill>
+                  <a:srgbClr val="000000"/>
+                </a:solidFill>
+              </a:defRPr>
+            </a:pPr>
+            <a:r>
+              <a:rPr sz="2850" b="1" i="0">
+                <a:solidFill>
+                  <a:srgbClr val="000000"/>
+                </a:solidFill>
+              </a:rPr>
+              <a:t>The selected thresholds explain the behavior change</a:t>
+            </a:r>
+          </a:p>
+        </p:txBody>
+      </p:sp>
+      <p:sp>
+        <p:nvSpPr>
+          <p:cNvPr id="3" name="">
+            <a:extLst xmlns:a="http://schemas.openxmlformats.org/drawingml/2006/main">
+              <a:ext uri="{FF2B5EF4-FFF2-40B4-BE49-F238E27FC236}">
+                <a16:creationId xmlns:a16="http://schemas.microsoft.com/office/drawing/2014/main" id="{2B9F3B9E-881B-4C58-B5F1-5E161C3E7D3B}"/>
+              </a:ext>
+            </a:extLst>
+          </p:cNvPr>
+          <p:cNvSpPr>
+            <a:spLocks xmlns:a="http://schemas.openxmlformats.org/drawingml/2006/main" noGrp="1"/>
+          </p:cNvSpPr>
+          <p:nvPr/>
+        </p:nvSpPr>
+        <p:spPr>
+          <a:xfrm xmlns:a="http://schemas.openxmlformats.org/drawingml/2006/main">
+            <a:off x="685800" y="1657350"/>
+            <a:ext cx="10820400" cy="19050"/>
+          </a:xfrm>
+          <a:prstGeom xmlns:a="http://schemas.openxmlformats.org/drawingml/2006/main" prst="rect">
+            <a:avLst/>
+          </a:prstGeom>
+          <a:solidFill xmlns:a="http://schemas.openxmlformats.org/drawingml/2006/main">
+            <a:srgbClr val="B8BCC4"/>
+          </a:solidFill>
+          <a:ln xmlns:a="http://schemas.openxmlformats.org/drawingml/2006/main" w="0">
+            <a:noFill/>
+            <a:prstDash val="solid"/>
+          </a:ln>
+        </p:spPr>
+      </p:sp>
+      <p:pic>
+        <p:nvPicPr>
+          <p:cNvPr id="10" name=""/>
+          <p:cNvPicPr>
+            <a:picLocks xmlns:a="http://schemas.openxmlformats.org/drawingml/2006/main" noChangeAspect="1"/>
+          </p:cNvPicPr>
+          <p:nvPr/>
+        </p:nvPicPr>
+        <p:blipFill>
+          <a:blip xmlns:r="http://schemas.openxmlformats.org/officeDocument/2006/relationships" xmlns:a="http://schemas.openxmlformats.org/drawingml/2006/main" r:embed="Rd98ddd17608a4c74"/>
+          <a:stretch xmlns:a="http://schemas.openxmlformats.org/drawingml/2006/main"/>
+        </p:blipFill>
+        <p:spPr>
+          <a:xfrm xmlns:a="http://schemas.openxmlformats.org/drawingml/2006/main">
+            <a:off x="704850" y="2423013"/>
+            <a:ext cx="4762500" cy="2564423"/>
+          </a:xfrm>
+          <a:prstGeom xmlns:a="http://schemas.openxmlformats.org/drawingml/2006/main" prst="rect">
+            <a:avLst/>
+          </a:prstGeom>
+        </p:spPr>
+      </p:pic>
+      <p:pic>
+        <p:nvPicPr>
+          <p:cNvPr id="11" name=""/>
+          <p:cNvPicPr>
+            <a:picLocks xmlns:a="http://schemas.openxmlformats.org/drawingml/2006/main" noChangeAspect="1"/>
+          </p:cNvPicPr>
+          <p:nvPr/>
+        </p:nvPicPr>
+        <p:blipFill>
+          <a:blip xmlns:r="http://schemas.openxmlformats.org/officeDocument/2006/relationships" xmlns:a="http://schemas.openxmlformats.org/drawingml/2006/main" r:embed="Ra7d703bb8ba34158"/>
+          <a:stretch xmlns:a="http://schemas.openxmlformats.org/drawingml/2006/main"/>
+        </p:blipFill>
+        <p:spPr>
+          <a:xfrm xmlns:a="http://schemas.openxmlformats.org/drawingml/2006/main">
+            <a:off x="5962650" y="2382308"/>
+            <a:ext cx="4762500" cy="2645833"/>
+          </a:xfrm>
+          <a:prstGeom xmlns:a="http://schemas.openxmlformats.org/drawingml/2006/main" prst="rect">
+            <a:avLst/>
+          </a:prstGeom>
+        </p:spPr>
+      </p:pic>
+      <p:sp>
+        <p:nvSpPr>
+          <p:cNvPr id="6" name="">
+            <a:extLst xmlns:a="http://schemas.openxmlformats.org/drawingml/2006/main">
+              <a:ext uri="{FF2B5EF4-FFF2-40B4-BE49-F238E27FC236}">
+                <a16:creationId xmlns:a16="http://schemas.microsoft.com/office/drawing/2014/main" id="{BB8C1535-43A3-484B-8C31-56A83797EA9D}"/>
+              </a:ext>
+            </a:extLst>
+          </p:cNvPr>
+          <p:cNvSpPr>
+            <a:spLocks xmlns:a="http://schemas.openxmlformats.org/drawingml/2006/main" noGrp="1"/>
+          </p:cNvSpPr>
+          <p:nvPr/>
+        </p:nvSpPr>
+        <p:spPr>
+          <a:xfrm xmlns:a="http://schemas.openxmlformats.org/drawingml/2006/main">
+            <a:off x="1104900" y="5753100"/>
+            <a:ext cx="9334500" cy="457200"/>
+          </a:xfrm>
+          <a:prstGeom xmlns:a="http://schemas.openxmlformats.org/drawingml/2006/main" prst="rect">
+            <a:avLst/>
+          </a:prstGeom>
+          <a:noFill xmlns:a="http://schemas.openxmlformats.org/drawingml/2006/main"/>
+          <a:ln xmlns:a="http://schemas.openxmlformats.org/drawingml/2006/main" w="0">
+            <a:noFill/>
+            <a:prstDash val="solid"/>
+          </a:ln>
+        </p:spPr>
+        <p:txBody>
+          <a:bodyPr xmlns:a="http://schemas.openxmlformats.org/drawingml/2006/main"/>
+          <a:lstStyle xmlns:a="http://schemas.openxmlformats.org/drawingml/2006/main"/>
+          <a:p xmlns:a="http://schemas.openxmlformats.org/drawingml/2006/main">
+            <a:pPr algn="ctr">
+              <a:defRPr sz="1500" b="0" i="0">
+                <a:solidFill>
+                  <a:srgbClr val="555555"/>
+                </a:solidFill>
+              </a:defRPr>
+            </a:pPr>
+            <a:r>
+              <a:rPr sz="1500" b="0" i="0">
+                <a:solidFill>
+                  <a:srgbClr val="555555"/>
+                </a:solidFill>
+              </a:rPr>
+              <a:t>The grid policy's average TRAIN entry threshold was 0.54, with a TRAIN proxy exposure target around 69.7%. That made it more permissive in 2020, but also more exposed in 2022.</a:t>
+            </a:r>
+          </a:p>
+        </p:txBody>
+      </p:sp>
+    </p:spTree>
+    <p:extLst>
+      <p:ext uri="{BB962C8B-B14F-4D97-AF65-F5344CB8AC3E}">
+        <p14:creationId xmlns:p14="http://schemas.microsoft.com/office/powerpoint/2010/main" val="101883177"/>
+      </p:ext>
+    </p:extLst>
+  </p:cSld>
+</p:sld>
+</file>
+
+<file path=ppt/slides/slide22.xml><?xml version="1.0" encoding="utf-8"?>
+<p:sld xmlns:p="http://schemas.openxmlformats.org/presentationml/2006/main">
+  <p:cSld>
+    <p:bg>
+      <p:bgPr>
+        <a:solidFill xmlns:a="http://schemas.openxmlformats.org/drawingml/2006/main">
+          <a:srgbClr val="FFFFFF"/>
+        </a:solidFill>
+      </p:bgPr>
+    </p:bg>
+    <p:spTree>
+      <p:nvGrpSpPr>
+        <p:cNvPr id="1" name=""/>
+        <p:cNvGrpSpPr/>
+        <p:nvPr/>
+      </p:nvGrpSpPr>
+      <p:grpSpPr>
+        <a:xfrm xmlns:a="http://schemas.openxmlformats.org/drawingml/2006/main"/>
+      </p:grpSpPr>
+      <p:sp>
+        <p:nvSpPr>
+          <p:cNvPr id="1" name="">
+            <a:extLst xmlns:a="http://schemas.openxmlformats.org/drawingml/2006/main">
+              <a:ext uri="{FF2B5EF4-FFF2-40B4-BE49-F238E27FC236}">
+                <a16:creationId xmlns:a16="http://schemas.microsoft.com/office/drawing/2014/main" id="{A02C6740-30F1-4D36-93A2-BB0F049895AC}"/>
+              </a:ext>
+            </a:extLst>
+          </p:cNvPr>
+          <p:cNvSpPr>
+            <a:spLocks xmlns:a="http://schemas.openxmlformats.org/drawingml/2006/main" noGrp="1"/>
+          </p:cNvSpPr>
+          <p:nvPr/>
+        </p:nvSpPr>
+        <p:spPr>
+          <a:xfrm xmlns:a="http://schemas.openxmlformats.org/drawingml/2006/main">
+            <a:off x="685800" y="400050"/>
+            <a:ext cx="8572500" cy="247650"/>
+          </a:xfrm>
+          <a:prstGeom xmlns:a="http://schemas.openxmlformats.org/drawingml/2006/main" prst="rect">
+            <a:avLst/>
+          </a:prstGeom>
+          <a:noFill xmlns:a="http://schemas.openxmlformats.org/drawingml/2006/main"/>
+          <a:ln xmlns:a="http://schemas.openxmlformats.org/drawingml/2006/main" w="0">
+            <a:noFill/>
+            <a:prstDash val="solid"/>
+          </a:ln>
+        </p:spPr>
+        <p:txBody>
+          <a:bodyPr xmlns:a="http://schemas.openxmlformats.org/drawingml/2006/main"/>
+          <a:lstStyle xmlns:a="http://schemas.openxmlformats.org/drawingml/2006/main"/>
+          <a:p xmlns:a="http://schemas.openxmlformats.org/drawingml/2006/main">
+            <a:pPr algn="l">
+              <a:defRPr sz="975" b="1" i="0">
+                <a:solidFill>
+                  <a:srgbClr val="555555"/>
+                </a:solidFill>
+              </a:defRPr>
+            </a:pPr>
+            <a:r>
+              <a:rPr sz="975" b="1" i="0">
+                <a:solidFill>
+                  <a:srgbClr val="555555"/>
+                </a:solidFill>
+              </a:rPr>
+              <a:t>GEN5.4 ML DECISION ENGINE</a:t>
+            </a:r>
+          </a:p>
+        </p:txBody>
+      </p:sp>
+      <p:sp>
+        <p:nvSpPr>
+          <p:cNvPr id="2" name="">
+            <a:extLst xmlns:a="http://schemas.openxmlformats.org/drawingml/2006/main">
+              <a:ext uri="{FF2B5EF4-FFF2-40B4-BE49-F238E27FC236}">
+                <a16:creationId xmlns:a16="http://schemas.microsoft.com/office/drawing/2014/main" id="{69727F43-7D1B-4582-A8B5-AD28A3ACB605}"/>
+              </a:ext>
+            </a:extLst>
+          </p:cNvPr>
+          <p:cNvSpPr>
+            <a:spLocks xmlns:a="http://schemas.openxmlformats.org/drawingml/2006/main" noGrp="1"/>
+          </p:cNvSpPr>
+          <p:nvPr/>
+        </p:nvSpPr>
+        <p:spPr>
+          <a:xfrm xmlns:a="http://schemas.openxmlformats.org/drawingml/2006/main">
+            <a:off x="685800" y="723900"/>
+            <a:ext cx="10287000" cy="876300"/>
+          </a:xfrm>
+          <a:prstGeom xmlns:a="http://schemas.openxmlformats.org/drawingml/2006/main" prst="rect">
+            <a:avLst/>
+          </a:prstGeom>
+          <a:noFill xmlns:a="http://schemas.openxmlformats.org/drawingml/2006/main"/>
+          <a:ln xmlns:a="http://schemas.openxmlformats.org/drawingml/2006/main" w="0">
+            <a:noFill/>
+            <a:prstDash val="solid"/>
+          </a:ln>
+        </p:spPr>
+        <p:txBody>
+          <a:bodyPr xmlns:a="http://schemas.openxmlformats.org/drawingml/2006/main"/>
+          <a:lstStyle xmlns:a="http://schemas.openxmlformats.org/drawingml/2006/main"/>
+          <a:p xmlns:a="http://schemas.openxmlformats.org/drawingml/2006/main">
+            <a:pPr algn="l">
+              <a:defRPr sz="2850" b="1" i="0">
+                <a:solidFill>
+                  <a:srgbClr val="000000"/>
+                </a:solidFill>
+              </a:defRPr>
+            </a:pPr>
+            <a:r>
+              <a:rPr sz="2850" b="1" i="0">
+                <a:solidFill>
+                  <a:srgbClr val="000000"/>
+                </a:solidFill>
+              </a:rPr>
+              <a:t>Probability tapes show that the model rarely loved the rally early enough</a:t>
+            </a:r>
+          </a:p>
+        </p:txBody>
+      </p:sp>
+      <p:sp>
+        <p:nvSpPr>
+          <p:cNvPr id="3" name="">
+            <a:extLst xmlns:a="http://schemas.openxmlformats.org/drawingml/2006/main">
+              <a:ext uri="{FF2B5EF4-FFF2-40B4-BE49-F238E27FC236}">
+                <a16:creationId xmlns:a16="http://schemas.microsoft.com/office/drawing/2014/main" id="{E8CF2791-57E7-4AC8-B93D-5321E68F3526}"/>
+              </a:ext>
+            </a:extLst>
+          </p:cNvPr>
+          <p:cNvSpPr>
+            <a:spLocks xmlns:a="http://schemas.openxmlformats.org/drawingml/2006/main" noGrp="1"/>
+          </p:cNvSpPr>
+          <p:nvPr/>
+        </p:nvSpPr>
+        <p:spPr>
+          <a:xfrm xmlns:a="http://schemas.openxmlformats.org/drawingml/2006/main">
+            <a:off x="685800" y="1657350"/>
+            <a:ext cx="10820400" cy="19050"/>
+          </a:xfrm>
+          <a:prstGeom xmlns:a="http://schemas.openxmlformats.org/drawingml/2006/main" prst="rect">
+            <a:avLst/>
+          </a:prstGeom>
+          <a:solidFill xmlns:a="http://schemas.openxmlformats.org/drawingml/2006/main">
+            <a:srgbClr val="B8BCC4"/>
+          </a:solidFill>
+          <a:ln xmlns:a="http://schemas.openxmlformats.org/drawingml/2006/main" w="0">
+            <a:noFill/>
+            <a:prstDash val="solid"/>
+          </a:ln>
+        </p:spPr>
+      </p:sp>
+      <p:pic>
+        <p:nvPicPr>
+          <p:cNvPr id="10" name=""/>
+          <p:cNvPicPr>
+            <a:picLocks xmlns:a="http://schemas.openxmlformats.org/drawingml/2006/main" noChangeAspect="1"/>
+          </p:cNvPicPr>
+          <p:nvPr/>
+        </p:nvPicPr>
+        <p:blipFill>
+          <a:blip xmlns:r="http://schemas.openxmlformats.org/officeDocument/2006/relationships" xmlns:a="http://schemas.openxmlformats.org/drawingml/2006/main" r:embed="R83abcb0ad649416f"/>
+          <a:stretch xmlns:a="http://schemas.openxmlformats.org/drawingml/2006/main"/>
+        </p:blipFill>
+        <p:spPr>
+          <a:xfrm xmlns:a="http://schemas.openxmlformats.org/drawingml/2006/main">
+            <a:off x="1038785" y="2000250"/>
+            <a:ext cx="6494929" cy="3943350"/>
+          </a:xfrm>
+          <a:prstGeom xmlns:a="http://schemas.openxmlformats.org/drawingml/2006/main" prst="rect">
+            <a:avLst/>
+          </a:prstGeom>
+        </p:spPr>
+      </p:pic>
+      <p:sp>
+        <p:nvSpPr>
+          <p:cNvPr id="5" name="">
+            <a:extLst xmlns:a="http://schemas.openxmlformats.org/drawingml/2006/main">
+              <a:ext uri="{FF2B5EF4-FFF2-40B4-BE49-F238E27FC236}">
+                <a16:creationId xmlns:a16="http://schemas.microsoft.com/office/drawing/2014/main" id="{A34E1FB5-5D95-4D38-A0B4-49271EE1E532}"/>
+              </a:ext>
+            </a:extLst>
+          </p:cNvPr>
+          <p:cNvSpPr>
+            <a:spLocks xmlns:a="http://schemas.openxmlformats.org/drawingml/2006/main" noGrp="1"/>
+          </p:cNvSpPr>
+          <p:nvPr/>
+        </p:nvSpPr>
+        <p:spPr>
+          <a:xfrm xmlns:a="http://schemas.openxmlformats.org/drawingml/2006/main">
+            <a:off x="8477250" y="2133600"/>
+            <a:ext cx="2571750" cy="304800"/>
+          </a:xfrm>
+          <a:prstGeom xmlns:a="http://schemas.openxmlformats.org/drawingml/2006/main" prst="rect">
+            <a:avLst/>
+          </a:prstGeom>
+          <a:noFill xmlns:a="http://schemas.openxmlformats.org/drawingml/2006/main"/>
+          <a:ln xmlns:a="http://schemas.openxmlformats.org/drawingml/2006/main" w="0">
+            <a:noFill/>
+            <a:prstDash val="solid"/>
+          </a:ln>
+        </p:spPr>
+        <p:txBody>
+          <a:bodyPr xmlns:a="http://schemas.openxmlformats.org/drawingml/2006/main"/>
+          <a:lstStyle xmlns:a="http://schemas.openxmlformats.org/drawingml/2006/main"/>
+          <a:p xmlns:a="http://schemas.openxmlformats.org/drawingml/2006/main">
+            <a:pPr algn="l">
+              <a:defRPr sz="1950" b="1" i="0">
+                <a:solidFill>
+                  <a:srgbClr val="222222"/>
+                </a:solidFill>
+              </a:defRPr>
+            </a:pPr>
+            <a:r>
+              <a:rPr sz="1950" b="1" i="0">
+                <a:solidFill>
+                  <a:srgbClr val="222222"/>
+                </a:solidFill>
+              </a:rPr>
+              <a:t>Why this matters</a:t>
+            </a:r>
+          </a:p>
+        </p:txBody>
+      </p:sp>
+      <p:sp>
+        <p:nvSpPr>
+          <p:cNvPr id="6" name="">
+            <a:extLst xmlns:a="http://schemas.openxmlformats.org/drawingml/2006/main">
+              <a:ext uri="{FF2B5EF4-FFF2-40B4-BE49-F238E27FC236}">
+                <a16:creationId xmlns:a16="http://schemas.microsoft.com/office/drawing/2014/main" id="{9538687C-79B2-43E1-9DA7-B640CB6B3B42}"/>
+              </a:ext>
+            </a:extLst>
+          </p:cNvPr>
+          <p:cNvSpPr>
+            <a:spLocks xmlns:a="http://schemas.openxmlformats.org/drawingml/2006/main" noGrp="1"/>
+          </p:cNvSpPr>
+          <p:nvPr/>
+        </p:nvSpPr>
+        <p:spPr>
+          <a:xfrm xmlns:a="http://schemas.openxmlformats.org/drawingml/2006/main">
+            <a:off x="8477250" y="2705100"/>
+            <a:ext cx="2705100" cy="2286000"/>
+          </a:xfrm>
+          <a:prstGeom xmlns:a="http://schemas.openxmlformats.org/drawingml/2006/main" prst="rect">
+            <a:avLst/>
+          </a:prstGeom>
+          <a:noFill xmlns:a="http://schemas.openxmlformats.org/drawingml/2006/main"/>
+          <a:ln xmlns:a="http://schemas.openxmlformats.org/drawingml/2006/main" w="0">
+            <a:noFill/>
+            <a:prstDash val="solid"/>
+          </a:ln>
+        </p:spPr>
+        <p:txBody>
+          <a:bodyPr xmlns:a="http://schemas.openxmlformats.org/drawingml/2006/main"/>
+          <a:lstStyle xmlns:a="http://schemas.openxmlformats.org/drawingml/2006/main"/>
+          <a:p xmlns:a="http://schemas.openxmlformats.org/drawingml/2006/main">
+            <a:pPr algn="l">
+              <a:defRPr sz="1650" b="0" i="0">
+                <a:solidFill>
+                  <a:srgbClr val="222222"/>
+                </a:solidFill>
+              </a:defRPr>
+            </a:pPr>
+            <a:r>
+              <a:rPr sz="1650" b="0" i="0">
+                <a:solidFill>
+                  <a:srgbClr val="222222"/>
+                </a:solidFill>
+              </a:rPr>
+              <a:t>Lowering thresholds creates more entries, but the probability trace still spends long rally stretches below the entry line. The next question is whether calibration, labels, or model class can rank those days better.</a:t>
+            </a:r>
+          </a:p>
+        </p:txBody>
+      </p:sp>
+    </p:spTree>
+    <p:extLst>
+      <p:ext uri="{BB962C8B-B14F-4D97-AF65-F5344CB8AC3E}">
+        <p14:creationId xmlns:p14="http://schemas.microsoft.com/office/powerpoint/2010/main" val="782373323"/>
+      </p:ext>
+    </p:extLst>
+  </p:cSld>
+</p:sld>
+</file>
+
+<file path=ppt/slides/slide23.xml><?xml version="1.0" encoding="utf-8"?>
+<p:sld xmlns:p="http://schemas.openxmlformats.org/presentationml/2006/main">
+  <p:cSld>
+    <p:bg>
+      <p:bgPr>
+        <a:solidFill xmlns:a="http://schemas.openxmlformats.org/drawingml/2006/main">
+          <a:srgbClr val="FFFFFF"/>
+        </a:solidFill>
+      </p:bgPr>
+    </p:bg>
+    <p:spTree>
+      <p:nvGrpSpPr>
+        <p:cNvPr id="1" name=""/>
+        <p:cNvGrpSpPr/>
+        <p:nvPr/>
+      </p:nvGrpSpPr>
+      <p:grpSpPr>
+        <a:xfrm xmlns:a="http://schemas.openxmlformats.org/drawingml/2006/main"/>
+      </p:grpSpPr>
+      <p:sp>
+        <p:nvSpPr>
+          <p:cNvPr id="1" name="">
+            <a:extLst xmlns:a="http://schemas.openxmlformats.org/drawingml/2006/main">
+              <a:ext uri="{FF2B5EF4-FFF2-40B4-BE49-F238E27FC236}">
+                <a16:creationId xmlns:a16="http://schemas.microsoft.com/office/drawing/2014/main" id="{FD17ADD5-5D4A-41E5-AF9E-1020C0C460AF}"/>
+              </a:ext>
+            </a:extLst>
+          </p:cNvPr>
+          <p:cNvSpPr>
+            <a:spLocks xmlns:a="http://schemas.openxmlformats.org/drawingml/2006/main" noGrp="1"/>
+          </p:cNvSpPr>
+          <p:nvPr/>
+        </p:nvSpPr>
+        <p:spPr>
+          <a:xfrm xmlns:a="http://schemas.openxmlformats.org/drawingml/2006/main">
+            <a:off x="685800" y="400050"/>
+            <a:ext cx="8572500" cy="247650"/>
+          </a:xfrm>
+          <a:prstGeom xmlns:a="http://schemas.openxmlformats.org/drawingml/2006/main" prst="rect">
+            <a:avLst/>
+          </a:prstGeom>
+          <a:noFill xmlns:a="http://schemas.openxmlformats.org/drawingml/2006/main"/>
+          <a:ln xmlns:a="http://schemas.openxmlformats.org/drawingml/2006/main" w="0">
+            <a:noFill/>
+            <a:prstDash val="solid"/>
+          </a:ln>
+        </p:spPr>
+        <p:txBody>
+          <a:bodyPr xmlns:a="http://schemas.openxmlformats.org/drawingml/2006/main"/>
+          <a:lstStyle xmlns:a="http://schemas.openxmlformats.org/drawingml/2006/main"/>
+          <a:p xmlns:a="http://schemas.openxmlformats.org/drawingml/2006/main">
+            <a:pPr algn="l">
+              <a:defRPr sz="975" b="1" i="0">
+                <a:solidFill>
+                  <a:srgbClr val="555555"/>
+                </a:solidFill>
+              </a:defRPr>
+            </a:pPr>
+            <a:r>
+              <a:rPr sz="975" b="1" i="0">
+                <a:solidFill>
+                  <a:srgbClr val="555555"/>
+                </a:solidFill>
+              </a:rPr>
+              <a:t>GEN5.4 ML DECISION ENGINE</a:t>
+            </a:r>
+          </a:p>
+        </p:txBody>
+      </p:sp>
+      <p:sp>
+        <p:nvSpPr>
+          <p:cNvPr id="2" name="">
+            <a:extLst xmlns:a="http://schemas.openxmlformats.org/drawingml/2006/main">
+              <a:ext uri="{FF2B5EF4-FFF2-40B4-BE49-F238E27FC236}">
+                <a16:creationId xmlns:a16="http://schemas.microsoft.com/office/drawing/2014/main" id="{FACCF5EB-DC5F-416A-B583-92492EDC6880}"/>
+              </a:ext>
+            </a:extLst>
+          </p:cNvPr>
+          <p:cNvSpPr>
+            <a:spLocks xmlns:a="http://schemas.openxmlformats.org/drawingml/2006/main" noGrp="1"/>
+          </p:cNvSpPr>
+          <p:nvPr/>
+        </p:nvSpPr>
+        <p:spPr>
+          <a:xfrm xmlns:a="http://schemas.openxmlformats.org/drawingml/2006/main">
+            <a:off x="685800" y="723900"/>
+            <a:ext cx="10287000" cy="876300"/>
+          </a:xfrm>
+          <a:prstGeom xmlns:a="http://schemas.openxmlformats.org/drawingml/2006/main" prst="rect">
+            <a:avLst/>
+          </a:prstGeom>
+          <a:noFill xmlns:a="http://schemas.openxmlformats.org/drawingml/2006/main"/>
+          <a:ln xmlns:a="http://schemas.openxmlformats.org/drawingml/2006/main" w="0">
+            <a:noFill/>
+            <a:prstDash val="solid"/>
+          </a:ln>
+        </p:spPr>
+        <p:txBody>
+          <a:bodyPr xmlns:a="http://schemas.openxmlformats.org/drawingml/2006/main"/>
+          <a:lstStyle xmlns:a="http://schemas.openxmlformats.org/drawingml/2006/main"/>
+          <a:p xmlns:a="http://schemas.openxmlformats.org/drawingml/2006/main">
+            <a:pPr algn="l">
+              <a:defRPr sz="2850" b="1" i="0">
+                <a:solidFill>
+                  <a:srgbClr val="000000"/>
+                </a:solidFill>
+              </a:defRPr>
+            </a:pPr>
+            <a:r>
+              <a:rPr sz="2850" b="1" i="0">
+                <a:solidFill>
+                  <a:srgbClr val="000000"/>
+                </a:solidFill>
+              </a:rPr>
+              <a:t>The next ML slice should test probability quality, not just more exposure</a:t>
+            </a:r>
+          </a:p>
+        </p:txBody>
+      </p:sp>
+      <p:sp>
+        <p:nvSpPr>
+          <p:cNvPr id="3" name="">
+            <a:extLst xmlns:a="http://schemas.openxmlformats.org/drawingml/2006/main">
+              <a:ext uri="{FF2B5EF4-FFF2-40B4-BE49-F238E27FC236}">
+                <a16:creationId xmlns:a16="http://schemas.microsoft.com/office/drawing/2014/main" id="{8099C2E4-2E99-47E9-BB55-FD15713B3DED}"/>
+              </a:ext>
+            </a:extLst>
+          </p:cNvPr>
+          <p:cNvSpPr>
+            <a:spLocks xmlns:a="http://schemas.openxmlformats.org/drawingml/2006/main" noGrp="1"/>
+          </p:cNvSpPr>
+          <p:nvPr/>
+        </p:nvSpPr>
+        <p:spPr>
+          <a:xfrm xmlns:a="http://schemas.openxmlformats.org/drawingml/2006/main">
+            <a:off x="685800" y="1657350"/>
+            <a:ext cx="10820400" cy="19050"/>
+          </a:xfrm>
+          <a:prstGeom xmlns:a="http://schemas.openxmlformats.org/drawingml/2006/main" prst="rect">
+            <a:avLst/>
+          </a:prstGeom>
+          <a:solidFill xmlns:a="http://schemas.openxmlformats.org/drawingml/2006/main">
+            <a:srgbClr val="B8BCC4"/>
+          </a:solidFill>
+          <a:ln xmlns:a="http://schemas.openxmlformats.org/drawingml/2006/main" w="0">
+            <a:noFill/>
+            <a:prstDash val="solid"/>
+          </a:ln>
+        </p:spPr>
+      </p:sp>
+      <p:sp>
+        <p:nvSpPr>
+          <p:cNvPr id="4" name="">
+            <a:extLst xmlns:a="http://schemas.openxmlformats.org/drawingml/2006/main">
+              <a:ext uri="{FF2B5EF4-FFF2-40B4-BE49-F238E27FC236}">
+                <a16:creationId xmlns:a16="http://schemas.microsoft.com/office/drawing/2014/main" id="{F7D8E924-5023-4E7D-84D9-15B959710D10}"/>
+              </a:ext>
+            </a:extLst>
+          </p:cNvPr>
+          <p:cNvSpPr>
+            <a:spLocks xmlns:a="http://schemas.openxmlformats.org/drawingml/2006/main" noGrp="1"/>
+          </p:cNvSpPr>
+          <p:nvPr/>
+        </p:nvSpPr>
+        <p:spPr>
+          <a:xfrm xmlns:a="http://schemas.openxmlformats.org/drawingml/2006/main">
+            <a:off x="876300" y="2133600"/>
+            <a:ext cx="9334500" cy="914400"/>
+          </a:xfrm>
+          <a:prstGeom xmlns:a="http://schemas.openxmlformats.org/drawingml/2006/main" prst="rect">
+            <a:avLst/>
+          </a:prstGeom>
+          <a:noFill xmlns:a="http://schemas.openxmlformats.org/drawingml/2006/main"/>
+          <a:ln xmlns:a="http://schemas.openxmlformats.org/drawingml/2006/main" w="0">
+            <a:noFill/>
+            <a:prstDash val="solid"/>
+          </a:ln>
+        </p:spPr>
+        <p:txBody>
+          <a:bodyPr xmlns:a="http://schemas.openxmlformats.org/drawingml/2006/main"/>
+          <a:lstStyle xmlns:a="http://schemas.openxmlformats.org/drawingml/2006/main"/>
+          <a:p xmlns:a="http://schemas.openxmlformats.org/drawingml/2006/main">
+            <a:pPr algn="l">
+              <a:defRPr sz="2250" b="1" i="0">
+                <a:solidFill>
+                  <a:srgbClr val="000000"/>
+                </a:solidFill>
+              </a:defRPr>
+            </a:pPr>
+            <a:r>
+              <a:rPr sz="2250" b="1" i="0">
+                <a:solidFill>
+                  <a:srgbClr val="000000"/>
+                </a:solidFill>
+              </a:rPr>
+              <a:t>ML-P1b showed that threshold policy is real, but it did not close the alpha gap. The forward-return grid made the model participate more, yet still undercaptured 2020 and weakened 2022 defense.</a:t>
+            </a:r>
+          </a:p>
+        </p:txBody>
+      </p:sp>
+      <p:sp>
+        <p:nvSpPr>
+          <p:cNvPr id="5" name="">
+            <a:extLst xmlns:a="http://schemas.openxmlformats.org/drawingml/2006/main">
+              <a:ext uri="{FF2B5EF4-FFF2-40B4-BE49-F238E27FC236}">
+                <a16:creationId xmlns:a16="http://schemas.microsoft.com/office/drawing/2014/main" id="{22CB1683-7DEC-42D1-98B1-611B1D1FB937}"/>
+              </a:ext>
+            </a:extLst>
+          </p:cNvPr>
+          <p:cNvSpPr>
+            <a:spLocks xmlns:a="http://schemas.openxmlformats.org/drawingml/2006/main" noGrp="1"/>
+          </p:cNvSpPr>
+          <p:nvPr/>
+        </p:nvSpPr>
+        <p:spPr>
+          <a:xfrm xmlns:a="http://schemas.openxmlformats.org/drawingml/2006/main">
+            <a:off x="1219200" y="3571875"/>
+            <a:ext cx="190500" cy="247650"/>
+          </a:xfrm>
+          <a:prstGeom xmlns:a="http://schemas.openxmlformats.org/drawingml/2006/main" prst="rect">
+            <a:avLst/>
+          </a:prstGeom>
+          <a:noFill xmlns:a="http://schemas.openxmlformats.org/drawingml/2006/main"/>
+          <a:ln xmlns:a="http://schemas.openxmlformats.org/drawingml/2006/main" w="0">
+            <a:noFill/>
+            <a:prstDash val="solid"/>
+          </a:ln>
+        </p:spPr>
+        <p:txBody>
+          <a:bodyPr xmlns:a="http://schemas.openxmlformats.org/drawingml/2006/main"/>
+          <a:lstStyle xmlns:a="http://schemas.openxmlformats.org/drawingml/2006/main"/>
+          <a:p xmlns:a="http://schemas.openxmlformats.org/drawingml/2006/main">
+            <a:pPr algn="l">
+              <a:defRPr sz="1575" b="1" i="0">
+                <a:solidFill>
+                  <a:srgbClr val="FF6B35"/>
+                </a:solidFill>
+              </a:defRPr>
+            </a:pPr>
+            <a:r>
+              <a:rPr sz="1575" b="1" i="0">
+                <a:solidFill>
+                  <a:srgbClr val="FF6B35"/>
+                </a:solidFill>
+              </a:rPr>
+              <a:t>-</a:t>
+            </a:r>
+          </a:p>
+        </p:txBody>
+      </p:sp>
+      <p:sp>
+        <p:nvSpPr>
+          <p:cNvPr id="6" name="">
+            <a:extLst xmlns:a="http://schemas.openxmlformats.org/drawingml/2006/main">
+              <a:ext uri="{FF2B5EF4-FFF2-40B4-BE49-F238E27FC236}">
+                <a16:creationId xmlns:a16="http://schemas.microsoft.com/office/drawing/2014/main" id="{03C43DC1-AAFC-4802-AE58-1FF985943875}"/>
+              </a:ext>
+            </a:extLst>
+          </p:cNvPr>
+          <p:cNvSpPr>
+            <a:spLocks xmlns:a="http://schemas.openxmlformats.org/drawingml/2006/main" noGrp="1"/>
+          </p:cNvSpPr>
+          <p:nvPr/>
+        </p:nvSpPr>
+        <p:spPr>
+          <a:xfrm xmlns:a="http://schemas.openxmlformats.org/drawingml/2006/main">
+            <a:off x="1485900" y="3562350"/>
+            <a:ext cx="6972300" cy="514350"/>
+          </a:xfrm>
+          <a:prstGeom xmlns:a="http://schemas.openxmlformats.org/drawingml/2006/main" prst="rect">
+            <a:avLst/>
+          </a:prstGeom>
+          <a:noFill xmlns:a="http://schemas.openxmlformats.org/drawingml/2006/main"/>
+          <a:ln xmlns:a="http://schemas.openxmlformats.org/drawingml/2006/main" w="0">
+            <a:noFill/>
+            <a:prstDash val="solid"/>
+          </a:ln>
+        </p:spPr>
+        <p:txBody>
+          <a:bodyPr xmlns:a="http://schemas.openxmlformats.org/drawingml/2006/main"/>
+          <a:lstStyle xmlns:a="http://schemas.openxmlformats.org/drawingml/2006/main"/>
+          <a:p xmlns:a="http://schemas.openxmlformats.org/drawingml/2006/main">
+            <a:pPr algn="l">
+              <a:defRPr sz="1575" b="0" i="0">
+                <a:solidFill>
+                  <a:srgbClr val="222222"/>
+                </a:solidFill>
+              </a:defRPr>
+            </a:pPr>
+            <a:r>
+              <a:rPr sz="1575" b="0" i="0">
+                <a:solidFill>
+                  <a:srgbClr val="222222"/>
+                </a:solidFill>
+              </a:rPr>
+              <a:t>Keep the continuous annual replay and policy audit as the required ML comparison surface.</a:t>
+            </a:r>
+          </a:p>
+        </p:txBody>
+      </p:sp>
+      <p:sp>
+        <p:nvSpPr>
+          <p:cNvPr id="7" name="">
+            <a:extLst xmlns:a="http://schemas.openxmlformats.org/drawingml/2006/main">
+              <a:ext uri="{FF2B5EF4-FFF2-40B4-BE49-F238E27FC236}">
+                <a16:creationId xmlns:a16="http://schemas.microsoft.com/office/drawing/2014/main" id="{CC89853D-2069-4E08-B945-B92476F420BC}"/>
+              </a:ext>
+            </a:extLst>
+          </p:cNvPr>
+          <p:cNvSpPr>
+            <a:spLocks xmlns:a="http://schemas.openxmlformats.org/drawingml/2006/main" noGrp="1"/>
+          </p:cNvSpPr>
+          <p:nvPr/>
+        </p:nvSpPr>
+        <p:spPr>
+          <a:xfrm xmlns:a="http://schemas.openxmlformats.org/drawingml/2006/main">
+            <a:off x="1219200" y="4238625"/>
+            <a:ext cx="190500" cy="247650"/>
+          </a:xfrm>
+          <a:prstGeom xmlns:a="http://schemas.openxmlformats.org/drawingml/2006/main" prst="rect">
+            <a:avLst/>
+          </a:prstGeom>
+          <a:noFill xmlns:a="http://schemas.openxmlformats.org/drawingml/2006/main"/>
+          <a:ln xmlns:a="http://schemas.openxmlformats.org/drawingml/2006/main" w="0">
+            <a:noFill/>
+            <a:prstDash val="solid"/>
+          </a:ln>
+        </p:spPr>
+        <p:txBody>
+          <a:bodyPr xmlns:a="http://schemas.openxmlformats.org/drawingml/2006/main"/>
+          <a:lstStyle xmlns:a="http://schemas.openxmlformats.org/drawingml/2006/main"/>
+          <a:p xmlns:a="http://schemas.openxmlformats.org/drawingml/2006/main">
+            <a:pPr algn="l">
+              <a:defRPr sz="1575" b="1" i="0">
+                <a:solidFill>
+                  <a:srgbClr val="FF6B35"/>
+                </a:solidFill>
+              </a:defRPr>
+            </a:pPr>
+            <a:r>
+              <a:rPr sz="1575" b="1" i="0">
+                <a:solidFill>
+                  <a:srgbClr val="FF6B35"/>
+                </a:solidFill>
+              </a:rPr>
+              <a:t>-</a:t>
+            </a:r>
+          </a:p>
+        </p:txBody>
+      </p:sp>
+      <p:sp>
+        <p:nvSpPr>
+          <p:cNvPr id="8" name="">
+            <a:extLst xmlns:a="http://schemas.openxmlformats.org/drawingml/2006/main">
+              <a:ext uri="{FF2B5EF4-FFF2-40B4-BE49-F238E27FC236}">
+                <a16:creationId xmlns:a16="http://schemas.microsoft.com/office/drawing/2014/main" id="{BCF2FBFA-E31F-42C4-9153-204B36F93D05}"/>
+              </a:ext>
+            </a:extLst>
+          </p:cNvPr>
+          <p:cNvSpPr>
+            <a:spLocks xmlns:a="http://schemas.openxmlformats.org/drawingml/2006/main" noGrp="1"/>
+          </p:cNvSpPr>
+          <p:nvPr/>
+        </p:nvSpPr>
+        <p:spPr>
+          <a:xfrm xmlns:a="http://schemas.openxmlformats.org/drawingml/2006/main">
+            <a:off x="1485900" y="4229100"/>
+            <a:ext cx="6972300" cy="514350"/>
+          </a:xfrm>
+          <a:prstGeom xmlns:a="http://schemas.openxmlformats.org/drawingml/2006/main" prst="rect">
+            <a:avLst/>
+          </a:prstGeom>
+          <a:noFill xmlns:a="http://schemas.openxmlformats.org/drawingml/2006/main"/>
+          <a:ln xmlns:a="http://schemas.openxmlformats.org/drawingml/2006/main" w="0">
+            <a:noFill/>
+            <a:prstDash val="solid"/>
+          </a:ln>
+        </p:spPr>
+        <p:txBody>
+          <a:bodyPr xmlns:a="http://schemas.openxmlformats.org/drawingml/2006/main"/>
+          <a:lstStyle xmlns:a="http://schemas.openxmlformats.org/drawingml/2006/main"/>
+          <a:p xmlns:a="http://schemas.openxmlformats.org/drawingml/2006/main">
+            <a:pPr algn="l">
+              <a:defRPr sz="1575" b="0" i="0">
+                <a:solidFill>
+                  <a:srgbClr val="222222"/>
+                </a:solidFill>
+              </a:defRPr>
+            </a:pPr>
+            <a:r>
+              <a:rPr sz="1575" b="0" i="0">
+                <a:solidFill>
+                  <a:srgbClr val="222222"/>
+                </a:solidFill>
+              </a:rPr>
+              <a:t>Next test should compare label horizons or probability calibration before adding XGBoost.</a:t>
+            </a:r>
+          </a:p>
+        </p:txBody>
+      </p:sp>
+      <p:sp>
+        <p:nvSpPr>
+          <p:cNvPr id="9" name="">
+            <a:extLst xmlns:a="http://schemas.openxmlformats.org/drawingml/2006/main">
+              <a:ext uri="{FF2B5EF4-FFF2-40B4-BE49-F238E27FC236}">
+                <a16:creationId xmlns:a16="http://schemas.microsoft.com/office/drawing/2014/main" id="{5400AD03-C32F-45E7-951B-0D1D5C3C6E8C}"/>
+              </a:ext>
+            </a:extLst>
+          </p:cNvPr>
+          <p:cNvSpPr>
+            <a:spLocks xmlns:a="http://schemas.openxmlformats.org/drawingml/2006/main" noGrp="1"/>
+          </p:cNvSpPr>
+          <p:nvPr/>
+        </p:nvSpPr>
+        <p:spPr>
+          <a:xfrm xmlns:a="http://schemas.openxmlformats.org/drawingml/2006/main">
+            <a:off x="1219200" y="4905375"/>
+            <a:ext cx="190500" cy="247650"/>
+          </a:xfrm>
+          <a:prstGeom xmlns:a="http://schemas.openxmlformats.org/drawingml/2006/main" prst="rect">
+            <a:avLst/>
+          </a:prstGeom>
+          <a:noFill xmlns:a="http://schemas.openxmlformats.org/drawingml/2006/main"/>
+          <a:ln xmlns:a="http://schemas.openxmlformats.org/drawingml/2006/main" w="0">
+            <a:noFill/>
+            <a:prstDash val="solid"/>
+          </a:ln>
+        </p:spPr>
+        <p:txBody>
+          <a:bodyPr xmlns:a="http://schemas.openxmlformats.org/drawingml/2006/main"/>
+          <a:lstStyle xmlns:a="http://schemas.openxmlformats.org/drawingml/2006/main"/>
+          <a:p xmlns:a="http://schemas.openxmlformats.org/drawingml/2006/main">
+            <a:pPr algn="l">
+              <a:defRPr sz="1575" b="1" i="0">
+                <a:solidFill>
+                  <a:srgbClr val="FF6B35"/>
+                </a:solidFill>
+              </a:defRPr>
+            </a:pPr>
+            <a:r>
+              <a:rPr sz="1575" b="1" i="0">
+                <a:solidFill>
+                  <a:srgbClr val="FF6B35"/>
+                </a:solidFill>
+              </a:rPr>
+              <a:t>-</a:t>
+            </a:r>
+          </a:p>
+        </p:txBody>
+      </p:sp>
+      <p:sp>
+        <p:nvSpPr>
+          <p:cNvPr id="10" name="">
+            <a:extLst xmlns:a="http://schemas.openxmlformats.org/drawingml/2006/main">
+              <a:ext uri="{FF2B5EF4-FFF2-40B4-BE49-F238E27FC236}">
+                <a16:creationId xmlns:a16="http://schemas.microsoft.com/office/drawing/2014/main" id="{8A42FCEE-7FEC-4686-BE9A-999C8D7C5B73}"/>
+              </a:ext>
+            </a:extLst>
+          </p:cNvPr>
+          <p:cNvSpPr>
+            <a:spLocks xmlns:a="http://schemas.openxmlformats.org/drawingml/2006/main" noGrp="1"/>
+          </p:cNvSpPr>
+          <p:nvPr/>
+        </p:nvSpPr>
+        <p:spPr>
+          <a:xfrm xmlns:a="http://schemas.openxmlformats.org/drawingml/2006/main">
+            <a:off x="1485900" y="4895850"/>
+            <a:ext cx="6972300" cy="514350"/>
+          </a:xfrm>
+          <a:prstGeom xmlns:a="http://schemas.openxmlformats.org/drawingml/2006/main" prst="rect">
+            <a:avLst/>
+          </a:prstGeom>
+          <a:noFill xmlns:a="http://schemas.openxmlformats.org/drawingml/2006/main"/>
+          <a:ln xmlns:a="http://schemas.openxmlformats.org/drawingml/2006/main" w="0">
+            <a:noFill/>
+            <a:prstDash val="solid"/>
+          </a:ln>
+        </p:spPr>
+        <p:txBody>
+          <a:bodyPr xmlns:a="http://schemas.openxmlformats.org/drawingml/2006/main"/>
+          <a:lstStyle xmlns:a="http://schemas.openxmlformats.org/drawingml/2006/main"/>
+          <a:p xmlns:a="http://schemas.openxmlformats.org/drawingml/2006/main">
+            <a:pPr algn="l">
+              <a:defRPr sz="1575" b="0" i="0">
+                <a:solidFill>
+                  <a:srgbClr val="222222"/>
+                </a:solidFill>
+              </a:defRPr>
+            </a:pPr>
+            <a:r>
+              <a:rPr sz="1575" b="0" i="0">
+                <a:solidFill>
+                  <a:srgbClr val="222222"/>
+                </a:solidFill>
+              </a:rPr>
+              <a:t>If XGBoost comes next, it should be judged on better ranking and timing, not merely higher exposure.</a:t>
+            </a:r>
+          </a:p>
+        </p:txBody>
+      </p:sp>
+      <p:sp>
+        <p:nvSpPr>
+          <p:cNvPr id="11" name="">
+            <a:extLst xmlns:a="http://schemas.openxmlformats.org/drawingml/2006/main">
+              <a:ext uri="{FF2B5EF4-FFF2-40B4-BE49-F238E27FC236}">
+                <a16:creationId xmlns:a16="http://schemas.microsoft.com/office/drawing/2014/main" id="{0D890192-E41C-475C-B34B-0C8F3E1312DA}"/>
+              </a:ext>
+            </a:extLst>
+          </p:cNvPr>
+          <p:cNvSpPr>
+            <a:spLocks xmlns:a="http://schemas.openxmlformats.org/drawingml/2006/main" noGrp="1"/>
+          </p:cNvSpPr>
+          <p:nvPr/>
+        </p:nvSpPr>
+        <p:spPr>
+          <a:xfrm xmlns:a="http://schemas.openxmlformats.org/drawingml/2006/main">
+            <a:off x="1219200" y="5572125"/>
+            <a:ext cx="190500" cy="247650"/>
+          </a:xfrm>
+          <a:prstGeom xmlns:a="http://schemas.openxmlformats.org/drawingml/2006/main" prst="rect">
+            <a:avLst/>
+          </a:prstGeom>
+          <a:noFill xmlns:a="http://schemas.openxmlformats.org/drawingml/2006/main"/>
+          <a:ln xmlns:a="http://schemas.openxmlformats.org/drawingml/2006/main" w="0">
+            <a:noFill/>
+            <a:prstDash val="solid"/>
+          </a:ln>
+        </p:spPr>
+        <p:txBody>
+          <a:bodyPr xmlns:a="http://schemas.openxmlformats.org/drawingml/2006/main"/>
+          <a:lstStyle xmlns:a="http://schemas.openxmlformats.org/drawingml/2006/main"/>
+          <a:p xmlns:a="http://schemas.openxmlformats.org/drawingml/2006/main">
+            <a:pPr algn="l">
+              <a:defRPr sz="1575" b="1" i="0">
+                <a:solidFill>
+                  <a:srgbClr val="FF6B35"/>
+                </a:solidFill>
+              </a:defRPr>
+            </a:pPr>
+            <a:r>
+              <a:rPr sz="1575" b="1" i="0">
+                <a:solidFill>
+                  <a:srgbClr val="FF6B35"/>
+                </a:solidFill>
+              </a:rPr>
+              <a:t>-</a:t>
+            </a:r>
+          </a:p>
+        </p:txBody>
+      </p:sp>
+      <p:sp>
+        <p:nvSpPr>
+          <p:cNvPr id="12" name="">
+            <a:extLst xmlns:a="http://schemas.openxmlformats.org/drawingml/2006/main">
+              <a:ext uri="{FF2B5EF4-FFF2-40B4-BE49-F238E27FC236}">
+                <a16:creationId xmlns:a16="http://schemas.microsoft.com/office/drawing/2014/main" id="{EA38F89B-66AD-452F-AA64-21C07064DA1A}"/>
+              </a:ext>
+            </a:extLst>
+          </p:cNvPr>
+          <p:cNvSpPr>
+            <a:spLocks xmlns:a="http://schemas.openxmlformats.org/drawingml/2006/main" noGrp="1"/>
+          </p:cNvSpPr>
+          <p:nvPr/>
+        </p:nvSpPr>
+        <p:spPr>
+          <a:xfrm xmlns:a="http://schemas.openxmlformats.org/drawingml/2006/main">
+            <a:off x="1485900" y="5562600"/>
+            <a:ext cx="6972300" cy="514350"/>
+          </a:xfrm>
+          <a:prstGeom xmlns:a="http://schemas.openxmlformats.org/drawingml/2006/main" prst="rect">
+            <a:avLst/>
+          </a:prstGeom>
+          <a:noFill xmlns:a="http://schemas.openxmlformats.org/drawingml/2006/main"/>
+          <a:ln xmlns:a="http://schemas.openxmlformats.org/drawingml/2006/main" w="0">
+            <a:noFill/>
+            <a:prstDash val="solid"/>
+          </a:ln>
+        </p:spPr>
+        <p:txBody>
+          <a:bodyPr xmlns:a="http://schemas.openxmlformats.org/drawingml/2006/main"/>
+          <a:lstStyle xmlns:a="http://schemas.openxmlformats.org/drawingml/2006/main"/>
+          <a:p xmlns:a="http://schemas.openxmlformats.org/drawingml/2006/main">
+            <a:pPr algn="l">
+              <a:defRPr sz="1575" b="0" i="0">
+                <a:solidFill>
+                  <a:srgbClr val="222222"/>
+                </a:solidFill>
+              </a:defRPr>
+            </a:pPr>
+            <a:r>
+              <a:rPr sz="1575" b="0" i="0">
+                <a:solidFill>
+                  <a:srgbClr val="222222"/>
+                </a:solidFill>
+              </a:rPr>
+              <a:t>Watch the 2022 tradeoff: grid exposure rose to 67.4% while return fell to -48.4%.</a:t>
+            </a:r>
+          </a:p>
+        </p:txBody>
+      </p:sp>
+    </p:spTree>
+    <p:extLst>
+      <p:ext uri="{BB962C8B-B14F-4D97-AF65-F5344CB8AC3E}">
+        <p14:creationId xmlns:p14="http://schemas.microsoft.com/office/powerpoint/2010/main" val="672011009"/>
       </p:ext>
     </p:extLst>
   </p:cSld>
@@ -7144,7 +10257,7 @@
           <p:cNvPr id="1" name="">
             <a:extLst xmlns:a="http://schemas.openxmlformats.org/drawingml/2006/main">
               <a:ext uri="{FF2B5EF4-FFF2-40B4-BE49-F238E27FC236}">
-                <a16:creationId xmlns:a16="http://schemas.microsoft.com/office/drawing/2014/main" id="{3C11B574-C1F3-44C2-BFDD-F21961BF1C3E}"/>
+                <a16:creationId xmlns:a16="http://schemas.microsoft.com/office/drawing/2014/main" id="{A1A1DE9B-2883-44C3-AE0C-093FE00A77E9}"/>
               </a:ext>
             </a:extLst>
           </p:cNvPr>
@@ -7194,7 +10307,7 @@
           <p:cNvPr id="2" name="">
             <a:extLst xmlns:a="http://schemas.openxmlformats.org/drawingml/2006/main">
               <a:ext uri="{FF2B5EF4-FFF2-40B4-BE49-F238E27FC236}">
-                <a16:creationId xmlns:a16="http://schemas.microsoft.com/office/drawing/2014/main" id="{A7CB5D9B-0291-4EE9-82E6-2642158D5577}"/>
+                <a16:creationId xmlns:a16="http://schemas.microsoft.com/office/drawing/2014/main" id="{3AE87DAD-B9A8-4510-9365-363B99B9B0D6}"/>
               </a:ext>
             </a:extLst>
           </p:cNvPr>
@@ -7244,7 +10357,7 @@
           <p:cNvPr id="3" name="">
             <a:extLst xmlns:a="http://schemas.openxmlformats.org/drawingml/2006/main">
               <a:ext uri="{FF2B5EF4-FFF2-40B4-BE49-F238E27FC236}">
-                <a16:creationId xmlns:a16="http://schemas.microsoft.com/office/drawing/2014/main" id="{1D87F613-3AF1-4682-AD3A-060509D7BF5D}"/>
+                <a16:creationId xmlns:a16="http://schemas.microsoft.com/office/drawing/2014/main" id="{29262F3E-589C-4A9F-9E2B-4F18647454EC}"/>
               </a:ext>
             </a:extLst>
           </p:cNvPr>
@@ -7275,7 +10388,7 @@
           <p:cNvPr id="4" name="">
             <a:extLst xmlns:a="http://schemas.openxmlformats.org/drawingml/2006/main">
               <a:ext uri="{FF2B5EF4-FFF2-40B4-BE49-F238E27FC236}">
-                <a16:creationId xmlns:a16="http://schemas.microsoft.com/office/drawing/2014/main" id="{F6616A57-8C91-4C73-A3BB-E60F55BB43D8}"/>
+                <a16:creationId xmlns:a16="http://schemas.microsoft.com/office/drawing/2014/main" id="{40F9C970-CE3B-4568-AEE1-D6F2A7FBC059}"/>
               </a:ext>
             </a:extLst>
           </p:cNvPr>
@@ -7287,7 +10400,7 @@
         <p:spPr>
           <a:xfrm xmlns:a="http://schemas.openxmlformats.org/drawingml/2006/main">
             <a:off x="876300" y="2190750"/>
-            <a:ext cx="2857500" cy="1200150"/>
+            <a:ext cx="2857500" cy="1428750"/>
           </a:xfrm>
           <a:prstGeom xmlns:a="http://schemas.openxmlformats.org/drawingml/2006/main" prst="rect">
             <a:avLst/>
@@ -7308,7 +10421,7 @@
           <p:cNvPr id="5" name="">
             <a:extLst xmlns:a="http://schemas.openxmlformats.org/drawingml/2006/main">
               <a:ext uri="{FF2B5EF4-FFF2-40B4-BE49-F238E27FC236}">
-                <a16:creationId xmlns:a16="http://schemas.microsoft.com/office/drawing/2014/main" id="{6D9D3AF4-5757-43E5-A418-F71F569A0FBD}"/>
+                <a16:creationId xmlns:a16="http://schemas.microsoft.com/office/drawing/2014/main" id="{A9B9C2DE-C2DC-4108-A01B-7A7E7685F33D}"/>
               </a:ext>
             </a:extLst>
           </p:cNvPr>
@@ -7358,7 +10471,7 @@
           <p:cNvPr id="6" name="">
             <a:extLst xmlns:a="http://schemas.openxmlformats.org/drawingml/2006/main">
               <a:ext uri="{FF2B5EF4-FFF2-40B4-BE49-F238E27FC236}">
-                <a16:creationId xmlns:a16="http://schemas.microsoft.com/office/drawing/2014/main" id="{C6A3C248-60D4-4990-9D39-DBB1829C406B}"/>
+                <a16:creationId xmlns:a16="http://schemas.microsoft.com/office/drawing/2014/main" id="{F47EDEA3-DA16-40AF-922F-0282DF735A1B}"/>
               </a:ext>
             </a:extLst>
           </p:cNvPr>
@@ -7408,7 +10521,7 @@
           <p:cNvPr id="7" name="">
             <a:extLst xmlns:a="http://schemas.openxmlformats.org/drawingml/2006/main">
               <a:ext uri="{FF2B5EF4-FFF2-40B4-BE49-F238E27FC236}">
-                <a16:creationId xmlns:a16="http://schemas.microsoft.com/office/drawing/2014/main" id="{7ACC55DD-3E8C-4F28-B518-55C3AC04973A}"/>
+                <a16:creationId xmlns:a16="http://schemas.microsoft.com/office/drawing/2014/main" id="{F6EA13BE-F47C-4262-B586-BDCBECF95DB1}"/>
               </a:ext>
             </a:extLst>
           </p:cNvPr>
@@ -7420,7 +10533,7 @@
         <p:spPr>
           <a:xfrm xmlns:a="http://schemas.openxmlformats.org/drawingml/2006/main">
             <a:off x="1047750" y="3009900"/>
-            <a:ext cx="2514600" cy="323850"/>
+            <a:ext cx="2514600" cy="552450"/>
           </a:xfrm>
           <a:prstGeom xmlns:a="http://schemas.openxmlformats.org/drawingml/2006/main" prst="rect">
             <a:avLst/>
@@ -7458,7 +10571,7 @@
           <p:cNvPr id="8" name="">
             <a:extLst xmlns:a="http://schemas.openxmlformats.org/drawingml/2006/main">
               <a:ext uri="{FF2B5EF4-FFF2-40B4-BE49-F238E27FC236}">
-                <a16:creationId xmlns:a16="http://schemas.microsoft.com/office/drawing/2014/main" id="{9F403F99-7F34-4602-829A-03CB9FF6A0CE}"/>
+                <a16:creationId xmlns:a16="http://schemas.microsoft.com/office/drawing/2014/main" id="{484862F7-734C-4774-8BE4-8D081EA179DA}"/>
               </a:ext>
             </a:extLst>
           </p:cNvPr>
@@ -7470,7 +10583,7 @@
         <p:spPr>
           <a:xfrm xmlns:a="http://schemas.openxmlformats.org/drawingml/2006/main">
             <a:off x="4667250" y="2190750"/>
-            <a:ext cx="2857500" cy="1200150"/>
+            <a:ext cx="2857500" cy="1428750"/>
           </a:xfrm>
           <a:prstGeom xmlns:a="http://schemas.openxmlformats.org/drawingml/2006/main" prst="rect">
             <a:avLst/>
@@ -7491,7 +10604,7 @@
           <p:cNvPr id="9" name="">
             <a:extLst xmlns:a="http://schemas.openxmlformats.org/drawingml/2006/main">
               <a:ext uri="{FF2B5EF4-FFF2-40B4-BE49-F238E27FC236}">
-                <a16:creationId xmlns:a16="http://schemas.microsoft.com/office/drawing/2014/main" id="{874F63C7-771C-454F-9587-47CCD93648EA}"/>
+                <a16:creationId xmlns:a16="http://schemas.microsoft.com/office/drawing/2014/main" id="{88020B65-549E-4C4C-A4EE-A13B1B6F7E64}"/>
               </a:ext>
             </a:extLst>
           </p:cNvPr>
@@ -7541,7 +10654,7 @@
           <p:cNvPr id="10" name="">
             <a:extLst xmlns:a="http://schemas.openxmlformats.org/drawingml/2006/main">
               <a:ext uri="{FF2B5EF4-FFF2-40B4-BE49-F238E27FC236}">
-                <a16:creationId xmlns:a16="http://schemas.microsoft.com/office/drawing/2014/main" id="{10B9D2F1-223D-4225-8DC0-EC935AB32A6B}"/>
+                <a16:creationId xmlns:a16="http://schemas.microsoft.com/office/drawing/2014/main" id="{8DF3CFCB-9E4E-4448-9121-E179A6A6446B}"/>
               </a:ext>
             </a:extLst>
           </p:cNvPr>
@@ -7591,7 +10704,7 @@
           <p:cNvPr id="11" name="">
             <a:extLst xmlns:a="http://schemas.openxmlformats.org/drawingml/2006/main">
               <a:ext uri="{FF2B5EF4-FFF2-40B4-BE49-F238E27FC236}">
-                <a16:creationId xmlns:a16="http://schemas.microsoft.com/office/drawing/2014/main" id="{E10288E7-C5CD-42FB-8ED6-33039496AEDD}"/>
+                <a16:creationId xmlns:a16="http://schemas.microsoft.com/office/drawing/2014/main" id="{E1082171-DDC1-480B-9B0C-B7888CEA09A7}"/>
               </a:ext>
             </a:extLst>
           </p:cNvPr>
@@ -7603,7 +10716,7 @@
         <p:spPr>
           <a:xfrm xmlns:a="http://schemas.openxmlformats.org/drawingml/2006/main">
             <a:off x="4838700" y="3009900"/>
-            <a:ext cx="2514600" cy="323850"/>
+            <a:ext cx="2514600" cy="552450"/>
           </a:xfrm>
           <a:prstGeom xmlns:a="http://schemas.openxmlformats.org/drawingml/2006/main" prst="rect">
             <a:avLst/>
@@ -7641,7 +10754,7 @@
           <p:cNvPr id="12" name="">
             <a:extLst xmlns:a="http://schemas.openxmlformats.org/drawingml/2006/main">
               <a:ext uri="{FF2B5EF4-FFF2-40B4-BE49-F238E27FC236}">
-                <a16:creationId xmlns:a16="http://schemas.microsoft.com/office/drawing/2014/main" id="{800C4630-44AC-4DA9-B90B-B460F1B27BB6}"/>
+                <a16:creationId xmlns:a16="http://schemas.microsoft.com/office/drawing/2014/main" id="{59EF25BC-22A2-47E0-B43A-649AA5B3A7F6}"/>
               </a:ext>
             </a:extLst>
           </p:cNvPr>
@@ -7653,7 +10766,7 @@
         <p:spPr>
           <a:xfrm xmlns:a="http://schemas.openxmlformats.org/drawingml/2006/main">
             <a:off x="8458200" y="2190750"/>
-            <a:ext cx="2857500" cy="1200150"/>
+            <a:ext cx="2857500" cy="1428750"/>
           </a:xfrm>
           <a:prstGeom xmlns:a="http://schemas.openxmlformats.org/drawingml/2006/main" prst="rect">
             <a:avLst/>
@@ -7674,7 +10787,7 @@
           <p:cNvPr id="13" name="">
             <a:extLst xmlns:a="http://schemas.openxmlformats.org/drawingml/2006/main">
               <a:ext uri="{FF2B5EF4-FFF2-40B4-BE49-F238E27FC236}">
-                <a16:creationId xmlns:a16="http://schemas.microsoft.com/office/drawing/2014/main" id="{10C2F5D8-D422-41F7-BF1F-01D5C340A4CB}"/>
+                <a16:creationId xmlns:a16="http://schemas.microsoft.com/office/drawing/2014/main" id="{C608CE68-3175-4AFD-981D-F6B6987ED796}"/>
               </a:ext>
             </a:extLst>
           </p:cNvPr>
@@ -7724,7 +10837,7 @@
           <p:cNvPr id="14" name="">
             <a:extLst xmlns:a="http://schemas.openxmlformats.org/drawingml/2006/main">
               <a:ext uri="{FF2B5EF4-FFF2-40B4-BE49-F238E27FC236}">
-                <a16:creationId xmlns:a16="http://schemas.microsoft.com/office/drawing/2014/main" id="{30B92D43-FD4C-450D-9C1F-7DF0B33ADF71}"/>
+                <a16:creationId xmlns:a16="http://schemas.microsoft.com/office/drawing/2014/main" id="{8C08F2C7-C230-48AE-BF1D-9384FAD02393}"/>
               </a:ext>
             </a:extLst>
           </p:cNvPr>
@@ -7774,7 +10887,7 @@
           <p:cNvPr id="15" name="">
             <a:extLst xmlns:a="http://schemas.openxmlformats.org/drawingml/2006/main">
               <a:ext uri="{FF2B5EF4-FFF2-40B4-BE49-F238E27FC236}">
-                <a16:creationId xmlns:a16="http://schemas.microsoft.com/office/drawing/2014/main" id="{C2CA55F2-5160-42FD-8A8F-D749DCEFA3CD}"/>
+                <a16:creationId xmlns:a16="http://schemas.microsoft.com/office/drawing/2014/main" id="{FC5B4A0A-04F8-482A-9315-390D62E16B5A}"/>
               </a:ext>
             </a:extLst>
           </p:cNvPr>
@@ -7786,7 +10899,7 @@
         <p:spPr>
           <a:xfrm xmlns:a="http://schemas.openxmlformats.org/drawingml/2006/main">
             <a:off x="8629650" y="3009900"/>
-            <a:ext cx="2514600" cy="323850"/>
+            <a:ext cx="2514600" cy="552450"/>
           </a:xfrm>
           <a:prstGeom xmlns:a="http://schemas.openxmlformats.org/drawingml/2006/main" prst="rect">
             <a:avLst/>
@@ -7824,7 +10937,7 @@
           <p:cNvPr id="16" name="">
             <a:extLst xmlns:a="http://schemas.openxmlformats.org/drawingml/2006/main">
               <a:ext uri="{FF2B5EF4-FFF2-40B4-BE49-F238E27FC236}">
-                <a16:creationId xmlns:a16="http://schemas.microsoft.com/office/drawing/2014/main" id="{1EDC3B2B-7968-4B81-BE81-0B1A266EE0E0}"/>
+                <a16:creationId xmlns:a16="http://schemas.microsoft.com/office/drawing/2014/main" id="{A1F2E1A7-D3D1-4BAD-9B58-E0FC726CECEB}"/>
               </a:ext>
             </a:extLst>
           </p:cNvPr>
@@ -7874,7 +10987,7 @@
           <p:cNvPr id="17" name="">
             <a:extLst xmlns:a="http://schemas.openxmlformats.org/drawingml/2006/main">
               <a:ext uri="{FF2B5EF4-FFF2-40B4-BE49-F238E27FC236}">
-                <a16:creationId xmlns:a16="http://schemas.microsoft.com/office/drawing/2014/main" id="{8A129D36-D038-419E-93E2-BA40532DB466}"/>
+                <a16:creationId xmlns:a16="http://schemas.microsoft.com/office/drawing/2014/main" id="{7E446C2F-FC9A-4C41-A95B-76BF7A9B3271}"/>
               </a:ext>
             </a:extLst>
           </p:cNvPr>
@@ -7924,7 +11037,7 @@
           <p:cNvPr id="18" name="">
             <a:extLst xmlns:a="http://schemas.openxmlformats.org/drawingml/2006/main">
               <a:ext uri="{FF2B5EF4-FFF2-40B4-BE49-F238E27FC236}">
-                <a16:creationId xmlns:a16="http://schemas.microsoft.com/office/drawing/2014/main" id="{3AD45CF1-64AB-42E1-A81F-87A2D5FD29C3}"/>
+                <a16:creationId xmlns:a16="http://schemas.microsoft.com/office/drawing/2014/main" id="{B252D230-A173-4E08-AE81-8468C574B7E0}"/>
               </a:ext>
             </a:extLst>
           </p:cNvPr>
@@ -7974,7 +11087,7 @@
           <p:cNvPr id="19" name="">
             <a:extLst xmlns:a="http://schemas.openxmlformats.org/drawingml/2006/main">
               <a:ext uri="{FF2B5EF4-FFF2-40B4-BE49-F238E27FC236}">
-                <a16:creationId xmlns:a16="http://schemas.microsoft.com/office/drawing/2014/main" id="{F3986E6B-B807-48ED-91F4-46CD332D4E09}"/>
+                <a16:creationId xmlns:a16="http://schemas.microsoft.com/office/drawing/2014/main" id="{01F0FABC-9EBF-4847-AAFD-64719C30B221}"/>
               </a:ext>
             </a:extLst>
           </p:cNvPr>
@@ -8024,7 +11137,7 @@
           <p:cNvPr id="20" name="">
             <a:extLst xmlns:a="http://schemas.openxmlformats.org/drawingml/2006/main">
               <a:ext uri="{FF2B5EF4-FFF2-40B4-BE49-F238E27FC236}">
-                <a16:creationId xmlns:a16="http://schemas.microsoft.com/office/drawing/2014/main" id="{B32FF8A3-725A-4BBF-89EE-F53E78CC35A3}"/>
+                <a16:creationId xmlns:a16="http://schemas.microsoft.com/office/drawing/2014/main" id="{35B1DB1C-E803-4022-8CBD-42D9F2C9B1F8}"/>
               </a:ext>
             </a:extLst>
           </p:cNvPr>
@@ -8074,7 +11187,7 @@
           <p:cNvPr id="21" name="">
             <a:extLst xmlns:a="http://schemas.openxmlformats.org/drawingml/2006/main">
               <a:ext uri="{FF2B5EF4-FFF2-40B4-BE49-F238E27FC236}">
-                <a16:creationId xmlns:a16="http://schemas.microsoft.com/office/drawing/2014/main" id="{0876B1BC-A436-4FB1-BB4D-A2CBFF9B3948}"/>
+                <a16:creationId xmlns:a16="http://schemas.microsoft.com/office/drawing/2014/main" id="{85FBB00B-371C-4B2E-9E29-F45824547D40}"/>
               </a:ext>
             </a:extLst>
           </p:cNvPr>
@@ -8124,7 +11237,7 @@
           <p:cNvPr id="22" name="">
             <a:extLst xmlns:a="http://schemas.openxmlformats.org/drawingml/2006/main">
               <a:ext uri="{FF2B5EF4-FFF2-40B4-BE49-F238E27FC236}">
-                <a16:creationId xmlns:a16="http://schemas.microsoft.com/office/drawing/2014/main" id="{2BFF81E5-AC0C-4CFA-9B6E-21F1F303FB3A}"/>
+                <a16:creationId xmlns:a16="http://schemas.microsoft.com/office/drawing/2014/main" id="{B57423C7-E917-42E5-8E69-B1FF861746D1}"/>
               </a:ext>
             </a:extLst>
           </p:cNvPr>
@@ -8174,7 +11287,7 @@
           <p:cNvPr id="23" name="">
             <a:extLst xmlns:a="http://schemas.openxmlformats.org/drawingml/2006/main">
               <a:ext uri="{FF2B5EF4-FFF2-40B4-BE49-F238E27FC236}">
-                <a16:creationId xmlns:a16="http://schemas.microsoft.com/office/drawing/2014/main" id="{BEF7CF42-7C61-43D1-85B3-239D6AD0007D}"/>
+                <a16:creationId xmlns:a16="http://schemas.microsoft.com/office/drawing/2014/main" id="{835C1339-EA84-4BF0-BA8A-A8216D688442}"/>
               </a:ext>
             </a:extLst>
           </p:cNvPr>
@@ -8222,7 +11335,7 @@
     </p:spTree>
     <p:extLst>
       <p:ext uri="{BB962C8B-B14F-4D97-AF65-F5344CB8AC3E}">
-        <p14:creationId xmlns:p14="http://schemas.microsoft.com/office/powerpoint/2010/main" val="283073382"/>
+        <p14:creationId xmlns:p14="http://schemas.microsoft.com/office/powerpoint/2010/main" val="1180259244"/>
       </p:ext>
     </p:extLst>
   </p:cSld>
@@ -8253,7 +11366,7 @@
           <p:cNvPr id="1" name="">
             <a:extLst xmlns:a="http://schemas.openxmlformats.org/drawingml/2006/main">
               <a:ext uri="{FF2B5EF4-FFF2-40B4-BE49-F238E27FC236}">
-                <a16:creationId xmlns:a16="http://schemas.microsoft.com/office/drawing/2014/main" id="{67558621-DBF2-4D73-917B-D15E0817111A}"/>
+                <a16:creationId xmlns:a16="http://schemas.microsoft.com/office/drawing/2014/main" id="{DBC1B214-6146-4764-AA7F-A99598AE04B6}"/>
               </a:ext>
             </a:extLst>
           </p:cNvPr>
@@ -8303,7 +11416,7 @@
           <p:cNvPr id="2" name="">
             <a:extLst xmlns:a="http://schemas.openxmlformats.org/drawingml/2006/main">
               <a:ext uri="{FF2B5EF4-FFF2-40B4-BE49-F238E27FC236}">
-                <a16:creationId xmlns:a16="http://schemas.microsoft.com/office/drawing/2014/main" id="{E5E9B7F3-496E-4356-BC9E-958257962B04}"/>
+                <a16:creationId xmlns:a16="http://schemas.microsoft.com/office/drawing/2014/main" id="{B96EB98F-3684-4769-B7BC-77AA9E0A39BB}"/>
               </a:ext>
             </a:extLst>
           </p:cNvPr>
@@ -8353,7 +11466,7 @@
           <p:cNvPr id="3" name="">
             <a:extLst xmlns:a="http://schemas.openxmlformats.org/drawingml/2006/main">
               <a:ext uri="{FF2B5EF4-FFF2-40B4-BE49-F238E27FC236}">
-                <a16:creationId xmlns:a16="http://schemas.microsoft.com/office/drawing/2014/main" id="{95C6FBB8-BA3D-4842-AE40-2D270782464A}"/>
+                <a16:creationId xmlns:a16="http://schemas.microsoft.com/office/drawing/2014/main" id="{F97BF7E6-EF90-4CA4-8982-95B2F589C516}"/>
               </a:ext>
             </a:extLst>
           </p:cNvPr>
@@ -8388,7 +11501,7 @@
           <p:nvPr/>
         </p:nvPicPr>
         <p:blipFill>
-          <a:blip xmlns:r="http://schemas.openxmlformats.org/officeDocument/2006/relationships" xmlns:a="http://schemas.openxmlformats.org/drawingml/2006/main" r:embed="Rb2781d92ac6f4ae2"/>
+          <a:blip xmlns:r="http://schemas.openxmlformats.org/officeDocument/2006/relationships" xmlns:a="http://schemas.openxmlformats.org/drawingml/2006/main" r:embed="Rd0cae3e91e884ee8"/>
           <a:stretch xmlns:a="http://schemas.openxmlformats.org/drawingml/2006/main"/>
         </p:blipFill>
         <p:spPr>
@@ -8406,7 +11519,7 @@
           <p:cNvPr id="5" name="">
             <a:extLst xmlns:a="http://schemas.openxmlformats.org/drawingml/2006/main">
               <a:ext uri="{FF2B5EF4-FFF2-40B4-BE49-F238E27FC236}">
-                <a16:creationId xmlns:a16="http://schemas.microsoft.com/office/drawing/2014/main" id="{D683C9EE-2243-4DB7-AF8F-03EDED947A7F}"/>
+                <a16:creationId xmlns:a16="http://schemas.microsoft.com/office/drawing/2014/main" id="{80654221-CF9C-451E-82EC-E9161A53E9D1}"/>
               </a:ext>
             </a:extLst>
           </p:cNvPr>
@@ -8456,7 +11569,7 @@
           <p:cNvPr id="6" name="">
             <a:extLst xmlns:a="http://schemas.openxmlformats.org/drawingml/2006/main">
               <a:ext uri="{FF2B5EF4-FFF2-40B4-BE49-F238E27FC236}">
-                <a16:creationId xmlns:a16="http://schemas.microsoft.com/office/drawing/2014/main" id="{21EBB7B0-9EA4-45D5-87A9-5EACBA1F6FB5}"/>
+                <a16:creationId xmlns:a16="http://schemas.microsoft.com/office/drawing/2014/main" id="{C923F815-86BA-4D33-96B6-17ACFECE378A}"/>
               </a:ext>
             </a:extLst>
           </p:cNvPr>
@@ -8504,7 +11617,7 @@
     </p:spTree>
     <p:extLst>
       <p:ext uri="{BB962C8B-B14F-4D97-AF65-F5344CB8AC3E}">
-        <p14:creationId xmlns:p14="http://schemas.microsoft.com/office/powerpoint/2010/main" val="1359632138"/>
+        <p14:creationId xmlns:p14="http://schemas.microsoft.com/office/powerpoint/2010/main" val="397574986"/>
       </p:ext>
     </p:extLst>
   </p:cSld>
@@ -8535,7 +11648,7 @@
           <p:cNvPr id="1" name="">
             <a:extLst xmlns:a="http://schemas.openxmlformats.org/drawingml/2006/main">
               <a:ext uri="{FF2B5EF4-FFF2-40B4-BE49-F238E27FC236}">
-                <a16:creationId xmlns:a16="http://schemas.microsoft.com/office/drawing/2014/main" id="{2062BF1D-E943-43D1-BC96-A2D9D66CCD13}"/>
+                <a16:creationId xmlns:a16="http://schemas.microsoft.com/office/drawing/2014/main" id="{33A49778-0DC4-4BAE-961F-97F82944949C}"/>
               </a:ext>
             </a:extLst>
           </p:cNvPr>
@@ -8585,7 +11698,7 @@
           <p:cNvPr id="2" name="">
             <a:extLst xmlns:a="http://schemas.openxmlformats.org/drawingml/2006/main">
               <a:ext uri="{FF2B5EF4-FFF2-40B4-BE49-F238E27FC236}">
-                <a16:creationId xmlns:a16="http://schemas.microsoft.com/office/drawing/2014/main" id="{0FA8E4B3-59D8-42EA-9528-0D837A5E61DC}"/>
+                <a16:creationId xmlns:a16="http://schemas.microsoft.com/office/drawing/2014/main" id="{84998785-9145-4FCE-A54F-5E8865DF29C2}"/>
               </a:ext>
             </a:extLst>
           </p:cNvPr>
@@ -8635,7 +11748,7 @@
           <p:cNvPr id="3" name="">
             <a:extLst xmlns:a="http://schemas.openxmlformats.org/drawingml/2006/main">
               <a:ext uri="{FF2B5EF4-FFF2-40B4-BE49-F238E27FC236}">
-                <a16:creationId xmlns:a16="http://schemas.microsoft.com/office/drawing/2014/main" id="{1752EB5F-2B85-4D80-9E43-BC85AE4AB711}"/>
+                <a16:creationId xmlns:a16="http://schemas.microsoft.com/office/drawing/2014/main" id="{689F875F-0750-4433-8F47-72914CBDCA1C}"/>
               </a:ext>
             </a:extLst>
           </p:cNvPr>
@@ -8670,7 +11783,7 @@
           <p:nvPr/>
         </p:nvPicPr>
         <p:blipFill>
-          <a:blip xmlns:r="http://schemas.openxmlformats.org/officeDocument/2006/relationships" xmlns:a="http://schemas.openxmlformats.org/drawingml/2006/main" r:embed="Rd48cbabb66624634"/>
+          <a:blip xmlns:r="http://schemas.openxmlformats.org/officeDocument/2006/relationships" xmlns:a="http://schemas.openxmlformats.org/drawingml/2006/main" r:embed="Rc358e62a2eae43d0"/>
           <a:stretch xmlns:a="http://schemas.openxmlformats.org/drawingml/2006/main"/>
         </p:blipFill>
         <p:spPr>
@@ -8688,7 +11801,7 @@
           <p:cNvPr id="5" name="">
             <a:extLst xmlns:a="http://schemas.openxmlformats.org/drawingml/2006/main">
               <a:ext uri="{FF2B5EF4-FFF2-40B4-BE49-F238E27FC236}">
-                <a16:creationId xmlns:a16="http://schemas.microsoft.com/office/drawing/2014/main" id="{7FFBB2C4-59DB-43F1-9B43-0D588CDABB3A}"/>
+                <a16:creationId xmlns:a16="http://schemas.microsoft.com/office/drawing/2014/main" id="{A8E681E7-870B-4C89-9820-9400A077D089}"/>
               </a:ext>
             </a:extLst>
           </p:cNvPr>
@@ -8738,7 +11851,7 @@
           <p:cNvPr id="6" name="">
             <a:extLst xmlns:a="http://schemas.openxmlformats.org/drawingml/2006/main">
               <a:ext uri="{FF2B5EF4-FFF2-40B4-BE49-F238E27FC236}">
-                <a16:creationId xmlns:a16="http://schemas.microsoft.com/office/drawing/2014/main" id="{B128D558-C29B-4E43-B0D5-442ABEF7773D}"/>
+                <a16:creationId xmlns:a16="http://schemas.microsoft.com/office/drawing/2014/main" id="{DF022C8C-A4E9-4944-901E-CDC712F6E770}"/>
               </a:ext>
             </a:extLst>
           </p:cNvPr>
@@ -8788,7 +11901,7 @@
           <p:cNvPr id="7" name="">
             <a:extLst xmlns:a="http://schemas.openxmlformats.org/drawingml/2006/main">
               <a:ext uri="{FF2B5EF4-FFF2-40B4-BE49-F238E27FC236}">
-                <a16:creationId xmlns:a16="http://schemas.microsoft.com/office/drawing/2014/main" id="{FE87E29F-E4A5-4C99-AC38-3EBB0379A1E2}"/>
+                <a16:creationId xmlns:a16="http://schemas.microsoft.com/office/drawing/2014/main" id="{C05BAF81-DD5C-48A0-99F5-5FC24CB8D9E7}"/>
               </a:ext>
             </a:extLst>
           </p:cNvPr>
@@ -8838,7 +11951,7 @@
           <p:cNvPr id="8" name="">
             <a:extLst xmlns:a="http://schemas.openxmlformats.org/drawingml/2006/main">
               <a:ext uri="{FF2B5EF4-FFF2-40B4-BE49-F238E27FC236}">
-                <a16:creationId xmlns:a16="http://schemas.microsoft.com/office/drawing/2014/main" id="{1407C223-C106-4223-BADA-30C50F3AB022}"/>
+                <a16:creationId xmlns:a16="http://schemas.microsoft.com/office/drawing/2014/main" id="{BDB79631-3684-407E-BA29-ACB6C1398777}"/>
               </a:ext>
             </a:extLst>
           </p:cNvPr>
@@ -8888,7 +12001,7 @@
           <p:cNvPr id="9" name="">
             <a:extLst xmlns:a="http://schemas.openxmlformats.org/drawingml/2006/main">
               <a:ext uri="{FF2B5EF4-FFF2-40B4-BE49-F238E27FC236}">
-                <a16:creationId xmlns:a16="http://schemas.microsoft.com/office/drawing/2014/main" id="{CF15DBFE-3B24-4233-8645-1D7BCCC33DD9}"/>
+                <a16:creationId xmlns:a16="http://schemas.microsoft.com/office/drawing/2014/main" id="{BA28C531-02EB-4B6C-AD4A-EB136170C2E0}"/>
               </a:ext>
             </a:extLst>
           </p:cNvPr>
@@ -8936,7 +12049,7 @@
     </p:spTree>
     <p:extLst>
       <p:ext uri="{BB962C8B-B14F-4D97-AF65-F5344CB8AC3E}">
-        <p14:creationId xmlns:p14="http://schemas.microsoft.com/office/powerpoint/2010/main" val="84248713"/>
+        <p14:creationId xmlns:p14="http://schemas.microsoft.com/office/powerpoint/2010/main" val="1899949632"/>
       </p:ext>
     </p:extLst>
   </p:cSld>
@@ -8967,7 +12080,7 @@
           <p:cNvPr id="1" name="">
             <a:extLst xmlns:a="http://schemas.openxmlformats.org/drawingml/2006/main">
               <a:ext uri="{FF2B5EF4-FFF2-40B4-BE49-F238E27FC236}">
-                <a16:creationId xmlns:a16="http://schemas.microsoft.com/office/drawing/2014/main" id="{47A552C9-2C95-4129-8038-484434E3CA8B}"/>
+                <a16:creationId xmlns:a16="http://schemas.microsoft.com/office/drawing/2014/main" id="{17922E52-8030-40D3-AF53-E9E4800AAB6F}"/>
               </a:ext>
             </a:extLst>
           </p:cNvPr>
@@ -9017,7 +12130,7 @@
           <p:cNvPr id="2" name="">
             <a:extLst xmlns:a="http://schemas.openxmlformats.org/drawingml/2006/main">
               <a:ext uri="{FF2B5EF4-FFF2-40B4-BE49-F238E27FC236}">
-                <a16:creationId xmlns:a16="http://schemas.microsoft.com/office/drawing/2014/main" id="{E0314130-4464-482D-9300-51DDD1A85025}"/>
+                <a16:creationId xmlns:a16="http://schemas.microsoft.com/office/drawing/2014/main" id="{2DF0F1A9-2846-4A2B-BEC7-C31643FCE090}"/>
               </a:ext>
             </a:extLst>
           </p:cNvPr>
@@ -9067,7 +12180,7 @@
           <p:cNvPr id="3" name="">
             <a:extLst xmlns:a="http://schemas.openxmlformats.org/drawingml/2006/main">
               <a:ext uri="{FF2B5EF4-FFF2-40B4-BE49-F238E27FC236}">
-                <a16:creationId xmlns:a16="http://schemas.microsoft.com/office/drawing/2014/main" id="{985557C4-1100-4616-8AB3-5AF8BD78D17F}"/>
+                <a16:creationId xmlns:a16="http://schemas.microsoft.com/office/drawing/2014/main" id="{BCDE0107-795F-45EC-A323-E5E754F60BDD}"/>
               </a:ext>
             </a:extLst>
           </p:cNvPr>
@@ -9102,7 +12215,7 @@
           <p:nvPr/>
         </p:nvPicPr>
         <p:blipFill>
-          <a:blip xmlns:r="http://schemas.openxmlformats.org/officeDocument/2006/relationships" xmlns:a="http://schemas.openxmlformats.org/drawingml/2006/main" r:embed="R2e63199a85354e8a"/>
+          <a:blip xmlns:r="http://schemas.openxmlformats.org/officeDocument/2006/relationships" xmlns:a="http://schemas.openxmlformats.org/drawingml/2006/main" r:embed="R867ffcad5f8d4eb0"/>
           <a:stretch xmlns:a="http://schemas.openxmlformats.org/drawingml/2006/main"/>
         </p:blipFill>
         <p:spPr>
@@ -9124,7 +12237,7 @@
           <p:nvPr/>
         </p:nvPicPr>
         <p:blipFill>
-          <a:blip xmlns:r="http://schemas.openxmlformats.org/officeDocument/2006/relationships" xmlns:a="http://schemas.openxmlformats.org/drawingml/2006/main" r:embed="R285caf0581ef4807"/>
+          <a:blip xmlns:r="http://schemas.openxmlformats.org/officeDocument/2006/relationships" xmlns:a="http://schemas.openxmlformats.org/drawingml/2006/main" r:embed="R097264eae7724fdf"/>
           <a:stretch xmlns:a="http://schemas.openxmlformats.org/drawingml/2006/main"/>
         </p:blipFill>
         <p:spPr>
@@ -9142,7 +12255,7 @@
           <p:cNvPr id="6" name="">
             <a:extLst xmlns:a="http://schemas.openxmlformats.org/drawingml/2006/main">
               <a:ext uri="{FF2B5EF4-FFF2-40B4-BE49-F238E27FC236}">
-                <a16:creationId xmlns:a16="http://schemas.microsoft.com/office/drawing/2014/main" id="{6892F3D6-E61A-4ABD-A16F-EA7D39989BC4}"/>
+                <a16:creationId xmlns:a16="http://schemas.microsoft.com/office/drawing/2014/main" id="{CDE2534B-A02B-4FE8-9130-36F73EE50FA9}"/>
               </a:ext>
             </a:extLst>
           </p:cNvPr>
@@ -9190,7 +12303,7 @@
     </p:spTree>
     <p:extLst>
       <p:ext uri="{BB962C8B-B14F-4D97-AF65-F5344CB8AC3E}">
-        <p14:creationId xmlns:p14="http://schemas.microsoft.com/office/powerpoint/2010/main" val="2145780310"/>
+        <p14:creationId xmlns:p14="http://schemas.microsoft.com/office/powerpoint/2010/main" val="379807712"/>
       </p:ext>
     </p:extLst>
   </p:cSld>
@@ -9221,7 +12334,7 @@
           <p:cNvPr id="1" name="">
             <a:extLst xmlns:a="http://schemas.openxmlformats.org/drawingml/2006/main">
               <a:ext uri="{FF2B5EF4-FFF2-40B4-BE49-F238E27FC236}">
-                <a16:creationId xmlns:a16="http://schemas.microsoft.com/office/drawing/2014/main" id="{FF945AB4-9652-4D23-B473-9DC19589EF78}"/>
+                <a16:creationId xmlns:a16="http://schemas.microsoft.com/office/drawing/2014/main" id="{C8993EC3-7D5F-458C-8607-911E97EFE4CF}"/>
               </a:ext>
             </a:extLst>
           </p:cNvPr>
@@ -9271,7 +12384,7 @@
           <p:cNvPr id="2" name="">
             <a:extLst xmlns:a="http://schemas.openxmlformats.org/drawingml/2006/main">
               <a:ext uri="{FF2B5EF4-FFF2-40B4-BE49-F238E27FC236}">
-                <a16:creationId xmlns:a16="http://schemas.microsoft.com/office/drawing/2014/main" id="{E0643663-21DD-4992-93E4-F4ECA1DEF43D}"/>
+                <a16:creationId xmlns:a16="http://schemas.microsoft.com/office/drawing/2014/main" id="{D6959B8B-3CEF-4456-AA62-AC60686EAD87}"/>
               </a:ext>
             </a:extLst>
           </p:cNvPr>
@@ -9321,7 +12434,7 @@
           <p:cNvPr id="3" name="">
             <a:extLst xmlns:a="http://schemas.openxmlformats.org/drawingml/2006/main">
               <a:ext uri="{FF2B5EF4-FFF2-40B4-BE49-F238E27FC236}">
-                <a16:creationId xmlns:a16="http://schemas.microsoft.com/office/drawing/2014/main" id="{3796EC5E-F207-42E4-8C75-9D007C512A3B}"/>
+                <a16:creationId xmlns:a16="http://schemas.microsoft.com/office/drawing/2014/main" id="{F32CF3EC-8F97-4B03-B3A1-3A0F7991B661}"/>
               </a:ext>
             </a:extLst>
           </p:cNvPr>
@@ -9356,7 +12469,7 @@
           <p:nvPr/>
         </p:nvPicPr>
         <p:blipFill>
-          <a:blip xmlns:r="http://schemas.openxmlformats.org/officeDocument/2006/relationships" xmlns:a="http://schemas.openxmlformats.org/drawingml/2006/main" r:embed="R041723920c6f4a3a"/>
+          <a:blip xmlns:r="http://schemas.openxmlformats.org/officeDocument/2006/relationships" xmlns:a="http://schemas.openxmlformats.org/drawingml/2006/main" r:embed="R7329df2c40af4213"/>
           <a:stretch xmlns:a="http://schemas.openxmlformats.org/drawingml/2006/main"/>
         </p:blipFill>
         <p:spPr>
@@ -9374,7 +12487,7 @@
           <p:cNvPr id="5" name="">
             <a:extLst xmlns:a="http://schemas.openxmlformats.org/drawingml/2006/main">
               <a:ext uri="{FF2B5EF4-FFF2-40B4-BE49-F238E27FC236}">
-                <a16:creationId xmlns:a16="http://schemas.microsoft.com/office/drawing/2014/main" id="{8057A7B9-6179-41BD-8DF5-D5FC8CF1C6A8}"/>
+                <a16:creationId xmlns:a16="http://schemas.microsoft.com/office/drawing/2014/main" id="{7619CEC8-A47B-40E8-B0D4-E1C429568030}"/>
               </a:ext>
             </a:extLst>
           </p:cNvPr>
@@ -9424,7 +12537,7 @@
           <p:cNvPr id="6" name="">
             <a:extLst xmlns:a="http://schemas.openxmlformats.org/drawingml/2006/main">
               <a:ext uri="{FF2B5EF4-FFF2-40B4-BE49-F238E27FC236}">
-                <a16:creationId xmlns:a16="http://schemas.microsoft.com/office/drawing/2014/main" id="{416B2653-493C-4521-BB8D-9C36593577C7}"/>
+                <a16:creationId xmlns:a16="http://schemas.microsoft.com/office/drawing/2014/main" id="{2E5380D4-5343-4706-989C-CBF57C3124BF}"/>
               </a:ext>
             </a:extLst>
           </p:cNvPr>
@@ -9472,7 +12585,7 @@
     </p:spTree>
     <p:extLst>
       <p:ext uri="{BB962C8B-B14F-4D97-AF65-F5344CB8AC3E}">
-        <p14:creationId xmlns:p14="http://schemas.microsoft.com/office/powerpoint/2010/main" val="1764599846"/>
+        <p14:creationId xmlns:p14="http://schemas.microsoft.com/office/powerpoint/2010/main" val="258425809"/>
       </p:ext>
     </p:extLst>
   </p:cSld>
@@ -9503,7 +12616,7 @@
           <p:cNvPr id="1" name="">
             <a:extLst xmlns:a="http://schemas.openxmlformats.org/drawingml/2006/main">
               <a:ext uri="{FF2B5EF4-FFF2-40B4-BE49-F238E27FC236}">
-                <a16:creationId xmlns:a16="http://schemas.microsoft.com/office/drawing/2014/main" id="{21763562-DC6A-49B1-88D0-B48B6A453911}"/>
+                <a16:creationId xmlns:a16="http://schemas.microsoft.com/office/drawing/2014/main" id="{CED06015-3DEE-4987-BEE4-7D3CB55AF8CE}"/>
               </a:ext>
             </a:extLst>
           </p:cNvPr>
@@ -9553,7 +12666,7 @@
           <p:cNvPr id="2" name="">
             <a:extLst xmlns:a="http://schemas.openxmlformats.org/drawingml/2006/main">
               <a:ext uri="{FF2B5EF4-FFF2-40B4-BE49-F238E27FC236}">
-                <a16:creationId xmlns:a16="http://schemas.microsoft.com/office/drawing/2014/main" id="{A6089CB9-54DF-4506-A248-93C6CFF38369}"/>
+                <a16:creationId xmlns:a16="http://schemas.microsoft.com/office/drawing/2014/main" id="{F79B0D3B-B7D0-47F1-B3E5-C6B1D1527276}"/>
               </a:ext>
             </a:extLst>
           </p:cNvPr>
@@ -9603,7 +12716,7 @@
           <p:cNvPr id="3" name="">
             <a:extLst xmlns:a="http://schemas.openxmlformats.org/drawingml/2006/main">
               <a:ext uri="{FF2B5EF4-FFF2-40B4-BE49-F238E27FC236}">
-                <a16:creationId xmlns:a16="http://schemas.microsoft.com/office/drawing/2014/main" id="{123AC082-A088-4B4E-AF3A-D1446AC0B734}"/>
+                <a16:creationId xmlns:a16="http://schemas.microsoft.com/office/drawing/2014/main" id="{7C2F7EAA-78BC-4DD0-8209-37E3A12453AC}"/>
               </a:ext>
             </a:extLst>
           </p:cNvPr>
@@ -9638,7 +12751,7 @@
           <p:nvPr/>
         </p:nvPicPr>
         <p:blipFill>
-          <a:blip xmlns:r="http://schemas.openxmlformats.org/officeDocument/2006/relationships" xmlns:a="http://schemas.openxmlformats.org/drawingml/2006/main" r:embed="Rb6097a288f9e44d8"/>
+          <a:blip xmlns:r="http://schemas.openxmlformats.org/officeDocument/2006/relationships" xmlns:a="http://schemas.openxmlformats.org/drawingml/2006/main" r:embed="Rb8bd0dd0b5e14e7e"/>
           <a:stretch xmlns:a="http://schemas.openxmlformats.org/drawingml/2006/main"/>
         </p:blipFill>
         <p:spPr>
@@ -9656,7 +12769,7 @@
           <p:cNvPr id="5" name="">
             <a:extLst xmlns:a="http://schemas.openxmlformats.org/drawingml/2006/main">
               <a:ext uri="{FF2B5EF4-FFF2-40B4-BE49-F238E27FC236}">
-                <a16:creationId xmlns:a16="http://schemas.microsoft.com/office/drawing/2014/main" id="{1BA55CEB-AA0D-4A33-A502-E96C60FDE8FA}"/>
+                <a16:creationId xmlns:a16="http://schemas.microsoft.com/office/drawing/2014/main" id="{67210EEC-B266-43DD-B01B-9A178D2AE458}"/>
               </a:ext>
             </a:extLst>
           </p:cNvPr>
@@ -9706,7 +12819,7 @@
           <p:cNvPr id="6" name="">
             <a:extLst xmlns:a="http://schemas.openxmlformats.org/drawingml/2006/main">
               <a:ext uri="{FF2B5EF4-FFF2-40B4-BE49-F238E27FC236}">
-                <a16:creationId xmlns:a16="http://schemas.microsoft.com/office/drawing/2014/main" id="{9D1095F9-DE1D-453D-A8CE-B48598375D70}"/>
+                <a16:creationId xmlns:a16="http://schemas.microsoft.com/office/drawing/2014/main" id="{59AC4BD4-2C25-4094-8747-F27400D7809D}"/>
               </a:ext>
             </a:extLst>
           </p:cNvPr>
@@ -9754,7 +12867,7 @@
     </p:spTree>
     <p:extLst>
       <p:ext uri="{BB962C8B-B14F-4D97-AF65-F5344CB8AC3E}">
-        <p14:creationId xmlns:p14="http://schemas.microsoft.com/office/powerpoint/2010/main" val="1271054265"/>
+        <p14:creationId xmlns:p14="http://schemas.microsoft.com/office/powerpoint/2010/main" val="1172100279"/>
       </p:ext>
     </p:extLst>
   </p:cSld>
@@ -9785,7 +12898,7 @@
           <p:cNvPr id="1" name="">
             <a:extLst xmlns:a="http://schemas.openxmlformats.org/drawingml/2006/main">
               <a:ext uri="{FF2B5EF4-FFF2-40B4-BE49-F238E27FC236}">
-                <a16:creationId xmlns:a16="http://schemas.microsoft.com/office/drawing/2014/main" id="{65C7D25F-8534-4CA8-8A63-1D7FAFB2C164}"/>
+                <a16:creationId xmlns:a16="http://schemas.microsoft.com/office/drawing/2014/main" id="{0954314F-4212-4C8F-BA46-430FA85F6AB2}"/>
               </a:ext>
             </a:extLst>
           </p:cNvPr>
@@ -9835,7 +12948,7 @@
           <p:cNvPr id="2" name="">
             <a:extLst xmlns:a="http://schemas.openxmlformats.org/drawingml/2006/main">
               <a:ext uri="{FF2B5EF4-FFF2-40B4-BE49-F238E27FC236}">
-                <a16:creationId xmlns:a16="http://schemas.microsoft.com/office/drawing/2014/main" id="{4A87B3F8-240C-4A58-8289-31D2FF30681F}"/>
+                <a16:creationId xmlns:a16="http://schemas.microsoft.com/office/drawing/2014/main" id="{59E977BA-DA8E-4F40-8666-CE90F67D3CE6}"/>
               </a:ext>
             </a:extLst>
           </p:cNvPr>
@@ -9885,7 +12998,7 @@
           <p:cNvPr id="3" name="">
             <a:extLst xmlns:a="http://schemas.openxmlformats.org/drawingml/2006/main">
               <a:ext uri="{FF2B5EF4-FFF2-40B4-BE49-F238E27FC236}">
-                <a16:creationId xmlns:a16="http://schemas.microsoft.com/office/drawing/2014/main" id="{0BBC8194-93C2-40C1-9E80-0C8231F063D1}"/>
+                <a16:creationId xmlns:a16="http://schemas.microsoft.com/office/drawing/2014/main" id="{3DF779C3-C95C-404C-943D-E80AF756DCB9}"/>
               </a:ext>
             </a:extLst>
           </p:cNvPr>
@@ -9920,7 +13033,7 @@
           <p:nvPr/>
         </p:nvPicPr>
         <p:blipFill>
-          <a:blip xmlns:r="http://schemas.openxmlformats.org/officeDocument/2006/relationships" xmlns:a="http://schemas.openxmlformats.org/drawingml/2006/main" r:embed="R143e6562c1864d33"/>
+          <a:blip xmlns:r="http://schemas.openxmlformats.org/officeDocument/2006/relationships" xmlns:a="http://schemas.openxmlformats.org/drawingml/2006/main" r:embed="R0dc2c4da3862492d"/>
           <a:stretch xmlns:a="http://schemas.openxmlformats.org/drawingml/2006/main"/>
         </p:blipFill>
         <p:spPr>
@@ -9938,7 +13051,7 @@
           <p:cNvPr id="5" name="">
             <a:extLst xmlns:a="http://schemas.openxmlformats.org/drawingml/2006/main">
               <a:ext uri="{FF2B5EF4-FFF2-40B4-BE49-F238E27FC236}">
-                <a16:creationId xmlns:a16="http://schemas.microsoft.com/office/drawing/2014/main" id="{8048E2A4-C1B1-4F8D-B887-50AA7EECD31F}"/>
+                <a16:creationId xmlns:a16="http://schemas.microsoft.com/office/drawing/2014/main" id="{FB84B190-E954-4506-9E68-09892F020881}"/>
               </a:ext>
             </a:extLst>
           </p:cNvPr>
@@ -9988,7 +13101,7 @@
           <p:cNvPr id="6" name="">
             <a:extLst xmlns:a="http://schemas.openxmlformats.org/drawingml/2006/main">
               <a:ext uri="{FF2B5EF4-FFF2-40B4-BE49-F238E27FC236}">
-                <a16:creationId xmlns:a16="http://schemas.microsoft.com/office/drawing/2014/main" id="{ADAE09F9-ECE6-4A98-A3CA-328753551038}"/>
+                <a16:creationId xmlns:a16="http://schemas.microsoft.com/office/drawing/2014/main" id="{DD36A641-710D-466D-A682-21C83768C2D1}"/>
               </a:ext>
             </a:extLst>
           </p:cNvPr>
@@ -10036,7 +13149,7 @@
     </p:spTree>
     <p:extLst>
       <p:ext uri="{BB962C8B-B14F-4D97-AF65-F5344CB8AC3E}">
-        <p14:creationId xmlns:p14="http://schemas.microsoft.com/office/powerpoint/2010/main" val="730828306"/>
+        <p14:creationId xmlns:p14="http://schemas.microsoft.com/office/powerpoint/2010/main" val="1465508923"/>
       </p:ext>
     </p:extLst>
   </p:cSld>

</xml_diff>